<commit_message>
v1.0.0 Avancé sur la fonction igc2vva + upload de fichier OK
</commit_message>
<xml_diff>
--- a/ressources/code.pptx
+++ b/ressources/code.pptx
@@ -243,7 +243,7 @@
           <a:p>
             <a:fld id="{253B1B7A-19D7-47DD-996A-6E83BE59A4F5}" type="datetimeFigureOut">
               <a:rPr lang="fr-FR" smtClean="0"/>
-              <a:t>18/01/2026</a:t>
+              <a:t>19/01/2026</a:t>
             </a:fld>
             <a:endParaRPr lang="fr-FR"/>
           </a:p>
@@ -413,7 +413,7 @@
           <a:p>
             <a:fld id="{253B1B7A-19D7-47DD-996A-6E83BE59A4F5}" type="datetimeFigureOut">
               <a:rPr lang="fr-FR" smtClean="0"/>
-              <a:t>18/01/2026</a:t>
+              <a:t>19/01/2026</a:t>
             </a:fld>
             <a:endParaRPr lang="fr-FR"/>
           </a:p>
@@ -593,7 +593,7 @@
           <a:p>
             <a:fld id="{253B1B7A-19D7-47DD-996A-6E83BE59A4F5}" type="datetimeFigureOut">
               <a:rPr lang="fr-FR" smtClean="0"/>
-              <a:t>18/01/2026</a:t>
+              <a:t>19/01/2026</a:t>
             </a:fld>
             <a:endParaRPr lang="fr-FR"/>
           </a:p>
@@ -763,7 +763,7 @@
           <a:p>
             <a:fld id="{253B1B7A-19D7-47DD-996A-6E83BE59A4F5}" type="datetimeFigureOut">
               <a:rPr lang="fr-FR" smtClean="0"/>
-              <a:t>18/01/2026</a:t>
+              <a:t>19/01/2026</a:t>
             </a:fld>
             <a:endParaRPr lang="fr-FR"/>
           </a:p>
@@ -1009,7 +1009,7 @@
           <a:p>
             <a:fld id="{253B1B7A-19D7-47DD-996A-6E83BE59A4F5}" type="datetimeFigureOut">
               <a:rPr lang="fr-FR" smtClean="0"/>
-              <a:t>18/01/2026</a:t>
+              <a:t>19/01/2026</a:t>
             </a:fld>
             <a:endParaRPr lang="fr-FR"/>
           </a:p>
@@ -1241,7 +1241,7 @@
           <a:p>
             <a:fld id="{253B1B7A-19D7-47DD-996A-6E83BE59A4F5}" type="datetimeFigureOut">
               <a:rPr lang="fr-FR" smtClean="0"/>
-              <a:t>18/01/2026</a:t>
+              <a:t>19/01/2026</a:t>
             </a:fld>
             <a:endParaRPr lang="fr-FR"/>
           </a:p>
@@ -1608,7 +1608,7 @@
           <a:p>
             <a:fld id="{253B1B7A-19D7-47DD-996A-6E83BE59A4F5}" type="datetimeFigureOut">
               <a:rPr lang="fr-FR" smtClean="0"/>
-              <a:t>18/01/2026</a:t>
+              <a:t>19/01/2026</a:t>
             </a:fld>
             <a:endParaRPr lang="fr-FR"/>
           </a:p>
@@ -1726,7 +1726,7 @@
           <a:p>
             <a:fld id="{253B1B7A-19D7-47DD-996A-6E83BE59A4F5}" type="datetimeFigureOut">
               <a:rPr lang="fr-FR" smtClean="0"/>
-              <a:t>18/01/2026</a:t>
+              <a:t>19/01/2026</a:t>
             </a:fld>
             <a:endParaRPr lang="fr-FR"/>
           </a:p>
@@ -1821,7 +1821,7 @@
           <a:p>
             <a:fld id="{253B1B7A-19D7-47DD-996A-6E83BE59A4F5}" type="datetimeFigureOut">
               <a:rPr lang="fr-FR" smtClean="0"/>
-              <a:t>18/01/2026</a:t>
+              <a:t>19/01/2026</a:t>
             </a:fld>
             <a:endParaRPr lang="fr-FR"/>
           </a:p>
@@ -2098,7 +2098,7 @@
           <a:p>
             <a:fld id="{253B1B7A-19D7-47DD-996A-6E83BE59A4F5}" type="datetimeFigureOut">
               <a:rPr lang="fr-FR" smtClean="0"/>
-              <a:t>18/01/2026</a:t>
+              <a:t>19/01/2026</a:t>
             </a:fld>
             <a:endParaRPr lang="fr-FR"/>
           </a:p>
@@ -2351,7 +2351,7 @@
           <a:p>
             <a:fld id="{253B1B7A-19D7-47DD-996A-6E83BE59A4F5}" type="datetimeFigureOut">
               <a:rPr lang="fr-FR" smtClean="0"/>
-              <a:t>18/01/2026</a:t>
+              <a:t>19/01/2026</a:t>
             </a:fld>
             <a:endParaRPr lang="fr-FR"/>
           </a:p>
@@ -2564,7 +2564,7 @@
           <a:p>
             <a:fld id="{253B1B7A-19D7-47DD-996A-6E83BE59A4F5}" type="datetimeFigureOut">
               <a:rPr lang="fr-FR" smtClean="0"/>
-              <a:t>18/01/2026</a:t>
+              <a:t>19/01/2026</a:t>
             </a:fld>
             <a:endParaRPr lang="fr-FR"/>
           </a:p>
@@ -3507,11 +3507,6 @@
               </a:rPr>
               <a:t>: </a:t>
             </a:r>
-            <a:endParaRPr lang="fr-FR" dirty="0" smtClean="0">
-              <a:solidFill>
-                <a:schemeClr val="tx1"/>
-              </a:solidFill>
-            </a:endParaRPr>
           </a:p>
           <a:p>
             <a:pPr algn="ctr"/>
@@ -3585,15 +3580,7 @@
                   <a:schemeClr val="tx1"/>
                 </a:solidFill>
               </a:rPr>
-              <a:t>	</a:t>
-            </a:r>
-            <a:r>
-              <a:rPr lang="fr-FR" dirty="0" smtClean="0">
-                <a:solidFill>
-                  <a:schemeClr val="tx1"/>
-                </a:solidFill>
-              </a:rPr>
-              <a:t>File </a:t>
+              <a:t>	File </a:t>
             </a:r>
             <a:r>
               <a:rPr lang="fr-FR" dirty="0" err="1" smtClean="0">
@@ -3789,7 +3776,7 @@
         </p:nvSpPr>
         <p:spPr>
           <a:xfrm>
-            <a:off x="7508243" y="3654777"/>
+            <a:off x="7508243" y="3438353"/>
             <a:ext cx="2343257" cy="1173448"/>
           </a:xfrm>
           <a:prstGeom prst="roundRect">

</xml_diff>

<commit_message>
v1.0.0 Loading des files OK ,conversion en VVA OK, affichage sur tableau de la database OK
</commit_message>
<xml_diff>
--- a/ressources/code.pptx
+++ b/ressources/code.pptx
@@ -243,7 +243,7 @@
           <a:p>
             <a:fld id="{253B1B7A-19D7-47DD-996A-6E83BE59A4F5}" type="datetimeFigureOut">
               <a:rPr lang="fr-FR" smtClean="0"/>
-              <a:t>19/01/2026</a:t>
+              <a:t>24/01/2026</a:t>
             </a:fld>
             <a:endParaRPr lang="fr-FR"/>
           </a:p>
@@ -413,7 +413,7 @@
           <a:p>
             <a:fld id="{253B1B7A-19D7-47DD-996A-6E83BE59A4F5}" type="datetimeFigureOut">
               <a:rPr lang="fr-FR" smtClean="0"/>
-              <a:t>19/01/2026</a:t>
+              <a:t>24/01/2026</a:t>
             </a:fld>
             <a:endParaRPr lang="fr-FR"/>
           </a:p>
@@ -593,7 +593,7 @@
           <a:p>
             <a:fld id="{253B1B7A-19D7-47DD-996A-6E83BE59A4F5}" type="datetimeFigureOut">
               <a:rPr lang="fr-FR" smtClean="0"/>
-              <a:t>19/01/2026</a:t>
+              <a:t>24/01/2026</a:t>
             </a:fld>
             <a:endParaRPr lang="fr-FR"/>
           </a:p>
@@ -763,7 +763,7 @@
           <a:p>
             <a:fld id="{253B1B7A-19D7-47DD-996A-6E83BE59A4F5}" type="datetimeFigureOut">
               <a:rPr lang="fr-FR" smtClean="0"/>
-              <a:t>19/01/2026</a:t>
+              <a:t>24/01/2026</a:t>
             </a:fld>
             <a:endParaRPr lang="fr-FR"/>
           </a:p>
@@ -1009,7 +1009,7 @@
           <a:p>
             <a:fld id="{253B1B7A-19D7-47DD-996A-6E83BE59A4F5}" type="datetimeFigureOut">
               <a:rPr lang="fr-FR" smtClean="0"/>
-              <a:t>19/01/2026</a:t>
+              <a:t>24/01/2026</a:t>
             </a:fld>
             <a:endParaRPr lang="fr-FR"/>
           </a:p>
@@ -1241,7 +1241,7 @@
           <a:p>
             <a:fld id="{253B1B7A-19D7-47DD-996A-6E83BE59A4F5}" type="datetimeFigureOut">
               <a:rPr lang="fr-FR" smtClean="0"/>
-              <a:t>19/01/2026</a:t>
+              <a:t>24/01/2026</a:t>
             </a:fld>
             <a:endParaRPr lang="fr-FR"/>
           </a:p>
@@ -1608,7 +1608,7 @@
           <a:p>
             <a:fld id="{253B1B7A-19D7-47DD-996A-6E83BE59A4F5}" type="datetimeFigureOut">
               <a:rPr lang="fr-FR" smtClean="0"/>
-              <a:t>19/01/2026</a:t>
+              <a:t>24/01/2026</a:t>
             </a:fld>
             <a:endParaRPr lang="fr-FR"/>
           </a:p>
@@ -1726,7 +1726,7 @@
           <a:p>
             <a:fld id="{253B1B7A-19D7-47DD-996A-6E83BE59A4F5}" type="datetimeFigureOut">
               <a:rPr lang="fr-FR" smtClean="0"/>
-              <a:t>19/01/2026</a:t>
+              <a:t>24/01/2026</a:t>
             </a:fld>
             <a:endParaRPr lang="fr-FR"/>
           </a:p>
@@ -1821,7 +1821,7 @@
           <a:p>
             <a:fld id="{253B1B7A-19D7-47DD-996A-6E83BE59A4F5}" type="datetimeFigureOut">
               <a:rPr lang="fr-FR" smtClean="0"/>
-              <a:t>19/01/2026</a:t>
+              <a:t>24/01/2026</a:t>
             </a:fld>
             <a:endParaRPr lang="fr-FR"/>
           </a:p>
@@ -2098,7 +2098,7 @@
           <a:p>
             <a:fld id="{253B1B7A-19D7-47DD-996A-6E83BE59A4F5}" type="datetimeFigureOut">
               <a:rPr lang="fr-FR" smtClean="0"/>
-              <a:t>19/01/2026</a:t>
+              <a:t>24/01/2026</a:t>
             </a:fld>
             <a:endParaRPr lang="fr-FR"/>
           </a:p>
@@ -2351,7 +2351,7 @@
           <a:p>
             <a:fld id="{253B1B7A-19D7-47DD-996A-6E83BE59A4F5}" type="datetimeFigureOut">
               <a:rPr lang="fr-FR" smtClean="0"/>
-              <a:t>19/01/2026</a:t>
+              <a:t>24/01/2026</a:t>
             </a:fld>
             <a:endParaRPr lang="fr-FR"/>
           </a:p>
@@ -2564,7 +2564,7 @@
           <a:p>
             <a:fld id="{253B1B7A-19D7-47DD-996A-6E83BE59A4F5}" type="datetimeFigureOut">
               <a:rPr lang="fr-FR" smtClean="0"/>
-              <a:t>19/01/2026</a:t>
+              <a:t>24/01/2026</a:t>
             </a:fld>
             <a:endParaRPr lang="fr-FR"/>
           </a:p>
@@ -3381,8 +3381,8 @@
         </p:nvSpPr>
         <p:spPr>
           <a:xfrm>
-            <a:off x="3837708" y="3616700"/>
-            <a:ext cx="2064327" cy="816755"/>
+            <a:off x="3687147" y="3944211"/>
+            <a:ext cx="2064327" cy="812512"/>
           </a:xfrm>
           <a:prstGeom prst="roundRect">
             <a:avLst/>
@@ -3410,6 +3410,14 @@
           <a:p>
             <a:pPr algn="ctr"/>
             <a:r>
+              <a:rPr lang="fr-FR" dirty="0" smtClean="0"/>
+              <a:t>Scan </a:t>
+            </a:r>
+            <a:r>
+              <a:rPr lang="fr-FR" dirty="0" smtClean="0"/>
+              <a:t>&amp; </a:t>
+            </a:r>
+            <a:r>
               <a:rPr lang="fr-FR" dirty="0" err="1" smtClean="0"/>
               <a:t>Fetch</a:t>
             </a:r>
@@ -3439,11 +3447,11 @@
             </a:r>
             <a:r>
               <a:rPr lang="fr-FR" dirty="0" smtClean="0"/>
-              <a:t> files in flight </a:t>
-            </a:r>
-            <a:r>
-              <a:rPr lang="fr-FR" dirty="0" err="1" smtClean="0"/>
-              <a:t>dir</a:t>
+              <a:t> </a:t>
+            </a:r>
+            <a:r>
+              <a:rPr lang="fr-FR" dirty="0" smtClean="0"/>
+              <a:t>files</a:t>
             </a:r>
             <a:endParaRPr lang="fr-FR" dirty="0"/>
           </a:p>
@@ -3684,7 +3692,7 @@
         </p:nvSpPr>
         <p:spPr>
           <a:xfrm>
-            <a:off x="3816927" y="4539438"/>
+            <a:off x="3777202" y="5028248"/>
             <a:ext cx="1884218" cy="484909"/>
           </a:xfrm>
           <a:prstGeom prst="roundRect">
@@ -3728,7 +3736,7 @@
         </p:nvSpPr>
         <p:spPr>
           <a:xfrm>
-            <a:off x="3837709" y="5324985"/>
+            <a:off x="3777202" y="5772839"/>
             <a:ext cx="1884218" cy="484909"/>
           </a:xfrm>
           <a:prstGeom prst="roundRect">

</xml_diff>

<commit_message>
v1.0.0 Suppresion des fichiers OK
</commit_message>
<xml_diff>
--- a/ressources/code.pptx
+++ b/ressources/code.pptx
@@ -243,7 +243,7 @@
           <a:p>
             <a:fld id="{253B1B7A-19D7-47DD-996A-6E83BE59A4F5}" type="datetimeFigureOut">
               <a:rPr lang="fr-FR" smtClean="0"/>
-              <a:t>24/01/2026</a:t>
+              <a:t>25/01/2026</a:t>
             </a:fld>
             <a:endParaRPr lang="fr-FR"/>
           </a:p>
@@ -413,7 +413,7 @@
           <a:p>
             <a:fld id="{253B1B7A-19D7-47DD-996A-6E83BE59A4F5}" type="datetimeFigureOut">
               <a:rPr lang="fr-FR" smtClean="0"/>
-              <a:t>24/01/2026</a:t>
+              <a:t>25/01/2026</a:t>
             </a:fld>
             <a:endParaRPr lang="fr-FR"/>
           </a:p>
@@ -593,7 +593,7 @@
           <a:p>
             <a:fld id="{253B1B7A-19D7-47DD-996A-6E83BE59A4F5}" type="datetimeFigureOut">
               <a:rPr lang="fr-FR" smtClean="0"/>
-              <a:t>24/01/2026</a:t>
+              <a:t>25/01/2026</a:t>
             </a:fld>
             <a:endParaRPr lang="fr-FR"/>
           </a:p>
@@ -763,7 +763,7 @@
           <a:p>
             <a:fld id="{253B1B7A-19D7-47DD-996A-6E83BE59A4F5}" type="datetimeFigureOut">
               <a:rPr lang="fr-FR" smtClean="0"/>
-              <a:t>24/01/2026</a:t>
+              <a:t>25/01/2026</a:t>
             </a:fld>
             <a:endParaRPr lang="fr-FR"/>
           </a:p>
@@ -1009,7 +1009,7 @@
           <a:p>
             <a:fld id="{253B1B7A-19D7-47DD-996A-6E83BE59A4F5}" type="datetimeFigureOut">
               <a:rPr lang="fr-FR" smtClean="0"/>
-              <a:t>24/01/2026</a:t>
+              <a:t>25/01/2026</a:t>
             </a:fld>
             <a:endParaRPr lang="fr-FR"/>
           </a:p>
@@ -1241,7 +1241,7 @@
           <a:p>
             <a:fld id="{253B1B7A-19D7-47DD-996A-6E83BE59A4F5}" type="datetimeFigureOut">
               <a:rPr lang="fr-FR" smtClean="0"/>
-              <a:t>24/01/2026</a:t>
+              <a:t>25/01/2026</a:t>
             </a:fld>
             <a:endParaRPr lang="fr-FR"/>
           </a:p>
@@ -1608,7 +1608,7 @@
           <a:p>
             <a:fld id="{253B1B7A-19D7-47DD-996A-6E83BE59A4F5}" type="datetimeFigureOut">
               <a:rPr lang="fr-FR" smtClean="0"/>
-              <a:t>24/01/2026</a:t>
+              <a:t>25/01/2026</a:t>
             </a:fld>
             <a:endParaRPr lang="fr-FR"/>
           </a:p>
@@ -1726,7 +1726,7 @@
           <a:p>
             <a:fld id="{253B1B7A-19D7-47DD-996A-6E83BE59A4F5}" type="datetimeFigureOut">
               <a:rPr lang="fr-FR" smtClean="0"/>
-              <a:t>24/01/2026</a:t>
+              <a:t>25/01/2026</a:t>
             </a:fld>
             <a:endParaRPr lang="fr-FR"/>
           </a:p>
@@ -1821,7 +1821,7 @@
           <a:p>
             <a:fld id="{253B1B7A-19D7-47DD-996A-6E83BE59A4F5}" type="datetimeFigureOut">
               <a:rPr lang="fr-FR" smtClean="0"/>
-              <a:t>24/01/2026</a:t>
+              <a:t>25/01/2026</a:t>
             </a:fld>
             <a:endParaRPr lang="fr-FR"/>
           </a:p>
@@ -2098,7 +2098,7 @@
           <a:p>
             <a:fld id="{253B1B7A-19D7-47DD-996A-6E83BE59A4F5}" type="datetimeFigureOut">
               <a:rPr lang="fr-FR" smtClean="0"/>
-              <a:t>24/01/2026</a:t>
+              <a:t>25/01/2026</a:t>
             </a:fld>
             <a:endParaRPr lang="fr-FR"/>
           </a:p>
@@ -2351,7 +2351,7 @@
           <a:p>
             <a:fld id="{253B1B7A-19D7-47DD-996A-6E83BE59A4F5}" type="datetimeFigureOut">
               <a:rPr lang="fr-FR" smtClean="0"/>
-              <a:t>24/01/2026</a:t>
+              <a:t>25/01/2026</a:t>
             </a:fld>
             <a:endParaRPr lang="fr-FR"/>
           </a:p>
@@ -2564,7 +2564,7 @@
           <a:p>
             <a:fld id="{253B1B7A-19D7-47DD-996A-6E83BE59A4F5}" type="datetimeFigureOut">
               <a:rPr lang="fr-FR" smtClean="0"/>
-              <a:t>24/01/2026</a:t>
+              <a:t>25/01/2026</a:t>
             </a:fld>
             <a:endParaRPr lang="fr-FR"/>
           </a:p>
@@ -3411,11 +3411,7 @@
             <a:pPr algn="ctr"/>
             <a:r>
               <a:rPr lang="fr-FR" dirty="0" smtClean="0"/>
-              <a:t>Scan </a:t>
-            </a:r>
-            <a:r>
-              <a:rPr lang="fr-FR" dirty="0" smtClean="0"/>
-              <a:t>&amp; </a:t>
+              <a:t>Scan &amp; </a:t>
             </a:r>
             <a:r>
               <a:rPr lang="fr-FR" dirty="0" err="1" smtClean="0"/>
@@ -3447,11 +3443,7 @@
             </a:r>
             <a:r>
               <a:rPr lang="fr-FR" dirty="0" smtClean="0"/>
-              <a:t> </a:t>
-            </a:r>
-            <a:r>
-              <a:rPr lang="fr-FR" dirty="0" smtClean="0"/>
-              <a:t>files</a:t>
+              <a:t> files</a:t>
             </a:r>
             <a:endParaRPr lang="fr-FR" dirty="0"/>
           </a:p>

</xml_diff>

<commit_message>
v1.0.0 Moulinette sur le igc non fini, calcule du heading et de la vitesse gps en cours
</commit_message>
<xml_diff>
--- a/ressources/code.pptx
+++ b/ressources/code.pptx
@@ -6,6 +6,8 @@
   </p:sldMasterIdLst>
   <p:sldIdLst>
     <p:sldId id="256" r:id="rId2"/>
+    <p:sldId id="257" r:id="rId3"/>
+    <p:sldId id="258" r:id="rId4"/>
   </p:sldIdLst>
   <p:sldSz cx="12192000" cy="6858000"/>
   <p:notesSz cx="6858000" cy="9144000"/>
@@ -243,7 +245,7 @@
           <a:p>
             <a:fld id="{253B1B7A-19D7-47DD-996A-6E83BE59A4F5}" type="datetimeFigureOut">
               <a:rPr lang="fr-FR" smtClean="0"/>
-              <a:t>25/01/2026</a:t>
+              <a:t>30/01/2026</a:t>
             </a:fld>
             <a:endParaRPr lang="fr-FR"/>
           </a:p>
@@ -413,7 +415,7 @@
           <a:p>
             <a:fld id="{253B1B7A-19D7-47DD-996A-6E83BE59A4F5}" type="datetimeFigureOut">
               <a:rPr lang="fr-FR" smtClean="0"/>
-              <a:t>25/01/2026</a:t>
+              <a:t>30/01/2026</a:t>
             </a:fld>
             <a:endParaRPr lang="fr-FR"/>
           </a:p>
@@ -593,7 +595,7 @@
           <a:p>
             <a:fld id="{253B1B7A-19D7-47DD-996A-6E83BE59A4F5}" type="datetimeFigureOut">
               <a:rPr lang="fr-FR" smtClean="0"/>
-              <a:t>25/01/2026</a:t>
+              <a:t>30/01/2026</a:t>
             </a:fld>
             <a:endParaRPr lang="fr-FR"/>
           </a:p>
@@ -763,7 +765,7 @@
           <a:p>
             <a:fld id="{253B1B7A-19D7-47DD-996A-6E83BE59A4F5}" type="datetimeFigureOut">
               <a:rPr lang="fr-FR" smtClean="0"/>
-              <a:t>25/01/2026</a:t>
+              <a:t>30/01/2026</a:t>
             </a:fld>
             <a:endParaRPr lang="fr-FR"/>
           </a:p>
@@ -1009,7 +1011,7 @@
           <a:p>
             <a:fld id="{253B1B7A-19D7-47DD-996A-6E83BE59A4F5}" type="datetimeFigureOut">
               <a:rPr lang="fr-FR" smtClean="0"/>
-              <a:t>25/01/2026</a:t>
+              <a:t>30/01/2026</a:t>
             </a:fld>
             <a:endParaRPr lang="fr-FR"/>
           </a:p>
@@ -1241,7 +1243,7 @@
           <a:p>
             <a:fld id="{253B1B7A-19D7-47DD-996A-6E83BE59A4F5}" type="datetimeFigureOut">
               <a:rPr lang="fr-FR" smtClean="0"/>
-              <a:t>25/01/2026</a:t>
+              <a:t>30/01/2026</a:t>
             </a:fld>
             <a:endParaRPr lang="fr-FR"/>
           </a:p>
@@ -1608,7 +1610,7 @@
           <a:p>
             <a:fld id="{253B1B7A-19D7-47DD-996A-6E83BE59A4F5}" type="datetimeFigureOut">
               <a:rPr lang="fr-FR" smtClean="0"/>
-              <a:t>25/01/2026</a:t>
+              <a:t>30/01/2026</a:t>
             </a:fld>
             <a:endParaRPr lang="fr-FR"/>
           </a:p>
@@ -1726,7 +1728,7 @@
           <a:p>
             <a:fld id="{253B1B7A-19D7-47DD-996A-6E83BE59A4F5}" type="datetimeFigureOut">
               <a:rPr lang="fr-FR" smtClean="0"/>
-              <a:t>25/01/2026</a:t>
+              <a:t>30/01/2026</a:t>
             </a:fld>
             <a:endParaRPr lang="fr-FR"/>
           </a:p>
@@ -1821,7 +1823,7 @@
           <a:p>
             <a:fld id="{253B1B7A-19D7-47DD-996A-6E83BE59A4F5}" type="datetimeFigureOut">
               <a:rPr lang="fr-FR" smtClean="0"/>
-              <a:t>25/01/2026</a:t>
+              <a:t>30/01/2026</a:t>
             </a:fld>
             <a:endParaRPr lang="fr-FR"/>
           </a:p>
@@ -2098,7 +2100,7 @@
           <a:p>
             <a:fld id="{253B1B7A-19D7-47DD-996A-6E83BE59A4F5}" type="datetimeFigureOut">
               <a:rPr lang="fr-FR" smtClean="0"/>
-              <a:t>25/01/2026</a:t>
+              <a:t>30/01/2026</a:t>
             </a:fld>
             <a:endParaRPr lang="fr-FR"/>
           </a:p>
@@ -2351,7 +2353,7 @@
           <a:p>
             <a:fld id="{253B1B7A-19D7-47DD-996A-6E83BE59A4F5}" type="datetimeFigureOut">
               <a:rPr lang="fr-FR" smtClean="0"/>
-              <a:t>25/01/2026</a:t>
+              <a:t>30/01/2026</a:t>
             </a:fld>
             <a:endParaRPr lang="fr-FR"/>
           </a:p>
@@ -2564,7 +2566,7 @@
           <a:p>
             <a:fld id="{253B1B7A-19D7-47DD-996A-6E83BE59A4F5}" type="datetimeFigureOut">
               <a:rPr lang="fr-FR" smtClean="0"/>
-              <a:t>25/01/2026</a:t>
+              <a:t>30/01/2026</a:t>
             </a:fld>
             <a:endParaRPr lang="fr-FR"/>
           </a:p>
@@ -3941,6 +3943,4754 @@
 </p:sld>
 </file>
 
+<file path=ppt/slides/slide2.xml><?xml version="1.0" encoding="utf-8"?>
+<p:sld xmlns:a="http://schemas.openxmlformats.org/drawingml/2006/main" xmlns:r="http://schemas.openxmlformats.org/officeDocument/2006/relationships" xmlns:p="http://schemas.openxmlformats.org/presentationml/2006/main">
+  <p:cSld>
+    <p:spTree>
+      <p:nvGrpSpPr>
+        <p:cNvPr id="1" name=""/>
+        <p:cNvGrpSpPr/>
+        <p:nvPr/>
+      </p:nvGrpSpPr>
+      <p:grpSpPr>
+        <a:xfrm>
+          <a:off x="0" y="0"/>
+          <a:ext cx="0" cy="0"/>
+          <a:chOff x="0" y="0"/>
+          <a:chExt cx="0" cy="0"/>
+        </a:xfrm>
+      </p:grpSpPr>
+      <p:sp>
+        <p:nvSpPr>
+          <p:cNvPr id="4" name="Rectangle 3"/>
+          <p:cNvSpPr/>
+          <p:nvPr/>
+        </p:nvSpPr>
+        <p:spPr>
+          <a:xfrm>
+            <a:off x="263236" y="415636"/>
+            <a:ext cx="2743200" cy="5846619"/>
+          </a:xfrm>
+          <a:prstGeom prst="rect">
+            <a:avLst/>
+          </a:prstGeom>
+          <a:noFill/>
+        </p:spPr>
+        <p:style>
+          <a:lnRef idx="2">
+            <a:schemeClr val="accent1">
+              <a:shade val="50000"/>
+            </a:schemeClr>
+          </a:lnRef>
+          <a:fillRef idx="1">
+            <a:schemeClr val="accent1"/>
+          </a:fillRef>
+          <a:effectRef idx="0">
+            <a:schemeClr val="accent1"/>
+          </a:effectRef>
+          <a:fontRef idx="minor">
+            <a:schemeClr val="lt1"/>
+          </a:fontRef>
+        </p:style>
+        <p:txBody>
+          <a:bodyPr rtlCol="0" anchor="ctr"/>
+          <a:lstStyle/>
+          <a:p>
+            <a:pPr algn="ctr"/>
+            <a:endParaRPr lang="fr-FR" dirty="0"/>
+          </a:p>
+        </p:txBody>
+      </p:sp>
+      <p:sp>
+        <p:nvSpPr>
+          <p:cNvPr id="5" name="Rectangle 4"/>
+          <p:cNvSpPr/>
+          <p:nvPr/>
+        </p:nvSpPr>
+        <p:spPr>
+          <a:xfrm>
+            <a:off x="3325091" y="415636"/>
+            <a:ext cx="8132618" cy="5846619"/>
+          </a:xfrm>
+          <a:prstGeom prst="rect">
+            <a:avLst/>
+          </a:prstGeom>
+          <a:noFill/>
+        </p:spPr>
+        <p:style>
+          <a:lnRef idx="2">
+            <a:schemeClr val="accent1">
+              <a:shade val="50000"/>
+            </a:schemeClr>
+          </a:lnRef>
+          <a:fillRef idx="1">
+            <a:schemeClr val="accent1"/>
+          </a:fillRef>
+          <a:effectRef idx="0">
+            <a:schemeClr val="accent1"/>
+          </a:effectRef>
+          <a:fontRef idx="minor">
+            <a:schemeClr val="lt1"/>
+          </a:fontRef>
+        </p:style>
+        <p:txBody>
+          <a:bodyPr rtlCol="0" anchor="ctr"/>
+          <a:lstStyle/>
+          <a:p>
+            <a:pPr algn="ctr"/>
+            <a:endParaRPr lang="fr-FR"/>
+          </a:p>
+        </p:txBody>
+      </p:sp>
+      <p:sp>
+        <p:nvSpPr>
+          <p:cNvPr id="10" name="ZoneTexte 9"/>
+          <p:cNvSpPr txBox="1"/>
+          <p:nvPr/>
+        </p:nvSpPr>
+        <p:spPr>
+          <a:xfrm>
+            <a:off x="583519" y="46304"/>
+            <a:ext cx="1037463" cy="369332"/>
+          </a:xfrm>
+          <a:prstGeom prst="rect">
+            <a:avLst/>
+          </a:prstGeom>
+          <a:noFill/>
+        </p:spPr>
+        <p:txBody>
+          <a:bodyPr wrap="none" rtlCol="0">
+            <a:spAutoFit/>
+          </a:bodyPr>
+          <a:lstStyle/>
+          <a:p>
+            <a:r>
+              <a:rPr lang="fr-FR" dirty="0" smtClean="0"/>
+              <a:t>Variables</a:t>
+            </a:r>
+            <a:endParaRPr lang="fr-FR" dirty="0"/>
+          </a:p>
+        </p:txBody>
+      </p:sp>
+      <p:sp>
+        <p:nvSpPr>
+          <p:cNvPr id="11" name="ZoneTexte 10"/>
+          <p:cNvSpPr txBox="1"/>
+          <p:nvPr/>
+        </p:nvSpPr>
+        <p:spPr>
+          <a:xfrm>
+            <a:off x="3548392" y="23153"/>
+            <a:ext cx="1092030" cy="369332"/>
+          </a:xfrm>
+          <a:prstGeom prst="rect">
+            <a:avLst/>
+          </a:prstGeom>
+          <a:noFill/>
+        </p:spPr>
+        <p:txBody>
+          <a:bodyPr wrap="none" rtlCol="0">
+            <a:spAutoFit/>
+          </a:bodyPr>
+          <a:lstStyle/>
+          <a:p>
+            <a:r>
+              <a:rPr lang="fr-FR" dirty="0" smtClean="0"/>
+              <a:t>Fonctions</a:t>
+            </a:r>
+            <a:endParaRPr lang="fr-FR" dirty="0"/>
+          </a:p>
+        </p:txBody>
+      </p:sp>
+      <p:sp>
+        <p:nvSpPr>
+          <p:cNvPr id="22" name="Rectangle 21"/>
+          <p:cNvSpPr/>
+          <p:nvPr/>
+        </p:nvSpPr>
+        <p:spPr>
+          <a:xfrm>
+            <a:off x="371423" y="784968"/>
+            <a:ext cx="2556374" cy="4485736"/>
+          </a:xfrm>
+          <a:prstGeom prst="rect">
+            <a:avLst/>
+          </a:prstGeom>
+          <a:solidFill>
+            <a:schemeClr val="accent2">
+              <a:lumMod val="40000"/>
+              <a:lumOff val="60000"/>
+            </a:schemeClr>
+          </a:solidFill>
+        </p:spPr>
+        <p:style>
+          <a:lnRef idx="2">
+            <a:schemeClr val="accent1">
+              <a:shade val="50000"/>
+            </a:schemeClr>
+          </a:lnRef>
+          <a:fillRef idx="1">
+            <a:schemeClr val="accent1"/>
+          </a:fillRef>
+          <a:effectRef idx="0">
+            <a:schemeClr val="accent1"/>
+          </a:effectRef>
+          <a:fontRef idx="minor">
+            <a:schemeClr val="lt1"/>
+          </a:fontRef>
+        </p:style>
+        <p:txBody>
+          <a:bodyPr rtlCol="0" anchor="ctr"/>
+          <a:lstStyle/>
+          <a:p>
+            <a:pPr algn="ctr"/>
+            <a:endParaRPr lang="fr-FR" dirty="0">
+              <a:solidFill>
+                <a:schemeClr val="tx1"/>
+              </a:solidFill>
+            </a:endParaRPr>
+          </a:p>
+        </p:txBody>
+      </p:sp>
+      <p:sp>
+        <p:nvSpPr>
+          <p:cNvPr id="2" name="ZoneTexte 1"/>
+          <p:cNvSpPr txBox="1"/>
+          <p:nvPr/>
+        </p:nvSpPr>
+        <p:spPr>
+          <a:xfrm>
+            <a:off x="3548392" y="415636"/>
+            <a:ext cx="6276109" cy="4154984"/>
+          </a:xfrm>
+          <a:prstGeom prst="rect">
+            <a:avLst/>
+          </a:prstGeom>
+          <a:noFill/>
+        </p:spPr>
+        <p:txBody>
+          <a:bodyPr wrap="square" rtlCol="0">
+            <a:spAutoFit/>
+          </a:bodyPr>
+          <a:lstStyle/>
+          <a:p>
+            <a:r>
+              <a:rPr lang="fr-FR" sz="1200" b="1" dirty="0" err="1" smtClean="0"/>
+              <a:t>Metadata</a:t>
+            </a:r>
+            <a:endParaRPr lang="fr-FR" sz="1200" b="1" dirty="0" smtClean="0"/>
+          </a:p>
+          <a:p>
+            <a:r>
+              <a:rPr lang="fr-FR" sz="1200" dirty="0"/>
+              <a:t>	"</a:t>
+            </a:r>
+            <a:r>
+              <a:rPr lang="fr-FR" sz="1200" dirty="0" err="1"/>
+              <a:t>vv_vva</a:t>
+            </a:r>
+            <a:r>
+              <a:rPr lang="fr-FR" sz="1200" dirty="0"/>
+              <a:t>" : </a:t>
+            </a:r>
+          </a:p>
+          <a:p>
+            <a:pPr lvl="2"/>
+            <a:r>
+              <a:rPr lang="fr-FR" sz="1200" dirty="0"/>
+              <a:t>"</a:t>
+            </a:r>
+            <a:r>
+              <a:rPr lang="fr-FR" sz="1200" dirty="0" err="1"/>
+              <a:t>vv_sn</a:t>
+            </a:r>
+            <a:r>
+              <a:rPr lang="fr-FR" sz="1200" dirty="0"/>
+              <a:t>" </a:t>
+            </a:r>
+            <a:r>
+              <a:rPr lang="fr-FR" sz="1200" dirty="0" smtClean="0"/>
+              <a:t>:,</a:t>
+            </a:r>
+            <a:endParaRPr lang="fr-FR" sz="1200" dirty="0"/>
+          </a:p>
+          <a:p>
+            <a:pPr lvl="2"/>
+            <a:r>
+              <a:rPr lang="fr-FR" sz="1200" dirty="0"/>
+              <a:t>"</a:t>
+            </a:r>
+            <a:r>
+              <a:rPr lang="fr-FR" sz="1200" dirty="0" err="1"/>
+              <a:t>vv_hw</a:t>
+            </a:r>
+            <a:r>
+              <a:rPr lang="fr-FR" sz="1200" dirty="0"/>
+              <a:t>" : </a:t>
+            </a:r>
+            <a:endParaRPr lang="fr-FR" sz="1200" dirty="0" smtClean="0"/>
+          </a:p>
+          <a:p>
+            <a:pPr lvl="2"/>
+            <a:r>
+              <a:rPr lang="fr-FR" sz="1200" dirty="0" smtClean="0"/>
+              <a:t>"</a:t>
+            </a:r>
+            <a:r>
+              <a:rPr lang="fr-FR" sz="1200" dirty="0" err="1"/>
+              <a:t>vv_fw</a:t>
+            </a:r>
+            <a:r>
+              <a:rPr lang="fr-FR" sz="1200" dirty="0"/>
+              <a:t>" </a:t>
+            </a:r>
+            <a:r>
+              <a:rPr lang="fr-FR" sz="1200" dirty="0" smtClean="0"/>
+              <a:t>:</a:t>
+            </a:r>
+            <a:endParaRPr lang="fr-FR" sz="1200" dirty="0"/>
+          </a:p>
+          <a:p>
+            <a:pPr lvl="2"/>
+            <a:r>
+              <a:rPr lang="fr-FR" sz="1200" dirty="0"/>
+              <a:t>"</a:t>
+            </a:r>
+            <a:r>
+              <a:rPr lang="fr-FR" sz="1200" dirty="0" err="1"/>
+              <a:t>calib</a:t>
+            </a:r>
+            <a:r>
+              <a:rPr lang="fr-FR" sz="1200" dirty="0"/>
+              <a:t>" </a:t>
+            </a:r>
+            <a:r>
+              <a:rPr lang="fr-FR" sz="1200" dirty="0" smtClean="0"/>
+              <a:t>:</a:t>
+            </a:r>
+            <a:endParaRPr lang="fr-FR" sz="1200" dirty="0"/>
+          </a:p>
+          <a:p>
+            <a:pPr lvl="2"/>
+            <a:r>
+              <a:rPr lang="fr-FR" sz="1200" dirty="0"/>
+              <a:t>"pilot" : </a:t>
+            </a:r>
+            <a:r>
+              <a:rPr lang="fr-FR" sz="1200" dirty="0" smtClean="0"/>
+              <a:t>,</a:t>
+            </a:r>
+            <a:endParaRPr lang="fr-FR" sz="1200" dirty="0"/>
+          </a:p>
+          <a:p>
+            <a:pPr lvl="2"/>
+            <a:r>
+              <a:rPr lang="fr-FR" sz="1200" dirty="0"/>
+              <a:t>"date" </a:t>
+            </a:r>
+            <a:r>
+              <a:rPr lang="fr-FR" sz="1200" dirty="0" smtClean="0"/>
+              <a:t>:,</a:t>
+            </a:r>
+            <a:endParaRPr lang="fr-FR" sz="1200" dirty="0"/>
+          </a:p>
+          <a:p>
+            <a:pPr lvl="2"/>
+            <a:r>
+              <a:rPr lang="fr-FR" sz="1200" dirty="0"/>
+              <a:t>"</a:t>
+            </a:r>
+            <a:r>
+              <a:rPr lang="fr-FR" sz="1200" dirty="0" err="1"/>
+              <a:t>hour</a:t>
+            </a:r>
+            <a:r>
+              <a:rPr lang="fr-FR" sz="1200" dirty="0"/>
+              <a:t>" : </a:t>
+            </a:r>
+            <a:r>
+              <a:rPr lang="fr-FR" sz="1200" dirty="0" smtClean="0"/>
+              <a:t>,</a:t>
+            </a:r>
+            <a:endParaRPr lang="fr-FR" sz="1200" dirty="0"/>
+          </a:p>
+          <a:p>
+            <a:pPr lvl="2"/>
+            <a:r>
+              <a:rPr lang="fr-FR" sz="1200" dirty="0"/>
+              <a:t>"</a:t>
+            </a:r>
+            <a:r>
+              <a:rPr lang="fr-FR" sz="1200" dirty="0" err="1"/>
+              <a:t>altitude_max</a:t>
+            </a:r>
+            <a:r>
+              <a:rPr lang="fr-FR" sz="1200" dirty="0"/>
+              <a:t>" </a:t>
+            </a:r>
+            <a:r>
+              <a:rPr lang="fr-FR" sz="1200" dirty="0" smtClean="0"/>
+              <a:t>:,</a:t>
+            </a:r>
+            <a:endParaRPr lang="fr-FR" sz="1200" dirty="0"/>
+          </a:p>
+          <a:p>
+            <a:pPr lvl="2"/>
+            <a:r>
+              <a:rPr lang="fr-FR" sz="1200" dirty="0"/>
+              <a:t>"</a:t>
+            </a:r>
+            <a:r>
+              <a:rPr lang="fr-FR" sz="1200" dirty="0" err="1"/>
+              <a:t>altitude_min</a:t>
+            </a:r>
+            <a:r>
+              <a:rPr lang="fr-FR" sz="1200" dirty="0"/>
+              <a:t>" </a:t>
+            </a:r>
+            <a:r>
+              <a:rPr lang="fr-FR" sz="1200" dirty="0" smtClean="0"/>
+              <a:t>:, </a:t>
+            </a:r>
+            <a:endParaRPr lang="fr-FR" sz="1200" dirty="0"/>
+          </a:p>
+          <a:p>
+            <a:pPr lvl="2"/>
+            <a:r>
+              <a:rPr lang="fr-FR" sz="1200" dirty="0"/>
+              <a:t>"</a:t>
+            </a:r>
+            <a:r>
+              <a:rPr lang="fr-FR" sz="1200" dirty="0" err="1"/>
+              <a:t>altitude_start</a:t>
+            </a:r>
+            <a:r>
+              <a:rPr lang="fr-FR" sz="1200" dirty="0"/>
+              <a:t>" </a:t>
+            </a:r>
+            <a:r>
+              <a:rPr lang="fr-FR" sz="1200" dirty="0" smtClean="0"/>
+              <a:t>:,</a:t>
+            </a:r>
+            <a:endParaRPr lang="fr-FR" sz="1200" dirty="0"/>
+          </a:p>
+          <a:p>
+            <a:pPr lvl="2"/>
+            <a:r>
+              <a:rPr lang="fr-FR" sz="1200" dirty="0"/>
+              <a:t>"</a:t>
+            </a:r>
+            <a:r>
+              <a:rPr lang="fr-FR" sz="1200" dirty="0" err="1"/>
+              <a:t>avg_windspeed</a:t>
+            </a:r>
+            <a:r>
+              <a:rPr lang="fr-FR" sz="1200" dirty="0"/>
+              <a:t>" </a:t>
+            </a:r>
+            <a:r>
+              <a:rPr lang="fr-FR" sz="1200" dirty="0" smtClean="0"/>
+              <a:t>:,</a:t>
+            </a:r>
+            <a:endParaRPr lang="fr-FR" sz="1200" dirty="0"/>
+          </a:p>
+          <a:p>
+            <a:pPr lvl="2"/>
+            <a:r>
+              <a:rPr lang="fr-FR" sz="1200" dirty="0"/>
+              <a:t>"</a:t>
+            </a:r>
+            <a:r>
+              <a:rPr lang="fr-FR" sz="1200" dirty="0" err="1"/>
+              <a:t>avg_winddir</a:t>
+            </a:r>
+            <a:r>
+              <a:rPr lang="fr-FR" sz="1200" dirty="0"/>
+              <a:t>" : </a:t>
+            </a:r>
+          </a:p>
+          <a:p>
+            <a:pPr lvl="2"/>
+            <a:r>
+              <a:rPr lang="fr-FR" sz="1200" dirty="0"/>
+              <a:t>"comment" : </a:t>
+            </a:r>
+            <a:endParaRPr lang="fr-FR" sz="1200" dirty="0" smtClean="0"/>
+          </a:p>
+          <a:p>
+            <a:r>
+              <a:rPr lang="fr-FR" sz="1200" b="1" dirty="0" err="1" smtClean="0"/>
+              <a:t>raw_data</a:t>
+            </a:r>
+            <a:endParaRPr lang="fr-FR" sz="1200" b="1" dirty="0" smtClean="0"/>
+          </a:p>
+          <a:p>
+            <a:r>
+              <a:rPr lang="fr-FR" sz="1200" b="1" dirty="0"/>
+              <a:t>	</a:t>
+            </a:r>
+            <a:endParaRPr lang="fr-FR" sz="1200" b="1" dirty="0" smtClean="0"/>
+          </a:p>
+          <a:p>
+            <a:r>
+              <a:rPr lang="fr-FR" sz="1200" b="1" dirty="0" err="1" smtClean="0"/>
+              <a:t>processed_data</a:t>
+            </a:r>
+            <a:endParaRPr lang="fr-FR" sz="1200" b="1" dirty="0" smtClean="0"/>
+          </a:p>
+          <a:p>
+            <a:r>
+              <a:rPr lang="fr-FR" sz="1200" b="1" dirty="0" err="1" smtClean="0"/>
+              <a:t>file_path</a:t>
+            </a:r>
+            <a:endParaRPr lang="fr-FR" sz="1200" b="1" dirty="0"/>
+          </a:p>
+          <a:p>
+            <a:r>
+              <a:rPr lang="fr-FR" sz="1200" b="1" dirty="0" err="1" smtClean="0"/>
+              <a:t>file_name</a:t>
+            </a:r>
+            <a:endParaRPr lang="fr-FR" sz="1200" b="1" dirty="0" smtClean="0"/>
+          </a:p>
+          <a:p>
+            <a:r>
+              <a:rPr lang="fr-FR" sz="1200" b="1" dirty="0" err="1" smtClean="0"/>
+              <a:t>origin_file_path</a:t>
+            </a:r>
+            <a:endParaRPr lang="fr-FR" sz="1200" b="1" dirty="0" smtClean="0"/>
+          </a:p>
+          <a:p>
+            <a:r>
+              <a:rPr lang="fr-FR" sz="1200" b="1" dirty="0" err="1" smtClean="0"/>
+              <a:t>is_active</a:t>
+            </a:r>
+            <a:r>
+              <a:rPr lang="fr-FR" sz="1200" b="1" dirty="0" smtClean="0"/>
+              <a:t> </a:t>
+            </a:r>
+            <a:endParaRPr lang="fr-FR" sz="1200" b="1" dirty="0"/>
+          </a:p>
+        </p:txBody>
+      </p:sp>
+    </p:spTree>
+    <p:extLst>
+      <p:ext uri="{BB962C8B-B14F-4D97-AF65-F5344CB8AC3E}">
+        <p14:creationId xmlns:p14="http://schemas.microsoft.com/office/powerpoint/2010/main" val="3726120774"/>
+      </p:ext>
+    </p:extLst>
+  </p:cSld>
+  <p:clrMapOvr>
+    <a:masterClrMapping/>
+  </p:clrMapOvr>
+</p:sld>
+</file>
+
+<file path=ppt/slides/slide3.xml><?xml version="1.0" encoding="utf-8"?>
+<p:sld xmlns:a="http://schemas.openxmlformats.org/drawingml/2006/main" xmlns:r="http://schemas.openxmlformats.org/officeDocument/2006/relationships" xmlns:p="http://schemas.openxmlformats.org/presentationml/2006/main">
+  <p:cSld>
+    <p:spTree>
+      <p:nvGrpSpPr>
+        <p:cNvPr id="1" name=""/>
+        <p:cNvGrpSpPr/>
+        <p:nvPr/>
+      </p:nvGrpSpPr>
+      <p:grpSpPr>
+        <a:xfrm>
+          <a:off x="0" y="0"/>
+          <a:ext cx="0" cy="0"/>
+          <a:chOff x="0" y="0"/>
+          <a:chExt cx="0" cy="0"/>
+        </a:xfrm>
+      </p:grpSpPr>
+      <p:sp>
+        <p:nvSpPr>
+          <p:cNvPr id="4" name="Rectangle 3"/>
+          <p:cNvSpPr/>
+          <p:nvPr/>
+        </p:nvSpPr>
+        <p:spPr>
+          <a:xfrm>
+            <a:off x="1039091" y="803564"/>
+            <a:ext cx="2770909" cy="5527963"/>
+          </a:xfrm>
+          <a:prstGeom prst="rect">
+            <a:avLst/>
+          </a:prstGeom>
+        </p:spPr>
+        <p:style>
+          <a:lnRef idx="2">
+            <a:schemeClr val="accent1">
+              <a:shade val="50000"/>
+            </a:schemeClr>
+          </a:lnRef>
+          <a:fillRef idx="1">
+            <a:schemeClr val="accent1"/>
+          </a:fillRef>
+          <a:effectRef idx="0">
+            <a:schemeClr val="accent1"/>
+          </a:effectRef>
+          <a:fontRef idx="minor">
+            <a:schemeClr val="lt1"/>
+          </a:fontRef>
+        </p:style>
+        <p:txBody>
+          <a:bodyPr rtlCol="0" anchor="ctr"/>
+          <a:lstStyle/>
+          <a:p>
+            <a:pPr algn="ctr"/>
+            <a:endParaRPr lang="fr-FR" dirty="0"/>
+          </a:p>
+        </p:txBody>
+      </p:sp>
+      <p:sp>
+        <p:nvSpPr>
+          <p:cNvPr id="5" name="Rectangle 4"/>
+          <p:cNvSpPr/>
+          <p:nvPr/>
+        </p:nvSpPr>
+        <p:spPr>
+          <a:xfrm>
+            <a:off x="4433454" y="803563"/>
+            <a:ext cx="2770909" cy="5527963"/>
+          </a:xfrm>
+          <a:prstGeom prst="rect">
+            <a:avLst/>
+          </a:prstGeom>
+          <a:solidFill>
+            <a:schemeClr val="accent4">
+              <a:lumMod val="40000"/>
+              <a:lumOff val="60000"/>
+            </a:schemeClr>
+          </a:solidFill>
+        </p:spPr>
+        <p:style>
+          <a:lnRef idx="2">
+            <a:schemeClr val="accent1">
+              <a:shade val="50000"/>
+            </a:schemeClr>
+          </a:lnRef>
+          <a:fillRef idx="1">
+            <a:schemeClr val="accent1"/>
+          </a:fillRef>
+          <a:effectRef idx="0">
+            <a:schemeClr val="accent1"/>
+          </a:effectRef>
+          <a:fontRef idx="minor">
+            <a:schemeClr val="lt1"/>
+          </a:fontRef>
+        </p:style>
+        <p:txBody>
+          <a:bodyPr rtlCol="0" anchor="ctr"/>
+          <a:lstStyle/>
+          <a:p>
+            <a:pPr algn="ctr"/>
+            <a:endParaRPr lang="fr-FR"/>
+          </a:p>
+        </p:txBody>
+      </p:sp>
+      <p:sp>
+        <p:nvSpPr>
+          <p:cNvPr id="6" name="Rectangle 5"/>
+          <p:cNvSpPr/>
+          <p:nvPr/>
+        </p:nvSpPr>
+        <p:spPr>
+          <a:xfrm>
+            <a:off x="8105197" y="782780"/>
+            <a:ext cx="2770909" cy="5527963"/>
+          </a:xfrm>
+          <a:prstGeom prst="rect">
+            <a:avLst/>
+          </a:prstGeom>
+          <a:solidFill>
+            <a:schemeClr val="accent6">
+              <a:lumMod val="40000"/>
+              <a:lumOff val="60000"/>
+            </a:schemeClr>
+          </a:solidFill>
+        </p:spPr>
+        <p:style>
+          <a:lnRef idx="2">
+            <a:schemeClr val="accent1">
+              <a:shade val="50000"/>
+            </a:schemeClr>
+          </a:lnRef>
+          <a:fillRef idx="1">
+            <a:schemeClr val="accent1"/>
+          </a:fillRef>
+          <a:effectRef idx="0">
+            <a:schemeClr val="accent1"/>
+          </a:effectRef>
+          <a:fontRef idx="minor">
+            <a:schemeClr val="lt1"/>
+          </a:fontRef>
+        </p:style>
+        <p:txBody>
+          <a:bodyPr rtlCol="0" anchor="ctr"/>
+          <a:lstStyle/>
+          <a:p>
+            <a:pPr algn="ctr"/>
+            <a:endParaRPr lang="fr-FR"/>
+          </a:p>
+        </p:txBody>
+      </p:sp>
+      <p:sp>
+        <p:nvSpPr>
+          <p:cNvPr id="7" name="ZoneTexte 6"/>
+          <p:cNvSpPr txBox="1"/>
+          <p:nvPr/>
+        </p:nvSpPr>
+        <p:spPr>
+          <a:xfrm>
+            <a:off x="2063715" y="157230"/>
+            <a:ext cx="787167" cy="646331"/>
+          </a:xfrm>
+          <a:prstGeom prst="rect">
+            <a:avLst/>
+          </a:prstGeom>
+          <a:noFill/>
+        </p:spPr>
+        <p:txBody>
+          <a:bodyPr wrap="square" rtlCol="0">
+            <a:spAutoFit/>
+          </a:bodyPr>
+          <a:lstStyle/>
+          <a:p>
+            <a:r>
+              <a:rPr lang="fr-FR" dirty="0" smtClean="0"/>
+              <a:t>IGC+</a:t>
+            </a:r>
+          </a:p>
+          <a:p>
+            <a:r>
+              <a:rPr lang="fr-FR" dirty="0" err="1" smtClean="0"/>
+              <a:t>igc</a:t>
+            </a:r>
+            <a:endParaRPr lang="fr-FR" dirty="0"/>
+          </a:p>
+        </p:txBody>
+      </p:sp>
+      <p:sp>
+        <p:nvSpPr>
+          <p:cNvPr id="8" name="ZoneTexte 7"/>
+          <p:cNvSpPr txBox="1"/>
+          <p:nvPr/>
+        </p:nvSpPr>
+        <p:spPr>
+          <a:xfrm>
+            <a:off x="5334288" y="227778"/>
+            <a:ext cx="969240" cy="646331"/>
+          </a:xfrm>
+          <a:prstGeom prst="rect">
+            <a:avLst/>
+          </a:prstGeom>
+          <a:noFill/>
+        </p:spPr>
+        <p:txBody>
+          <a:bodyPr wrap="none" rtlCol="0">
+            <a:spAutoFit/>
+          </a:bodyPr>
+          <a:lstStyle/>
+          <a:p>
+            <a:r>
+              <a:rPr lang="fr-FR" dirty="0" smtClean="0"/>
+              <a:t>LOGPRO</a:t>
+            </a:r>
+          </a:p>
+          <a:p>
+            <a:r>
+              <a:rPr lang="fr-FR" dirty="0" smtClean="0"/>
+              <a:t>csv</a:t>
+            </a:r>
+            <a:endParaRPr lang="fr-FR" dirty="0"/>
+          </a:p>
+        </p:txBody>
+      </p:sp>
+      <p:sp>
+        <p:nvSpPr>
+          <p:cNvPr id="9" name="ZoneTexte 8"/>
+          <p:cNvSpPr txBox="1"/>
+          <p:nvPr/>
+        </p:nvSpPr>
+        <p:spPr>
+          <a:xfrm>
+            <a:off x="8739652" y="413448"/>
+            <a:ext cx="1362874" cy="369332"/>
+          </a:xfrm>
+          <a:prstGeom prst="rect">
+            <a:avLst/>
+          </a:prstGeom>
+          <a:noFill/>
+        </p:spPr>
+        <p:txBody>
+          <a:bodyPr wrap="none" rtlCol="0">
+            <a:spAutoFit/>
+          </a:bodyPr>
+          <a:lstStyle/>
+          <a:p>
+            <a:r>
+              <a:rPr lang="fr-FR" dirty="0" smtClean="0"/>
+              <a:t>ADDITIONAL</a:t>
+            </a:r>
+            <a:endParaRPr lang="fr-FR" dirty="0"/>
+          </a:p>
+        </p:txBody>
+      </p:sp>
+      <p:graphicFrame>
+        <p:nvGraphicFramePr>
+          <p:cNvPr id="10" name="Tableau 9"/>
+          <p:cNvGraphicFramePr>
+            <a:graphicFrameLocks noGrp="1"/>
+          </p:cNvGraphicFramePr>
+          <p:nvPr>
+            <p:extLst>
+              <p:ext uri="{D42A27DB-BD31-4B8C-83A1-F6EECF244321}">
+                <p14:modId xmlns:p14="http://schemas.microsoft.com/office/powerpoint/2010/main" val="4001750398"/>
+              </p:ext>
+            </p:extLst>
+          </p:nvPr>
+        </p:nvGraphicFramePr>
+        <p:xfrm>
+          <a:off x="1111215" y="874109"/>
+          <a:ext cx="952500" cy="3870960"/>
+        </p:xfrm>
+        <a:graphic>
+          <a:graphicData uri="http://schemas.openxmlformats.org/drawingml/2006/table">
+            <a:tbl>
+              <a:tblPr/>
+              <a:tblGrid>
+                <a:gridCol w="952500">
+                  <a:extLst>
+                    <a:ext uri="{9D8B030D-6E8A-4147-A177-3AD203B41FA5}">
+                      <a16:colId xmlns:a16="http://schemas.microsoft.com/office/drawing/2014/main" val="1233900184"/>
+                    </a:ext>
+                  </a:extLst>
+                </a:gridCol>
+              </a:tblGrid>
+              <a:tr h="0">
+                <a:tc>
+                  <a:txBody>
+                    <a:bodyPr/>
+                    <a:lstStyle/>
+                    <a:p>
+                      <a:pPr rtl="0" fontAlgn="t">
+                        <a:spcBef>
+                          <a:spcPts val="0"/>
+                        </a:spcBef>
+                        <a:spcAft>
+                          <a:spcPts val="0"/>
+                        </a:spcAft>
+                      </a:pPr>
+                      <a:r>
+                        <a:rPr lang="fr-FR" sz="1100" b="1" i="0" u="none" strike="noStrike" dirty="0">
+                          <a:solidFill>
+                            <a:srgbClr val="000000"/>
+                          </a:solidFill>
+                          <a:effectLst/>
+                          <a:latin typeface="Arial" panose="020B0604020202020204" pitchFamily="34" charset="0"/>
+                        </a:rPr>
+                        <a:t>Time</a:t>
+                      </a:r>
+                      <a:endParaRPr lang="fr-FR" dirty="0">
+                        <a:effectLst/>
+                      </a:endParaRPr>
+                    </a:p>
+                  </a:txBody>
+                  <a:tcPr marL="63500" marR="63500" marT="63500" marB="63500">
+                    <a:lnL w="12700" cap="flat" cmpd="sng" algn="ctr">
+                      <a:solidFill>
+                        <a:srgbClr val="000000"/>
+                      </a:solidFill>
+                      <a:prstDash val="solid"/>
+                      <a:round/>
+                      <a:headEnd type="none" w="med" len="med"/>
+                      <a:tailEnd type="none" w="med" len="med"/>
+                    </a:lnL>
+                    <a:lnR w="12700" cap="flat" cmpd="sng" algn="ctr">
+                      <a:solidFill>
+                        <a:srgbClr val="000000"/>
+                      </a:solidFill>
+                      <a:prstDash val="solid"/>
+                      <a:round/>
+                      <a:headEnd type="none" w="med" len="med"/>
+                      <a:tailEnd type="none" w="med" len="med"/>
+                    </a:lnR>
+                    <a:lnT w="12700" cap="flat" cmpd="sng" algn="ctr">
+                      <a:solidFill>
+                        <a:srgbClr val="000000"/>
+                      </a:solidFill>
+                      <a:prstDash val="solid"/>
+                      <a:round/>
+                      <a:headEnd type="none" w="med" len="med"/>
+                      <a:tailEnd type="none" w="med" len="med"/>
+                    </a:lnT>
+                    <a:lnB w="12700" cap="flat" cmpd="sng" algn="ctr">
+                      <a:solidFill>
+                        <a:srgbClr val="000000"/>
+                      </a:solidFill>
+                      <a:prstDash val="solid"/>
+                      <a:round/>
+                      <a:headEnd type="none" w="med" len="med"/>
+                      <a:tailEnd type="none" w="med" len="med"/>
+                    </a:lnB>
+                  </a:tcPr>
+                </a:tc>
+                <a:extLst>
+                  <a:ext uri="{0D108BD9-81ED-4DB2-BD59-A6C34878D82A}">
+                    <a16:rowId xmlns:a16="http://schemas.microsoft.com/office/drawing/2014/main" val="4062161006"/>
+                  </a:ext>
+                </a:extLst>
+              </a:tr>
+              <a:tr h="0">
+                <a:tc>
+                  <a:txBody>
+                    <a:bodyPr/>
+                    <a:lstStyle/>
+                    <a:p>
+                      <a:pPr rtl="0" fontAlgn="t">
+                        <a:spcBef>
+                          <a:spcPts val="0"/>
+                        </a:spcBef>
+                        <a:spcAft>
+                          <a:spcPts val="0"/>
+                        </a:spcAft>
+                      </a:pPr>
+                      <a:r>
+                        <a:rPr lang="fr-FR" sz="1100" b="1" i="0" u="none" strike="noStrike" dirty="0" err="1">
+                          <a:solidFill>
+                            <a:srgbClr val="000000"/>
+                          </a:solidFill>
+                          <a:effectLst/>
+                          <a:latin typeface="Arial" panose="020B0604020202020204" pitchFamily="34" charset="0"/>
+                        </a:rPr>
+                        <a:t>Lat</a:t>
+                      </a:r>
+                      <a:endParaRPr lang="fr-FR" dirty="0">
+                        <a:effectLst/>
+                      </a:endParaRPr>
+                    </a:p>
+                    <a:p>
+                      <a:pPr rtl="0" fontAlgn="t">
+                        <a:spcBef>
+                          <a:spcPts val="0"/>
+                        </a:spcBef>
+                        <a:spcAft>
+                          <a:spcPts val="0"/>
+                        </a:spcAft>
+                      </a:pPr>
+                      <a:r>
+                        <a:rPr lang="fr-FR" sz="1100" b="1" i="0" u="none" strike="noStrike" dirty="0" err="1">
+                          <a:solidFill>
+                            <a:srgbClr val="000000"/>
+                          </a:solidFill>
+                          <a:effectLst/>
+                          <a:latin typeface="Arial" panose="020B0604020202020204" pitchFamily="34" charset="0"/>
+                        </a:rPr>
+                        <a:t>Lon</a:t>
+                      </a:r>
+                      <a:endParaRPr lang="fr-FR" dirty="0">
+                        <a:effectLst/>
+                      </a:endParaRPr>
+                    </a:p>
+                  </a:txBody>
+                  <a:tcPr marL="63500" marR="63500" marT="63500" marB="63500">
+                    <a:lnL w="12700" cap="flat" cmpd="sng" algn="ctr">
+                      <a:solidFill>
+                        <a:srgbClr val="000000"/>
+                      </a:solidFill>
+                      <a:prstDash val="solid"/>
+                      <a:round/>
+                      <a:headEnd type="none" w="med" len="med"/>
+                      <a:tailEnd type="none" w="med" len="med"/>
+                    </a:lnL>
+                    <a:lnR w="12700" cap="flat" cmpd="sng" algn="ctr">
+                      <a:solidFill>
+                        <a:srgbClr val="000000"/>
+                      </a:solidFill>
+                      <a:prstDash val="solid"/>
+                      <a:round/>
+                      <a:headEnd type="none" w="med" len="med"/>
+                      <a:tailEnd type="none" w="med" len="med"/>
+                    </a:lnR>
+                    <a:lnT w="12700" cap="flat" cmpd="sng" algn="ctr">
+                      <a:solidFill>
+                        <a:srgbClr val="000000"/>
+                      </a:solidFill>
+                      <a:prstDash val="solid"/>
+                      <a:round/>
+                      <a:headEnd type="none" w="med" len="med"/>
+                      <a:tailEnd type="none" w="med" len="med"/>
+                    </a:lnT>
+                    <a:lnB w="12700" cap="flat" cmpd="sng" algn="ctr">
+                      <a:solidFill>
+                        <a:srgbClr val="000000"/>
+                      </a:solidFill>
+                      <a:prstDash val="solid"/>
+                      <a:round/>
+                      <a:headEnd type="none" w="med" len="med"/>
+                      <a:tailEnd type="none" w="med" len="med"/>
+                    </a:lnB>
+                  </a:tcPr>
+                </a:tc>
+                <a:extLst>
+                  <a:ext uri="{0D108BD9-81ED-4DB2-BD59-A6C34878D82A}">
+                    <a16:rowId xmlns:a16="http://schemas.microsoft.com/office/drawing/2014/main" val="3057342897"/>
+                  </a:ext>
+                </a:extLst>
+              </a:tr>
+              <a:tr h="0">
+                <a:tc>
+                  <a:txBody>
+                    <a:bodyPr/>
+                    <a:lstStyle/>
+                    <a:p>
+                      <a:pPr rtl="0" fontAlgn="t">
+                        <a:spcBef>
+                          <a:spcPts val="0"/>
+                        </a:spcBef>
+                        <a:spcAft>
+                          <a:spcPts val="0"/>
+                        </a:spcAft>
+                      </a:pPr>
+                      <a:r>
+                        <a:rPr lang="fr-FR" sz="1100" b="1" i="0" u="none" strike="noStrike" dirty="0" err="1">
+                          <a:solidFill>
+                            <a:srgbClr val="000000"/>
+                          </a:solidFill>
+                          <a:effectLst/>
+                          <a:latin typeface="Arial" panose="020B0604020202020204" pitchFamily="34" charset="0"/>
+                        </a:rPr>
+                        <a:t>Alt_GPS</a:t>
+                      </a:r>
+                      <a:endParaRPr lang="fr-FR" dirty="0">
+                        <a:effectLst/>
+                      </a:endParaRPr>
+                    </a:p>
+                  </a:txBody>
+                  <a:tcPr marL="63500" marR="63500" marT="63500" marB="63500">
+                    <a:lnL w="12700" cap="flat" cmpd="sng" algn="ctr">
+                      <a:solidFill>
+                        <a:srgbClr val="000000"/>
+                      </a:solidFill>
+                      <a:prstDash val="solid"/>
+                      <a:round/>
+                      <a:headEnd type="none" w="med" len="med"/>
+                      <a:tailEnd type="none" w="med" len="med"/>
+                    </a:lnL>
+                    <a:lnR w="12700" cap="flat" cmpd="sng" algn="ctr">
+                      <a:solidFill>
+                        <a:srgbClr val="000000"/>
+                      </a:solidFill>
+                      <a:prstDash val="solid"/>
+                      <a:round/>
+                      <a:headEnd type="none" w="med" len="med"/>
+                      <a:tailEnd type="none" w="med" len="med"/>
+                    </a:lnR>
+                    <a:lnT w="12700" cap="flat" cmpd="sng" algn="ctr">
+                      <a:solidFill>
+                        <a:srgbClr val="000000"/>
+                      </a:solidFill>
+                      <a:prstDash val="solid"/>
+                      <a:round/>
+                      <a:headEnd type="none" w="med" len="med"/>
+                      <a:tailEnd type="none" w="med" len="med"/>
+                    </a:lnT>
+                    <a:lnB w="12700" cap="flat" cmpd="sng" algn="ctr">
+                      <a:solidFill>
+                        <a:srgbClr val="000000"/>
+                      </a:solidFill>
+                      <a:prstDash val="solid"/>
+                      <a:round/>
+                      <a:headEnd type="none" w="med" len="med"/>
+                      <a:tailEnd type="none" w="med" len="med"/>
+                    </a:lnB>
+                  </a:tcPr>
+                </a:tc>
+                <a:extLst>
+                  <a:ext uri="{0D108BD9-81ED-4DB2-BD59-A6C34878D82A}">
+                    <a16:rowId xmlns:a16="http://schemas.microsoft.com/office/drawing/2014/main" val="3079033935"/>
+                  </a:ext>
+                </a:extLst>
+              </a:tr>
+              <a:tr h="0">
+                <a:tc>
+                  <a:txBody>
+                    <a:bodyPr/>
+                    <a:lstStyle/>
+                    <a:p>
+                      <a:pPr rtl="0" fontAlgn="t">
+                        <a:spcBef>
+                          <a:spcPts val="0"/>
+                        </a:spcBef>
+                        <a:spcAft>
+                          <a:spcPts val="0"/>
+                        </a:spcAft>
+                      </a:pPr>
+                      <a:r>
+                        <a:rPr lang="fr-FR" sz="1100" b="1" i="0" u="none" strike="noStrike" dirty="0">
+                          <a:solidFill>
+                            <a:srgbClr val="000000"/>
+                          </a:solidFill>
+                          <a:effectLst/>
+                          <a:latin typeface="Arial" panose="020B0604020202020204" pitchFamily="34" charset="0"/>
+                        </a:rPr>
+                        <a:t>Alt</a:t>
+                      </a:r>
+                      <a:endParaRPr lang="fr-FR" dirty="0">
+                        <a:effectLst/>
+                      </a:endParaRPr>
+                    </a:p>
+                  </a:txBody>
+                  <a:tcPr marL="63500" marR="63500" marT="63500" marB="63500">
+                    <a:lnL w="12700" cap="flat" cmpd="sng" algn="ctr">
+                      <a:solidFill>
+                        <a:srgbClr val="000000"/>
+                      </a:solidFill>
+                      <a:prstDash val="solid"/>
+                      <a:round/>
+                      <a:headEnd type="none" w="med" len="med"/>
+                      <a:tailEnd type="none" w="med" len="med"/>
+                    </a:lnL>
+                    <a:lnR w="12700" cap="flat" cmpd="sng" algn="ctr">
+                      <a:solidFill>
+                        <a:srgbClr val="000000"/>
+                      </a:solidFill>
+                      <a:prstDash val="solid"/>
+                      <a:round/>
+                      <a:headEnd type="none" w="med" len="med"/>
+                      <a:tailEnd type="none" w="med" len="med"/>
+                    </a:lnR>
+                    <a:lnT w="12700" cap="flat" cmpd="sng" algn="ctr">
+                      <a:solidFill>
+                        <a:srgbClr val="000000"/>
+                      </a:solidFill>
+                      <a:prstDash val="solid"/>
+                      <a:round/>
+                      <a:headEnd type="none" w="med" len="med"/>
+                      <a:tailEnd type="none" w="med" len="med"/>
+                    </a:lnT>
+                    <a:lnB w="12700" cap="flat" cmpd="sng" algn="ctr">
+                      <a:solidFill>
+                        <a:srgbClr val="000000"/>
+                      </a:solidFill>
+                      <a:prstDash val="solid"/>
+                      <a:round/>
+                      <a:headEnd type="none" w="med" len="med"/>
+                      <a:tailEnd type="none" w="med" len="med"/>
+                    </a:lnB>
+                  </a:tcPr>
+                </a:tc>
+                <a:extLst>
+                  <a:ext uri="{0D108BD9-81ED-4DB2-BD59-A6C34878D82A}">
+                    <a16:rowId xmlns:a16="http://schemas.microsoft.com/office/drawing/2014/main" val="1574232452"/>
+                  </a:ext>
+                </a:extLst>
+              </a:tr>
+              <a:tr h="0">
+                <a:tc>
+                  <a:txBody>
+                    <a:bodyPr/>
+                    <a:lstStyle/>
+                    <a:p>
+                      <a:pPr rtl="0" fontAlgn="t">
+                        <a:spcBef>
+                          <a:spcPts val="0"/>
+                        </a:spcBef>
+                        <a:spcAft>
+                          <a:spcPts val="0"/>
+                        </a:spcAft>
+                      </a:pPr>
+                      <a:r>
+                        <a:rPr lang="fr-FR" sz="1100" b="1" i="0" u="none" strike="noStrike" dirty="0">
+                          <a:solidFill>
+                            <a:srgbClr val="000000"/>
+                          </a:solidFill>
+                          <a:effectLst/>
+                          <a:latin typeface="Arial" panose="020B0604020202020204" pitchFamily="34" charset="0"/>
+                        </a:rPr>
+                        <a:t>IAS</a:t>
+                      </a:r>
+                      <a:endParaRPr lang="fr-FR" dirty="0">
+                        <a:effectLst/>
+                      </a:endParaRPr>
+                    </a:p>
+                  </a:txBody>
+                  <a:tcPr marL="63500" marR="63500" marT="63500" marB="63500">
+                    <a:lnL w="12700" cap="flat" cmpd="sng" algn="ctr">
+                      <a:solidFill>
+                        <a:srgbClr val="000000"/>
+                      </a:solidFill>
+                      <a:prstDash val="solid"/>
+                      <a:round/>
+                      <a:headEnd type="none" w="med" len="med"/>
+                      <a:tailEnd type="none" w="med" len="med"/>
+                    </a:lnL>
+                    <a:lnR w="12700" cap="flat" cmpd="sng" algn="ctr">
+                      <a:solidFill>
+                        <a:srgbClr val="000000"/>
+                      </a:solidFill>
+                      <a:prstDash val="solid"/>
+                      <a:round/>
+                      <a:headEnd type="none" w="med" len="med"/>
+                      <a:tailEnd type="none" w="med" len="med"/>
+                    </a:lnR>
+                    <a:lnT w="12700" cap="flat" cmpd="sng" algn="ctr">
+                      <a:solidFill>
+                        <a:srgbClr val="000000"/>
+                      </a:solidFill>
+                      <a:prstDash val="solid"/>
+                      <a:round/>
+                      <a:headEnd type="none" w="med" len="med"/>
+                      <a:tailEnd type="none" w="med" len="med"/>
+                    </a:lnT>
+                    <a:lnB w="12700" cap="flat" cmpd="sng" algn="ctr">
+                      <a:solidFill>
+                        <a:srgbClr val="000000"/>
+                      </a:solidFill>
+                      <a:prstDash val="solid"/>
+                      <a:round/>
+                      <a:headEnd type="none" w="med" len="med"/>
+                      <a:tailEnd type="none" w="med" len="med"/>
+                    </a:lnB>
+                  </a:tcPr>
+                </a:tc>
+                <a:extLst>
+                  <a:ext uri="{0D108BD9-81ED-4DB2-BD59-A6C34878D82A}">
+                    <a16:rowId xmlns:a16="http://schemas.microsoft.com/office/drawing/2014/main" val="4102961750"/>
+                  </a:ext>
+                </a:extLst>
+              </a:tr>
+              <a:tr h="0">
+                <a:tc>
+                  <a:txBody>
+                    <a:bodyPr/>
+                    <a:lstStyle/>
+                    <a:p>
+                      <a:pPr rtl="0" fontAlgn="t">
+                        <a:spcBef>
+                          <a:spcPts val="0"/>
+                        </a:spcBef>
+                        <a:spcAft>
+                          <a:spcPts val="0"/>
+                        </a:spcAft>
+                      </a:pPr>
+                      <a:r>
+                        <a:rPr lang="fr-FR" sz="1100" b="1" i="0" u="none" strike="noStrike" dirty="0">
+                          <a:solidFill>
+                            <a:srgbClr val="000000"/>
+                          </a:solidFill>
+                          <a:effectLst/>
+                          <a:latin typeface="Arial" panose="020B0604020202020204" pitchFamily="34" charset="0"/>
+                        </a:rPr>
+                        <a:t>Wind</a:t>
+                      </a:r>
+                      <a:endParaRPr lang="fr-FR" dirty="0">
+                        <a:effectLst/>
+                      </a:endParaRPr>
+                    </a:p>
+                  </a:txBody>
+                  <a:tcPr marL="63500" marR="63500" marT="63500" marB="63500">
+                    <a:lnL w="12700" cap="flat" cmpd="sng" algn="ctr">
+                      <a:solidFill>
+                        <a:srgbClr val="000000"/>
+                      </a:solidFill>
+                      <a:prstDash val="solid"/>
+                      <a:round/>
+                      <a:headEnd type="none" w="med" len="med"/>
+                      <a:tailEnd type="none" w="med" len="med"/>
+                    </a:lnL>
+                    <a:lnR w="12700" cap="flat" cmpd="sng" algn="ctr">
+                      <a:solidFill>
+                        <a:srgbClr val="000000"/>
+                      </a:solidFill>
+                      <a:prstDash val="solid"/>
+                      <a:round/>
+                      <a:headEnd type="none" w="med" len="med"/>
+                      <a:tailEnd type="none" w="med" len="med"/>
+                    </a:lnR>
+                    <a:lnT w="12700" cap="flat" cmpd="sng" algn="ctr">
+                      <a:solidFill>
+                        <a:srgbClr val="000000"/>
+                      </a:solidFill>
+                      <a:prstDash val="solid"/>
+                      <a:round/>
+                      <a:headEnd type="none" w="med" len="med"/>
+                      <a:tailEnd type="none" w="med" len="med"/>
+                    </a:lnT>
+                    <a:lnB w="12700" cap="flat" cmpd="sng" algn="ctr">
+                      <a:solidFill>
+                        <a:srgbClr val="000000"/>
+                      </a:solidFill>
+                      <a:prstDash val="solid"/>
+                      <a:round/>
+                      <a:headEnd type="none" w="med" len="med"/>
+                      <a:tailEnd type="none" w="med" len="med"/>
+                    </a:lnB>
+                  </a:tcPr>
+                </a:tc>
+                <a:extLst>
+                  <a:ext uri="{0D108BD9-81ED-4DB2-BD59-A6C34878D82A}">
+                    <a16:rowId xmlns:a16="http://schemas.microsoft.com/office/drawing/2014/main" val="3226097002"/>
+                  </a:ext>
+                </a:extLst>
+              </a:tr>
+              <a:tr h="0">
+                <a:tc>
+                  <a:txBody>
+                    <a:bodyPr/>
+                    <a:lstStyle/>
+                    <a:p>
+                      <a:pPr rtl="0" fontAlgn="t">
+                        <a:spcBef>
+                          <a:spcPts val="0"/>
+                        </a:spcBef>
+                        <a:spcAft>
+                          <a:spcPts val="0"/>
+                        </a:spcAft>
+                      </a:pPr>
+                      <a:r>
+                        <a:rPr lang="fr-FR" sz="1100" b="1" i="0" u="none" strike="noStrike" dirty="0" err="1">
+                          <a:solidFill>
+                            <a:srgbClr val="000000"/>
+                          </a:solidFill>
+                          <a:effectLst/>
+                          <a:latin typeface="Arial" panose="020B0604020202020204" pitchFamily="34" charset="0"/>
+                        </a:rPr>
+                        <a:t>WindDir</a:t>
+                      </a:r>
+                      <a:endParaRPr lang="fr-FR" dirty="0">
+                        <a:effectLst/>
+                      </a:endParaRPr>
+                    </a:p>
+                  </a:txBody>
+                  <a:tcPr marL="63500" marR="63500" marT="63500" marB="63500">
+                    <a:lnL w="12700" cap="flat" cmpd="sng" algn="ctr">
+                      <a:solidFill>
+                        <a:srgbClr val="000000"/>
+                      </a:solidFill>
+                      <a:prstDash val="solid"/>
+                      <a:round/>
+                      <a:headEnd type="none" w="med" len="med"/>
+                      <a:tailEnd type="none" w="med" len="med"/>
+                    </a:lnL>
+                    <a:lnR w="12700" cap="flat" cmpd="sng" algn="ctr">
+                      <a:solidFill>
+                        <a:srgbClr val="000000"/>
+                      </a:solidFill>
+                      <a:prstDash val="solid"/>
+                      <a:round/>
+                      <a:headEnd type="none" w="med" len="med"/>
+                      <a:tailEnd type="none" w="med" len="med"/>
+                    </a:lnR>
+                    <a:lnT w="12700" cap="flat" cmpd="sng" algn="ctr">
+                      <a:solidFill>
+                        <a:srgbClr val="000000"/>
+                      </a:solidFill>
+                      <a:prstDash val="solid"/>
+                      <a:round/>
+                      <a:headEnd type="none" w="med" len="med"/>
+                      <a:tailEnd type="none" w="med" len="med"/>
+                    </a:lnT>
+                    <a:lnB w="12700" cap="flat" cmpd="sng" algn="ctr">
+                      <a:solidFill>
+                        <a:srgbClr val="000000"/>
+                      </a:solidFill>
+                      <a:prstDash val="solid"/>
+                      <a:round/>
+                      <a:headEnd type="none" w="med" len="med"/>
+                      <a:tailEnd type="none" w="med" len="med"/>
+                    </a:lnB>
+                  </a:tcPr>
+                </a:tc>
+                <a:extLst>
+                  <a:ext uri="{0D108BD9-81ED-4DB2-BD59-A6C34878D82A}">
+                    <a16:rowId xmlns:a16="http://schemas.microsoft.com/office/drawing/2014/main" val="1839492842"/>
+                  </a:ext>
+                </a:extLst>
+              </a:tr>
+              <a:tr h="0">
+                <a:tc>
+                  <a:txBody>
+                    <a:bodyPr/>
+                    <a:lstStyle/>
+                    <a:p>
+                      <a:pPr rtl="0" fontAlgn="t">
+                        <a:spcBef>
+                          <a:spcPts val="0"/>
+                        </a:spcBef>
+                        <a:spcAft>
+                          <a:spcPts val="0"/>
+                        </a:spcAft>
+                      </a:pPr>
+                      <a:r>
+                        <a:rPr lang="fr-FR" sz="1100" b="1" i="0" u="none" strike="noStrike" dirty="0" err="1">
+                          <a:solidFill>
+                            <a:srgbClr val="000000"/>
+                          </a:solidFill>
+                          <a:effectLst/>
+                          <a:latin typeface="Arial" panose="020B0604020202020204" pitchFamily="34" charset="0"/>
+                        </a:rPr>
+                        <a:t>Netto</a:t>
+                      </a:r>
+                      <a:endParaRPr lang="fr-FR" dirty="0">
+                        <a:effectLst/>
+                      </a:endParaRPr>
+                    </a:p>
+                  </a:txBody>
+                  <a:tcPr marL="63500" marR="63500" marT="63500" marB="63500">
+                    <a:lnL w="12700" cap="flat" cmpd="sng" algn="ctr">
+                      <a:solidFill>
+                        <a:srgbClr val="000000"/>
+                      </a:solidFill>
+                      <a:prstDash val="solid"/>
+                      <a:round/>
+                      <a:headEnd type="none" w="med" len="med"/>
+                      <a:tailEnd type="none" w="med" len="med"/>
+                    </a:lnL>
+                    <a:lnR w="12700" cap="flat" cmpd="sng" algn="ctr">
+                      <a:solidFill>
+                        <a:srgbClr val="000000"/>
+                      </a:solidFill>
+                      <a:prstDash val="solid"/>
+                      <a:round/>
+                      <a:headEnd type="none" w="med" len="med"/>
+                      <a:tailEnd type="none" w="med" len="med"/>
+                    </a:lnR>
+                    <a:lnT w="12700" cap="flat" cmpd="sng" algn="ctr">
+                      <a:solidFill>
+                        <a:srgbClr val="000000"/>
+                      </a:solidFill>
+                      <a:prstDash val="solid"/>
+                      <a:round/>
+                      <a:headEnd type="none" w="med" len="med"/>
+                      <a:tailEnd type="none" w="med" len="med"/>
+                    </a:lnT>
+                    <a:lnB w="12700" cap="flat" cmpd="sng" algn="ctr">
+                      <a:solidFill>
+                        <a:srgbClr val="000000"/>
+                      </a:solidFill>
+                      <a:prstDash val="solid"/>
+                      <a:round/>
+                      <a:headEnd type="none" w="med" len="med"/>
+                      <a:tailEnd type="none" w="med" len="med"/>
+                    </a:lnB>
+                  </a:tcPr>
+                </a:tc>
+                <a:extLst>
+                  <a:ext uri="{0D108BD9-81ED-4DB2-BD59-A6C34878D82A}">
+                    <a16:rowId xmlns:a16="http://schemas.microsoft.com/office/drawing/2014/main" val="1574029082"/>
+                  </a:ext>
+                </a:extLst>
+              </a:tr>
+              <a:tr h="0">
+                <a:tc>
+                  <a:txBody>
+                    <a:bodyPr/>
+                    <a:lstStyle/>
+                    <a:p>
+                      <a:pPr rtl="0" fontAlgn="t">
+                        <a:spcBef>
+                          <a:spcPts val="0"/>
+                        </a:spcBef>
+                        <a:spcAft>
+                          <a:spcPts val="0"/>
+                        </a:spcAft>
+                      </a:pPr>
+                      <a:r>
+                        <a:rPr lang="fr-FR" sz="1100" b="1" i="0" u="none" strike="noStrike" dirty="0" err="1">
+                          <a:solidFill>
+                            <a:srgbClr val="000000"/>
+                          </a:solidFill>
+                          <a:effectLst/>
+                          <a:latin typeface="Arial" panose="020B0604020202020204" pitchFamily="34" charset="0"/>
+                        </a:rPr>
+                        <a:t>AirT</a:t>
+                      </a:r>
+                      <a:endParaRPr lang="fr-FR" dirty="0">
+                        <a:effectLst/>
+                      </a:endParaRPr>
+                    </a:p>
+                  </a:txBody>
+                  <a:tcPr marL="63500" marR="63500" marT="63500" marB="63500">
+                    <a:lnL w="12700" cap="flat" cmpd="sng" algn="ctr">
+                      <a:solidFill>
+                        <a:srgbClr val="000000"/>
+                      </a:solidFill>
+                      <a:prstDash val="solid"/>
+                      <a:round/>
+                      <a:headEnd type="none" w="med" len="med"/>
+                      <a:tailEnd type="none" w="med" len="med"/>
+                    </a:lnL>
+                    <a:lnR w="12700" cap="flat" cmpd="sng" algn="ctr">
+                      <a:solidFill>
+                        <a:srgbClr val="000000"/>
+                      </a:solidFill>
+                      <a:prstDash val="solid"/>
+                      <a:round/>
+                      <a:headEnd type="none" w="med" len="med"/>
+                      <a:tailEnd type="none" w="med" len="med"/>
+                    </a:lnR>
+                    <a:lnT w="12700" cap="flat" cmpd="sng" algn="ctr">
+                      <a:solidFill>
+                        <a:srgbClr val="000000"/>
+                      </a:solidFill>
+                      <a:prstDash val="solid"/>
+                      <a:round/>
+                      <a:headEnd type="none" w="med" len="med"/>
+                      <a:tailEnd type="none" w="med" len="med"/>
+                    </a:lnT>
+                    <a:lnB w="12700" cap="flat" cmpd="sng" algn="ctr">
+                      <a:solidFill>
+                        <a:srgbClr val="000000"/>
+                      </a:solidFill>
+                      <a:prstDash val="solid"/>
+                      <a:round/>
+                      <a:headEnd type="none" w="med" len="med"/>
+                      <a:tailEnd type="none" w="med" len="med"/>
+                    </a:lnB>
+                  </a:tcPr>
+                </a:tc>
+                <a:extLst>
+                  <a:ext uri="{0D108BD9-81ED-4DB2-BD59-A6C34878D82A}">
+                    <a16:rowId xmlns:a16="http://schemas.microsoft.com/office/drawing/2014/main" val="343263060"/>
+                  </a:ext>
+                </a:extLst>
+              </a:tr>
+              <a:tr h="0">
+                <a:tc>
+                  <a:txBody>
+                    <a:bodyPr/>
+                    <a:lstStyle/>
+                    <a:p>
+                      <a:pPr rtl="0" fontAlgn="t">
+                        <a:spcBef>
+                          <a:spcPts val="0"/>
+                        </a:spcBef>
+                        <a:spcAft>
+                          <a:spcPts val="0"/>
+                        </a:spcAft>
+                      </a:pPr>
+                      <a:r>
+                        <a:rPr lang="fr-FR" sz="1100" b="1" i="0" u="none" strike="noStrike" dirty="0" err="1">
+                          <a:solidFill>
+                            <a:srgbClr val="000000"/>
+                          </a:solidFill>
+                          <a:effectLst/>
+                          <a:latin typeface="Arial" panose="020B0604020202020204" pitchFamily="34" charset="0"/>
+                        </a:rPr>
+                        <a:t>AirRH</a:t>
+                      </a:r>
+                      <a:endParaRPr lang="fr-FR" dirty="0">
+                        <a:effectLst/>
+                      </a:endParaRPr>
+                    </a:p>
+                  </a:txBody>
+                  <a:tcPr marL="63500" marR="63500" marT="63500" marB="63500">
+                    <a:lnL w="12700" cap="flat" cmpd="sng" algn="ctr">
+                      <a:solidFill>
+                        <a:srgbClr val="000000"/>
+                      </a:solidFill>
+                      <a:prstDash val="solid"/>
+                      <a:round/>
+                      <a:headEnd type="none" w="med" len="med"/>
+                      <a:tailEnd type="none" w="med" len="med"/>
+                    </a:lnL>
+                    <a:lnR w="12700" cap="flat" cmpd="sng" algn="ctr">
+                      <a:solidFill>
+                        <a:srgbClr val="000000"/>
+                      </a:solidFill>
+                      <a:prstDash val="solid"/>
+                      <a:round/>
+                      <a:headEnd type="none" w="med" len="med"/>
+                      <a:tailEnd type="none" w="med" len="med"/>
+                    </a:lnR>
+                    <a:lnT w="12700" cap="flat" cmpd="sng" algn="ctr">
+                      <a:solidFill>
+                        <a:srgbClr val="000000"/>
+                      </a:solidFill>
+                      <a:prstDash val="solid"/>
+                      <a:round/>
+                      <a:headEnd type="none" w="med" len="med"/>
+                      <a:tailEnd type="none" w="med" len="med"/>
+                    </a:lnT>
+                    <a:lnB w="12700" cap="flat" cmpd="sng" algn="ctr">
+                      <a:solidFill>
+                        <a:srgbClr val="000000"/>
+                      </a:solidFill>
+                      <a:prstDash val="solid"/>
+                      <a:round/>
+                      <a:headEnd type="none" w="med" len="med"/>
+                      <a:tailEnd type="none" w="med" len="med"/>
+                    </a:lnB>
+                  </a:tcPr>
+                </a:tc>
+                <a:extLst>
+                  <a:ext uri="{0D108BD9-81ED-4DB2-BD59-A6C34878D82A}">
+                    <a16:rowId xmlns:a16="http://schemas.microsoft.com/office/drawing/2014/main" val="4076100299"/>
+                  </a:ext>
+                </a:extLst>
+              </a:tr>
+              <a:tr h="0">
+                <a:tc>
+                  <a:txBody>
+                    <a:bodyPr/>
+                    <a:lstStyle/>
+                    <a:p>
+                      <a:pPr rtl="0" fontAlgn="t">
+                        <a:spcBef>
+                          <a:spcPts val="0"/>
+                        </a:spcBef>
+                        <a:spcAft>
+                          <a:spcPts val="0"/>
+                        </a:spcAft>
+                      </a:pPr>
+                      <a:r>
+                        <a:rPr lang="fr-FR" sz="1100" b="1" i="0" u="none" strike="noStrike" dirty="0" err="1">
+                          <a:solidFill>
+                            <a:srgbClr val="000000"/>
+                          </a:solidFill>
+                          <a:effectLst/>
+                          <a:latin typeface="Arial" panose="020B0604020202020204" pitchFamily="34" charset="0"/>
+                        </a:rPr>
+                        <a:t>Gs</a:t>
+                      </a:r>
+                      <a:endParaRPr lang="fr-FR" dirty="0">
+                        <a:effectLst/>
+                      </a:endParaRPr>
+                    </a:p>
+                  </a:txBody>
+                  <a:tcPr marL="63500" marR="63500" marT="63500" marB="63500">
+                    <a:lnL w="12700" cap="flat" cmpd="sng" algn="ctr">
+                      <a:solidFill>
+                        <a:srgbClr val="000000"/>
+                      </a:solidFill>
+                      <a:prstDash val="solid"/>
+                      <a:round/>
+                      <a:headEnd type="none" w="med" len="med"/>
+                      <a:tailEnd type="none" w="med" len="med"/>
+                    </a:lnL>
+                    <a:lnR w="12700" cap="flat" cmpd="sng" algn="ctr">
+                      <a:solidFill>
+                        <a:srgbClr val="000000"/>
+                      </a:solidFill>
+                      <a:prstDash val="solid"/>
+                      <a:round/>
+                      <a:headEnd type="none" w="med" len="med"/>
+                      <a:tailEnd type="none" w="med" len="med"/>
+                    </a:lnR>
+                    <a:lnT w="12700" cap="flat" cmpd="sng" algn="ctr">
+                      <a:solidFill>
+                        <a:srgbClr val="000000"/>
+                      </a:solidFill>
+                      <a:prstDash val="solid"/>
+                      <a:round/>
+                      <a:headEnd type="none" w="med" len="med"/>
+                      <a:tailEnd type="none" w="med" len="med"/>
+                    </a:lnT>
+                    <a:lnB w="12700" cap="flat" cmpd="sng" algn="ctr">
+                      <a:solidFill>
+                        <a:srgbClr val="000000"/>
+                      </a:solidFill>
+                      <a:prstDash val="solid"/>
+                      <a:round/>
+                      <a:headEnd type="none" w="med" len="med"/>
+                      <a:tailEnd type="none" w="med" len="med"/>
+                    </a:lnB>
+                  </a:tcPr>
+                </a:tc>
+                <a:extLst>
+                  <a:ext uri="{0D108BD9-81ED-4DB2-BD59-A6C34878D82A}">
+                    <a16:rowId xmlns:a16="http://schemas.microsoft.com/office/drawing/2014/main" val="278607701"/>
+                  </a:ext>
+                </a:extLst>
+              </a:tr>
+              <a:tr h="0">
+                <a:tc>
+                  <a:txBody>
+                    <a:bodyPr/>
+                    <a:lstStyle/>
+                    <a:p>
+                      <a:pPr rtl="0" fontAlgn="t">
+                        <a:spcBef>
+                          <a:spcPts val="0"/>
+                        </a:spcBef>
+                        <a:spcAft>
+                          <a:spcPts val="0"/>
+                        </a:spcAft>
+                      </a:pPr>
+                      <a:r>
+                        <a:rPr lang="fr-FR" sz="1100" b="1" i="0" u="none" strike="noStrike" dirty="0" err="1" smtClean="0">
+                          <a:solidFill>
+                            <a:srgbClr val="000000"/>
+                          </a:solidFill>
+                          <a:effectLst/>
+                          <a:latin typeface="Arial" panose="020B0604020202020204" pitchFamily="34" charset="0"/>
+                        </a:rPr>
+                        <a:t>compass_Heading</a:t>
+                      </a:r>
+                      <a:endParaRPr lang="fr-FR" dirty="0">
+                        <a:effectLst/>
+                      </a:endParaRPr>
+                    </a:p>
+                  </a:txBody>
+                  <a:tcPr marL="63500" marR="63500" marT="63500" marB="63500">
+                    <a:lnL w="12700" cap="flat" cmpd="sng" algn="ctr">
+                      <a:solidFill>
+                        <a:srgbClr val="000000"/>
+                      </a:solidFill>
+                      <a:prstDash val="solid"/>
+                      <a:round/>
+                      <a:headEnd type="none" w="med" len="med"/>
+                      <a:tailEnd type="none" w="med" len="med"/>
+                    </a:lnL>
+                    <a:lnR w="12700" cap="flat" cmpd="sng" algn="ctr">
+                      <a:solidFill>
+                        <a:srgbClr val="000000"/>
+                      </a:solidFill>
+                      <a:prstDash val="solid"/>
+                      <a:round/>
+                      <a:headEnd type="none" w="med" len="med"/>
+                      <a:tailEnd type="none" w="med" len="med"/>
+                    </a:lnR>
+                    <a:lnT w="12700" cap="flat" cmpd="sng" algn="ctr">
+                      <a:solidFill>
+                        <a:srgbClr val="000000"/>
+                      </a:solidFill>
+                      <a:prstDash val="solid"/>
+                      <a:round/>
+                      <a:headEnd type="none" w="med" len="med"/>
+                      <a:tailEnd type="none" w="med" len="med"/>
+                    </a:lnT>
+                    <a:lnB w="12700" cap="flat" cmpd="sng" algn="ctr">
+                      <a:solidFill>
+                        <a:srgbClr val="000000"/>
+                      </a:solidFill>
+                      <a:prstDash val="solid"/>
+                      <a:round/>
+                      <a:headEnd type="none" w="med" len="med"/>
+                      <a:tailEnd type="none" w="med" len="med"/>
+                    </a:lnB>
+                  </a:tcPr>
+                </a:tc>
+                <a:extLst>
+                  <a:ext uri="{0D108BD9-81ED-4DB2-BD59-A6C34878D82A}">
+                    <a16:rowId xmlns:a16="http://schemas.microsoft.com/office/drawing/2014/main" val="1455713635"/>
+                  </a:ext>
+                </a:extLst>
+              </a:tr>
+            </a:tbl>
+          </a:graphicData>
+        </a:graphic>
+      </p:graphicFrame>
+      <p:graphicFrame>
+        <p:nvGraphicFramePr>
+          <p:cNvPr id="11" name="Tableau 10"/>
+          <p:cNvGraphicFramePr>
+            <a:graphicFrameLocks noGrp="1"/>
+          </p:cNvGraphicFramePr>
+          <p:nvPr>
+            <p:extLst>
+              <p:ext uri="{D42A27DB-BD31-4B8C-83A1-F6EECF244321}">
+                <p14:modId xmlns:p14="http://schemas.microsoft.com/office/powerpoint/2010/main" val="77452228"/>
+              </p:ext>
+            </p:extLst>
+          </p:nvPr>
+        </p:nvGraphicFramePr>
+        <p:xfrm>
+          <a:off x="4572798" y="874109"/>
+          <a:ext cx="821745" cy="4752198"/>
+        </p:xfrm>
+        <a:graphic>
+          <a:graphicData uri="http://schemas.openxmlformats.org/drawingml/2006/table">
+            <a:tbl>
+              <a:tblPr/>
+              <a:tblGrid>
+                <a:gridCol w="821745">
+                  <a:extLst>
+                    <a:ext uri="{9D8B030D-6E8A-4147-A177-3AD203B41FA5}">
+                      <a16:colId xmlns:a16="http://schemas.microsoft.com/office/drawing/2014/main" val="2977931163"/>
+                    </a:ext>
+                  </a:extLst>
+                </a:gridCol>
+              </a:tblGrid>
+              <a:tr h="201741">
+                <a:tc>
+                  <a:txBody>
+                    <a:bodyPr/>
+                    <a:lstStyle/>
+                    <a:p>
+                      <a:pPr rtl="0" fontAlgn="t">
+                        <a:spcBef>
+                          <a:spcPts val="0"/>
+                        </a:spcBef>
+                        <a:spcAft>
+                          <a:spcPts val="0"/>
+                        </a:spcAft>
+                      </a:pPr>
+                      <a:r>
+                        <a:rPr lang="fr-FR" sz="800" b="1" i="0" u="none" strike="noStrike">
+                          <a:solidFill>
+                            <a:srgbClr val="000000"/>
+                          </a:solidFill>
+                          <a:effectLst/>
+                          <a:latin typeface="Arial" panose="020B0604020202020204" pitchFamily="34" charset="0"/>
+                        </a:rPr>
+                        <a:t>Time</a:t>
+                      </a:r>
+                      <a:endParaRPr lang="fr-FR" sz="1200">
+                        <a:effectLst/>
+                      </a:endParaRPr>
+                    </a:p>
+                  </a:txBody>
+                  <a:tcPr marL="43479" marR="43479" marT="43479" marB="43479">
+                    <a:lnL w="12700" cap="flat" cmpd="sng" algn="ctr">
+                      <a:solidFill>
+                        <a:srgbClr val="000000"/>
+                      </a:solidFill>
+                      <a:prstDash val="solid"/>
+                      <a:round/>
+                      <a:headEnd type="none" w="med" len="med"/>
+                      <a:tailEnd type="none" w="med" len="med"/>
+                    </a:lnL>
+                    <a:lnR w="12700" cap="flat" cmpd="sng" algn="ctr">
+                      <a:solidFill>
+                        <a:srgbClr val="000000"/>
+                      </a:solidFill>
+                      <a:prstDash val="solid"/>
+                      <a:round/>
+                      <a:headEnd type="none" w="med" len="med"/>
+                      <a:tailEnd type="none" w="med" len="med"/>
+                    </a:lnR>
+                    <a:lnT w="12700" cap="flat" cmpd="sng" algn="ctr">
+                      <a:solidFill>
+                        <a:srgbClr val="000000"/>
+                      </a:solidFill>
+                      <a:prstDash val="solid"/>
+                      <a:round/>
+                      <a:headEnd type="none" w="med" len="med"/>
+                      <a:tailEnd type="none" w="med" len="med"/>
+                    </a:lnT>
+                    <a:lnB w="12700" cap="flat" cmpd="sng" algn="ctr">
+                      <a:solidFill>
+                        <a:srgbClr val="000000"/>
+                      </a:solidFill>
+                      <a:prstDash val="solid"/>
+                      <a:round/>
+                      <a:headEnd type="none" w="med" len="med"/>
+                      <a:tailEnd type="none" w="med" len="med"/>
+                    </a:lnB>
+                  </a:tcPr>
+                </a:tc>
+                <a:extLst>
+                  <a:ext uri="{0D108BD9-81ED-4DB2-BD59-A6C34878D82A}">
+                    <a16:rowId xmlns:a16="http://schemas.microsoft.com/office/drawing/2014/main" val="1052327899"/>
+                  </a:ext>
+                </a:extLst>
+              </a:tr>
+              <a:tr h="316524">
+                <a:tc>
+                  <a:txBody>
+                    <a:bodyPr/>
+                    <a:lstStyle/>
+                    <a:p>
+                      <a:pPr rtl="0" fontAlgn="t">
+                        <a:spcBef>
+                          <a:spcPts val="0"/>
+                        </a:spcBef>
+                        <a:spcAft>
+                          <a:spcPts val="0"/>
+                        </a:spcAft>
+                      </a:pPr>
+                      <a:r>
+                        <a:rPr lang="fr-FR" sz="800" b="1" i="0" u="none" strike="noStrike">
+                          <a:solidFill>
+                            <a:srgbClr val="000000"/>
+                          </a:solidFill>
+                          <a:effectLst/>
+                          <a:latin typeface="Arial" panose="020B0604020202020204" pitchFamily="34" charset="0"/>
+                        </a:rPr>
+                        <a:t>Lat</a:t>
+                      </a:r>
+                      <a:endParaRPr lang="fr-FR" sz="1200">
+                        <a:effectLst/>
+                      </a:endParaRPr>
+                    </a:p>
+                    <a:p>
+                      <a:pPr rtl="0" fontAlgn="t">
+                        <a:spcBef>
+                          <a:spcPts val="0"/>
+                        </a:spcBef>
+                        <a:spcAft>
+                          <a:spcPts val="0"/>
+                        </a:spcAft>
+                      </a:pPr>
+                      <a:r>
+                        <a:rPr lang="fr-FR" sz="800" b="1" i="0" u="none" strike="noStrike">
+                          <a:solidFill>
+                            <a:srgbClr val="000000"/>
+                          </a:solidFill>
+                          <a:effectLst/>
+                          <a:latin typeface="Arial" panose="020B0604020202020204" pitchFamily="34" charset="0"/>
+                        </a:rPr>
+                        <a:t>Lon</a:t>
+                      </a:r>
+                      <a:endParaRPr lang="fr-FR" sz="1200">
+                        <a:effectLst/>
+                      </a:endParaRPr>
+                    </a:p>
+                  </a:txBody>
+                  <a:tcPr marL="43479" marR="43479" marT="43479" marB="43479">
+                    <a:lnL w="12700" cap="flat" cmpd="sng" algn="ctr">
+                      <a:solidFill>
+                        <a:srgbClr val="000000"/>
+                      </a:solidFill>
+                      <a:prstDash val="solid"/>
+                      <a:round/>
+                      <a:headEnd type="none" w="med" len="med"/>
+                      <a:tailEnd type="none" w="med" len="med"/>
+                    </a:lnL>
+                    <a:lnR w="12700" cap="flat" cmpd="sng" algn="ctr">
+                      <a:solidFill>
+                        <a:srgbClr val="000000"/>
+                      </a:solidFill>
+                      <a:prstDash val="solid"/>
+                      <a:round/>
+                      <a:headEnd type="none" w="med" len="med"/>
+                      <a:tailEnd type="none" w="med" len="med"/>
+                    </a:lnR>
+                    <a:lnT w="12700" cap="flat" cmpd="sng" algn="ctr">
+                      <a:solidFill>
+                        <a:srgbClr val="000000"/>
+                      </a:solidFill>
+                      <a:prstDash val="solid"/>
+                      <a:round/>
+                      <a:headEnd type="none" w="med" len="med"/>
+                      <a:tailEnd type="none" w="med" len="med"/>
+                    </a:lnT>
+                    <a:lnB w="12700" cap="flat" cmpd="sng" algn="ctr">
+                      <a:solidFill>
+                        <a:srgbClr val="000000"/>
+                      </a:solidFill>
+                      <a:prstDash val="solid"/>
+                      <a:round/>
+                      <a:headEnd type="none" w="med" len="med"/>
+                      <a:tailEnd type="none" w="med" len="med"/>
+                    </a:lnB>
+                  </a:tcPr>
+                </a:tc>
+                <a:extLst>
+                  <a:ext uri="{0D108BD9-81ED-4DB2-BD59-A6C34878D82A}">
+                    <a16:rowId xmlns:a16="http://schemas.microsoft.com/office/drawing/2014/main" val="44955183"/>
+                  </a:ext>
+                </a:extLst>
+              </a:tr>
+              <a:tr h="201741">
+                <a:tc>
+                  <a:txBody>
+                    <a:bodyPr/>
+                    <a:lstStyle/>
+                    <a:p>
+                      <a:pPr rtl="0" fontAlgn="t">
+                        <a:spcBef>
+                          <a:spcPts val="0"/>
+                        </a:spcBef>
+                        <a:spcAft>
+                          <a:spcPts val="0"/>
+                        </a:spcAft>
+                      </a:pPr>
+                      <a:r>
+                        <a:rPr lang="fr-FR" sz="800" b="1" i="0" u="none" strike="noStrike">
+                          <a:solidFill>
+                            <a:srgbClr val="000000"/>
+                          </a:solidFill>
+                          <a:effectLst/>
+                          <a:latin typeface="Arial" panose="020B0604020202020204" pitchFamily="34" charset="0"/>
+                        </a:rPr>
+                        <a:t>Alt_GPS</a:t>
+                      </a:r>
+                      <a:endParaRPr lang="fr-FR" sz="1200">
+                        <a:effectLst/>
+                      </a:endParaRPr>
+                    </a:p>
+                  </a:txBody>
+                  <a:tcPr marL="43479" marR="43479" marT="43479" marB="43479">
+                    <a:lnL w="12700" cap="flat" cmpd="sng" algn="ctr">
+                      <a:solidFill>
+                        <a:srgbClr val="000000"/>
+                      </a:solidFill>
+                      <a:prstDash val="solid"/>
+                      <a:round/>
+                      <a:headEnd type="none" w="med" len="med"/>
+                      <a:tailEnd type="none" w="med" len="med"/>
+                    </a:lnL>
+                    <a:lnR w="12700" cap="flat" cmpd="sng" algn="ctr">
+                      <a:solidFill>
+                        <a:srgbClr val="000000"/>
+                      </a:solidFill>
+                      <a:prstDash val="solid"/>
+                      <a:round/>
+                      <a:headEnd type="none" w="med" len="med"/>
+                      <a:tailEnd type="none" w="med" len="med"/>
+                    </a:lnR>
+                    <a:lnT w="12700" cap="flat" cmpd="sng" algn="ctr">
+                      <a:solidFill>
+                        <a:srgbClr val="000000"/>
+                      </a:solidFill>
+                      <a:prstDash val="solid"/>
+                      <a:round/>
+                      <a:headEnd type="none" w="med" len="med"/>
+                      <a:tailEnd type="none" w="med" len="med"/>
+                    </a:lnT>
+                    <a:lnB w="12700" cap="flat" cmpd="sng" algn="ctr">
+                      <a:solidFill>
+                        <a:srgbClr val="000000"/>
+                      </a:solidFill>
+                      <a:prstDash val="solid"/>
+                      <a:round/>
+                      <a:headEnd type="none" w="med" len="med"/>
+                      <a:tailEnd type="none" w="med" len="med"/>
+                    </a:lnB>
+                  </a:tcPr>
+                </a:tc>
+                <a:extLst>
+                  <a:ext uri="{0D108BD9-81ED-4DB2-BD59-A6C34878D82A}">
+                    <a16:rowId xmlns:a16="http://schemas.microsoft.com/office/drawing/2014/main" val="848534307"/>
+                  </a:ext>
+                </a:extLst>
+              </a:tr>
+              <a:tr h="201741">
+                <a:tc>
+                  <a:txBody>
+                    <a:bodyPr/>
+                    <a:lstStyle/>
+                    <a:p>
+                      <a:pPr rtl="0" fontAlgn="t">
+                        <a:spcBef>
+                          <a:spcPts val="0"/>
+                        </a:spcBef>
+                        <a:spcAft>
+                          <a:spcPts val="0"/>
+                        </a:spcAft>
+                      </a:pPr>
+                      <a:endParaRPr lang="fr-FR" sz="1200" dirty="0">
+                        <a:effectLst/>
+                      </a:endParaRPr>
+                    </a:p>
+                  </a:txBody>
+                  <a:tcPr marL="43479" marR="43479" marT="43479" marB="43479">
+                    <a:lnL w="12700" cap="flat" cmpd="sng" algn="ctr">
+                      <a:solidFill>
+                        <a:srgbClr val="000000"/>
+                      </a:solidFill>
+                      <a:prstDash val="solid"/>
+                      <a:round/>
+                      <a:headEnd type="none" w="med" len="med"/>
+                      <a:tailEnd type="none" w="med" len="med"/>
+                    </a:lnL>
+                    <a:lnR w="12700" cap="flat" cmpd="sng" algn="ctr">
+                      <a:solidFill>
+                        <a:srgbClr val="000000"/>
+                      </a:solidFill>
+                      <a:prstDash val="solid"/>
+                      <a:round/>
+                      <a:headEnd type="none" w="med" len="med"/>
+                      <a:tailEnd type="none" w="med" len="med"/>
+                    </a:lnR>
+                    <a:lnT w="12700" cap="flat" cmpd="sng" algn="ctr">
+                      <a:solidFill>
+                        <a:srgbClr val="000000"/>
+                      </a:solidFill>
+                      <a:prstDash val="solid"/>
+                      <a:round/>
+                      <a:headEnd type="none" w="med" len="med"/>
+                      <a:tailEnd type="none" w="med" len="med"/>
+                    </a:lnT>
+                    <a:lnB w="12700" cap="flat" cmpd="sng" algn="ctr">
+                      <a:solidFill>
+                        <a:srgbClr val="000000"/>
+                      </a:solidFill>
+                      <a:prstDash val="solid"/>
+                      <a:round/>
+                      <a:headEnd type="none" w="med" len="med"/>
+                      <a:tailEnd type="none" w="med" len="med"/>
+                    </a:lnB>
+                  </a:tcPr>
+                </a:tc>
+                <a:extLst>
+                  <a:ext uri="{0D108BD9-81ED-4DB2-BD59-A6C34878D82A}">
+                    <a16:rowId xmlns:a16="http://schemas.microsoft.com/office/drawing/2014/main" val="2367605568"/>
+                  </a:ext>
+                </a:extLst>
+              </a:tr>
+              <a:tr h="201741">
+                <a:tc>
+                  <a:txBody>
+                    <a:bodyPr/>
+                    <a:lstStyle/>
+                    <a:p>
+                      <a:pPr rtl="0" fontAlgn="t">
+                        <a:spcBef>
+                          <a:spcPts val="0"/>
+                        </a:spcBef>
+                        <a:spcAft>
+                          <a:spcPts val="0"/>
+                        </a:spcAft>
+                      </a:pPr>
+                      <a:r>
+                        <a:rPr lang="fr-FR" sz="800" b="1" i="0" u="none" strike="noStrike">
+                          <a:solidFill>
+                            <a:srgbClr val="0000FF"/>
+                          </a:solidFill>
+                          <a:effectLst/>
+                          <a:latin typeface="Arial" panose="020B0604020202020204" pitchFamily="34" charset="0"/>
+                        </a:rPr>
+                        <a:t>Speed_GPS</a:t>
+                      </a:r>
+                      <a:endParaRPr lang="fr-FR" sz="1200">
+                        <a:effectLst/>
+                      </a:endParaRPr>
+                    </a:p>
+                  </a:txBody>
+                  <a:tcPr marL="43479" marR="43479" marT="43479" marB="43479">
+                    <a:lnL w="12700" cap="flat" cmpd="sng" algn="ctr">
+                      <a:solidFill>
+                        <a:srgbClr val="000000"/>
+                      </a:solidFill>
+                      <a:prstDash val="solid"/>
+                      <a:round/>
+                      <a:headEnd type="none" w="med" len="med"/>
+                      <a:tailEnd type="none" w="med" len="med"/>
+                    </a:lnL>
+                    <a:lnR w="12700" cap="flat" cmpd="sng" algn="ctr">
+                      <a:solidFill>
+                        <a:srgbClr val="000000"/>
+                      </a:solidFill>
+                      <a:prstDash val="solid"/>
+                      <a:round/>
+                      <a:headEnd type="none" w="med" len="med"/>
+                      <a:tailEnd type="none" w="med" len="med"/>
+                    </a:lnR>
+                    <a:lnT w="12700" cap="flat" cmpd="sng" algn="ctr">
+                      <a:solidFill>
+                        <a:srgbClr val="000000"/>
+                      </a:solidFill>
+                      <a:prstDash val="solid"/>
+                      <a:round/>
+                      <a:headEnd type="none" w="med" len="med"/>
+                      <a:tailEnd type="none" w="med" len="med"/>
+                    </a:lnT>
+                    <a:lnB w="12700" cap="flat" cmpd="sng" algn="ctr">
+                      <a:solidFill>
+                        <a:srgbClr val="000000"/>
+                      </a:solidFill>
+                      <a:prstDash val="solid"/>
+                      <a:round/>
+                      <a:headEnd type="none" w="med" len="med"/>
+                      <a:tailEnd type="none" w="med" len="med"/>
+                    </a:lnB>
+                  </a:tcPr>
+                </a:tc>
+                <a:extLst>
+                  <a:ext uri="{0D108BD9-81ED-4DB2-BD59-A6C34878D82A}">
+                    <a16:rowId xmlns:a16="http://schemas.microsoft.com/office/drawing/2014/main" val="2129317135"/>
+                  </a:ext>
+                </a:extLst>
+              </a:tr>
+              <a:tr h="201741">
+                <a:tc>
+                  <a:txBody>
+                    <a:bodyPr/>
+                    <a:lstStyle/>
+                    <a:p>
+                      <a:pPr rtl="0" fontAlgn="t">
+                        <a:spcBef>
+                          <a:spcPts val="0"/>
+                        </a:spcBef>
+                        <a:spcAft>
+                          <a:spcPts val="0"/>
+                        </a:spcAft>
+                      </a:pPr>
+                      <a:r>
+                        <a:rPr lang="fr-FR" sz="800" b="1" i="0" u="none" strike="noStrike" dirty="0" err="1">
+                          <a:solidFill>
+                            <a:srgbClr val="0000FF"/>
+                          </a:solidFill>
+                          <a:effectLst/>
+                          <a:latin typeface="Arial" panose="020B0604020202020204" pitchFamily="34" charset="0"/>
+                        </a:rPr>
+                        <a:t>Heading_GPS</a:t>
+                      </a:r>
+                      <a:endParaRPr lang="fr-FR" sz="1200" dirty="0">
+                        <a:effectLst/>
+                      </a:endParaRPr>
+                    </a:p>
+                  </a:txBody>
+                  <a:tcPr marL="43479" marR="43479" marT="43479" marB="43479">
+                    <a:lnL w="12700" cap="flat" cmpd="sng" algn="ctr">
+                      <a:solidFill>
+                        <a:srgbClr val="000000"/>
+                      </a:solidFill>
+                      <a:prstDash val="solid"/>
+                      <a:round/>
+                      <a:headEnd type="none" w="med" len="med"/>
+                      <a:tailEnd type="none" w="med" len="med"/>
+                    </a:lnL>
+                    <a:lnR w="12700" cap="flat" cmpd="sng" algn="ctr">
+                      <a:solidFill>
+                        <a:srgbClr val="000000"/>
+                      </a:solidFill>
+                      <a:prstDash val="solid"/>
+                      <a:round/>
+                      <a:headEnd type="none" w="med" len="med"/>
+                      <a:tailEnd type="none" w="med" len="med"/>
+                    </a:lnR>
+                    <a:lnT w="12700" cap="flat" cmpd="sng" algn="ctr">
+                      <a:solidFill>
+                        <a:srgbClr val="000000"/>
+                      </a:solidFill>
+                      <a:prstDash val="solid"/>
+                      <a:round/>
+                      <a:headEnd type="none" w="med" len="med"/>
+                      <a:tailEnd type="none" w="med" len="med"/>
+                    </a:lnT>
+                    <a:lnB w="12700" cap="flat" cmpd="sng" algn="ctr">
+                      <a:solidFill>
+                        <a:srgbClr val="000000"/>
+                      </a:solidFill>
+                      <a:prstDash val="solid"/>
+                      <a:round/>
+                      <a:headEnd type="none" w="med" len="med"/>
+                      <a:tailEnd type="none" w="med" len="med"/>
+                    </a:lnB>
+                  </a:tcPr>
+                </a:tc>
+                <a:extLst>
+                  <a:ext uri="{0D108BD9-81ED-4DB2-BD59-A6C34878D82A}">
+                    <a16:rowId xmlns:a16="http://schemas.microsoft.com/office/drawing/2014/main" val="929638361"/>
+                  </a:ext>
+                </a:extLst>
+              </a:tr>
+              <a:tr h="201741">
+                <a:tc>
+                  <a:txBody>
+                    <a:bodyPr/>
+                    <a:lstStyle/>
+                    <a:p>
+                      <a:pPr rtl="0" fontAlgn="t">
+                        <a:spcBef>
+                          <a:spcPts val="0"/>
+                        </a:spcBef>
+                        <a:spcAft>
+                          <a:spcPts val="0"/>
+                        </a:spcAft>
+                      </a:pPr>
+                      <a:r>
+                        <a:rPr lang="fr-FR" sz="800" b="1" i="0" u="none" strike="noStrike" dirty="0">
+                          <a:solidFill>
+                            <a:srgbClr val="0000FF"/>
+                          </a:solidFill>
+                          <a:effectLst/>
+                          <a:latin typeface="Arial" panose="020B0604020202020204" pitchFamily="34" charset="0"/>
+                        </a:rPr>
+                        <a:t>DP</a:t>
+                      </a:r>
+                      <a:endParaRPr lang="fr-FR" sz="1200" dirty="0">
+                        <a:effectLst/>
+                      </a:endParaRPr>
+                    </a:p>
+                  </a:txBody>
+                  <a:tcPr marL="43479" marR="43479" marT="43479" marB="43479">
+                    <a:lnL w="12700" cap="flat" cmpd="sng" algn="ctr">
+                      <a:solidFill>
+                        <a:srgbClr val="000000"/>
+                      </a:solidFill>
+                      <a:prstDash val="solid"/>
+                      <a:round/>
+                      <a:headEnd type="none" w="med" len="med"/>
+                      <a:tailEnd type="none" w="med" len="med"/>
+                    </a:lnL>
+                    <a:lnR w="12700" cap="flat" cmpd="sng" algn="ctr">
+                      <a:solidFill>
+                        <a:srgbClr val="000000"/>
+                      </a:solidFill>
+                      <a:prstDash val="solid"/>
+                      <a:round/>
+                      <a:headEnd type="none" w="med" len="med"/>
+                      <a:tailEnd type="none" w="med" len="med"/>
+                    </a:lnR>
+                    <a:lnT w="12700" cap="flat" cmpd="sng" algn="ctr">
+                      <a:solidFill>
+                        <a:srgbClr val="000000"/>
+                      </a:solidFill>
+                      <a:prstDash val="solid"/>
+                      <a:round/>
+                      <a:headEnd type="none" w="med" len="med"/>
+                      <a:tailEnd type="none" w="med" len="med"/>
+                    </a:lnT>
+                    <a:lnB w="12700" cap="flat" cmpd="sng" algn="ctr">
+                      <a:solidFill>
+                        <a:srgbClr val="000000"/>
+                      </a:solidFill>
+                      <a:prstDash val="solid"/>
+                      <a:round/>
+                      <a:headEnd type="none" w="med" len="med"/>
+                      <a:tailEnd type="none" w="med" len="med"/>
+                    </a:lnB>
+                  </a:tcPr>
+                </a:tc>
+                <a:extLst>
+                  <a:ext uri="{0D108BD9-81ED-4DB2-BD59-A6C34878D82A}">
+                    <a16:rowId xmlns:a16="http://schemas.microsoft.com/office/drawing/2014/main" val="4196712723"/>
+                  </a:ext>
+                </a:extLst>
+              </a:tr>
+              <a:tr h="201741">
+                <a:tc>
+                  <a:txBody>
+                    <a:bodyPr/>
+                    <a:lstStyle/>
+                    <a:p>
+                      <a:pPr rtl="0" fontAlgn="t">
+                        <a:spcBef>
+                          <a:spcPts val="0"/>
+                        </a:spcBef>
+                        <a:spcAft>
+                          <a:spcPts val="0"/>
+                        </a:spcAft>
+                      </a:pPr>
+                      <a:r>
+                        <a:rPr lang="fr-FR" sz="800" b="1" i="0" u="none" strike="noStrike">
+                          <a:solidFill>
+                            <a:srgbClr val="0000FF"/>
+                          </a:solidFill>
+                          <a:effectLst/>
+                          <a:latin typeface="Arial" panose="020B0604020202020204" pitchFamily="34" charset="0"/>
+                        </a:rPr>
+                        <a:t>T_sensor</a:t>
+                      </a:r>
+                      <a:endParaRPr lang="fr-FR" sz="1200">
+                        <a:effectLst/>
+                      </a:endParaRPr>
+                    </a:p>
+                  </a:txBody>
+                  <a:tcPr marL="43479" marR="43479" marT="43479" marB="43479">
+                    <a:lnL w="12700" cap="flat" cmpd="sng" algn="ctr">
+                      <a:solidFill>
+                        <a:srgbClr val="000000"/>
+                      </a:solidFill>
+                      <a:prstDash val="solid"/>
+                      <a:round/>
+                      <a:headEnd type="none" w="med" len="med"/>
+                      <a:tailEnd type="none" w="med" len="med"/>
+                    </a:lnL>
+                    <a:lnR w="12700" cap="flat" cmpd="sng" algn="ctr">
+                      <a:solidFill>
+                        <a:srgbClr val="000000"/>
+                      </a:solidFill>
+                      <a:prstDash val="solid"/>
+                      <a:round/>
+                      <a:headEnd type="none" w="med" len="med"/>
+                      <a:tailEnd type="none" w="med" len="med"/>
+                    </a:lnR>
+                    <a:lnT w="12700" cap="flat" cmpd="sng" algn="ctr">
+                      <a:solidFill>
+                        <a:srgbClr val="000000"/>
+                      </a:solidFill>
+                      <a:prstDash val="solid"/>
+                      <a:round/>
+                      <a:headEnd type="none" w="med" len="med"/>
+                      <a:tailEnd type="none" w="med" len="med"/>
+                    </a:lnT>
+                    <a:lnB w="12700" cap="flat" cmpd="sng" algn="ctr">
+                      <a:solidFill>
+                        <a:srgbClr val="000000"/>
+                      </a:solidFill>
+                      <a:prstDash val="solid"/>
+                      <a:round/>
+                      <a:headEnd type="none" w="med" len="med"/>
+                      <a:tailEnd type="none" w="med" len="med"/>
+                    </a:lnB>
+                  </a:tcPr>
+                </a:tc>
+                <a:extLst>
+                  <a:ext uri="{0D108BD9-81ED-4DB2-BD59-A6C34878D82A}">
+                    <a16:rowId xmlns:a16="http://schemas.microsoft.com/office/drawing/2014/main" val="803833665"/>
+                  </a:ext>
+                </a:extLst>
+              </a:tr>
+              <a:tr h="201741">
+                <a:tc>
+                  <a:txBody>
+                    <a:bodyPr/>
+                    <a:lstStyle/>
+                    <a:p>
+                      <a:pPr rtl="0" fontAlgn="t">
+                        <a:spcBef>
+                          <a:spcPts val="0"/>
+                        </a:spcBef>
+                        <a:spcAft>
+                          <a:spcPts val="0"/>
+                        </a:spcAft>
+                      </a:pPr>
+                      <a:r>
+                        <a:rPr lang="fr-FR" sz="800" b="1" i="0" u="none" strike="noStrike">
+                          <a:solidFill>
+                            <a:srgbClr val="0000FF"/>
+                          </a:solidFill>
+                          <a:effectLst/>
+                          <a:latin typeface="Arial" panose="020B0604020202020204" pitchFamily="34" charset="0"/>
+                        </a:rPr>
+                        <a:t>A0</a:t>
+                      </a:r>
+                      <a:endParaRPr lang="fr-FR" sz="1200">
+                        <a:effectLst/>
+                      </a:endParaRPr>
+                    </a:p>
+                  </a:txBody>
+                  <a:tcPr marL="43479" marR="43479" marT="43479" marB="43479">
+                    <a:lnL w="12700" cap="flat" cmpd="sng" algn="ctr">
+                      <a:solidFill>
+                        <a:srgbClr val="000000"/>
+                      </a:solidFill>
+                      <a:prstDash val="solid"/>
+                      <a:round/>
+                      <a:headEnd type="none" w="med" len="med"/>
+                      <a:tailEnd type="none" w="med" len="med"/>
+                    </a:lnL>
+                    <a:lnR w="12700" cap="flat" cmpd="sng" algn="ctr">
+                      <a:solidFill>
+                        <a:srgbClr val="000000"/>
+                      </a:solidFill>
+                      <a:prstDash val="solid"/>
+                      <a:round/>
+                      <a:headEnd type="none" w="med" len="med"/>
+                      <a:tailEnd type="none" w="med" len="med"/>
+                    </a:lnR>
+                    <a:lnT w="12700" cap="flat" cmpd="sng" algn="ctr">
+                      <a:solidFill>
+                        <a:srgbClr val="000000"/>
+                      </a:solidFill>
+                      <a:prstDash val="solid"/>
+                      <a:round/>
+                      <a:headEnd type="none" w="med" len="med"/>
+                      <a:tailEnd type="none" w="med" len="med"/>
+                    </a:lnT>
+                    <a:lnB w="12700" cap="flat" cmpd="sng" algn="ctr">
+                      <a:solidFill>
+                        <a:srgbClr val="000000"/>
+                      </a:solidFill>
+                      <a:prstDash val="solid"/>
+                      <a:round/>
+                      <a:headEnd type="none" w="med" len="med"/>
+                      <a:tailEnd type="none" w="med" len="med"/>
+                    </a:lnB>
+                  </a:tcPr>
+                </a:tc>
+                <a:extLst>
+                  <a:ext uri="{0D108BD9-81ED-4DB2-BD59-A6C34878D82A}">
+                    <a16:rowId xmlns:a16="http://schemas.microsoft.com/office/drawing/2014/main" val="1651934671"/>
+                  </a:ext>
+                </a:extLst>
+              </a:tr>
+              <a:tr h="201741">
+                <a:tc>
+                  <a:txBody>
+                    <a:bodyPr/>
+                    <a:lstStyle/>
+                    <a:p>
+                      <a:pPr rtl="0" fontAlgn="t">
+                        <a:spcBef>
+                          <a:spcPts val="0"/>
+                        </a:spcBef>
+                        <a:spcAft>
+                          <a:spcPts val="0"/>
+                        </a:spcAft>
+                      </a:pPr>
+                      <a:r>
+                        <a:rPr lang="fr-FR" sz="800" b="1" i="0" u="none" strike="noStrike">
+                          <a:solidFill>
+                            <a:srgbClr val="0000FF"/>
+                          </a:solidFill>
+                          <a:effectLst/>
+                          <a:latin typeface="Arial" panose="020B0604020202020204" pitchFamily="34" charset="0"/>
+                        </a:rPr>
+                        <a:t>A1</a:t>
+                      </a:r>
+                      <a:endParaRPr lang="fr-FR" sz="1200">
+                        <a:effectLst/>
+                      </a:endParaRPr>
+                    </a:p>
+                  </a:txBody>
+                  <a:tcPr marL="43479" marR="43479" marT="43479" marB="43479">
+                    <a:lnL w="12700" cap="flat" cmpd="sng" algn="ctr">
+                      <a:solidFill>
+                        <a:srgbClr val="000000"/>
+                      </a:solidFill>
+                      <a:prstDash val="solid"/>
+                      <a:round/>
+                      <a:headEnd type="none" w="med" len="med"/>
+                      <a:tailEnd type="none" w="med" len="med"/>
+                    </a:lnL>
+                    <a:lnR w="12700" cap="flat" cmpd="sng" algn="ctr">
+                      <a:solidFill>
+                        <a:srgbClr val="000000"/>
+                      </a:solidFill>
+                      <a:prstDash val="solid"/>
+                      <a:round/>
+                      <a:headEnd type="none" w="med" len="med"/>
+                      <a:tailEnd type="none" w="med" len="med"/>
+                    </a:lnR>
+                    <a:lnT w="12700" cap="flat" cmpd="sng" algn="ctr">
+                      <a:solidFill>
+                        <a:srgbClr val="000000"/>
+                      </a:solidFill>
+                      <a:prstDash val="solid"/>
+                      <a:round/>
+                      <a:headEnd type="none" w="med" len="med"/>
+                      <a:tailEnd type="none" w="med" len="med"/>
+                    </a:lnT>
+                    <a:lnB w="12700" cap="flat" cmpd="sng" algn="ctr">
+                      <a:solidFill>
+                        <a:srgbClr val="000000"/>
+                      </a:solidFill>
+                      <a:prstDash val="solid"/>
+                      <a:round/>
+                      <a:headEnd type="none" w="med" len="med"/>
+                      <a:tailEnd type="none" w="med" len="med"/>
+                    </a:lnB>
+                  </a:tcPr>
+                </a:tc>
+                <a:extLst>
+                  <a:ext uri="{0D108BD9-81ED-4DB2-BD59-A6C34878D82A}">
+                    <a16:rowId xmlns:a16="http://schemas.microsoft.com/office/drawing/2014/main" val="3292036623"/>
+                  </a:ext>
+                </a:extLst>
+              </a:tr>
+              <a:tr h="201741">
+                <a:tc>
+                  <a:txBody>
+                    <a:bodyPr/>
+                    <a:lstStyle/>
+                    <a:p>
+                      <a:pPr rtl="0" fontAlgn="t">
+                        <a:spcBef>
+                          <a:spcPts val="0"/>
+                        </a:spcBef>
+                        <a:spcAft>
+                          <a:spcPts val="0"/>
+                        </a:spcAft>
+                      </a:pPr>
+                      <a:r>
+                        <a:rPr lang="fr-FR" sz="800" b="1" i="0" u="none" strike="noStrike">
+                          <a:solidFill>
+                            <a:srgbClr val="000000"/>
+                          </a:solidFill>
+                          <a:effectLst/>
+                          <a:latin typeface="Arial" panose="020B0604020202020204" pitchFamily="34" charset="0"/>
+                        </a:rPr>
+                        <a:t>Wind</a:t>
+                      </a:r>
+                      <a:endParaRPr lang="fr-FR" sz="1200">
+                        <a:effectLst/>
+                      </a:endParaRPr>
+                    </a:p>
+                  </a:txBody>
+                  <a:tcPr marL="43479" marR="43479" marT="43479" marB="43479">
+                    <a:lnL w="12700" cap="flat" cmpd="sng" algn="ctr">
+                      <a:solidFill>
+                        <a:srgbClr val="000000"/>
+                      </a:solidFill>
+                      <a:prstDash val="solid"/>
+                      <a:round/>
+                      <a:headEnd type="none" w="med" len="med"/>
+                      <a:tailEnd type="none" w="med" len="med"/>
+                    </a:lnL>
+                    <a:lnR w="12700" cap="flat" cmpd="sng" algn="ctr">
+                      <a:solidFill>
+                        <a:srgbClr val="000000"/>
+                      </a:solidFill>
+                      <a:prstDash val="solid"/>
+                      <a:round/>
+                      <a:headEnd type="none" w="med" len="med"/>
+                      <a:tailEnd type="none" w="med" len="med"/>
+                    </a:lnR>
+                    <a:lnT w="12700" cap="flat" cmpd="sng" algn="ctr">
+                      <a:solidFill>
+                        <a:srgbClr val="000000"/>
+                      </a:solidFill>
+                      <a:prstDash val="solid"/>
+                      <a:round/>
+                      <a:headEnd type="none" w="med" len="med"/>
+                      <a:tailEnd type="none" w="med" len="med"/>
+                    </a:lnT>
+                    <a:lnB w="12700" cap="flat" cmpd="sng" algn="ctr">
+                      <a:solidFill>
+                        <a:srgbClr val="000000"/>
+                      </a:solidFill>
+                      <a:prstDash val="solid"/>
+                      <a:round/>
+                      <a:headEnd type="none" w="med" len="med"/>
+                      <a:tailEnd type="none" w="med" len="med"/>
+                    </a:lnB>
+                  </a:tcPr>
+                </a:tc>
+                <a:extLst>
+                  <a:ext uri="{0D108BD9-81ED-4DB2-BD59-A6C34878D82A}">
+                    <a16:rowId xmlns:a16="http://schemas.microsoft.com/office/drawing/2014/main" val="1170299833"/>
+                  </a:ext>
+                </a:extLst>
+              </a:tr>
+              <a:tr h="201741">
+                <a:tc>
+                  <a:txBody>
+                    <a:bodyPr/>
+                    <a:lstStyle/>
+                    <a:p>
+                      <a:pPr rtl="0" fontAlgn="t">
+                        <a:spcBef>
+                          <a:spcPts val="0"/>
+                        </a:spcBef>
+                        <a:spcAft>
+                          <a:spcPts val="0"/>
+                        </a:spcAft>
+                      </a:pPr>
+                      <a:r>
+                        <a:rPr lang="fr-FR" sz="800" b="1" i="0" u="none" strike="noStrike">
+                          <a:solidFill>
+                            <a:srgbClr val="000000"/>
+                          </a:solidFill>
+                          <a:effectLst/>
+                          <a:latin typeface="Arial" panose="020B0604020202020204" pitchFamily="34" charset="0"/>
+                        </a:rPr>
+                        <a:t>WindDir</a:t>
+                      </a:r>
+                      <a:endParaRPr lang="fr-FR" sz="1200">
+                        <a:effectLst/>
+                      </a:endParaRPr>
+                    </a:p>
+                  </a:txBody>
+                  <a:tcPr marL="43479" marR="43479" marT="43479" marB="43479">
+                    <a:lnL w="12700" cap="flat" cmpd="sng" algn="ctr">
+                      <a:solidFill>
+                        <a:srgbClr val="000000"/>
+                      </a:solidFill>
+                      <a:prstDash val="solid"/>
+                      <a:round/>
+                      <a:headEnd type="none" w="med" len="med"/>
+                      <a:tailEnd type="none" w="med" len="med"/>
+                    </a:lnL>
+                    <a:lnR w="12700" cap="flat" cmpd="sng" algn="ctr">
+                      <a:solidFill>
+                        <a:srgbClr val="000000"/>
+                      </a:solidFill>
+                      <a:prstDash val="solid"/>
+                      <a:round/>
+                      <a:headEnd type="none" w="med" len="med"/>
+                      <a:tailEnd type="none" w="med" len="med"/>
+                    </a:lnR>
+                    <a:lnT w="12700" cap="flat" cmpd="sng" algn="ctr">
+                      <a:solidFill>
+                        <a:srgbClr val="000000"/>
+                      </a:solidFill>
+                      <a:prstDash val="solid"/>
+                      <a:round/>
+                      <a:headEnd type="none" w="med" len="med"/>
+                      <a:tailEnd type="none" w="med" len="med"/>
+                    </a:lnT>
+                    <a:lnB w="12700" cap="flat" cmpd="sng" algn="ctr">
+                      <a:solidFill>
+                        <a:srgbClr val="000000"/>
+                      </a:solidFill>
+                      <a:prstDash val="solid"/>
+                      <a:round/>
+                      <a:headEnd type="none" w="med" len="med"/>
+                      <a:tailEnd type="none" w="med" len="med"/>
+                    </a:lnB>
+                  </a:tcPr>
+                </a:tc>
+                <a:extLst>
+                  <a:ext uri="{0D108BD9-81ED-4DB2-BD59-A6C34878D82A}">
+                    <a16:rowId xmlns:a16="http://schemas.microsoft.com/office/drawing/2014/main" val="3019799347"/>
+                  </a:ext>
+                </a:extLst>
+              </a:tr>
+              <a:tr h="201741">
+                <a:tc>
+                  <a:txBody>
+                    <a:bodyPr/>
+                    <a:lstStyle/>
+                    <a:p>
+                      <a:pPr rtl="0" fontAlgn="t">
+                        <a:spcBef>
+                          <a:spcPts val="0"/>
+                        </a:spcBef>
+                        <a:spcAft>
+                          <a:spcPts val="0"/>
+                        </a:spcAft>
+                      </a:pPr>
+                      <a:endParaRPr lang="fr-FR" sz="1200" dirty="0">
+                        <a:effectLst/>
+                      </a:endParaRPr>
+                    </a:p>
+                  </a:txBody>
+                  <a:tcPr marL="43479" marR="43479" marT="43479" marB="43479">
+                    <a:lnL w="12700" cap="flat" cmpd="sng" algn="ctr">
+                      <a:solidFill>
+                        <a:srgbClr val="000000"/>
+                      </a:solidFill>
+                      <a:prstDash val="solid"/>
+                      <a:round/>
+                      <a:headEnd type="none" w="med" len="med"/>
+                      <a:tailEnd type="none" w="med" len="med"/>
+                    </a:lnL>
+                    <a:lnR w="12700" cap="flat" cmpd="sng" algn="ctr">
+                      <a:solidFill>
+                        <a:srgbClr val="000000"/>
+                      </a:solidFill>
+                      <a:prstDash val="solid"/>
+                      <a:round/>
+                      <a:headEnd type="none" w="med" len="med"/>
+                      <a:tailEnd type="none" w="med" len="med"/>
+                    </a:lnR>
+                    <a:lnT w="12700" cap="flat" cmpd="sng" algn="ctr">
+                      <a:solidFill>
+                        <a:srgbClr val="000000"/>
+                      </a:solidFill>
+                      <a:prstDash val="solid"/>
+                      <a:round/>
+                      <a:headEnd type="none" w="med" len="med"/>
+                      <a:tailEnd type="none" w="med" len="med"/>
+                    </a:lnT>
+                    <a:lnB w="12700" cap="flat" cmpd="sng" algn="ctr">
+                      <a:solidFill>
+                        <a:srgbClr val="000000"/>
+                      </a:solidFill>
+                      <a:prstDash val="solid"/>
+                      <a:round/>
+                      <a:headEnd type="none" w="med" len="med"/>
+                      <a:tailEnd type="none" w="med" len="med"/>
+                    </a:lnB>
+                  </a:tcPr>
+                </a:tc>
+                <a:extLst>
+                  <a:ext uri="{0D108BD9-81ED-4DB2-BD59-A6C34878D82A}">
+                    <a16:rowId xmlns:a16="http://schemas.microsoft.com/office/drawing/2014/main" val="1130776670"/>
+                  </a:ext>
+                </a:extLst>
+              </a:tr>
+              <a:tr h="201741">
+                <a:tc>
+                  <a:txBody>
+                    <a:bodyPr/>
+                    <a:lstStyle/>
+                    <a:p>
+                      <a:pPr rtl="0" fontAlgn="t">
+                        <a:spcBef>
+                          <a:spcPts val="0"/>
+                        </a:spcBef>
+                        <a:spcAft>
+                          <a:spcPts val="0"/>
+                        </a:spcAft>
+                      </a:pPr>
+                      <a:r>
+                        <a:rPr lang="fr-FR" sz="800" b="1" i="0" u="none" strike="noStrike">
+                          <a:solidFill>
+                            <a:srgbClr val="000000"/>
+                          </a:solidFill>
+                          <a:effectLst/>
+                          <a:latin typeface="Arial" panose="020B0604020202020204" pitchFamily="34" charset="0"/>
+                        </a:rPr>
+                        <a:t>AirT</a:t>
+                      </a:r>
+                      <a:endParaRPr lang="fr-FR" sz="1200">
+                        <a:effectLst/>
+                      </a:endParaRPr>
+                    </a:p>
+                  </a:txBody>
+                  <a:tcPr marL="43479" marR="43479" marT="43479" marB="43479">
+                    <a:lnL w="12700" cap="flat" cmpd="sng" algn="ctr">
+                      <a:solidFill>
+                        <a:srgbClr val="000000"/>
+                      </a:solidFill>
+                      <a:prstDash val="solid"/>
+                      <a:round/>
+                      <a:headEnd type="none" w="med" len="med"/>
+                      <a:tailEnd type="none" w="med" len="med"/>
+                    </a:lnL>
+                    <a:lnR w="12700" cap="flat" cmpd="sng" algn="ctr">
+                      <a:solidFill>
+                        <a:srgbClr val="000000"/>
+                      </a:solidFill>
+                      <a:prstDash val="solid"/>
+                      <a:round/>
+                      <a:headEnd type="none" w="med" len="med"/>
+                      <a:tailEnd type="none" w="med" len="med"/>
+                    </a:lnR>
+                    <a:lnT w="12700" cap="flat" cmpd="sng" algn="ctr">
+                      <a:solidFill>
+                        <a:srgbClr val="000000"/>
+                      </a:solidFill>
+                      <a:prstDash val="solid"/>
+                      <a:round/>
+                      <a:headEnd type="none" w="med" len="med"/>
+                      <a:tailEnd type="none" w="med" len="med"/>
+                    </a:lnT>
+                    <a:lnB w="12700" cap="flat" cmpd="sng" algn="ctr">
+                      <a:solidFill>
+                        <a:srgbClr val="000000"/>
+                      </a:solidFill>
+                      <a:prstDash val="solid"/>
+                      <a:round/>
+                      <a:headEnd type="none" w="med" len="med"/>
+                      <a:tailEnd type="none" w="med" len="med"/>
+                    </a:lnB>
+                  </a:tcPr>
+                </a:tc>
+                <a:extLst>
+                  <a:ext uri="{0D108BD9-81ED-4DB2-BD59-A6C34878D82A}">
+                    <a16:rowId xmlns:a16="http://schemas.microsoft.com/office/drawing/2014/main" val="138640127"/>
+                  </a:ext>
+                </a:extLst>
+              </a:tr>
+              <a:tr h="201741">
+                <a:tc>
+                  <a:txBody>
+                    <a:bodyPr/>
+                    <a:lstStyle/>
+                    <a:p>
+                      <a:pPr rtl="0" fontAlgn="t">
+                        <a:spcBef>
+                          <a:spcPts val="0"/>
+                        </a:spcBef>
+                        <a:spcAft>
+                          <a:spcPts val="0"/>
+                        </a:spcAft>
+                      </a:pPr>
+                      <a:r>
+                        <a:rPr lang="fr-FR" sz="800" b="1" i="0" u="none" strike="noStrike">
+                          <a:solidFill>
+                            <a:srgbClr val="000000"/>
+                          </a:solidFill>
+                          <a:effectLst/>
+                          <a:latin typeface="Arial" panose="020B0604020202020204" pitchFamily="34" charset="0"/>
+                        </a:rPr>
+                        <a:t>AirRH</a:t>
+                      </a:r>
+                      <a:endParaRPr lang="fr-FR" sz="1200">
+                        <a:effectLst/>
+                      </a:endParaRPr>
+                    </a:p>
+                  </a:txBody>
+                  <a:tcPr marL="43479" marR="43479" marT="43479" marB="43479">
+                    <a:lnL w="12700" cap="flat" cmpd="sng" algn="ctr">
+                      <a:solidFill>
+                        <a:srgbClr val="000000"/>
+                      </a:solidFill>
+                      <a:prstDash val="solid"/>
+                      <a:round/>
+                      <a:headEnd type="none" w="med" len="med"/>
+                      <a:tailEnd type="none" w="med" len="med"/>
+                    </a:lnL>
+                    <a:lnR w="12700" cap="flat" cmpd="sng" algn="ctr">
+                      <a:solidFill>
+                        <a:srgbClr val="000000"/>
+                      </a:solidFill>
+                      <a:prstDash val="solid"/>
+                      <a:round/>
+                      <a:headEnd type="none" w="med" len="med"/>
+                      <a:tailEnd type="none" w="med" len="med"/>
+                    </a:lnR>
+                    <a:lnT w="12700" cap="flat" cmpd="sng" algn="ctr">
+                      <a:solidFill>
+                        <a:srgbClr val="000000"/>
+                      </a:solidFill>
+                      <a:prstDash val="solid"/>
+                      <a:round/>
+                      <a:headEnd type="none" w="med" len="med"/>
+                      <a:tailEnd type="none" w="med" len="med"/>
+                    </a:lnT>
+                    <a:lnB w="12700" cap="flat" cmpd="sng" algn="ctr">
+                      <a:solidFill>
+                        <a:srgbClr val="000000"/>
+                      </a:solidFill>
+                      <a:prstDash val="solid"/>
+                      <a:round/>
+                      <a:headEnd type="none" w="med" len="med"/>
+                      <a:tailEnd type="none" w="med" len="med"/>
+                    </a:lnB>
+                  </a:tcPr>
+                </a:tc>
+                <a:extLst>
+                  <a:ext uri="{0D108BD9-81ED-4DB2-BD59-A6C34878D82A}">
+                    <a16:rowId xmlns:a16="http://schemas.microsoft.com/office/drawing/2014/main" val="313593971"/>
+                  </a:ext>
+                </a:extLst>
+              </a:tr>
+              <a:tr h="201741">
+                <a:tc>
+                  <a:txBody>
+                    <a:bodyPr/>
+                    <a:lstStyle/>
+                    <a:p>
+                      <a:pPr rtl="0" fontAlgn="t">
+                        <a:spcBef>
+                          <a:spcPts val="0"/>
+                        </a:spcBef>
+                        <a:spcAft>
+                          <a:spcPts val="0"/>
+                        </a:spcAft>
+                      </a:pPr>
+                      <a:r>
+                        <a:rPr lang="fr-FR" sz="800" b="1" i="0" u="none" strike="noStrike">
+                          <a:solidFill>
+                            <a:srgbClr val="0000FF"/>
+                          </a:solidFill>
+                          <a:effectLst/>
+                          <a:latin typeface="Arial" panose="020B0604020202020204" pitchFamily="34" charset="0"/>
+                        </a:rPr>
+                        <a:t>Pstat</a:t>
+                      </a:r>
+                      <a:endParaRPr lang="fr-FR" sz="1200">
+                        <a:effectLst/>
+                      </a:endParaRPr>
+                    </a:p>
+                  </a:txBody>
+                  <a:tcPr marL="43479" marR="43479" marT="43479" marB="43479">
+                    <a:lnL w="12700" cap="flat" cmpd="sng" algn="ctr">
+                      <a:solidFill>
+                        <a:srgbClr val="000000"/>
+                      </a:solidFill>
+                      <a:prstDash val="solid"/>
+                      <a:round/>
+                      <a:headEnd type="none" w="med" len="med"/>
+                      <a:tailEnd type="none" w="med" len="med"/>
+                    </a:lnL>
+                    <a:lnR w="12700" cap="flat" cmpd="sng" algn="ctr">
+                      <a:solidFill>
+                        <a:srgbClr val="000000"/>
+                      </a:solidFill>
+                      <a:prstDash val="solid"/>
+                      <a:round/>
+                      <a:headEnd type="none" w="med" len="med"/>
+                      <a:tailEnd type="none" w="med" len="med"/>
+                    </a:lnR>
+                    <a:lnT w="12700" cap="flat" cmpd="sng" algn="ctr">
+                      <a:solidFill>
+                        <a:srgbClr val="000000"/>
+                      </a:solidFill>
+                      <a:prstDash val="solid"/>
+                      <a:round/>
+                      <a:headEnd type="none" w="med" len="med"/>
+                      <a:tailEnd type="none" w="med" len="med"/>
+                    </a:lnT>
+                    <a:lnB w="12700" cap="flat" cmpd="sng" algn="ctr">
+                      <a:solidFill>
+                        <a:srgbClr val="000000"/>
+                      </a:solidFill>
+                      <a:prstDash val="solid"/>
+                      <a:round/>
+                      <a:headEnd type="none" w="med" len="med"/>
+                      <a:tailEnd type="none" w="med" len="med"/>
+                    </a:lnB>
+                  </a:tcPr>
+                </a:tc>
+                <a:extLst>
+                  <a:ext uri="{0D108BD9-81ED-4DB2-BD59-A6C34878D82A}">
+                    <a16:rowId xmlns:a16="http://schemas.microsoft.com/office/drawing/2014/main" val="1946682792"/>
+                  </a:ext>
+                </a:extLst>
+              </a:tr>
+              <a:tr h="201741">
+                <a:tc>
+                  <a:txBody>
+                    <a:bodyPr/>
+                    <a:lstStyle/>
+                    <a:p>
+                      <a:pPr rtl="0" fontAlgn="t">
+                        <a:spcBef>
+                          <a:spcPts val="0"/>
+                        </a:spcBef>
+                        <a:spcAft>
+                          <a:spcPts val="0"/>
+                        </a:spcAft>
+                      </a:pPr>
+                      <a:r>
+                        <a:rPr lang="fr-FR" sz="800" b="1" i="0" u="none" strike="noStrike">
+                          <a:solidFill>
+                            <a:srgbClr val="0000FF"/>
+                          </a:solidFill>
+                          <a:effectLst/>
+                          <a:latin typeface="Arial" panose="020B0604020202020204" pitchFamily="34" charset="0"/>
+                        </a:rPr>
+                        <a:t>Vario</a:t>
+                      </a:r>
+                      <a:endParaRPr lang="fr-FR" sz="1200">
+                        <a:effectLst/>
+                      </a:endParaRPr>
+                    </a:p>
+                  </a:txBody>
+                  <a:tcPr marL="43479" marR="43479" marT="43479" marB="43479">
+                    <a:lnL w="12700" cap="flat" cmpd="sng" algn="ctr">
+                      <a:solidFill>
+                        <a:srgbClr val="000000"/>
+                      </a:solidFill>
+                      <a:prstDash val="solid"/>
+                      <a:round/>
+                      <a:headEnd type="none" w="med" len="med"/>
+                      <a:tailEnd type="none" w="med" len="med"/>
+                    </a:lnL>
+                    <a:lnR w="12700" cap="flat" cmpd="sng" algn="ctr">
+                      <a:solidFill>
+                        <a:srgbClr val="000000"/>
+                      </a:solidFill>
+                      <a:prstDash val="solid"/>
+                      <a:round/>
+                      <a:headEnd type="none" w="med" len="med"/>
+                      <a:tailEnd type="none" w="med" len="med"/>
+                    </a:lnR>
+                    <a:lnT w="12700" cap="flat" cmpd="sng" algn="ctr">
+                      <a:solidFill>
+                        <a:srgbClr val="000000"/>
+                      </a:solidFill>
+                      <a:prstDash val="solid"/>
+                      <a:round/>
+                      <a:headEnd type="none" w="med" len="med"/>
+                      <a:tailEnd type="none" w="med" len="med"/>
+                    </a:lnT>
+                    <a:lnB w="12700" cap="flat" cmpd="sng" algn="ctr">
+                      <a:solidFill>
+                        <a:srgbClr val="000000"/>
+                      </a:solidFill>
+                      <a:prstDash val="solid"/>
+                      <a:round/>
+                      <a:headEnd type="none" w="med" len="med"/>
+                      <a:tailEnd type="none" w="med" len="med"/>
+                    </a:lnB>
+                  </a:tcPr>
+                </a:tc>
+                <a:extLst>
+                  <a:ext uri="{0D108BD9-81ED-4DB2-BD59-A6C34878D82A}">
+                    <a16:rowId xmlns:a16="http://schemas.microsoft.com/office/drawing/2014/main" val="272188427"/>
+                  </a:ext>
+                </a:extLst>
+              </a:tr>
+              <a:tr h="201741">
+                <a:tc>
+                  <a:txBody>
+                    <a:bodyPr/>
+                    <a:lstStyle/>
+                    <a:p>
+                      <a:pPr rtl="0" fontAlgn="t">
+                        <a:spcBef>
+                          <a:spcPts val="0"/>
+                        </a:spcBef>
+                        <a:spcAft>
+                          <a:spcPts val="0"/>
+                        </a:spcAft>
+                      </a:pPr>
+                      <a:r>
+                        <a:rPr lang="fr-FR" sz="800" b="1" i="0" u="none" strike="noStrike">
+                          <a:solidFill>
+                            <a:srgbClr val="000000"/>
+                          </a:solidFill>
+                          <a:effectLst/>
+                          <a:latin typeface="Arial" panose="020B0604020202020204" pitchFamily="34" charset="0"/>
+                        </a:rPr>
+                        <a:t>Gs</a:t>
+                      </a:r>
+                      <a:endParaRPr lang="fr-FR" sz="1200">
+                        <a:effectLst/>
+                      </a:endParaRPr>
+                    </a:p>
+                  </a:txBody>
+                  <a:tcPr marL="43479" marR="43479" marT="43479" marB="43479">
+                    <a:lnL w="12700" cap="flat" cmpd="sng" algn="ctr">
+                      <a:solidFill>
+                        <a:srgbClr val="000000"/>
+                      </a:solidFill>
+                      <a:prstDash val="solid"/>
+                      <a:round/>
+                      <a:headEnd type="none" w="med" len="med"/>
+                      <a:tailEnd type="none" w="med" len="med"/>
+                    </a:lnL>
+                    <a:lnR w="12700" cap="flat" cmpd="sng" algn="ctr">
+                      <a:solidFill>
+                        <a:srgbClr val="000000"/>
+                      </a:solidFill>
+                      <a:prstDash val="solid"/>
+                      <a:round/>
+                      <a:headEnd type="none" w="med" len="med"/>
+                      <a:tailEnd type="none" w="med" len="med"/>
+                    </a:lnR>
+                    <a:lnT w="12700" cap="flat" cmpd="sng" algn="ctr">
+                      <a:solidFill>
+                        <a:srgbClr val="000000"/>
+                      </a:solidFill>
+                      <a:prstDash val="solid"/>
+                      <a:round/>
+                      <a:headEnd type="none" w="med" len="med"/>
+                      <a:tailEnd type="none" w="med" len="med"/>
+                    </a:lnT>
+                    <a:lnB w="12700" cap="flat" cmpd="sng" algn="ctr">
+                      <a:solidFill>
+                        <a:srgbClr val="000000"/>
+                      </a:solidFill>
+                      <a:prstDash val="solid"/>
+                      <a:round/>
+                      <a:headEnd type="none" w="med" len="med"/>
+                      <a:tailEnd type="none" w="med" len="med"/>
+                    </a:lnB>
+                  </a:tcPr>
+                </a:tc>
+                <a:extLst>
+                  <a:ext uri="{0D108BD9-81ED-4DB2-BD59-A6C34878D82A}">
+                    <a16:rowId xmlns:a16="http://schemas.microsoft.com/office/drawing/2014/main" val="2058734764"/>
+                  </a:ext>
+                </a:extLst>
+              </a:tr>
+              <a:tr h="201741">
+                <a:tc>
+                  <a:txBody>
+                    <a:bodyPr/>
+                    <a:lstStyle/>
+                    <a:p>
+                      <a:pPr rtl="0" fontAlgn="t">
+                        <a:spcBef>
+                          <a:spcPts val="0"/>
+                        </a:spcBef>
+                        <a:spcAft>
+                          <a:spcPts val="0"/>
+                        </a:spcAft>
+                      </a:pPr>
+                      <a:r>
+                        <a:rPr lang="fr-FR" sz="800" b="1" i="0" u="none" strike="noStrike" dirty="0" err="1" smtClean="0">
+                          <a:solidFill>
+                            <a:srgbClr val="000000"/>
+                          </a:solidFill>
+                          <a:effectLst/>
+                          <a:latin typeface="Arial" panose="020B0604020202020204" pitchFamily="34" charset="0"/>
+                        </a:rPr>
+                        <a:t>Compass_heading</a:t>
+                      </a:r>
+                      <a:endParaRPr lang="fr-FR" sz="1200" dirty="0">
+                        <a:effectLst/>
+                      </a:endParaRPr>
+                    </a:p>
+                  </a:txBody>
+                  <a:tcPr marL="43479" marR="43479" marT="43479" marB="43479">
+                    <a:lnL w="12700" cap="flat" cmpd="sng" algn="ctr">
+                      <a:solidFill>
+                        <a:srgbClr val="000000"/>
+                      </a:solidFill>
+                      <a:prstDash val="solid"/>
+                      <a:round/>
+                      <a:headEnd type="none" w="med" len="med"/>
+                      <a:tailEnd type="none" w="med" len="med"/>
+                    </a:lnL>
+                    <a:lnR w="12700" cap="flat" cmpd="sng" algn="ctr">
+                      <a:solidFill>
+                        <a:srgbClr val="000000"/>
+                      </a:solidFill>
+                      <a:prstDash val="solid"/>
+                      <a:round/>
+                      <a:headEnd type="none" w="med" len="med"/>
+                      <a:tailEnd type="none" w="med" len="med"/>
+                    </a:lnR>
+                    <a:lnT w="12700" cap="flat" cmpd="sng" algn="ctr">
+                      <a:solidFill>
+                        <a:srgbClr val="000000"/>
+                      </a:solidFill>
+                      <a:prstDash val="solid"/>
+                      <a:round/>
+                      <a:headEnd type="none" w="med" len="med"/>
+                      <a:tailEnd type="none" w="med" len="med"/>
+                    </a:lnT>
+                    <a:lnB w="12700" cap="flat" cmpd="sng" algn="ctr">
+                      <a:solidFill>
+                        <a:srgbClr val="000000"/>
+                      </a:solidFill>
+                      <a:prstDash val="solid"/>
+                      <a:round/>
+                      <a:headEnd type="none" w="med" len="med"/>
+                      <a:tailEnd type="none" w="med" len="med"/>
+                    </a:lnB>
+                  </a:tcPr>
+                </a:tc>
+                <a:extLst>
+                  <a:ext uri="{0D108BD9-81ED-4DB2-BD59-A6C34878D82A}">
+                    <a16:rowId xmlns:a16="http://schemas.microsoft.com/office/drawing/2014/main" val="933689694"/>
+                  </a:ext>
+                </a:extLst>
+              </a:tr>
+              <a:tr h="201741">
+                <a:tc>
+                  <a:txBody>
+                    <a:bodyPr/>
+                    <a:lstStyle/>
+                    <a:p>
+                      <a:pPr rtl="0" fontAlgn="t">
+                        <a:spcBef>
+                          <a:spcPts val="0"/>
+                        </a:spcBef>
+                        <a:spcAft>
+                          <a:spcPts val="0"/>
+                        </a:spcAft>
+                      </a:pPr>
+                      <a:r>
+                        <a:rPr lang="fr-FR" sz="800" b="1" i="0" u="none" strike="noStrike">
+                          <a:solidFill>
+                            <a:srgbClr val="000000"/>
+                          </a:solidFill>
+                          <a:effectLst/>
+                          <a:latin typeface="Arial" panose="020B0604020202020204" pitchFamily="34" charset="0"/>
+                        </a:rPr>
+                        <a:t>Pitch</a:t>
+                      </a:r>
+                      <a:endParaRPr lang="fr-FR" sz="1200">
+                        <a:effectLst/>
+                      </a:endParaRPr>
+                    </a:p>
+                  </a:txBody>
+                  <a:tcPr marL="43479" marR="43479" marT="43479" marB="43479">
+                    <a:lnL w="12700" cap="flat" cmpd="sng" algn="ctr">
+                      <a:solidFill>
+                        <a:srgbClr val="000000"/>
+                      </a:solidFill>
+                      <a:prstDash val="solid"/>
+                      <a:round/>
+                      <a:headEnd type="none" w="med" len="med"/>
+                      <a:tailEnd type="none" w="med" len="med"/>
+                    </a:lnL>
+                    <a:lnR w="12700" cap="flat" cmpd="sng" algn="ctr">
+                      <a:solidFill>
+                        <a:srgbClr val="000000"/>
+                      </a:solidFill>
+                      <a:prstDash val="solid"/>
+                      <a:round/>
+                      <a:headEnd type="none" w="med" len="med"/>
+                      <a:tailEnd type="none" w="med" len="med"/>
+                    </a:lnR>
+                    <a:lnT w="12700" cap="flat" cmpd="sng" algn="ctr">
+                      <a:solidFill>
+                        <a:srgbClr val="000000"/>
+                      </a:solidFill>
+                      <a:prstDash val="solid"/>
+                      <a:round/>
+                      <a:headEnd type="none" w="med" len="med"/>
+                      <a:tailEnd type="none" w="med" len="med"/>
+                    </a:lnT>
+                    <a:lnB w="12700" cap="flat" cmpd="sng" algn="ctr">
+                      <a:solidFill>
+                        <a:srgbClr val="000000"/>
+                      </a:solidFill>
+                      <a:prstDash val="solid"/>
+                      <a:round/>
+                      <a:headEnd type="none" w="med" len="med"/>
+                      <a:tailEnd type="none" w="med" len="med"/>
+                    </a:lnB>
+                  </a:tcPr>
+                </a:tc>
+                <a:extLst>
+                  <a:ext uri="{0D108BD9-81ED-4DB2-BD59-A6C34878D82A}">
+                    <a16:rowId xmlns:a16="http://schemas.microsoft.com/office/drawing/2014/main" val="3271958007"/>
+                  </a:ext>
+                </a:extLst>
+              </a:tr>
+              <a:tr h="201741">
+                <a:tc>
+                  <a:txBody>
+                    <a:bodyPr/>
+                    <a:lstStyle/>
+                    <a:p>
+                      <a:pPr rtl="0" fontAlgn="t">
+                        <a:spcBef>
+                          <a:spcPts val="0"/>
+                        </a:spcBef>
+                        <a:spcAft>
+                          <a:spcPts val="0"/>
+                        </a:spcAft>
+                      </a:pPr>
+                      <a:r>
+                        <a:rPr lang="fr-FR" sz="800" b="1" i="0" u="none" strike="noStrike" dirty="0">
+                          <a:solidFill>
+                            <a:srgbClr val="000000"/>
+                          </a:solidFill>
+                          <a:effectLst/>
+                          <a:latin typeface="Arial" panose="020B0604020202020204" pitchFamily="34" charset="0"/>
+                        </a:rPr>
+                        <a:t>Roll</a:t>
+                      </a:r>
+                      <a:endParaRPr lang="fr-FR" sz="1200" dirty="0">
+                        <a:effectLst/>
+                      </a:endParaRPr>
+                    </a:p>
+                  </a:txBody>
+                  <a:tcPr marL="43479" marR="43479" marT="43479" marB="43479">
+                    <a:lnL w="12700" cap="flat" cmpd="sng" algn="ctr">
+                      <a:solidFill>
+                        <a:srgbClr val="000000"/>
+                      </a:solidFill>
+                      <a:prstDash val="solid"/>
+                      <a:round/>
+                      <a:headEnd type="none" w="med" len="med"/>
+                      <a:tailEnd type="none" w="med" len="med"/>
+                    </a:lnL>
+                    <a:lnR w="12700" cap="flat" cmpd="sng" algn="ctr">
+                      <a:solidFill>
+                        <a:srgbClr val="000000"/>
+                      </a:solidFill>
+                      <a:prstDash val="solid"/>
+                      <a:round/>
+                      <a:headEnd type="none" w="med" len="med"/>
+                      <a:tailEnd type="none" w="med" len="med"/>
+                    </a:lnR>
+                    <a:lnT w="12700" cap="flat" cmpd="sng" algn="ctr">
+                      <a:solidFill>
+                        <a:srgbClr val="000000"/>
+                      </a:solidFill>
+                      <a:prstDash val="solid"/>
+                      <a:round/>
+                      <a:headEnd type="none" w="med" len="med"/>
+                      <a:tailEnd type="none" w="med" len="med"/>
+                    </a:lnT>
+                    <a:lnB w="12700" cap="flat" cmpd="sng" algn="ctr">
+                      <a:solidFill>
+                        <a:srgbClr val="000000"/>
+                      </a:solidFill>
+                      <a:prstDash val="solid"/>
+                      <a:round/>
+                      <a:headEnd type="none" w="med" len="med"/>
+                      <a:tailEnd type="none" w="med" len="med"/>
+                    </a:lnB>
+                  </a:tcPr>
+                </a:tc>
+                <a:extLst>
+                  <a:ext uri="{0D108BD9-81ED-4DB2-BD59-A6C34878D82A}">
+                    <a16:rowId xmlns:a16="http://schemas.microsoft.com/office/drawing/2014/main" val="1206041243"/>
+                  </a:ext>
+                </a:extLst>
+              </a:tr>
+            </a:tbl>
+          </a:graphicData>
+        </a:graphic>
+      </p:graphicFrame>
+      <p:graphicFrame>
+        <p:nvGraphicFramePr>
+          <p:cNvPr id="12" name="Tableau 11"/>
+          <p:cNvGraphicFramePr>
+            <a:graphicFrameLocks noGrp="1"/>
+          </p:cNvGraphicFramePr>
+          <p:nvPr>
+            <p:extLst>
+              <p:ext uri="{D42A27DB-BD31-4B8C-83A1-F6EECF244321}">
+                <p14:modId xmlns:p14="http://schemas.microsoft.com/office/powerpoint/2010/main" val="2028769552"/>
+              </p:ext>
+            </p:extLst>
+          </p:nvPr>
+        </p:nvGraphicFramePr>
+        <p:xfrm>
+          <a:off x="8186860" y="925944"/>
+          <a:ext cx="1200150" cy="2463800"/>
+        </p:xfrm>
+        <a:graphic>
+          <a:graphicData uri="http://schemas.openxmlformats.org/drawingml/2006/table">
+            <a:tbl>
+              <a:tblPr/>
+              <a:tblGrid>
+                <a:gridCol w="1200150">
+                  <a:extLst>
+                    <a:ext uri="{9D8B030D-6E8A-4147-A177-3AD203B41FA5}">
+                      <a16:colId xmlns:a16="http://schemas.microsoft.com/office/drawing/2014/main" val="2682108522"/>
+                    </a:ext>
+                  </a:extLst>
+                </a:gridCol>
+              </a:tblGrid>
+              <a:tr h="0">
+                <a:tc>
+                  <a:txBody>
+                    <a:bodyPr/>
+                    <a:lstStyle/>
+                    <a:p>
+                      <a:pPr rtl="0" fontAlgn="t">
+                        <a:spcBef>
+                          <a:spcPts val="0"/>
+                        </a:spcBef>
+                        <a:spcAft>
+                          <a:spcPts val="0"/>
+                        </a:spcAft>
+                      </a:pPr>
+                      <a:endParaRPr lang="fr-FR" dirty="0">
+                        <a:effectLst/>
+                      </a:endParaRPr>
+                    </a:p>
+                  </a:txBody>
+                  <a:tcPr marL="63500" marR="63500" marT="63500" marB="63500">
+                    <a:lnL w="12700" cap="flat" cmpd="sng" algn="ctr">
+                      <a:solidFill>
+                        <a:srgbClr val="000000"/>
+                      </a:solidFill>
+                      <a:prstDash val="solid"/>
+                      <a:round/>
+                      <a:headEnd type="none" w="med" len="med"/>
+                      <a:tailEnd type="none" w="med" len="med"/>
+                    </a:lnL>
+                    <a:lnR w="12700" cap="flat" cmpd="sng" algn="ctr">
+                      <a:solidFill>
+                        <a:srgbClr val="000000"/>
+                      </a:solidFill>
+                      <a:prstDash val="solid"/>
+                      <a:round/>
+                      <a:headEnd type="none" w="med" len="med"/>
+                      <a:tailEnd type="none" w="med" len="med"/>
+                    </a:lnR>
+                    <a:lnT w="12700" cap="flat" cmpd="sng" algn="ctr">
+                      <a:solidFill>
+                        <a:srgbClr val="000000"/>
+                      </a:solidFill>
+                      <a:prstDash val="solid"/>
+                      <a:round/>
+                      <a:headEnd type="none" w="med" len="med"/>
+                      <a:tailEnd type="none" w="med" len="med"/>
+                    </a:lnT>
+                    <a:lnB w="12700" cap="flat" cmpd="sng" algn="ctr">
+                      <a:solidFill>
+                        <a:srgbClr val="000000"/>
+                      </a:solidFill>
+                      <a:prstDash val="solid"/>
+                      <a:round/>
+                      <a:headEnd type="none" w="med" len="med"/>
+                      <a:tailEnd type="none" w="med" len="med"/>
+                    </a:lnB>
+                  </a:tcPr>
+                </a:tc>
+                <a:extLst>
+                  <a:ext uri="{0D108BD9-81ED-4DB2-BD59-A6C34878D82A}">
+                    <a16:rowId xmlns:a16="http://schemas.microsoft.com/office/drawing/2014/main" val="706080440"/>
+                  </a:ext>
+                </a:extLst>
+              </a:tr>
+              <a:tr h="0">
+                <a:tc>
+                  <a:txBody>
+                    <a:bodyPr/>
+                    <a:lstStyle/>
+                    <a:p>
+                      <a:pPr rtl="0" fontAlgn="t">
+                        <a:spcBef>
+                          <a:spcPts val="0"/>
+                        </a:spcBef>
+                        <a:spcAft>
+                          <a:spcPts val="0"/>
+                        </a:spcAft>
+                      </a:pPr>
+                      <a:r>
+                        <a:rPr lang="fr-FR" sz="1100" b="1" i="0" u="none" strike="noStrike">
+                          <a:solidFill>
+                            <a:srgbClr val="000000"/>
+                          </a:solidFill>
+                          <a:effectLst/>
+                          <a:latin typeface="Arial" panose="020B0604020202020204" pitchFamily="34" charset="0"/>
+                        </a:rPr>
+                        <a:t>AirES</a:t>
+                      </a:r>
+                      <a:endParaRPr lang="fr-FR">
+                        <a:effectLst/>
+                      </a:endParaRPr>
+                    </a:p>
+                  </a:txBody>
+                  <a:tcPr marL="63500" marR="63500" marT="63500" marB="63500">
+                    <a:lnL w="12700" cap="flat" cmpd="sng" algn="ctr">
+                      <a:solidFill>
+                        <a:srgbClr val="000000"/>
+                      </a:solidFill>
+                      <a:prstDash val="solid"/>
+                      <a:round/>
+                      <a:headEnd type="none" w="med" len="med"/>
+                      <a:tailEnd type="none" w="med" len="med"/>
+                    </a:lnL>
+                    <a:lnR w="12700" cap="flat" cmpd="sng" algn="ctr">
+                      <a:solidFill>
+                        <a:srgbClr val="000000"/>
+                      </a:solidFill>
+                      <a:prstDash val="solid"/>
+                      <a:round/>
+                      <a:headEnd type="none" w="med" len="med"/>
+                      <a:tailEnd type="none" w="med" len="med"/>
+                    </a:lnR>
+                    <a:lnT w="12700" cap="flat" cmpd="sng" algn="ctr">
+                      <a:solidFill>
+                        <a:srgbClr val="000000"/>
+                      </a:solidFill>
+                      <a:prstDash val="solid"/>
+                      <a:round/>
+                      <a:headEnd type="none" w="med" len="med"/>
+                      <a:tailEnd type="none" w="med" len="med"/>
+                    </a:lnT>
+                    <a:lnB w="12700" cap="flat" cmpd="sng" algn="ctr">
+                      <a:solidFill>
+                        <a:srgbClr val="000000"/>
+                      </a:solidFill>
+                      <a:prstDash val="solid"/>
+                      <a:round/>
+                      <a:headEnd type="none" w="med" len="med"/>
+                      <a:tailEnd type="none" w="med" len="med"/>
+                    </a:lnB>
+                  </a:tcPr>
+                </a:tc>
+                <a:extLst>
+                  <a:ext uri="{0D108BD9-81ED-4DB2-BD59-A6C34878D82A}">
+                    <a16:rowId xmlns:a16="http://schemas.microsoft.com/office/drawing/2014/main" val="777090840"/>
+                  </a:ext>
+                </a:extLst>
+              </a:tr>
+              <a:tr h="0">
+                <a:tc>
+                  <a:txBody>
+                    <a:bodyPr/>
+                    <a:lstStyle/>
+                    <a:p>
+                      <a:pPr rtl="0" fontAlgn="t">
+                        <a:spcBef>
+                          <a:spcPts val="0"/>
+                        </a:spcBef>
+                        <a:spcAft>
+                          <a:spcPts val="0"/>
+                        </a:spcAft>
+                      </a:pPr>
+                      <a:r>
+                        <a:rPr lang="fr-FR" sz="1100" b="1" i="0" u="none" strike="noStrike">
+                          <a:solidFill>
+                            <a:srgbClr val="000000"/>
+                          </a:solidFill>
+                          <a:effectLst/>
+                          <a:latin typeface="Arial" panose="020B0604020202020204" pitchFamily="34" charset="0"/>
+                        </a:rPr>
+                        <a:t>AirE</a:t>
+                      </a:r>
+                      <a:endParaRPr lang="fr-FR">
+                        <a:effectLst/>
+                      </a:endParaRPr>
+                    </a:p>
+                  </a:txBody>
+                  <a:tcPr marL="63500" marR="63500" marT="63500" marB="63500">
+                    <a:lnL w="12700" cap="flat" cmpd="sng" algn="ctr">
+                      <a:solidFill>
+                        <a:srgbClr val="000000"/>
+                      </a:solidFill>
+                      <a:prstDash val="solid"/>
+                      <a:round/>
+                      <a:headEnd type="none" w="med" len="med"/>
+                      <a:tailEnd type="none" w="med" len="med"/>
+                    </a:lnL>
+                    <a:lnR w="12700" cap="flat" cmpd="sng" algn="ctr">
+                      <a:solidFill>
+                        <a:srgbClr val="000000"/>
+                      </a:solidFill>
+                      <a:prstDash val="solid"/>
+                      <a:round/>
+                      <a:headEnd type="none" w="med" len="med"/>
+                      <a:tailEnd type="none" w="med" len="med"/>
+                    </a:lnR>
+                    <a:lnT w="12700" cap="flat" cmpd="sng" algn="ctr">
+                      <a:solidFill>
+                        <a:srgbClr val="000000"/>
+                      </a:solidFill>
+                      <a:prstDash val="solid"/>
+                      <a:round/>
+                      <a:headEnd type="none" w="med" len="med"/>
+                      <a:tailEnd type="none" w="med" len="med"/>
+                    </a:lnT>
+                    <a:lnB w="12700" cap="flat" cmpd="sng" algn="ctr">
+                      <a:solidFill>
+                        <a:srgbClr val="000000"/>
+                      </a:solidFill>
+                      <a:prstDash val="solid"/>
+                      <a:round/>
+                      <a:headEnd type="none" w="med" len="med"/>
+                      <a:tailEnd type="none" w="med" len="med"/>
+                    </a:lnB>
+                  </a:tcPr>
+                </a:tc>
+                <a:extLst>
+                  <a:ext uri="{0D108BD9-81ED-4DB2-BD59-A6C34878D82A}">
+                    <a16:rowId xmlns:a16="http://schemas.microsoft.com/office/drawing/2014/main" val="2811565597"/>
+                  </a:ext>
+                </a:extLst>
+              </a:tr>
+              <a:tr h="0">
+                <a:tc>
+                  <a:txBody>
+                    <a:bodyPr/>
+                    <a:lstStyle/>
+                    <a:p>
+                      <a:pPr rtl="0" fontAlgn="t">
+                        <a:spcBef>
+                          <a:spcPts val="0"/>
+                        </a:spcBef>
+                        <a:spcAft>
+                          <a:spcPts val="0"/>
+                        </a:spcAft>
+                      </a:pPr>
+                      <a:r>
+                        <a:rPr lang="fr-FR" sz="1100" b="1" i="0" u="none" strike="noStrike">
+                          <a:solidFill>
+                            <a:srgbClr val="000000"/>
+                          </a:solidFill>
+                          <a:effectLst/>
+                          <a:latin typeface="Arial" panose="020B0604020202020204" pitchFamily="34" charset="0"/>
+                        </a:rPr>
+                        <a:t>AirW</a:t>
+                      </a:r>
+                      <a:endParaRPr lang="fr-FR">
+                        <a:effectLst/>
+                      </a:endParaRPr>
+                    </a:p>
+                  </a:txBody>
+                  <a:tcPr marL="63500" marR="63500" marT="63500" marB="63500">
+                    <a:lnL w="12700" cap="flat" cmpd="sng" algn="ctr">
+                      <a:solidFill>
+                        <a:srgbClr val="000000"/>
+                      </a:solidFill>
+                      <a:prstDash val="solid"/>
+                      <a:round/>
+                      <a:headEnd type="none" w="med" len="med"/>
+                      <a:tailEnd type="none" w="med" len="med"/>
+                    </a:lnL>
+                    <a:lnR w="12700" cap="flat" cmpd="sng" algn="ctr">
+                      <a:solidFill>
+                        <a:srgbClr val="000000"/>
+                      </a:solidFill>
+                      <a:prstDash val="solid"/>
+                      <a:round/>
+                      <a:headEnd type="none" w="med" len="med"/>
+                      <a:tailEnd type="none" w="med" len="med"/>
+                    </a:lnR>
+                    <a:lnT w="12700" cap="flat" cmpd="sng" algn="ctr">
+                      <a:solidFill>
+                        <a:srgbClr val="000000"/>
+                      </a:solidFill>
+                      <a:prstDash val="solid"/>
+                      <a:round/>
+                      <a:headEnd type="none" w="med" len="med"/>
+                      <a:tailEnd type="none" w="med" len="med"/>
+                    </a:lnT>
+                    <a:lnB w="12700" cap="flat" cmpd="sng" algn="ctr">
+                      <a:solidFill>
+                        <a:srgbClr val="000000"/>
+                      </a:solidFill>
+                      <a:prstDash val="solid"/>
+                      <a:round/>
+                      <a:headEnd type="none" w="med" len="med"/>
+                      <a:tailEnd type="none" w="med" len="med"/>
+                    </a:lnB>
+                  </a:tcPr>
+                </a:tc>
+                <a:extLst>
+                  <a:ext uri="{0D108BD9-81ED-4DB2-BD59-A6C34878D82A}">
+                    <a16:rowId xmlns:a16="http://schemas.microsoft.com/office/drawing/2014/main" val="4220401889"/>
+                  </a:ext>
+                </a:extLst>
+              </a:tr>
+              <a:tr h="0">
+                <a:tc>
+                  <a:txBody>
+                    <a:bodyPr/>
+                    <a:lstStyle/>
+                    <a:p>
+                      <a:pPr rtl="0" fontAlgn="t">
+                        <a:spcBef>
+                          <a:spcPts val="0"/>
+                        </a:spcBef>
+                        <a:spcAft>
+                          <a:spcPts val="0"/>
+                        </a:spcAft>
+                      </a:pPr>
+                      <a:r>
+                        <a:rPr lang="fr-FR" sz="1100" b="1" i="0" u="none" strike="noStrike">
+                          <a:solidFill>
+                            <a:srgbClr val="000000"/>
+                          </a:solidFill>
+                          <a:effectLst/>
+                          <a:latin typeface="Arial" panose="020B0604020202020204" pitchFamily="34" charset="0"/>
+                        </a:rPr>
+                        <a:t>AirTd</a:t>
+                      </a:r>
+                      <a:endParaRPr lang="fr-FR">
+                        <a:effectLst/>
+                      </a:endParaRPr>
+                    </a:p>
+                  </a:txBody>
+                  <a:tcPr marL="63500" marR="63500" marT="63500" marB="63500">
+                    <a:lnL w="12700" cap="flat" cmpd="sng" algn="ctr">
+                      <a:solidFill>
+                        <a:srgbClr val="000000"/>
+                      </a:solidFill>
+                      <a:prstDash val="solid"/>
+                      <a:round/>
+                      <a:headEnd type="none" w="med" len="med"/>
+                      <a:tailEnd type="none" w="med" len="med"/>
+                    </a:lnL>
+                    <a:lnR w="12700" cap="flat" cmpd="sng" algn="ctr">
+                      <a:solidFill>
+                        <a:srgbClr val="000000"/>
+                      </a:solidFill>
+                      <a:prstDash val="solid"/>
+                      <a:round/>
+                      <a:headEnd type="none" w="med" len="med"/>
+                      <a:tailEnd type="none" w="med" len="med"/>
+                    </a:lnR>
+                    <a:lnT w="12700" cap="flat" cmpd="sng" algn="ctr">
+                      <a:solidFill>
+                        <a:srgbClr val="000000"/>
+                      </a:solidFill>
+                      <a:prstDash val="solid"/>
+                      <a:round/>
+                      <a:headEnd type="none" w="med" len="med"/>
+                      <a:tailEnd type="none" w="med" len="med"/>
+                    </a:lnT>
+                    <a:lnB w="12700" cap="flat" cmpd="sng" algn="ctr">
+                      <a:solidFill>
+                        <a:srgbClr val="000000"/>
+                      </a:solidFill>
+                      <a:prstDash val="solid"/>
+                      <a:round/>
+                      <a:headEnd type="none" w="med" len="med"/>
+                      <a:tailEnd type="none" w="med" len="med"/>
+                    </a:lnB>
+                  </a:tcPr>
+                </a:tc>
+                <a:extLst>
+                  <a:ext uri="{0D108BD9-81ED-4DB2-BD59-A6C34878D82A}">
+                    <a16:rowId xmlns:a16="http://schemas.microsoft.com/office/drawing/2014/main" val="3376330620"/>
+                  </a:ext>
+                </a:extLst>
+              </a:tr>
+              <a:tr h="0">
+                <a:tc>
+                  <a:txBody>
+                    <a:bodyPr/>
+                    <a:lstStyle/>
+                    <a:p>
+                      <a:pPr rtl="0" fontAlgn="t">
+                        <a:spcBef>
+                          <a:spcPts val="0"/>
+                        </a:spcBef>
+                        <a:spcAft>
+                          <a:spcPts val="0"/>
+                        </a:spcAft>
+                      </a:pPr>
+                      <a:r>
+                        <a:rPr lang="fr-FR" sz="1100" b="1" i="0" u="none" strike="noStrike" dirty="0">
+                          <a:solidFill>
+                            <a:srgbClr val="000000"/>
+                          </a:solidFill>
+                          <a:effectLst/>
+                          <a:latin typeface="Arial" panose="020B0604020202020204" pitchFamily="34" charset="0"/>
+                        </a:rPr>
+                        <a:t>LCL</a:t>
+                      </a:r>
+                      <a:endParaRPr lang="fr-FR" dirty="0">
+                        <a:effectLst/>
+                      </a:endParaRPr>
+                    </a:p>
+                  </a:txBody>
+                  <a:tcPr marL="63500" marR="63500" marT="63500" marB="63500">
+                    <a:lnL w="12700" cap="flat" cmpd="sng" algn="ctr">
+                      <a:solidFill>
+                        <a:srgbClr val="000000"/>
+                      </a:solidFill>
+                      <a:prstDash val="solid"/>
+                      <a:round/>
+                      <a:headEnd type="none" w="med" len="med"/>
+                      <a:tailEnd type="none" w="med" len="med"/>
+                    </a:lnL>
+                    <a:lnR w="12700" cap="flat" cmpd="sng" algn="ctr">
+                      <a:solidFill>
+                        <a:srgbClr val="000000"/>
+                      </a:solidFill>
+                      <a:prstDash val="solid"/>
+                      <a:round/>
+                      <a:headEnd type="none" w="med" len="med"/>
+                      <a:tailEnd type="none" w="med" len="med"/>
+                    </a:lnR>
+                    <a:lnT w="12700" cap="flat" cmpd="sng" algn="ctr">
+                      <a:solidFill>
+                        <a:srgbClr val="000000"/>
+                      </a:solidFill>
+                      <a:prstDash val="solid"/>
+                      <a:round/>
+                      <a:headEnd type="none" w="med" len="med"/>
+                      <a:tailEnd type="none" w="med" len="med"/>
+                    </a:lnT>
+                    <a:lnB w="12700" cap="flat" cmpd="sng" algn="ctr">
+                      <a:solidFill>
+                        <a:srgbClr val="000000"/>
+                      </a:solidFill>
+                      <a:prstDash val="solid"/>
+                      <a:round/>
+                      <a:headEnd type="none" w="med" len="med"/>
+                      <a:tailEnd type="none" w="med" len="med"/>
+                    </a:lnB>
+                  </a:tcPr>
+                </a:tc>
+                <a:extLst>
+                  <a:ext uri="{0D108BD9-81ED-4DB2-BD59-A6C34878D82A}">
+                    <a16:rowId xmlns:a16="http://schemas.microsoft.com/office/drawing/2014/main" val="828092208"/>
+                  </a:ext>
+                </a:extLst>
+              </a:tr>
+              <a:tr h="0">
+                <a:tc>
+                  <a:txBody>
+                    <a:bodyPr/>
+                    <a:lstStyle/>
+                    <a:p>
+                      <a:pPr rtl="0" fontAlgn="t">
+                        <a:spcBef>
+                          <a:spcPts val="0"/>
+                        </a:spcBef>
+                        <a:spcAft>
+                          <a:spcPts val="0"/>
+                        </a:spcAft>
+                      </a:pPr>
+                      <a:r>
+                        <a:rPr lang="fr-FR" sz="1100" b="1" i="0" u="none" strike="noStrike" dirty="0" err="1">
+                          <a:solidFill>
+                            <a:srgbClr val="000000"/>
+                          </a:solidFill>
+                          <a:effectLst/>
+                          <a:latin typeface="Arial" panose="020B0604020202020204" pitchFamily="34" charset="0"/>
+                        </a:rPr>
+                        <a:t>AirTheta</a:t>
+                      </a:r>
+                      <a:endParaRPr lang="fr-FR" dirty="0">
+                        <a:effectLst/>
+                      </a:endParaRPr>
+                    </a:p>
+                  </a:txBody>
+                  <a:tcPr marL="63500" marR="63500" marT="63500" marB="63500">
+                    <a:lnL w="12700" cap="flat" cmpd="sng" algn="ctr">
+                      <a:solidFill>
+                        <a:srgbClr val="000000"/>
+                      </a:solidFill>
+                      <a:prstDash val="solid"/>
+                      <a:round/>
+                      <a:headEnd type="none" w="med" len="med"/>
+                      <a:tailEnd type="none" w="med" len="med"/>
+                    </a:lnL>
+                    <a:lnR w="12700" cap="flat" cmpd="sng" algn="ctr">
+                      <a:solidFill>
+                        <a:srgbClr val="000000"/>
+                      </a:solidFill>
+                      <a:prstDash val="solid"/>
+                      <a:round/>
+                      <a:headEnd type="none" w="med" len="med"/>
+                      <a:tailEnd type="none" w="med" len="med"/>
+                    </a:lnR>
+                    <a:lnT w="12700" cap="flat" cmpd="sng" algn="ctr">
+                      <a:solidFill>
+                        <a:srgbClr val="000000"/>
+                      </a:solidFill>
+                      <a:prstDash val="solid"/>
+                      <a:round/>
+                      <a:headEnd type="none" w="med" len="med"/>
+                      <a:tailEnd type="none" w="med" len="med"/>
+                    </a:lnT>
+                    <a:lnB w="12700" cap="flat" cmpd="sng" algn="ctr">
+                      <a:solidFill>
+                        <a:srgbClr val="000000"/>
+                      </a:solidFill>
+                      <a:prstDash val="solid"/>
+                      <a:round/>
+                      <a:headEnd type="none" w="med" len="med"/>
+                      <a:tailEnd type="none" w="med" len="med"/>
+                    </a:lnB>
+                  </a:tcPr>
+                </a:tc>
+                <a:extLst>
+                  <a:ext uri="{0D108BD9-81ED-4DB2-BD59-A6C34878D82A}">
+                    <a16:rowId xmlns:a16="http://schemas.microsoft.com/office/drawing/2014/main" val="2801792511"/>
+                  </a:ext>
+                </a:extLst>
+              </a:tr>
+              <a:tr h="0">
+                <a:tc>
+                  <a:txBody>
+                    <a:bodyPr/>
+                    <a:lstStyle/>
+                    <a:p>
+                      <a:pPr rtl="0" fontAlgn="t">
+                        <a:spcBef>
+                          <a:spcPts val="0"/>
+                        </a:spcBef>
+                        <a:spcAft>
+                          <a:spcPts val="0"/>
+                        </a:spcAft>
+                      </a:pPr>
+                      <a:r>
+                        <a:rPr lang="fr-FR" sz="1100" b="1" i="0" u="none" strike="noStrike" dirty="0" err="1">
+                          <a:solidFill>
+                            <a:srgbClr val="000000"/>
+                          </a:solidFill>
+                          <a:effectLst/>
+                          <a:latin typeface="Arial" panose="020B0604020202020204" pitchFamily="34" charset="0"/>
+                        </a:rPr>
+                        <a:t>AirRho</a:t>
+                      </a:r>
+                      <a:endParaRPr lang="fr-FR" dirty="0">
+                        <a:effectLst/>
+                      </a:endParaRPr>
+                    </a:p>
+                  </a:txBody>
+                  <a:tcPr marL="63500" marR="63500" marT="63500" marB="63500">
+                    <a:lnL w="12700" cap="flat" cmpd="sng" algn="ctr">
+                      <a:solidFill>
+                        <a:srgbClr val="000000"/>
+                      </a:solidFill>
+                      <a:prstDash val="solid"/>
+                      <a:round/>
+                      <a:headEnd type="none" w="med" len="med"/>
+                      <a:tailEnd type="none" w="med" len="med"/>
+                    </a:lnL>
+                    <a:lnR w="12700" cap="flat" cmpd="sng" algn="ctr">
+                      <a:solidFill>
+                        <a:srgbClr val="000000"/>
+                      </a:solidFill>
+                      <a:prstDash val="solid"/>
+                      <a:round/>
+                      <a:headEnd type="none" w="med" len="med"/>
+                      <a:tailEnd type="none" w="med" len="med"/>
+                    </a:lnR>
+                    <a:lnT w="12700" cap="flat" cmpd="sng" algn="ctr">
+                      <a:solidFill>
+                        <a:srgbClr val="000000"/>
+                      </a:solidFill>
+                      <a:prstDash val="solid"/>
+                      <a:round/>
+                      <a:headEnd type="none" w="med" len="med"/>
+                      <a:tailEnd type="none" w="med" len="med"/>
+                    </a:lnT>
+                    <a:lnB w="12700" cap="flat" cmpd="sng" algn="ctr">
+                      <a:solidFill>
+                        <a:srgbClr val="000000"/>
+                      </a:solidFill>
+                      <a:prstDash val="solid"/>
+                      <a:round/>
+                      <a:headEnd type="none" w="med" len="med"/>
+                      <a:tailEnd type="none" w="med" len="med"/>
+                    </a:lnB>
+                  </a:tcPr>
+                </a:tc>
+                <a:extLst>
+                  <a:ext uri="{0D108BD9-81ED-4DB2-BD59-A6C34878D82A}">
+                    <a16:rowId xmlns:a16="http://schemas.microsoft.com/office/drawing/2014/main" val="1359389034"/>
+                  </a:ext>
+                </a:extLst>
+              </a:tr>
+            </a:tbl>
+          </a:graphicData>
+        </a:graphic>
+      </p:graphicFrame>
+      <p:graphicFrame>
+        <p:nvGraphicFramePr>
+          <p:cNvPr id="13" name="Tableau 12"/>
+          <p:cNvGraphicFramePr>
+            <a:graphicFrameLocks noGrp="1"/>
+          </p:cNvGraphicFramePr>
+          <p:nvPr>
+            <p:extLst>
+              <p:ext uri="{D42A27DB-BD31-4B8C-83A1-F6EECF244321}">
+                <p14:modId xmlns:p14="http://schemas.microsoft.com/office/powerpoint/2010/main" val="2884047217"/>
+              </p:ext>
+            </p:extLst>
+          </p:nvPr>
+        </p:nvGraphicFramePr>
+        <p:xfrm>
+          <a:off x="9667007" y="925944"/>
+          <a:ext cx="1200150" cy="2297316"/>
+        </p:xfrm>
+        <a:graphic>
+          <a:graphicData uri="http://schemas.openxmlformats.org/drawingml/2006/table">
+            <a:tbl>
+              <a:tblPr/>
+              <a:tblGrid>
+                <a:gridCol w="1200150">
+                  <a:extLst>
+                    <a:ext uri="{9D8B030D-6E8A-4147-A177-3AD203B41FA5}">
+                      <a16:colId xmlns:a16="http://schemas.microsoft.com/office/drawing/2014/main" val="2282372846"/>
+                    </a:ext>
+                  </a:extLst>
+                </a:gridCol>
+              </a:tblGrid>
+              <a:tr h="0">
+                <a:tc>
+                  <a:txBody>
+                    <a:bodyPr/>
+                    <a:lstStyle/>
+                    <a:p>
+                      <a:pPr rtl="0" fontAlgn="t">
+                        <a:spcBef>
+                          <a:spcPts val="0"/>
+                        </a:spcBef>
+                        <a:spcAft>
+                          <a:spcPts val="0"/>
+                        </a:spcAft>
+                      </a:pPr>
+                      <a:endParaRPr lang="fr-FR" dirty="0">
+                        <a:effectLst/>
+                      </a:endParaRPr>
+                    </a:p>
+                  </a:txBody>
+                  <a:tcPr marL="63500" marR="63500" marT="63500" marB="63500">
+                    <a:lnL w="12700" cap="flat" cmpd="sng" algn="ctr">
+                      <a:solidFill>
+                        <a:srgbClr val="000000"/>
+                      </a:solidFill>
+                      <a:prstDash val="solid"/>
+                      <a:round/>
+                      <a:headEnd type="none" w="med" len="med"/>
+                      <a:tailEnd type="none" w="med" len="med"/>
+                    </a:lnL>
+                    <a:lnR w="12700" cap="flat" cmpd="sng" algn="ctr">
+                      <a:solidFill>
+                        <a:srgbClr val="000000"/>
+                      </a:solidFill>
+                      <a:prstDash val="solid"/>
+                      <a:round/>
+                      <a:headEnd type="none" w="med" len="med"/>
+                      <a:tailEnd type="none" w="med" len="med"/>
+                    </a:lnR>
+                    <a:lnT w="12700" cap="flat" cmpd="sng" algn="ctr">
+                      <a:solidFill>
+                        <a:srgbClr val="000000"/>
+                      </a:solidFill>
+                      <a:prstDash val="solid"/>
+                      <a:round/>
+                      <a:headEnd type="none" w="med" len="med"/>
+                      <a:tailEnd type="none" w="med" len="med"/>
+                    </a:lnT>
+                    <a:lnB w="12700" cap="flat" cmpd="sng" algn="ctr">
+                      <a:solidFill>
+                        <a:srgbClr val="000000"/>
+                      </a:solidFill>
+                      <a:prstDash val="solid"/>
+                      <a:round/>
+                      <a:headEnd type="none" w="med" len="med"/>
+                      <a:tailEnd type="none" w="med" len="med"/>
+                    </a:lnB>
+                  </a:tcPr>
+                </a:tc>
+                <a:extLst>
+                  <a:ext uri="{0D108BD9-81ED-4DB2-BD59-A6C34878D82A}">
+                    <a16:rowId xmlns:a16="http://schemas.microsoft.com/office/drawing/2014/main" val="3167354724"/>
+                  </a:ext>
+                </a:extLst>
+              </a:tr>
+              <a:tr h="0">
+                <a:tc>
+                  <a:txBody>
+                    <a:bodyPr/>
+                    <a:lstStyle/>
+                    <a:p>
+                      <a:pPr rtl="0" fontAlgn="t">
+                        <a:spcBef>
+                          <a:spcPts val="0"/>
+                        </a:spcBef>
+                        <a:spcAft>
+                          <a:spcPts val="0"/>
+                        </a:spcAft>
+                      </a:pPr>
+                      <a:endParaRPr lang="fr-FR" dirty="0">
+                        <a:effectLst/>
+                      </a:endParaRPr>
+                    </a:p>
+                  </a:txBody>
+                  <a:tcPr marL="63500" marR="63500" marT="63500" marB="63500">
+                    <a:lnL w="12700" cap="flat" cmpd="sng" algn="ctr">
+                      <a:solidFill>
+                        <a:srgbClr val="000000"/>
+                      </a:solidFill>
+                      <a:prstDash val="solid"/>
+                      <a:round/>
+                      <a:headEnd type="none" w="med" len="med"/>
+                      <a:tailEnd type="none" w="med" len="med"/>
+                    </a:lnL>
+                    <a:lnR w="12700" cap="flat" cmpd="sng" algn="ctr">
+                      <a:solidFill>
+                        <a:srgbClr val="000000"/>
+                      </a:solidFill>
+                      <a:prstDash val="solid"/>
+                      <a:round/>
+                      <a:headEnd type="none" w="med" len="med"/>
+                      <a:tailEnd type="none" w="med" len="med"/>
+                    </a:lnR>
+                    <a:lnT w="12700" cap="flat" cmpd="sng" algn="ctr">
+                      <a:solidFill>
+                        <a:srgbClr val="000000"/>
+                      </a:solidFill>
+                      <a:prstDash val="solid"/>
+                      <a:round/>
+                      <a:headEnd type="none" w="med" len="med"/>
+                      <a:tailEnd type="none" w="med" len="med"/>
+                    </a:lnT>
+                    <a:lnB w="12700" cap="flat" cmpd="sng" algn="ctr">
+                      <a:solidFill>
+                        <a:srgbClr val="000000"/>
+                      </a:solidFill>
+                      <a:prstDash val="solid"/>
+                      <a:round/>
+                      <a:headEnd type="none" w="med" len="med"/>
+                      <a:tailEnd type="none" w="med" len="med"/>
+                    </a:lnB>
+                  </a:tcPr>
+                </a:tc>
+                <a:extLst>
+                  <a:ext uri="{0D108BD9-81ED-4DB2-BD59-A6C34878D82A}">
+                    <a16:rowId xmlns:a16="http://schemas.microsoft.com/office/drawing/2014/main" val="1923777904"/>
+                  </a:ext>
+                </a:extLst>
+              </a:tr>
+              <a:tr h="352728">
+                <a:tc>
+                  <a:txBody>
+                    <a:bodyPr/>
+                    <a:lstStyle/>
+                    <a:p>
+                      <a:pPr rtl="0" fontAlgn="t">
+                        <a:spcBef>
+                          <a:spcPts val="0"/>
+                        </a:spcBef>
+                        <a:spcAft>
+                          <a:spcPts val="0"/>
+                        </a:spcAft>
+                      </a:pPr>
+                      <a:r>
+                        <a:rPr lang="fr-FR" sz="1100" b="1" i="0" u="none" strike="noStrike" dirty="0">
+                          <a:solidFill>
+                            <a:srgbClr val="000000"/>
+                          </a:solidFill>
+                          <a:effectLst/>
+                          <a:latin typeface="Arial" panose="020B0604020202020204" pitchFamily="34" charset="0"/>
+                        </a:rPr>
+                        <a:t> </a:t>
+                      </a:r>
+                      <a:endParaRPr lang="fr-FR" dirty="0">
+                        <a:effectLst/>
+                      </a:endParaRPr>
+                    </a:p>
+                  </a:txBody>
+                  <a:tcPr marL="63500" marR="63500" marT="63500" marB="63500">
+                    <a:lnL w="12700" cap="flat" cmpd="sng" algn="ctr">
+                      <a:solidFill>
+                        <a:srgbClr val="000000"/>
+                      </a:solidFill>
+                      <a:prstDash val="solid"/>
+                      <a:round/>
+                      <a:headEnd type="none" w="med" len="med"/>
+                      <a:tailEnd type="none" w="med" len="med"/>
+                    </a:lnL>
+                    <a:lnR w="12700" cap="flat" cmpd="sng" algn="ctr">
+                      <a:solidFill>
+                        <a:srgbClr val="000000"/>
+                      </a:solidFill>
+                      <a:prstDash val="solid"/>
+                      <a:round/>
+                      <a:headEnd type="none" w="med" len="med"/>
+                      <a:tailEnd type="none" w="med" len="med"/>
+                    </a:lnR>
+                    <a:lnT w="12700" cap="flat" cmpd="sng" algn="ctr">
+                      <a:solidFill>
+                        <a:srgbClr val="000000"/>
+                      </a:solidFill>
+                      <a:prstDash val="solid"/>
+                      <a:round/>
+                      <a:headEnd type="none" w="med" len="med"/>
+                      <a:tailEnd type="none" w="med" len="med"/>
+                    </a:lnT>
+                    <a:lnB w="12700" cap="flat" cmpd="sng" algn="ctr">
+                      <a:solidFill>
+                        <a:srgbClr val="000000"/>
+                      </a:solidFill>
+                      <a:prstDash val="solid"/>
+                      <a:round/>
+                      <a:headEnd type="none" w="med" len="med"/>
+                      <a:tailEnd type="none" w="med" len="med"/>
+                    </a:lnB>
+                  </a:tcPr>
+                </a:tc>
+                <a:extLst>
+                  <a:ext uri="{0D108BD9-81ED-4DB2-BD59-A6C34878D82A}">
+                    <a16:rowId xmlns:a16="http://schemas.microsoft.com/office/drawing/2014/main" val="1039321649"/>
+                  </a:ext>
+                </a:extLst>
+              </a:tr>
+              <a:tr h="445988">
+                <a:tc>
+                  <a:txBody>
+                    <a:bodyPr/>
+                    <a:lstStyle/>
+                    <a:p>
+                      <a:pPr rtl="0" fontAlgn="t">
+                        <a:spcBef>
+                          <a:spcPts val="0"/>
+                        </a:spcBef>
+                        <a:spcAft>
+                          <a:spcPts val="0"/>
+                        </a:spcAft>
+                      </a:pPr>
+                      <a:r>
+                        <a:rPr lang="fr-FR" sz="1100" b="1" i="0" u="none" strike="noStrike" dirty="0" err="1">
+                          <a:solidFill>
+                            <a:srgbClr val="000000"/>
+                          </a:solidFill>
+                          <a:effectLst/>
+                          <a:latin typeface="Arial" panose="020B0604020202020204" pitchFamily="34" charset="0"/>
+                        </a:rPr>
+                        <a:t>VarioIAS</a:t>
+                      </a:r>
+                      <a:endParaRPr lang="fr-FR" dirty="0">
+                        <a:effectLst/>
+                      </a:endParaRPr>
+                    </a:p>
+                  </a:txBody>
+                  <a:tcPr marL="63500" marR="63500" marT="63500" marB="63500">
+                    <a:lnL w="12700" cap="flat" cmpd="sng" algn="ctr">
+                      <a:solidFill>
+                        <a:srgbClr val="000000"/>
+                      </a:solidFill>
+                      <a:prstDash val="solid"/>
+                      <a:round/>
+                      <a:headEnd type="none" w="med" len="med"/>
+                      <a:tailEnd type="none" w="med" len="med"/>
+                    </a:lnL>
+                    <a:lnR w="12700" cap="flat" cmpd="sng" algn="ctr">
+                      <a:solidFill>
+                        <a:srgbClr val="000000"/>
+                      </a:solidFill>
+                      <a:prstDash val="solid"/>
+                      <a:round/>
+                      <a:headEnd type="none" w="med" len="med"/>
+                      <a:tailEnd type="none" w="med" len="med"/>
+                    </a:lnR>
+                    <a:lnT w="12700" cap="flat" cmpd="sng" algn="ctr">
+                      <a:solidFill>
+                        <a:srgbClr val="000000"/>
+                      </a:solidFill>
+                      <a:prstDash val="solid"/>
+                      <a:round/>
+                      <a:headEnd type="none" w="med" len="med"/>
+                      <a:tailEnd type="none" w="med" len="med"/>
+                    </a:lnT>
+                    <a:lnB w="12700" cap="flat" cmpd="sng" algn="ctr">
+                      <a:solidFill>
+                        <a:srgbClr val="000000"/>
+                      </a:solidFill>
+                      <a:prstDash val="solid"/>
+                      <a:round/>
+                      <a:headEnd type="none" w="med" len="med"/>
+                      <a:tailEnd type="none" w="med" len="med"/>
+                    </a:lnB>
+                  </a:tcPr>
+                </a:tc>
+                <a:extLst>
+                  <a:ext uri="{0D108BD9-81ED-4DB2-BD59-A6C34878D82A}">
+                    <a16:rowId xmlns:a16="http://schemas.microsoft.com/office/drawing/2014/main" val="1414917636"/>
+                  </a:ext>
+                </a:extLst>
+              </a:tr>
+              <a:tr h="0">
+                <a:tc>
+                  <a:txBody>
+                    <a:bodyPr/>
+                    <a:lstStyle/>
+                    <a:p>
+                      <a:pPr rtl="0" fontAlgn="t">
+                        <a:spcBef>
+                          <a:spcPts val="0"/>
+                        </a:spcBef>
+                        <a:spcAft>
+                          <a:spcPts val="0"/>
+                        </a:spcAft>
+                      </a:pPr>
+                      <a:endParaRPr lang="fr-FR" dirty="0">
+                        <a:effectLst/>
+                      </a:endParaRPr>
+                    </a:p>
+                  </a:txBody>
+                  <a:tcPr marL="63500" marR="63500" marT="63500" marB="63500">
+                    <a:lnL w="12700" cap="flat" cmpd="sng" algn="ctr">
+                      <a:solidFill>
+                        <a:srgbClr val="000000"/>
+                      </a:solidFill>
+                      <a:prstDash val="solid"/>
+                      <a:round/>
+                      <a:headEnd type="none" w="med" len="med"/>
+                      <a:tailEnd type="none" w="med" len="med"/>
+                    </a:lnL>
+                    <a:lnR w="12700" cap="flat" cmpd="sng" algn="ctr">
+                      <a:solidFill>
+                        <a:srgbClr val="000000"/>
+                      </a:solidFill>
+                      <a:prstDash val="solid"/>
+                      <a:round/>
+                      <a:headEnd type="none" w="med" len="med"/>
+                      <a:tailEnd type="none" w="med" len="med"/>
+                    </a:lnR>
+                    <a:lnT w="12700" cap="flat" cmpd="sng" algn="ctr">
+                      <a:solidFill>
+                        <a:srgbClr val="000000"/>
+                      </a:solidFill>
+                      <a:prstDash val="solid"/>
+                      <a:round/>
+                      <a:headEnd type="none" w="med" len="med"/>
+                      <a:tailEnd type="none" w="med" len="med"/>
+                    </a:lnT>
+                    <a:lnB w="12700" cap="flat" cmpd="sng" algn="ctr">
+                      <a:solidFill>
+                        <a:srgbClr val="000000"/>
+                      </a:solidFill>
+                      <a:prstDash val="solid"/>
+                      <a:round/>
+                      <a:headEnd type="none" w="med" len="med"/>
+                      <a:tailEnd type="none" w="med" len="med"/>
+                    </a:lnB>
+                  </a:tcPr>
+                </a:tc>
+                <a:extLst>
+                  <a:ext uri="{0D108BD9-81ED-4DB2-BD59-A6C34878D82A}">
+                    <a16:rowId xmlns:a16="http://schemas.microsoft.com/office/drawing/2014/main" val="2450942517"/>
+                  </a:ext>
+                </a:extLst>
+              </a:tr>
+              <a:tr h="0">
+                <a:tc>
+                  <a:txBody>
+                    <a:bodyPr/>
+                    <a:lstStyle/>
+                    <a:p>
+                      <a:pPr rtl="0" fontAlgn="t">
+                        <a:spcBef>
+                          <a:spcPts val="0"/>
+                        </a:spcBef>
+                        <a:spcAft>
+                          <a:spcPts val="0"/>
+                        </a:spcAft>
+                      </a:pPr>
+                      <a:r>
+                        <a:rPr lang="fr-FR" sz="1100" b="1" i="0" u="none" strike="noStrike" dirty="0">
+                          <a:solidFill>
+                            <a:srgbClr val="000000"/>
+                          </a:solidFill>
+                          <a:effectLst/>
+                          <a:latin typeface="Arial" panose="020B0604020202020204" pitchFamily="34" charset="0"/>
+                        </a:rPr>
+                        <a:t>TAS</a:t>
+                      </a:r>
+                      <a:endParaRPr lang="fr-FR" dirty="0">
+                        <a:effectLst/>
+                      </a:endParaRPr>
+                    </a:p>
+                  </a:txBody>
+                  <a:tcPr marL="63500" marR="63500" marT="63500" marB="63500">
+                    <a:lnL w="12700" cap="flat" cmpd="sng" algn="ctr">
+                      <a:solidFill>
+                        <a:srgbClr val="000000"/>
+                      </a:solidFill>
+                      <a:prstDash val="solid"/>
+                      <a:round/>
+                      <a:headEnd type="none" w="med" len="med"/>
+                      <a:tailEnd type="none" w="med" len="med"/>
+                    </a:lnL>
+                    <a:lnR w="12700" cap="flat" cmpd="sng" algn="ctr">
+                      <a:solidFill>
+                        <a:srgbClr val="000000"/>
+                      </a:solidFill>
+                      <a:prstDash val="solid"/>
+                      <a:round/>
+                      <a:headEnd type="none" w="med" len="med"/>
+                      <a:tailEnd type="none" w="med" len="med"/>
+                    </a:lnR>
+                    <a:lnT w="12700" cap="flat" cmpd="sng" algn="ctr">
+                      <a:solidFill>
+                        <a:srgbClr val="000000"/>
+                      </a:solidFill>
+                      <a:prstDash val="solid"/>
+                      <a:round/>
+                      <a:headEnd type="none" w="med" len="med"/>
+                      <a:tailEnd type="none" w="med" len="med"/>
+                    </a:lnT>
+                    <a:lnB w="12700" cap="flat" cmpd="sng" algn="ctr">
+                      <a:solidFill>
+                        <a:srgbClr val="000000"/>
+                      </a:solidFill>
+                      <a:prstDash val="solid"/>
+                      <a:round/>
+                      <a:headEnd type="none" w="med" len="med"/>
+                      <a:tailEnd type="none" w="med" len="med"/>
+                    </a:lnB>
+                  </a:tcPr>
+                </a:tc>
+                <a:extLst>
+                  <a:ext uri="{0D108BD9-81ED-4DB2-BD59-A6C34878D82A}">
+                    <a16:rowId xmlns:a16="http://schemas.microsoft.com/office/drawing/2014/main" val="397980594"/>
+                  </a:ext>
+                </a:extLst>
+              </a:tr>
+            </a:tbl>
+          </a:graphicData>
+        </a:graphic>
+      </p:graphicFrame>
+      <p:graphicFrame>
+        <p:nvGraphicFramePr>
+          <p:cNvPr id="14" name="Tableau 13"/>
+          <p:cNvGraphicFramePr>
+            <a:graphicFrameLocks noGrp="1"/>
+          </p:cNvGraphicFramePr>
+          <p:nvPr>
+            <p:extLst>
+              <p:ext uri="{D42A27DB-BD31-4B8C-83A1-F6EECF244321}">
+                <p14:modId xmlns:p14="http://schemas.microsoft.com/office/powerpoint/2010/main" val="2579402466"/>
+              </p:ext>
+            </p:extLst>
+          </p:nvPr>
+        </p:nvGraphicFramePr>
+        <p:xfrm>
+          <a:off x="2135839" y="925944"/>
+          <a:ext cx="1046163" cy="990600"/>
+        </p:xfrm>
+        <a:graphic>
+          <a:graphicData uri="http://schemas.openxmlformats.org/drawingml/2006/table">
+            <a:tbl>
+              <a:tblPr/>
+              <a:tblGrid>
+                <a:gridCol w="1046163">
+                  <a:extLst>
+                    <a:ext uri="{9D8B030D-6E8A-4147-A177-3AD203B41FA5}">
+                      <a16:colId xmlns:a16="http://schemas.microsoft.com/office/drawing/2014/main" val="590288273"/>
+                    </a:ext>
+                  </a:extLst>
+                </a:gridCol>
+              </a:tblGrid>
+              <a:tr h="0">
+                <a:tc>
+                  <a:txBody>
+                    <a:bodyPr/>
+                    <a:lstStyle/>
+                    <a:p>
+                      <a:pPr rtl="0" fontAlgn="t">
+                        <a:spcBef>
+                          <a:spcPts val="0"/>
+                        </a:spcBef>
+                        <a:spcAft>
+                          <a:spcPts val="0"/>
+                        </a:spcAft>
+                      </a:pPr>
+                      <a:r>
+                        <a:rPr lang="fr-FR" sz="1100" b="1" i="0" u="none" strike="noStrike" dirty="0" smtClean="0">
+                          <a:solidFill>
+                            <a:srgbClr val="000000"/>
+                          </a:solidFill>
+                          <a:effectLst/>
+                          <a:latin typeface="Arial" panose="020B0604020202020204" pitchFamily="34" charset="0"/>
+                        </a:rPr>
+                        <a:t>pitch</a:t>
+                      </a:r>
+                      <a:endParaRPr lang="fr-FR" dirty="0">
+                        <a:effectLst/>
+                      </a:endParaRPr>
+                    </a:p>
+                  </a:txBody>
+                  <a:tcPr marL="63500" marR="63500" marT="63500" marB="63500">
+                    <a:lnL w="12700" cap="flat" cmpd="sng" algn="ctr">
+                      <a:solidFill>
+                        <a:srgbClr val="000000"/>
+                      </a:solidFill>
+                      <a:prstDash val="solid"/>
+                      <a:round/>
+                      <a:headEnd type="none" w="med" len="med"/>
+                      <a:tailEnd type="none" w="med" len="med"/>
+                    </a:lnL>
+                    <a:lnR w="12700" cap="flat" cmpd="sng" algn="ctr">
+                      <a:solidFill>
+                        <a:srgbClr val="000000"/>
+                      </a:solidFill>
+                      <a:prstDash val="solid"/>
+                      <a:round/>
+                      <a:headEnd type="none" w="med" len="med"/>
+                      <a:tailEnd type="none" w="med" len="med"/>
+                    </a:lnR>
+                    <a:lnT w="12700" cap="flat" cmpd="sng" algn="ctr">
+                      <a:solidFill>
+                        <a:srgbClr val="000000"/>
+                      </a:solidFill>
+                      <a:prstDash val="solid"/>
+                      <a:round/>
+                      <a:headEnd type="none" w="med" len="med"/>
+                      <a:tailEnd type="none" w="med" len="med"/>
+                    </a:lnT>
+                    <a:lnB w="12700" cap="flat" cmpd="sng" algn="ctr">
+                      <a:solidFill>
+                        <a:srgbClr val="000000"/>
+                      </a:solidFill>
+                      <a:prstDash val="solid"/>
+                      <a:round/>
+                      <a:headEnd type="none" w="med" len="med"/>
+                      <a:tailEnd type="none" w="med" len="med"/>
+                    </a:lnB>
+                  </a:tcPr>
+                </a:tc>
+                <a:extLst>
+                  <a:ext uri="{0D108BD9-81ED-4DB2-BD59-A6C34878D82A}">
+                    <a16:rowId xmlns:a16="http://schemas.microsoft.com/office/drawing/2014/main" val="3204336746"/>
+                  </a:ext>
+                </a:extLst>
+              </a:tr>
+              <a:tr h="0">
+                <a:tc>
+                  <a:txBody>
+                    <a:bodyPr/>
+                    <a:lstStyle/>
+                    <a:p>
+                      <a:pPr rtl="0" fontAlgn="t">
+                        <a:spcBef>
+                          <a:spcPts val="0"/>
+                        </a:spcBef>
+                        <a:spcAft>
+                          <a:spcPts val="0"/>
+                        </a:spcAft>
+                      </a:pPr>
+                      <a:r>
+                        <a:rPr lang="fr-FR" sz="1100" b="1" i="0" u="none" strike="noStrike" dirty="0" smtClean="0">
+                          <a:solidFill>
+                            <a:srgbClr val="000000"/>
+                          </a:solidFill>
+                          <a:effectLst/>
+                          <a:latin typeface="Arial" panose="020B0604020202020204" pitchFamily="34" charset="0"/>
+                        </a:rPr>
+                        <a:t>roll</a:t>
+                      </a:r>
+                      <a:endParaRPr lang="fr-FR" dirty="0">
+                        <a:effectLst/>
+                      </a:endParaRPr>
+                    </a:p>
+                  </a:txBody>
+                  <a:tcPr marL="63500" marR="63500" marT="63500" marB="63500">
+                    <a:lnL w="12700" cap="flat" cmpd="sng" algn="ctr">
+                      <a:solidFill>
+                        <a:srgbClr val="000000"/>
+                      </a:solidFill>
+                      <a:prstDash val="solid"/>
+                      <a:round/>
+                      <a:headEnd type="none" w="med" len="med"/>
+                      <a:tailEnd type="none" w="med" len="med"/>
+                    </a:lnL>
+                    <a:lnR w="12700" cap="flat" cmpd="sng" algn="ctr">
+                      <a:solidFill>
+                        <a:srgbClr val="000000"/>
+                      </a:solidFill>
+                      <a:prstDash val="solid"/>
+                      <a:round/>
+                      <a:headEnd type="none" w="med" len="med"/>
+                      <a:tailEnd type="none" w="med" len="med"/>
+                    </a:lnR>
+                    <a:lnT w="12700" cap="flat" cmpd="sng" algn="ctr">
+                      <a:solidFill>
+                        <a:srgbClr val="000000"/>
+                      </a:solidFill>
+                      <a:prstDash val="solid"/>
+                      <a:round/>
+                      <a:headEnd type="none" w="med" len="med"/>
+                      <a:tailEnd type="none" w="med" len="med"/>
+                    </a:lnT>
+                    <a:lnB w="12700" cap="flat" cmpd="sng" algn="ctr">
+                      <a:solidFill>
+                        <a:srgbClr val="000000"/>
+                      </a:solidFill>
+                      <a:prstDash val="solid"/>
+                      <a:round/>
+                      <a:headEnd type="none" w="med" len="med"/>
+                      <a:tailEnd type="none" w="med" len="med"/>
+                    </a:lnB>
+                  </a:tcPr>
+                </a:tc>
+                <a:extLst>
+                  <a:ext uri="{0D108BD9-81ED-4DB2-BD59-A6C34878D82A}">
+                    <a16:rowId xmlns:a16="http://schemas.microsoft.com/office/drawing/2014/main" val="853608259"/>
+                  </a:ext>
+                </a:extLst>
+              </a:tr>
+              <a:tr h="0">
+                <a:tc>
+                  <a:txBody>
+                    <a:bodyPr/>
+                    <a:lstStyle/>
+                    <a:p>
+                      <a:pPr rtl="0" fontAlgn="t">
+                        <a:spcBef>
+                          <a:spcPts val="0"/>
+                        </a:spcBef>
+                        <a:spcAft>
+                          <a:spcPts val="0"/>
+                        </a:spcAft>
+                      </a:pPr>
+                      <a:endParaRPr lang="fr-FR" dirty="0">
+                        <a:effectLst/>
+                      </a:endParaRPr>
+                    </a:p>
+                  </a:txBody>
+                  <a:tcPr marL="63500" marR="63500" marT="63500" marB="63500">
+                    <a:lnL w="12700" cap="flat" cmpd="sng" algn="ctr">
+                      <a:solidFill>
+                        <a:srgbClr val="000000"/>
+                      </a:solidFill>
+                      <a:prstDash val="solid"/>
+                      <a:round/>
+                      <a:headEnd type="none" w="med" len="med"/>
+                      <a:tailEnd type="none" w="med" len="med"/>
+                    </a:lnL>
+                    <a:lnR w="12700" cap="flat" cmpd="sng" algn="ctr">
+                      <a:solidFill>
+                        <a:srgbClr val="000000"/>
+                      </a:solidFill>
+                      <a:prstDash val="solid"/>
+                      <a:round/>
+                      <a:headEnd type="none" w="med" len="med"/>
+                      <a:tailEnd type="none" w="med" len="med"/>
+                    </a:lnR>
+                    <a:lnT w="12700" cap="flat" cmpd="sng" algn="ctr">
+                      <a:solidFill>
+                        <a:srgbClr val="000000"/>
+                      </a:solidFill>
+                      <a:prstDash val="solid"/>
+                      <a:round/>
+                      <a:headEnd type="none" w="med" len="med"/>
+                      <a:tailEnd type="none" w="med" len="med"/>
+                    </a:lnT>
+                    <a:lnB w="12700" cap="flat" cmpd="sng" algn="ctr">
+                      <a:solidFill>
+                        <a:srgbClr val="000000"/>
+                      </a:solidFill>
+                      <a:prstDash val="solid"/>
+                      <a:round/>
+                      <a:headEnd type="none" w="med" len="med"/>
+                      <a:tailEnd type="none" w="med" len="med"/>
+                    </a:lnB>
+                  </a:tcPr>
+                </a:tc>
+                <a:extLst>
+                  <a:ext uri="{0D108BD9-81ED-4DB2-BD59-A6C34878D82A}">
+                    <a16:rowId xmlns:a16="http://schemas.microsoft.com/office/drawing/2014/main" val="1185430977"/>
+                  </a:ext>
+                </a:extLst>
+              </a:tr>
+            </a:tbl>
+          </a:graphicData>
+        </a:graphic>
+      </p:graphicFrame>
+      <p:sp>
+        <p:nvSpPr>
+          <p:cNvPr id="17" name="ZoneTexte 16"/>
+          <p:cNvSpPr txBox="1"/>
+          <p:nvPr/>
+        </p:nvSpPr>
+        <p:spPr>
+          <a:xfrm>
+            <a:off x="6063817" y="5626307"/>
+            <a:ext cx="1590963" cy="369332"/>
+          </a:xfrm>
+          <a:prstGeom prst="rect">
+            <a:avLst/>
+          </a:prstGeom>
+          <a:noFill/>
+        </p:spPr>
+        <p:txBody>
+          <a:bodyPr wrap="square" rtlCol="0">
+            <a:spAutoFit/>
+          </a:bodyPr>
+          <a:lstStyle/>
+          <a:p>
+            <a:r>
+              <a:rPr lang="fr-FR" dirty="0" smtClean="0"/>
+              <a:t>IAS</a:t>
+            </a:r>
+            <a:endParaRPr lang="fr-FR" dirty="0"/>
+          </a:p>
+        </p:txBody>
+      </p:sp>
+      <p:sp>
+        <p:nvSpPr>
+          <p:cNvPr id="19" name="ZoneTexte 18"/>
+          <p:cNvSpPr txBox="1"/>
+          <p:nvPr/>
+        </p:nvSpPr>
+        <p:spPr>
+          <a:xfrm>
+            <a:off x="2297462" y="4928632"/>
+            <a:ext cx="1590963" cy="1477328"/>
+          </a:xfrm>
+          <a:prstGeom prst="rect">
+            <a:avLst/>
+          </a:prstGeom>
+          <a:noFill/>
+        </p:spPr>
+        <p:txBody>
+          <a:bodyPr wrap="square" rtlCol="0">
+            <a:spAutoFit/>
+          </a:bodyPr>
+          <a:lstStyle/>
+          <a:p>
+            <a:r>
+              <a:rPr lang="fr-FR" dirty="0" smtClean="0"/>
+              <a:t>PSTAT</a:t>
+            </a:r>
+            <a:br>
+              <a:rPr lang="fr-FR" dirty="0" smtClean="0"/>
+            </a:br>
+            <a:r>
+              <a:rPr lang="fr-FR" dirty="0" smtClean="0"/>
+              <a:t>VARIO</a:t>
+            </a:r>
+          </a:p>
+          <a:p>
+            <a:r>
+              <a:rPr lang="fr-FR" dirty="0" err="1" smtClean="0"/>
+              <a:t>Heading</a:t>
+            </a:r>
+            <a:r>
+              <a:rPr lang="fr-FR" dirty="0" smtClean="0"/>
+              <a:t> </a:t>
+            </a:r>
+            <a:r>
+              <a:rPr lang="fr-FR" dirty="0" err="1" smtClean="0"/>
+              <a:t>gps</a:t>
+            </a:r>
+            <a:endParaRPr lang="fr-FR" dirty="0" smtClean="0"/>
+          </a:p>
+          <a:p>
+            <a:r>
+              <a:rPr lang="fr-FR" dirty="0" err="1" smtClean="0"/>
+              <a:t>Speed_gps</a:t>
+            </a:r>
+            <a:endParaRPr lang="fr-FR" dirty="0" smtClean="0"/>
+          </a:p>
+          <a:p>
+            <a:endParaRPr lang="fr-FR" dirty="0"/>
+          </a:p>
+        </p:txBody>
+      </p:sp>
+    </p:spTree>
+    <p:extLst>
+      <p:ext uri="{BB962C8B-B14F-4D97-AF65-F5344CB8AC3E}">
+        <p14:creationId xmlns:p14="http://schemas.microsoft.com/office/powerpoint/2010/main" val="2892422797"/>
+      </p:ext>
+    </p:extLst>
+  </p:cSld>
+  <p:clrMapOvr>
+    <a:masterClrMapping/>
+  </p:clrMapOvr>
+</p:sld>
+</file>
+
 <file path=ppt/theme/theme1.xml><?xml version="1.0" encoding="utf-8"?>
 <a:theme xmlns:a="http://schemas.openxmlformats.org/drawingml/2006/main" name="Thème Office">
   <a:themeElements>

</xml_diff>

<commit_message>
Correction des calculs et des récupérations des valeurs IGC
</commit_message>
<xml_diff>
--- a/ressources/code.pptx
+++ b/ressources/code.pptx
@@ -156,10 +156,9 @@
           </a:lstStyle>
           <a:p>
             <a:r>
-              <a:rPr lang="fr-FR" smtClean="0"/>
+              <a:rPr lang="fr-FR"/>
               <a:t>Modifiez le style du titre</a:t>
             </a:r>
-            <a:endParaRPr lang="fr-FR"/>
           </a:p>
         </p:txBody>
       </p:sp>
@@ -221,10 +220,9 @@
           </a:lstStyle>
           <a:p>
             <a:r>
-              <a:rPr lang="fr-FR" smtClean="0"/>
+              <a:rPr lang="fr-FR"/>
               <a:t>Modifier le style des sous-titres du masque</a:t>
             </a:r>
-            <a:endParaRPr lang="fr-FR"/>
           </a:p>
         </p:txBody>
       </p:sp>
@@ -245,7 +243,7 @@
           <a:p>
             <a:fld id="{253B1B7A-19D7-47DD-996A-6E83BE59A4F5}" type="datetimeFigureOut">
               <a:rPr lang="fr-FR" smtClean="0"/>
-              <a:t>30/01/2026</a:t>
+              <a:t>04/03/2026</a:t>
             </a:fld>
             <a:endParaRPr lang="fr-FR"/>
           </a:p>
@@ -339,10 +337,9 @@
           <a:lstStyle/>
           <a:p>
             <a:r>
-              <a:rPr lang="fr-FR" smtClean="0"/>
+              <a:rPr lang="fr-FR"/>
               <a:t>Modifiez le style du titre</a:t>
             </a:r>
-            <a:endParaRPr lang="fr-FR"/>
           </a:p>
         </p:txBody>
       </p:sp>
@@ -363,38 +360,37 @@
           <a:p>
             <a:pPr lvl="0"/>
             <a:r>
-              <a:rPr lang="fr-FR" smtClean="0"/>
+              <a:rPr lang="fr-FR"/>
               <a:t>Modifier les styles du texte du masque</a:t>
             </a:r>
           </a:p>
           <a:p>
             <a:pPr lvl="1"/>
             <a:r>
-              <a:rPr lang="fr-FR" smtClean="0"/>
+              <a:rPr lang="fr-FR"/>
               <a:t>Deuxième niveau</a:t>
             </a:r>
           </a:p>
           <a:p>
             <a:pPr lvl="2"/>
             <a:r>
-              <a:rPr lang="fr-FR" smtClean="0"/>
+              <a:rPr lang="fr-FR"/>
               <a:t>Troisième niveau</a:t>
             </a:r>
           </a:p>
           <a:p>
             <a:pPr lvl="3"/>
             <a:r>
-              <a:rPr lang="fr-FR" smtClean="0"/>
+              <a:rPr lang="fr-FR"/>
               <a:t>Quatrième niveau</a:t>
             </a:r>
           </a:p>
           <a:p>
             <a:pPr lvl="4"/>
             <a:r>
-              <a:rPr lang="fr-FR" smtClean="0"/>
+              <a:rPr lang="fr-FR"/>
               <a:t>Cinquième niveau</a:t>
             </a:r>
-            <a:endParaRPr lang="fr-FR"/>
           </a:p>
         </p:txBody>
       </p:sp>
@@ -415,7 +411,7 @@
           <a:p>
             <a:fld id="{253B1B7A-19D7-47DD-996A-6E83BE59A4F5}" type="datetimeFigureOut">
               <a:rPr lang="fr-FR" smtClean="0"/>
-              <a:t>30/01/2026</a:t>
+              <a:t>04/03/2026</a:t>
             </a:fld>
             <a:endParaRPr lang="fr-FR"/>
           </a:p>
@@ -514,10 +510,9 @@
           <a:lstStyle/>
           <a:p>
             <a:r>
-              <a:rPr lang="fr-FR" smtClean="0"/>
+              <a:rPr lang="fr-FR"/>
               <a:t>Modifiez le style du titre</a:t>
             </a:r>
-            <a:endParaRPr lang="fr-FR"/>
           </a:p>
         </p:txBody>
       </p:sp>
@@ -543,38 +538,37 @@
           <a:p>
             <a:pPr lvl="0"/>
             <a:r>
-              <a:rPr lang="fr-FR" smtClean="0"/>
+              <a:rPr lang="fr-FR"/>
               <a:t>Modifier les styles du texte du masque</a:t>
             </a:r>
           </a:p>
           <a:p>
             <a:pPr lvl="1"/>
             <a:r>
-              <a:rPr lang="fr-FR" smtClean="0"/>
+              <a:rPr lang="fr-FR"/>
               <a:t>Deuxième niveau</a:t>
             </a:r>
           </a:p>
           <a:p>
             <a:pPr lvl="2"/>
             <a:r>
-              <a:rPr lang="fr-FR" smtClean="0"/>
+              <a:rPr lang="fr-FR"/>
               <a:t>Troisième niveau</a:t>
             </a:r>
           </a:p>
           <a:p>
             <a:pPr lvl="3"/>
             <a:r>
-              <a:rPr lang="fr-FR" smtClean="0"/>
+              <a:rPr lang="fr-FR"/>
               <a:t>Quatrième niveau</a:t>
             </a:r>
           </a:p>
           <a:p>
             <a:pPr lvl="4"/>
             <a:r>
-              <a:rPr lang="fr-FR" smtClean="0"/>
+              <a:rPr lang="fr-FR"/>
               <a:t>Cinquième niveau</a:t>
             </a:r>
-            <a:endParaRPr lang="fr-FR"/>
           </a:p>
         </p:txBody>
       </p:sp>
@@ -595,7 +589,7 @@
           <a:p>
             <a:fld id="{253B1B7A-19D7-47DD-996A-6E83BE59A4F5}" type="datetimeFigureOut">
               <a:rPr lang="fr-FR" smtClean="0"/>
-              <a:t>30/01/2026</a:t>
+              <a:t>04/03/2026</a:t>
             </a:fld>
             <a:endParaRPr lang="fr-FR"/>
           </a:p>
@@ -689,10 +683,9 @@
           <a:lstStyle/>
           <a:p>
             <a:r>
-              <a:rPr lang="fr-FR" smtClean="0"/>
+              <a:rPr lang="fr-FR"/>
               <a:t>Modifiez le style du titre</a:t>
             </a:r>
-            <a:endParaRPr lang="fr-FR"/>
           </a:p>
         </p:txBody>
       </p:sp>
@@ -713,38 +706,37 @@
           <a:p>
             <a:pPr lvl="0"/>
             <a:r>
-              <a:rPr lang="fr-FR" smtClean="0"/>
+              <a:rPr lang="fr-FR"/>
               <a:t>Modifier les styles du texte du masque</a:t>
             </a:r>
           </a:p>
           <a:p>
             <a:pPr lvl="1"/>
             <a:r>
-              <a:rPr lang="fr-FR" smtClean="0"/>
+              <a:rPr lang="fr-FR"/>
               <a:t>Deuxième niveau</a:t>
             </a:r>
           </a:p>
           <a:p>
             <a:pPr lvl="2"/>
             <a:r>
-              <a:rPr lang="fr-FR" smtClean="0"/>
+              <a:rPr lang="fr-FR"/>
               <a:t>Troisième niveau</a:t>
             </a:r>
           </a:p>
           <a:p>
             <a:pPr lvl="3"/>
             <a:r>
-              <a:rPr lang="fr-FR" smtClean="0"/>
+              <a:rPr lang="fr-FR"/>
               <a:t>Quatrième niveau</a:t>
             </a:r>
           </a:p>
           <a:p>
             <a:pPr lvl="4"/>
             <a:r>
-              <a:rPr lang="fr-FR" smtClean="0"/>
+              <a:rPr lang="fr-FR"/>
               <a:t>Cinquième niveau</a:t>
             </a:r>
-            <a:endParaRPr lang="fr-FR"/>
           </a:p>
         </p:txBody>
       </p:sp>
@@ -765,7 +757,7 @@
           <a:p>
             <a:fld id="{253B1B7A-19D7-47DD-996A-6E83BE59A4F5}" type="datetimeFigureOut">
               <a:rPr lang="fr-FR" smtClean="0"/>
-              <a:t>30/01/2026</a:t>
+              <a:t>04/03/2026</a:t>
             </a:fld>
             <a:endParaRPr lang="fr-FR"/>
           </a:p>
@@ -868,10 +860,9 @@
           </a:lstStyle>
           <a:p>
             <a:r>
-              <a:rPr lang="fr-FR" smtClean="0"/>
+              <a:rPr lang="fr-FR"/>
               <a:t>Modifiez le style du titre</a:t>
             </a:r>
-            <a:endParaRPr lang="fr-FR"/>
           </a:p>
         </p:txBody>
       </p:sp>
@@ -988,7 +979,7 @@
           <a:p>
             <a:pPr lvl="0"/>
             <a:r>
-              <a:rPr lang="fr-FR" smtClean="0"/>
+              <a:rPr lang="fr-FR"/>
               <a:t>Modifier les styles du texte du masque</a:t>
             </a:r>
           </a:p>
@@ -1011,7 +1002,7 @@
           <a:p>
             <a:fld id="{253B1B7A-19D7-47DD-996A-6E83BE59A4F5}" type="datetimeFigureOut">
               <a:rPr lang="fr-FR" smtClean="0"/>
-              <a:t>30/01/2026</a:t>
+              <a:t>04/03/2026</a:t>
             </a:fld>
             <a:endParaRPr lang="fr-FR"/>
           </a:p>
@@ -1105,10 +1096,9 @@
           <a:lstStyle/>
           <a:p>
             <a:r>
-              <a:rPr lang="fr-FR" smtClean="0"/>
+              <a:rPr lang="fr-FR"/>
               <a:t>Modifiez le style du titre</a:t>
             </a:r>
-            <a:endParaRPr lang="fr-FR"/>
           </a:p>
         </p:txBody>
       </p:sp>
@@ -1134,38 +1124,37 @@
           <a:p>
             <a:pPr lvl="0"/>
             <a:r>
-              <a:rPr lang="fr-FR" smtClean="0"/>
+              <a:rPr lang="fr-FR"/>
               <a:t>Modifier les styles du texte du masque</a:t>
             </a:r>
           </a:p>
           <a:p>
             <a:pPr lvl="1"/>
             <a:r>
-              <a:rPr lang="fr-FR" smtClean="0"/>
+              <a:rPr lang="fr-FR"/>
               <a:t>Deuxième niveau</a:t>
             </a:r>
           </a:p>
           <a:p>
             <a:pPr lvl="2"/>
             <a:r>
-              <a:rPr lang="fr-FR" smtClean="0"/>
+              <a:rPr lang="fr-FR"/>
               <a:t>Troisième niveau</a:t>
             </a:r>
           </a:p>
           <a:p>
             <a:pPr lvl="3"/>
             <a:r>
-              <a:rPr lang="fr-FR" smtClean="0"/>
+              <a:rPr lang="fr-FR"/>
               <a:t>Quatrième niveau</a:t>
             </a:r>
           </a:p>
           <a:p>
             <a:pPr lvl="4"/>
             <a:r>
-              <a:rPr lang="fr-FR" smtClean="0"/>
+              <a:rPr lang="fr-FR"/>
               <a:t>Cinquième niveau</a:t>
             </a:r>
-            <a:endParaRPr lang="fr-FR"/>
           </a:p>
         </p:txBody>
       </p:sp>
@@ -1191,38 +1180,37 @@
           <a:p>
             <a:pPr lvl="0"/>
             <a:r>
-              <a:rPr lang="fr-FR" smtClean="0"/>
+              <a:rPr lang="fr-FR"/>
               <a:t>Modifier les styles du texte du masque</a:t>
             </a:r>
           </a:p>
           <a:p>
             <a:pPr lvl="1"/>
             <a:r>
-              <a:rPr lang="fr-FR" smtClean="0"/>
+              <a:rPr lang="fr-FR"/>
               <a:t>Deuxième niveau</a:t>
             </a:r>
           </a:p>
           <a:p>
             <a:pPr lvl="2"/>
             <a:r>
-              <a:rPr lang="fr-FR" smtClean="0"/>
+              <a:rPr lang="fr-FR"/>
               <a:t>Troisième niveau</a:t>
             </a:r>
           </a:p>
           <a:p>
             <a:pPr lvl="3"/>
             <a:r>
-              <a:rPr lang="fr-FR" smtClean="0"/>
+              <a:rPr lang="fr-FR"/>
               <a:t>Quatrième niveau</a:t>
             </a:r>
           </a:p>
           <a:p>
             <a:pPr lvl="4"/>
             <a:r>
-              <a:rPr lang="fr-FR" smtClean="0"/>
+              <a:rPr lang="fr-FR"/>
               <a:t>Cinquième niveau</a:t>
             </a:r>
-            <a:endParaRPr lang="fr-FR"/>
           </a:p>
         </p:txBody>
       </p:sp>
@@ -1243,7 +1231,7 @@
           <a:p>
             <a:fld id="{253B1B7A-19D7-47DD-996A-6E83BE59A4F5}" type="datetimeFigureOut">
               <a:rPr lang="fr-FR" smtClean="0"/>
-              <a:t>30/01/2026</a:t>
+              <a:t>04/03/2026</a:t>
             </a:fld>
             <a:endParaRPr lang="fr-FR"/>
           </a:p>
@@ -1342,10 +1330,9 @@
           <a:lstStyle/>
           <a:p>
             <a:r>
-              <a:rPr lang="fr-FR" smtClean="0"/>
+              <a:rPr lang="fr-FR"/>
               <a:t>Modifiez le style du titre</a:t>
             </a:r>
-            <a:endParaRPr lang="fr-FR"/>
           </a:p>
         </p:txBody>
       </p:sp>
@@ -1408,7 +1395,7 @@
           <a:p>
             <a:pPr lvl="0"/>
             <a:r>
-              <a:rPr lang="fr-FR" smtClean="0"/>
+              <a:rPr lang="fr-FR"/>
               <a:t>Modifier les styles du texte du masque</a:t>
             </a:r>
           </a:p>
@@ -1436,38 +1423,37 @@
           <a:p>
             <a:pPr lvl="0"/>
             <a:r>
-              <a:rPr lang="fr-FR" smtClean="0"/>
+              <a:rPr lang="fr-FR"/>
               <a:t>Modifier les styles du texte du masque</a:t>
             </a:r>
           </a:p>
           <a:p>
             <a:pPr lvl="1"/>
             <a:r>
-              <a:rPr lang="fr-FR" smtClean="0"/>
+              <a:rPr lang="fr-FR"/>
               <a:t>Deuxième niveau</a:t>
             </a:r>
           </a:p>
           <a:p>
             <a:pPr lvl="2"/>
             <a:r>
-              <a:rPr lang="fr-FR" smtClean="0"/>
+              <a:rPr lang="fr-FR"/>
               <a:t>Troisième niveau</a:t>
             </a:r>
           </a:p>
           <a:p>
             <a:pPr lvl="3"/>
             <a:r>
-              <a:rPr lang="fr-FR" smtClean="0"/>
+              <a:rPr lang="fr-FR"/>
               <a:t>Quatrième niveau</a:t>
             </a:r>
           </a:p>
           <a:p>
             <a:pPr lvl="4"/>
             <a:r>
-              <a:rPr lang="fr-FR" smtClean="0"/>
+              <a:rPr lang="fr-FR"/>
               <a:t>Cinquième niveau</a:t>
             </a:r>
-            <a:endParaRPr lang="fr-FR"/>
           </a:p>
         </p:txBody>
       </p:sp>
@@ -1530,7 +1516,7 @@
           <a:p>
             <a:pPr lvl="0"/>
             <a:r>
-              <a:rPr lang="fr-FR" smtClean="0"/>
+              <a:rPr lang="fr-FR"/>
               <a:t>Modifier les styles du texte du masque</a:t>
             </a:r>
           </a:p>
@@ -1558,38 +1544,37 @@
           <a:p>
             <a:pPr lvl="0"/>
             <a:r>
-              <a:rPr lang="fr-FR" smtClean="0"/>
+              <a:rPr lang="fr-FR"/>
               <a:t>Modifier les styles du texte du masque</a:t>
             </a:r>
           </a:p>
           <a:p>
             <a:pPr lvl="1"/>
             <a:r>
-              <a:rPr lang="fr-FR" smtClean="0"/>
+              <a:rPr lang="fr-FR"/>
               <a:t>Deuxième niveau</a:t>
             </a:r>
           </a:p>
           <a:p>
             <a:pPr lvl="2"/>
             <a:r>
-              <a:rPr lang="fr-FR" smtClean="0"/>
+              <a:rPr lang="fr-FR"/>
               <a:t>Troisième niveau</a:t>
             </a:r>
           </a:p>
           <a:p>
             <a:pPr lvl="3"/>
             <a:r>
-              <a:rPr lang="fr-FR" smtClean="0"/>
+              <a:rPr lang="fr-FR"/>
               <a:t>Quatrième niveau</a:t>
             </a:r>
           </a:p>
           <a:p>
             <a:pPr lvl="4"/>
             <a:r>
-              <a:rPr lang="fr-FR" smtClean="0"/>
+              <a:rPr lang="fr-FR"/>
               <a:t>Cinquième niveau</a:t>
             </a:r>
-            <a:endParaRPr lang="fr-FR"/>
           </a:p>
         </p:txBody>
       </p:sp>
@@ -1610,7 +1595,7 @@
           <a:p>
             <a:fld id="{253B1B7A-19D7-47DD-996A-6E83BE59A4F5}" type="datetimeFigureOut">
               <a:rPr lang="fr-FR" smtClean="0"/>
-              <a:t>30/01/2026</a:t>
+              <a:t>04/03/2026</a:t>
             </a:fld>
             <a:endParaRPr lang="fr-FR"/>
           </a:p>
@@ -1704,10 +1689,9 @@
           <a:lstStyle/>
           <a:p>
             <a:r>
-              <a:rPr lang="fr-FR" smtClean="0"/>
+              <a:rPr lang="fr-FR"/>
               <a:t>Modifiez le style du titre</a:t>
             </a:r>
-            <a:endParaRPr lang="fr-FR"/>
           </a:p>
         </p:txBody>
       </p:sp>
@@ -1728,7 +1712,7 @@
           <a:p>
             <a:fld id="{253B1B7A-19D7-47DD-996A-6E83BE59A4F5}" type="datetimeFigureOut">
               <a:rPr lang="fr-FR" smtClean="0"/>
-              <a:t>30/01/2026</a:t>
+              <a:t>04/03/2026</a:t>
             </a:fld>
             <a:endParaRPr lang="fr-FR"/>
           </a:p>
@@ -1823,7 +1807,7 @@
           <a:p>
             <a:fld id="{253B1B7A-19D7-47DD-996A-6E83BE59A4F5}" type="datetimeFigureOut">
               <a:rPr lang="fr-FR" smtClean="0"/>
-              <a:t>30/01/2026</a:t>
+              <a:t>04/03/2026</a:t>
             </a:fld>
             <a:endParaRPr lang="fr-FR"/>
           </a:p>
@@ -1926,10 +1910,9 @@
           </a:lstStyle>
           <a:p>
             <a:r>
-              <a:rPr lang="fr-FR" smtClean="0"/>
+              <a:rPr lang="fr-FR"/>
               <a:t>Modifiez le style du titre</a:t>
             </a:r>
-            <a:endParaRPr lang="fr-FR"/>
           </a:p>
         </p:txBody>
       </p:sp>
@@ -1983,38 +1966,37 @@
           <a:p>
             <a:pPr lvl="0"/>
             <a:r>
-              <a:rPr lang="fr-FR" smtClean="0"/>
+              <a:rPr lang="fr-FR"/>
               <a:t>Modifier les styles du texte du masque</a:t>
             </a:r>
           </a:p>
           <a:p>
             <a:pPr lvl="1"/>
             <a:r>
-              <a:rPr lang="fr-FR" smtClean="0"/>
+              <a:rPr lang="fr-FR"/>
               <a:t>Deuxième niveau</a:t>
             </a:r>
           </a:p>
           <a:p>
             <a:pPr lvl="2"/>
             <a:r>
-              <a:rPr lang="fr-FR" smtClean="0"/>
+              <a:rPr lang="fr-FR"/>
               <a:t>Troisième niveau</a:t>
             </a:r>
           </a:p>
           <a:p>
             <a:pPr lvl="3"/>
             <a:r>
-              <a:rPr lang="fr-FR" smtClean="0"/>
+              <a:rPr lang="fr-FR"/>
               <a:t>Quatrième niveau</a:t>
             </a:r>
           </a:p>
           <a:p>
             <a:pPr lvl="4"/>
             <a:r>
-              <a:rPr lang="fr-FR" smtClean="0"/>
+              <a:rPr lang="fr-FR"/>
               <a:t>Cinquième niveau</a:t>
             </a:r>
-            <a:endParaRPr lang="fr-FR"/>
           </a:p>
         </p:txBody>
       </p:sp>
@@ -2077,7 +2059,7 @@
           <a:p>
             <a:pPr lvl="0"/>
             <a:r>
-              <a:rPr lang="fr-FR" smtClean="0"/>
+              <a:rPr lang="fr-FR"/>
               <a:t>Modifier les styles du texte du masque</a:t>
             </a:r>
           </a:p>
@@ -2100,7 +2082,7 @@
           <a:p>
             <a:fld id="{253B1B7A-19D7-47DD-996A-6E83BE59A4F5}" type="datetimeFigureOut">
               <a:rPr lang="fr-FR" smtClean="0"/>
-              <a:t>30/01/2026</a:t>
+              <a:t>04/03/2026</a:t>
             </a:fld>
             <a:endParaRPr lang="fr-FR"/>
           </a:p>
@@ -2203,10 +2185,9 @@
           </a:lstStyle>
           <a:p>
             <a:r>
-              <a:rPr lang="fr-FR" smtClean="0"/>
+              <a:rPr lang="fr-FR"/>
               <a:t>Modifiez le style du titre</a:t>
             </a:r>
-            <a:endParaRPr lang="fr-FR"/>
           </a:p>
         </p:txBody>
       </p:sp>
@@ -2330,7 +2311,7 @@
           <a:p>
             <a:pPr lvl="0"/>
             <a:r>
-              <a:rPr lang="fr-FR" smtClean="0"/>
+              <a:rPr lang="fr-FR"/>
               <a:t>Modifier les styles du texte du masque</a:t>
             </a:r>
           </a:p>
@@ -2353,7 +2334,7 @@
           <a:p>
             <a:fld id="{253B1B7A-19D7-47DD-996A-6E83BE59A4F5}" type="datetimeFigureOut">
               <a:rPr lang="fr-FR" smtClean="0"/>
-              <a:t>30/01/2026</a:t>
+              <a:t>04/03/2026</a:t>
             </a:fld>
             <a:endParaRPr lang="fr-FR"/>
           </a:p>
@@ -2462,10 +2443,9 @@
           <a:lstStyle/>
           <a:p>
             <a:r>
-              <a:rPr lang="fr-FR" smtClean="0"/>
+              <a:rPr lang="fr-FR"/>
               <a:t>Modifiez le style du titre</a:t>
             </a:r>
-            <a:endParaRPr lang="fr-FR"/>
           </a:p>
         </p:txBody>
       </p:sp>
@@ -2496,38 +2476,37 @@
           <a:p>
             <a:pPr lvl="0"/>
             <a:r>
-              <a:rPr lang="fr-FR" smtClean="0"/>
+              <a:rPr lang="fr-FR"/>
               <a:t>Modifier les styles du texte du masque</a:t>
             </a:r>
           </a:p>
           <a:p>
             <a:pPr lvl="1"/>
             <a:r>
-              <a:rPr lang="fr-FR" smtClean="0"/>
+              <a:rPr lang="fr-FR"/>
               <a:t>Deuxième niveau</a:t>
             </a:r>
           </a:p>
           <a:p>
             <a:pPr lvl="2"/>
             <a:r>
-              <a:rPr lang="fr-FR" smtClean="0"/>
+              <a:rPr lang="fr-FR"/>
               <a:t>Troisième niveau</a:t>
             </a:r>
           </a:p>
           <a:p>
             <a:pPr lvl="3"/>
             <a:r>
-              <a:rPr lang="fr-FR" smtClean="0"/>
+              <a:rPr lang="fr-FR"/>
               <a:t>Quatrième niveau</a:t>
             </a:r>
           </a:p>
           <a:p>
             <a:pPr lvl="4"/>
             <a:r>
-              <a:rPr lang="fr-FR" smtClean="0"/>
+              <a:rPr lang="fr-FR"/>
               <a:t>Cinquième niveau</a:t>
             </a:r>
-            <a:endParaRPr lang="fr-FR"/>
           </a:p>
         </p:txBody>
       </p:sp>
@@ -2566,7 +2545,7 @@
           <a:p>
             <a:fld id="{253B1B7A-19D7-47DD-996A-6E83BE59A4F5}" type="datetimeFigureOut">
               <a:rPr lang="fr-FR" smtClean="0"/>
-              <a:t>30/01/2026</a:t>
+              <a:t>04/03/2026</a:t>
             </a:fld>
             <a:endParaRPr lang="fr-FR"/>
           </a:p>
@@ -3090,27 +3069,27 @@
           <a:p>
             <a:pPr algn="ctr"/>
             <a:r>
-              <a:rPr lang="fr-FR" dirty="0" smtClean="0"/>
+              <a:rPr lang="fr-FR" dirty="0"/>
               <a:t>Select file </a:t>
             </a:r>
             <a:r>
-              <a:rPr lang="fr-FR" dirty="0" err="1" smtClean="0"/>
+              <a:rPr lang="fr-FR" dirty="0" err="1"/>
               <a:t>path</a:t>
             </a:r>
             <a:r>
-              <a:rPr lang="fr-FR" dirty="0" smtClean="0"/>
+              <a:rPr lang="fr-FR" dirty="0"/>
               <a:t> and copy to </a:t>
             </a:r>
             <a:r>
-              <a:rPr lang="fr-FR" dirty="0" err="1" smtClean="0"/>
+              <a:rPr lang="fr-FR" dirty="0" err="1"/>
               <a:t>flights</a:t>
             </a:r>
             <a:r>
-              <a:rPr lang="fr-FR" dirty="0" smtClean="0"/>
+              <a:rPr lang="fr-FR" dirty="0"/>
               <a:t> </a:t>
             </a:r>
             <a:r>
-              <a:rPr lang="fr-FR" dirty="0" err="1" smtClean="0"/>
+              <a:rPr lang="fr-FR" dirty="0" err="1"/>
               <a:t>dir</a:t>
             </a:r>
             <a:endParaRPr lang="fr-FR" dirty="0"/>
@@ -3160,7 +3139,7 @@
           <a:p>
             <a:pPr algn="ctr"/>
             <a:r>
-              <a:rPr lang="fr-FR" dirty="0" smtClean="0">
+              <a:rPr lang="fr-FR" dirty="0">
                 <a:solidFill>
                   <a:schemeClr val="tx1"/>
                 </a:solidFill>
@@ -3168,7 +3147,7 @@
               <a:t>new file </a:t>
             </a:r>
             <a:r>
-              <a:rPr lang="fr-FR" dirty="0" err="1" smtClean="0">
+              <a:rPr lang="fr-FR" dirty="0" err="1">
                 <a:solidFill>
                   <a:schemeClr val="tx1"/>
                 </a:solidFill>
@@ -3220,30 +3199,29 @@
           <a:p>
             <a:pPr algn="ctr"/>
             <a:r>
-              <a:rPr lang="fr-FR" dirty="0" err="1" smtClean="0"/>
+              <a:rPr lang="fr-FR" dirty="0" err="1"/>
               <a:t>create</a:t>
             </a:r>
             <a:r>
-              <a:rPr lang="fr-FR" dirty="0" smtClean="0"/>
+              <a:rPr lang="fr-FR" dirty="0"/>
               <a:t> </a:t>
             </a:r>
             <a:r>
-              <a:rPr lang="fr-FR" dirty="0" err="1" smtClean="0"/>
+              <a:rPr lang="fr-FR" dirty="0" err="1"/>
               <a:t>vva</a:t>
             </a:r>
             <a:r>
-              <a:rPr lang="fr-FR" dirty="0" smtClean="0"/>
+              <a:rPr lang="fr-FR" dirty="0"/>
               <a:t> file </a:t>
             </a:r>
             <a:r>
-              <a:rPr lang="fr-FR" dirty="0" err="1" smtClean="0"/>
+              <a:rPr lang="fr-FR" dirty="0" err="1"/>
               <a:t>from</a:t>
             </a:r>
             <a:r>
-              <a:rPr lang="fr-FR" dirty="0" smtClean="0"/>
+              <a:rPr lang="fr-FR" dirty="0"/>
               <a:t> csv</a:t>
             </a:r>
-            <a:endParaRPr lang="fr-FR" dirty="0"/>
           </a:p>
         </p:txBody>
       </p:sp>
@@ -3270,10 +3248,9 @@
           <a:lstStyle/>
           <a:p>
             <a:r>
-              <a:rPr lang="fr-FR" dirty="0" smtClean="0"/>
+              <a:rPr lang="fr-FR" dirty="0"/>
               <a:t>Variables</a:t>
             </a:r>
-            <a:endParaRPr lang="fr-FR" dirty="0"/>
           </a:p>
         </p:txBody>
       </p:sp>
@@ -3300,10 +3277,9 @@
           <a:lstStyle/>
           <a:p>
             <a:r>
-              <a:rPr lang="fr-FR" dirty="0" smtClean="0"/>
+              <a:rPr lang="fr-FR" dirty="0"/>
               <a:t>Fonctions</a:t>
             </a:r>
-            <a:endParaRPr lang="fr-FR" dirty="0"/>
           </a:p>
         </p:txBody>
       </p:sp>
@@ -3344,34 +3320,33 @@
           <a:p>
             <a:pPr algn="ctr"/>
             <a:r>
-              <a:rPr lang="fr-FR" dirty="0" smtClean="0"/>
+              <a:rPr lang="fr-FR" dirty="0"/>
               <a:t>Scan </a:t>
             </a:r>
             <a:r>
-              <a:rPr lang="fr-FR" dirty="0" err="1" smtClean="0"/>
+              <a:rPr lang="fr-FR" dirty="0" err="1"/>
               <a:t>flights</a:t>
             </a:r>
             <a:r>
-              <a:rPr lang="fr-FR" dirty="0" smtClean="0"/>
+              <a:rPr lang="fr-FR" dirty="0"/>
               <a:t> </a:t>
             </a:r>
             <a:r>
-              <a:rPr lang="fr-FR" dirty="0" err="1" smtClean="0"/>
+              <a:rPr lang="fr-FR" dirty="0" err="1"/>
               <a:t>inside</a:t>
             </a:r>
             <a:r>
-              <a:rPr lang="fr-FR" dirty="0" smtClean="0"/>
+              <a:rPr lang="fr-FR" dirty="0"/>
               <a:t> flight </a:t>
             </a:r>
             <a:r>
-              <a:rPr lang="fr-FR" dirty="0" err="1" smtClean="0"/>
+              <a:rPr lang="fr-FR" dirty="0" err="1"/>
               <a:t>dir</a:t>
             </a:r>
             <a:r>
-              <a:rPr lang="fr-FR" dirty="0" smtClean="0"/>
+              <a:rPr lang="fr-FR" dirty="0"/>
               <a:t> </a:t>
             </a:r>
-            <a:endParaRPr lang="fr-FR" dirty="0"/>
           </a:p>
         </p:txBody>
       </p:sp>
@@ -3412,42 +3387,41 @@
           <a:p>
             <a:pPr algn="ctr"/>
             <a:r>
-              <a:rPr lang="fr-FR" dirty="0" smtClean="0"/>
+              <a:rPr lang="fr-FR" dirty="0"/>
               <a:t>Scan &amp; </a:t>
             </a:r>
             <a:r>
-              <a:rPr lang="fr-FR" dirty="0" err="1" smtClean="0"/>
+              <a:rPr lang="fr-FR" dirty="0" err="1"/>
               <a:t>Fetch</a:t>
             </a:r>
             <a:r>
-              <a:rPr lang="fr-FR" dirty="0" smtClean="0"/>
+              <a:rPr lang="fr-FR" dirty="0"/>
               <a:t> </a:t>
             </a:r>
             <a:r>
-              <a:rPr lang="fr-FR" dirty="0" err="1" smtClean="0"/>
+              <a:rPr lang="fr-FR" dirty="0" err="1"/>
               <a:t>metadata</a:t>
             </a:r>
             <a:r>
-              <a:rPr lang="fr-FR" dirty="0" smtClean="0"/>
+              <a:rPr lang="fr-FR" dirty="0"/>
               <a:t> </a:t>
             </a:r>
             <a:r>
-              <a:rPr lang="fr-FR" dirty="0" err="1" smtClean="0"/>
+              <a:rPr lang="fr-FR" dirty="0" err="1"/>
               <a:t>from</a:t>
             </a:r>
             <a:r>
-              <a:rPr lang="fr-FR" dirty="0" smtClean="0"/>
+              <a:rPr lang="fr-FR" dirty="0"/>
               <a:t> </a:t>
             </a:r>
             <a:r>
-              <a:rPr lang="fr-FR" dirty="0" err="1" smtClean="0"/>
+              <a:rPr lang="fr-FR" dirty="0" err="1"/>
               <a:t>vva</a:t>
             </a:r>
             <a:r>
-              <a:rPr lang="fr-FR" dirty="0" smtClean="0"/>
+              <a:rPr lang="fr-FR" dirty="0"/>
               <a:t> files</a:t>
             </a:r>
-            <a:endParaRPr lang="fr-FR" dirty="0"/>
           </a:p>
         </p:txBody>
       </p:sp>
@@ -3494,7 +3468,7 @@
           <a:p>
             <a:pPr algn="ctr"/>
             <a:r>
-              <a:rPr lang="fr-FR" dirty="0" err="1" smtClean="0">
+              <a:rPr lang="fr-FR" dirty="0" err="1">
                 <a:solidFill>
                   <a:schemeClr val="tx1"/>
                 </a:solidFill>
@@ -3502,7 +3476,7 @@
               <a:t>vva_flight_dic</a:t>
             </a:r>
             <a:r>
-              <a:rPr lang="fr-FR" dirty="0" smtClean="0">
+              <a:rPr lang="fr-FR" dirty="0">
                 <a:solidFill>
                   <a:schemeClr val="tx1"/>
                 </a:solidFill>
@@ -3521,7 +3495,7 @@
               <a:t>	</a:t>
             </a:r>
             <a:r>
-              <a:rPr lang="fr-FR" dirty="0" err="1" smtClean="0">
+              <a:rPr lang="fr-FR" dirty="0" err="1">
                 <a:solidFill>
                   <a:schemeClr val="tx1"/>
                 </a:solidFill>
@@ -3533,73 +3507,6 @@
                 <a:schemeClr val="tx1"/>
               </a:solidFill>
             </a:endParaRPr>
-          </a:p>
-          <a:p>
-            <a:pPr algn="ctr"/>
-            <a:r>
-              <a:rPr lang="fr-FR" dirty="0" smtClean="0">
-                <a:solidFill>
-                  <a:schemeClr val="tx1"/>
-                </a:solidFill>
-              </a:rPr>
-              <a:t>	</a:t>
-            </a:r>
-            <a:r>
-              <a:rPr lang="fr-FR" dirty="0" err="1" smtClean="0">
-                <a:solidFill>
-                  <a:schemeClr val="tx1"/>
-                </a:solidFill>
-              </a:rPr>
-              <a:t>Filetype</a:t>
-            </a:r>
-            <a:r>
-              <a:rPr lang="fr-FR" dirty="0" smtClean="0">
-                <a:solidFill>
-                  <a:schemeClr val="tx1"/>
-                </a:solidFill>
-              </a:rPr>
-              <a:t> </a:t>
-            </a:r>
-            <a:r>
-              <a:rPr lang="fr-FR" dirty="0" err="1" smtClean="0">
-                <a:solidFill>
-                  <a:schemeClr val="tx1"/>
-                </a:solidFill>
-              </a:rPr>
-              <a:t>origin</a:t>
-            </a:r>
-            <a:endParaRPr lang="fr-FR" dirty="0">
-              <a:solidFill>
-                <a:schemeClr val="tx1"/>
-              </a:solidFill>
-            </a:endParaRPr>
-          </a:p>
-          <a:p>
-            <a:pPr algn="ctr"/>
-            <a:r>
-              <a:rPr lang="fr-FR" dirty="0" smtClean="0">
-                <a:solidFill>
-                  <a:schemeClr val="tx1"/>
-                </a:solidFill>
-              </a:rPr>
-              <a:t>	File </a:t>
-            </a:r>
-            <a:r>
-              <a:rPr lang="fr-FR" dirty="0" err="1" smtClean="0">
-                <a:solidFill>
-                  <a:schemeClr val="tx1"/>
-                </a:solidFill>
-              </a:rPr>
-              <a:t>path</a:t>
-            </a:r>
-            <a:r>
-              <a:rPr lang="fr-FR" dirty="0" smtClean="0">
-                <a:solidFill>
-                  <a:schemeClr val="tx1"/>
-                </a:solidFill>
-              </a:rPr>
-              <a:t> </a:t>
-            </a:r>
           </a:p>
           <a:p>
             <a:pPr algn="ctr"/>
@@ -3612,15 +3519,47 @@
               <a:t>	</a:t>
             </a:r>
             <a:r>
-              <a:rPr lang="fr-FR" dirty="0" smtClean="0">
+              <a:rPr lang="fr-FR" dirty="0" err="1">
                 <a:solidFill>
                   <a:schemeClr val="tx1"/>
                 </a:solidFill>
               </a:rPr>
-              <a:t>File </a:t>
-            </a:r>
-            <a:r>
-              <a:rPr lang="fr-FR" dirty="0" err="1" smtClean="0">
+              <a:t>Filetype</a:t>
+            </a:r>
+            <a:r>
+              <a:rPr lang="fr-FR" dirty="0">
+                <a:solidFill>
+                  <a:schemeClr val="tx1"/>
+                </a:solidFill>
+              </a:rPr>
+              <a:t> </a:t>
+            </a:r>
+            <a:r>
+              <a:rPr lang="fr-FR" dirty="0" err="1">
+                <a:solidFill>
+                  <a:schemeClr val="tx1"/>
+                </a:solidFill>
+              </a:rPr>
+              <a:t>origin</a:t>
+            </a:r>
+            <a:endParaRPr lang="fr-FR" dirty="0">
+              <a:solidFill>
+                <a:schemeClr val="tx1"/>
+              </a:solidFill>
+            </a:endParaRPr>
+          </a:p>
+          <a:p>
+            <a:pPr algn="ctr"/>
+            <a:r>
+              <a:rPr lang="fr-FR" dirty="0">
+                <a:solidFill>
+                  <a:schemeClr val="tx1"/>
+                </a:solidFill>
+              </a:rPr>
+              <a:t>	File </a:t>
+            </a:r>
+            <a:r>
+              <a:rPr lang="fr-FR" dirty="0" err="1">
                 <a:solidFill>
                   <a:schemeClr val="tx1"/>
                 </a:solidFill>
@@ -3628,22 +3567,49 @@
               <a:t>path</a:t>
             </a:r>
             <a:r>
-              <a:rPr lang="fr-FR" dirty="0" smtClean="0">
+              <a:rPr lang="fr-FR" dirty="0">
                 <a:solidFill>
                   <a:schemeClr val="tx1"/>
                 </a:solidFill>
               </a:rPr>
               <a:t> </a:t>
             </a:r>
-            <a:r>
-              <a:rPr lang="fr-FR" dirty="0" err="1" smtClean="0">
+          </a:p>
+          <a:p>
+            <a:pPr algn="ctr"/>
+            <a:r>
+              <a:rPr lang="fr-FR" dirty="0">
+                <a:solidFill>
+                  <a:schemeClr val="tx1"/>
+                </a:solidFill>
+              </a:rPr>
+              <a:t>	File </a:t>
+            </a:r>
+            <a:r>
+              <a:rPr lang="fr-FR" dirty="0" err="1">
+                <a:solidFill>
+                  <a:schemeClr val="tx1"/>
+                </a:solidFill>
+              </a:rPr>
+              <a:t>path</a:t>
+            </a:r>
+            <a:r>
+              <a:rPr lang="fr-FR" dirty="0">
+                <a:solidFill>
+                  <a:schemeClr val="tx1"/>
+                </a:solidFill>
+              </a:rPr>
+              <a:t> </a:t>
+            </a:r>
+            <a:r>
+              <a:rPr lang="fr-FR" dirty="0" err="1">
                 <a:solidFill>
                   <a:schemeClr val="tx1"/>
                 </a:solidFill>
               </a:rPr>
               <a:t>origin</a:t>
             </a:r>
-            <a:endParaRPr lang="fr-FR" dirty="0" smtClean="0">
+            <a:endParaRPr lang="fr-FR" dirty="0">
               <a:solidFill>
                 <a:schemeClr val="tx1"/>
               </a:solidFill>
@@ -3652,7 +3618,7 @@
           <a:p>
             <a:pPr algn="ctr"/>
             <a:r>
-              <a:rPr lang="fr-FR" dirty="0" smtClean="0">
+              <a:rPr lang="fr-FR" dirty="0">
                 <a:solidFill>
                   <a:schemeClr val="tx1"/>
                 </a:solidFill>
@@ -3663,18 +3629,13 @@
           <a:p>
             <a:pPr algn="ctr"/>
             <a:r>
-              <a:rPr lang="fr-FR" dirty="0" smtClean="0">
+              <a:rPr lang="fr-FR" dirty="0">
                 <a:solidFill>
                   <a:schemeClr val="tx1"/>
                 </a:solidFill>
               </a:rPr>
               <a:t>Data </a:t>
             </a:r>
-            <a:endParaRPr lang="fr-FR" dirty="0">
-              <a:solidFill>
-                <a:schemeClr val="tx1"/>
-              </a:solidFill>
-            </a:endParaRPr>
           </a:p>
         </p:txBody>
       </p:sp>
@@ -3715,10 +3676,9 @@
           <a:p>
             <a:pPr algn="ctr"/>
             <a:r>
-              <a:rPr lang="fr-FR" dirty="0" smtClean="0"/>
+              <a:rPr lang="fr-FR" dirty="0"/>
               <a:t>Update table</a:t>
             </a:r>
-            <a:endParaRPr lang="fr-FR" dirty="0"/>
           </a:p>
         </p:txBody>
       </p:sp>
@@ -3759,14 +3719,13 @@
           <a:p>
             <a:pPr algn="ctr"/>
             <a:r>
-              <a:rPr lang="fr-FR" dirty="0" err="1" smtClean="0"/>
+              <a:rPr lang="fr-FR" dirty="0" err="1"/>
               <a:t>Delete</a:t>
             </a:r>
             <a:r>
-              <a:rPr lang="fr-FR" dirty="0" smtClean="0"/>
+              <a:rPr lang="fr-FR" dirty="0"/>
               <a:t> entries</a:t>
             </a:r>
-            <a:endParaRPr lang="fr-FR" dirty="0"/>
           </a:p>
         </p:txBody>
       </p:sp>
@@ -3807,55 +3766,55 @@
           <a:p>
             <a:pPr algn="ctr"/>
             <a:r>
-              <a:rPr lang="fr-FR" dirty="0" err="1" smtClean="0"/>
+              <a:rPr lang="fr-FR" dirty="0" err="1"/>
               <a:t>Load</a:t>
             </a:r>
             <a:r>
-              <a:rPr lang="fr-FR" dirty="0" smtClean="0"/>
+              <a:rPr lang="fr-FR" dirty="0"/>
               <a:t> </a:t>
             </a:r>
             <a:r>
-              <a:rPr lang="fr-FR" dirty="0" err="1" smtClean="0"/>
+              <a:rPr lang="fr-FR" dirty="0" err="1"/>
               <a:t>flights</a:t>
             </a:r>
             <a:r>
-              <a:rPr lang="fr-FR" dirty="0" smtClean="0"/>
+              <a:rPr lang="fr-FR" dirty="0"/>
               <a:t> for </a:t>
             </a:r>
             <a:r>
-              <a:rPr lang="fr-FR" dirty="0" err="1" smtClean="0"/>
+              <a:rPr lang="fr-FR" dirty="0" err="1"/>
               <a:t>analysis</a:t>
             </a:r>
             <a:r>
-              <a:rPr lang="fr-FR" dirty="0" smtClean="0"/>
+              <a:rPr lang="fr-FR" dirty="0"/>
               <a:t>: </a:t>
             </a:r>
             <a:r>
-              <a:rPr lang="fr-FR" dirty="0" err="1" smtClean="0"/>
+              <a:rPr lang="fr-FR" dirty="0" err="1"/>
               <a:t>fetch</a:t>
             </a:r>
             <a:r>
-              <a:rPr lang="fr-FR" dirty="0" smtClean="0"/>
+              <a:rPr lang="fr-FR" dirty="0"/>
               <a:t> data </a:t>
             </a:r>
             <a:r>
-              <a:rPr lang="fr-FR" dirty="0" err="1" smtClean="0"/>
+              <a:rPr lang="fr-FR" dirty="0" err="1"/>
               <a:t>from</a:t>
             </a:r>
             <a:r>
-              <a:rPr lang="fr-FR" dirty="0" smtClean="0"/>
+              <a:rPr lang="fr-FR" dirty="0"/>
               <a:t> </a:t>
             </a:r>
             <a:r>
-              <a:rPr lang="fr-FR" dirty="0" err="1" smtClean="0"/>
+              <a:rPr lang="fr-FR" dirty="0" err="1"/>
               <a:t>corresponding</a:t>
             </a:r>
             <a:r>
-              <a:rPr lang="fr-FR" dirty="0" smtClean="0"/>
+              <a:rPr lang="fr-FR" dirty="0"/>
               <a:t> csv or </a:t>
             </a:r>
             <a:r>
-              <a:rPr lang="fr-FR" dirty="0" err="1" smtClean="0"/>
+              <a:rPr lang="fr-FR" dirty="0" err="1"/>
               <a:t>igc</a:t>
             </a:r>
             <a:endParaRPr lang="fr-FR" dirty="0"/>
@@ -3899,31 +3858,31 @@
           <a:p>
             <a:pPr algn="ctr"/>
             <a:r>
-              <a:rPr lang="fr-FR" dirty="0" err="1" smtClean="0"/>
+              <a:rPr lang="fr-FR" dirty="0" err="1"/>
               <a:t>create</a:t>
             </a:r>
             <a:r>
-              <a:rPr lang="fr-FR" dirty="0" smtClean="0"/>
+              <a:rPr lang="fr-FR" dirty="0"/>
               <a:t> </a:t>
             </a:r>
             <a:r>
-              <a:rPr lang="fr-FR" dirty="0" err="1" smtClean="0"/>
+              <a:rPr lang="fr-FR" dirty="0" err="1"/>
               <a:t>vva</a:t>
             </a:r>
             <a:r>
-              <a:rPr lang="fr-FR" dirty="0" smtClean="0"/>
+              <a:rPr lang="fr-FR" dirty="0"/>
               <a:t> file </a:t>
             </a:r>
             <a:r>
-              <a:rPr lang="fr-FR" dirty="0" err="1" smtClean="0"/>
+              <a:rPr lang="fr-FR" dirty="0" err="1"/>
               <a:t>from</a:t>
             </a:r>
             <a:r>
-              <a:rPr lang="fr-FR" dirty="0" smtClean="0"/>
+              <a:rPr lang="fr-FR" dirty="0"/>
               <a:t> </a:t>
             </a:r>
             <a:r>
-              <a:rPr lang="fr-FR" dirty="0" err="1" smtClean="0"/>
+              <a:rPr lang="fr-FR" dirty="0" err="1"/>
               <a:t>igc</a:t>
             </a:r>
             <a:endParaRPr lang="fr-FR" dirty="0"/>
@@ -4065,10 +4024,9 @@
           <a:lstStyle/>
           <a:p>
             <a:r>
-              <a:rPr lang="fr-FR" dirty="0" smtClean="0"/>
+              <a:rPr lang="fr-FR" dirty="0"/>
               <a:t>Variables</a:t>
             </a:r>
-            <a:endParaRPr lang="fr-FR" dirty="0"/>
           </a:p>
         </p:txBody>
       </p:sp>
@@ -4095,10 +4053,9 @@
           <a:lstStyle/>
           <a:p>
             <a:r>
-              <a:rPr lang="fr-FR" dirty="0" smtClean="0"/>
+              <a:rPr lang="fr-FR" dirty="0"/>
               <a:t>Fonctions</a:t>
             </a:r>
-            <a:endParaRPr lang="fr-FR" dirty="0"/>
           </a:p>
         </p:txBody>
       </p:sp>
@@ -4175,10 +4132,10 @@
           <a:lstStyle/>
           <a:p>
             <a:r>
-              <a:rPr lang="fr-FR" sz="1200" b="1" dirty="0" err="1" smtClean="0"/>
+              <a:rPr lang="fr-FR" sz="1200" b="1" dirty="0" err="1"/>
               <a:t>Metadata</a:t>
             </a:r>
-            <a:endParaRPr lang="fr-FR" sz="1200" b="1" dirty="0" smtClean="0"/>
+            <a:endParaRPr lang="fr-FR" sz="1200" b="1" dirty="0"/>
           </a:p>
           <a:p>
             <a:r>
@@ -4206,13 +4163,8 @@
             </a:r>
             <a:r>
               <a:rPr lang="fr-FR" sz="1200" dirty="0"/>
-              <a:t>" </a:t>
-            </a:r>
-            <a:r>
-              <a:rPr lang="fr-FR" sz="1200" dirty="0" smtClean="0"/>
-              <a:t>:,</a:t>
-            </a:r>
-            <a:endParaRPr lang="fr-FR" sz="1200" dirty="0"/>
+              <a:t>" :,</a:t>
+            </a:r>
           </a:p>
           <a:p>
             <a:pPr lvl="2"/>
@@ -4228,12 +4180,11 @@
               <a:rPr lang="fr-FR" sz="1200" dirty="0"/>
               <a:t>" : </a:t>
             </a:r>
-            <a:endParaRPr lang="fr-FR" sz="1200" dirty="0" smtClean="0"/>
           </a:p>
           <a:p>
             <a:pPr lvl="2"/>
             <a:r>
-              <a:rPr lang="fr-FR" sz="1200" dirty="0" smtClean="0"/>
+              <a:rPr lang="fr-FR" sz="1200" dirty="0"/>
               <a:t>"</a:t>
             </a:r>
             <a:r>
@@ -4242,13 +4193,8 @@
             </a:r>
             <a:r>
               <a:rPr lang="fr-FR" sz="1200" dirty="0"/>
-              <a:t>" </a:t>
-            </a:r>
-            <a:r>
-              <a:rPr lang="fr-FR" sz="1200" dirty="0" smtClean="0"/>
-              <a:t>:</a:t>
-            </a:r>
-            <a:endParaRPr lang="fr-FR" sz="1200" dirty="0"/>
+              <a:t>" :</a:t>
+            </a:r>
           </a:p>
           <a:p>
             <a:pPr lvl="2"/>
@@ -4262,37 +4208,22 @@
             </a:r>
             <a:r>
               <a:rPr lang="fr-FR" sz="1200" dirty="0"/>
-              <a:t>" </a:t>
-            </a:r>
-            <a:r>
-              <a:rPr lang="fr-FR" sz="1200" dirty="0" smtClean="0"/>
-              <a:t>:</a:t>
-            </a:r>
-            <a:endParaRPr lang="fr-FR" sz="1200" dirty="0"/>
+              <a:t>" :</a:t>
+            </a:r>
           </a:p>
           <a:p>
             <a:pPr lvl="2"/>
             <a:r>
               <a:rPr lang="fr-FR" sz="1200" dirty="0"/>
-              <a:t>"pilot" : </a:t>
-            </a:r>
-            <a:r>
-              <a:rPr lang="fr-FR" sz="1200" dirty="0" smtClean="0"/>
-              <a:t>,</a:t>
-            </a:r>
-            <a:endParaRPr lang="fr-FR" sz="1200" dirty="0"/>
+              <a:t>"pilot" : ,</a:t>
+            </a:r>
           </a:p>
           <a:p>
             <a:pPr lvl="2"/>
             <a:r>
               <a:rPr lang="fr-FR" sz="1200" dirty="0"/>
-              <a:t>"date" </a:t>
-            </a:r>
-            <a:r>
-              <a:rPr lang="fr-FR" sz="1200" dirty="0" smtClean="0"/>
-              <a:t>:,</a:t>
-            </a:r>
-            <a:endParaRPr lang="fr-FR" sz="1200" dirty="0"/>
+              <a:t>"date" :,</a:t>
+            </a:r>
           </a:p>
           <a:p>
             <a:pPr lvl="2"/>
@@ -4306,13 +4237,8 @@
             </a:r>
             <a:r>
               <a:rPr lang="fr-FR" sz="1200" dirty="0"/>
-              <a:t>" : </a:t>
-            </a:r>
-            <a:r>
-              <a:rPr lang="fr-FR" sz="1200" dirty="0" smtClean="0"/>
-              <a:t>,</a:t>
-            </a:r>
-            <a:endParaRPr lang="fr-FR" sz="1200" dirty="0"/>
+              <a:t>" : ,</a:t>
+            </a:r>
           </a:p>
           <a:p>
             <a:pPr lvl="2"/>
@@ -4326,13 +4252,8 @@
             </a:r>
             <a:r>
               <a:rPr lang="fr-FR" sz="1200" dirty="0"/>
-              <a:t>" </a:t>
-            </a:r>
-            <a:r>
-              <a:rPr lang="fr-FR" sz="1200" dirty="0" smtClean="0"/>
-              <a:t>:,</a:t>
-            </a:r>
-            <a:endParaRPr lang="fr-FR" sz="1200" dirty="0"/>
+              <a:t>" :,</a:t>
+            </a:r>
           </a:p>
           <a:p>
             <a:pPr lvl="2"/>
@@ -4346,13 +4267,8 @@
             </a:r>
             <a:r>
               <a:rPr lang="fr-FR" sz="1200" dirty="0"/>
-              <a:t>" </a:t>
-            </a:r>
-            <a:r>
-              <a:rPr lang="fr-FR" sz="1200" dirty="0" smtClean="0"/>
-              <a:t>:, </a:t>
-            </a:r>
-            <a:endParaRPr lang="fr-FR" sz="1200" dirty="0"/>
+              <a:t>" :, </a:t>
+            </a:r>
           </a:p>
           <a:p>
             <a:pPr lvl="2"/>
@@ -4366,13 +4282,8 @@
             </a:r>
             <a:r>
               <a:rPr lang="fr-FR" sz="1200" dirty="0"/>
-              <a:t>" </a:t>
-            </a:r>
-            <a:r>
-              <a:rPr lang="fr-FR" sz="1200" dirty="0" smtClean="0"/>
-              <a:t>:,</a:t>
-            </a:r>
-            <a:endParaRPr lang="fr-FR" sz="1200" dirty="0"/>
+              <a:t>" :,</a:t>
+            </a:r>
           </a:p>
           <a:p>
             <a:pPr lvl="2"/>
@@ -4386,13 +4297,8 @@
             </a:r>
             <a:r>
               <a:rPr lang="fr-FR" sz="1200" dirty="0"/>
-              <a:t>" </a:t>
-            </a:r>
-            <a:r>
-              <a:rPr lang="fr-FR" sz="1200" dirty="0" smtClean="0"/>
-              <a:t>:,</a:t>
-            </a:r>
-            <a:endParaRPr lang="fr-FR" sz="1200" dirty="0"/>
+              <a:t>" :,</a:t>
+            </a:r>
           </a:p>
           <a:p>
             <a:pPr lvl="2"/>
@@ -4415,60 +4321,57 @@
               <a:rPr lang="fr-FR" sz="1200" dirty="0"/>
               <a:t>"comment" : </a:t>
             </a:r>
-            <a:endParaRPr lang="fr-FR" sz="1200" dirty="0" smtClean="0"/>
-          </a:p>
-          <a:p>
-            <a:r>
-              <a:rPr lang="fr-FR" sz="1200" b="1" dirty="0" err="1" smtClean="0"/>
+          </a:p>
+          <a:p>
+            <a:r>
+              <a:rPr lang="fr-FR" sz="1200" b="1" dirty="0" err="1"/>
               <a:t>raw_data</a:t>
             </a:r>
-            <a:endParaRPr lang="fr-FR" sz="1200" b="1" dirty="0" smtClean="0"/>
+            <a:endParaRPr lang="fr-FR" sz="1200" b="1" dirty="0"/>
           </a:p>
           <a:p>
             <a:r>
               <a:rPr lang="fr-FR" sz="1200" b="1" dirty="0"/>
               <a:t>	</a:t>
             </a:r>
-            <a:endParaRPr lang="fr-FR" sz="1200" b="1" dirty="0" smtClean="0"/>
-          </a:p>
-          <a:p>
-            <a:r>
-              <a:rPr lang="fr-FR" sz="1200" b="1" dirty="0" err="1" smtClean="0"/>
+          </a:p>
+          <a:p>
+            <a:r>
+              <a:rPr lang="fr-FR" sz="1200" b="1" dirty="0" err="1"/>
               <a:t>processed_data</a:t>
             </a:r>
-            <a:endParaRPr lang="fr-FR" sz="1200" b="1" dirty="0" smtClean="0"/>
-          </a:p>
-          <a:p>
-            <a:r>
-              <a:rPr lang="fr-FR" sz="1200" b="1" dirty="0" err="1" smtClean="0"/>
+            <a:endParaRPr lang="fr-FR" sz="1200" b="1" dirty="0"/>
+          </a:p>
+          <a:p>
+            <a:r>
+              <a:rPr lang="fr-FR" sz="1200" b="1" dirty="0" err="1"/>
               <a:t>file_path</a:t>
             </a:r>
             <a:endParaRPr lang="fr-FR" sz="1200" b="1" dirty="0"/>
           </a:p>
           <a:p>
             <a:r>
-              <a:rPr lang="fr-FR" sz="1200" b="1" dirty="0" err="1" smtClean="0"/>
+              <a:rPr lang="fr-FR" sz="1200" b="1" dirty="0" err="1"/>
               <a:t>file_name</a:t>
             </a:r>
-            <a:endParaRPr lang="fr-FR" sz="1200" b="1" dirty="0" smtClean="0"/>
-          </a:p>
-          <a:p>
-            <a:r>
-              <a:rPr lang="fr-FR" sz="1200" b="1" dirty="0" err="1" smtClean="0"/>
+            <a:endParaRPr lang="fr-FR" sz="1200" b="1" dirty="0"/>
+          </a:p>
+          <a:p>
+            <a:r>
+              <a:rPr lang="fr-FR" sz="1200" b="1" dirty="0" err="1"/>
               <a:t>origin_file_path</a:t>
             </a:r>
-            <a:endParaRPr lang="fr-FR" sz="1200" b="1" dirty="0" smtClean="0"/>
-          </a:p>
-          <a:p>
-            <a:r>
-              <a:rPr lang="fr-FR" sz="1200" b="1" dirty="0" err="1" smtClean="0"/>
+            <a:endParaRPr lang="fr-FR" sz="1200" b="1" dirty="0"/>
+          </a:p>
+          <a:p>
+            <a:r>
+              <a:rPr lang="fr-FR" sz="1200" b="1" dirty="0" err="1"/>
               <a:t>is_active</a:t>
             </a:r>
             <a:r>
-              <a:rPr lang="fr-FR" sz="1200" b="1" dirty="0" smtClean="0"/>
+              <a:rPr lang="fr-FR" sz="1200" b="1" dirty="0"/>
               <a:t> </a:t>
             </a:r>
-            <a:endParaRPr lang="fr-FR" sz="1200" b="1" dirty="0"/>
           </a:p>
         </p:txBody>
       </p:sp>
@@ -4657,13 +4560,13 @@
           <a:lstStyle/>
           <a:p>
             <a:r>
-              <a:rPr lang="fr-FR" dirty="0" smtClean="0"/>
+              <a:rPr lang="fr-FR" dirty="0"/>
               <a:t>IGC+</a:t>
             </a:r>
           </a:p>
           <a:p>
             <a:r>
-              <a:rPr lang="fr-FR" dirty="0" err="1" smtClean="0"/>
+              <a:rPr lang="fr-FR" dirty="0" err="1"/>
               <a:t>igc</a:t>
             </a:r>
             <a:endParaRPr lang="fr-FR" dirty="0"/>
@@ -4693,16 +4596,15 @@
           <a:lstStyle/>
           <a:p>
             <a:r>
-              <a:rPr lang="fr-FR" dirty="0" smtClean="0"/>
+              <a:rPr lang="fr-FR" dirty="0"/>
               <a:t>LOGPRO</a:t>
             </a:r>
           </a:p>
           <a:p>
             <a:r>
-              <a:rPr lang="fr-FR" dirty="0" smtClean="0"/>
+              <a:rPr lang="fr-FR" dirty="0"/>
               <a:t>csv</a:t>
             </a:r>
-            <a:endParaRPr lang="fr-FR" dirty="0"/>
           </a:p>
         </p:txBody>
       </p:sp>
@@ -4729,10 +4631,9 @@
           <a:lstStyle/>
           <a:p>
             <a:r>
-              <a:rPr lang="fr-FR" dirty="0" smtClean="0"/>
+              <a:rPr lang="fr-FR" dirty="0"/>
               <a:t>ADDITIONAL</a:t>
             </a:r>
-            <a:endParaRPr lang="fr-FR" dirty="0"/>
           </a:p>
         </p:txBody>
       </p:sp>
@@ -5619,7 +5520,7 @@
                         </a:spcAft>
                       </a:pPr>
                       <a:r>
-                        <a:rPr lang="fr-FR" sz="1100" b="1" i="0" u="none" strike="noStrike" dirty="0" err="1" smtClean="0">
+                        <a:rPr lang="fr-FR" sz="1100" b="1" i="0" u="none" strike="noStrike" dirty="0" err="1">
                           <a:solidFill>
                             <a:srgbClr val="000000"/>
                           </a:solidFill>
@@ -7063,7 +6964,7 @@
                         </a:spcAft>
                       </a:pPr>
                       <a:r>
-                        <a:rPr lang="fr-FR" sz="800" b="1" i="0" u="none" strike="noStrike" dirty="0" err="1" smtClean="0">
+                        <a:rPr lang="fr-FR" sz="800" b="1" i="0" u="none" strike="noStrike" dirty="0" err="1">
                           <a:solidFill>
                             <a:srgbClr val="000000"/>
                           </a:solidFill>
@@ -8386,7 +8287,7 @@
                         </a:spcAft>
                       </a:pPr>
                       <a:r>
-                        <a:rPr lang="fr-FR" sz="1100" b="1" i="0" u="none" strike="noStrike" dirty="0" smtClean="0">
+                        <a:rPr lang="fr-FR" sz="1100" b="1" i="0" u="none" strike="noStrike" dirty="0">
                           <a:solidFill>
                             <a:srgbClr val="000000"/>
                           </a:solidFill>
@@ -8460,7 +8361,7 @@
                         </a:spcAft>
                       </a:pPr>
                       <a:r>
-                        <a:rPr lang="fr-FR" sz="1100" b="1" i="0" u="none" strike="noStrike" dirty="0" smtClean="0">
+                        <a:rPr lang="fr-FR" sz="1100" b="1" i="0" u="none" strike="noStrike" dirty="0">
                           <a:solidFill>
                             <a:srgbClr val="000000"/>
                           </a:solidFill>
@@ -8610,10 +8511,9 @@
           <a:lstStyle/>
           <a:p>
             <a:r>
-              <a:rPr lang="fr-FR" dirty="0" smtClean="0"/>
+              <a:rPr lang="fr-FR" dirty="0"/>
               <a:t>IAS</a:t>
             </a:r>
-            <a:endParaRPr lang="fr-FR" dirty="0"/>
           </a:p>
         </p:txBody>
       </p:sp>
@@ -8640,38 +8540,38 @@
           <a:lstStyle/>
           <a:p>
             <a:r>
-              <a:rPr lang="fr-FR" dirty="0" smtClean="0"/>
+              <a:rPr lang="fr-FR" dirty="0"/>
               <a:t>PSTAT</a:t>
             </a:r>
             <a:br>
-              <a:rPr lang="fr-FR" dirty="0" smtClean="0"/>
+              <a:rPr lang="fr-FR" dirty="0"/>
             </a:br>
             <a:r>
-              <a:rPr lang="fr-FR" dirty="0" smtClean="0"/>
+              <a:rPr lang="fr-FR" dirty="0"/>
               <a:t>VARIO</a:t>
             </a:r>
           </a:p>
           <a:p>
             <a:r>
-              <a:rPr lang="fr-FR" dirty="0" err="1" smtClean="0"/>
+              <a:rPr lang="fr-FR" dirty="0" err="1"/>
               <a:t>Heading</a:t>
             </a:r>
             <a:r>
-              <a:rPr lang="fr-FR" dirty="0" smtClean="0"/>
+              <a:rPr lang="fr-FR" dirty="0"/>
               <a:t> </a:t>
             </a:r>
             <a:r>
-              <a:rPr lang="fr-FR" dirty="0" err="1" smtClean="0"/>
+              <a:rPr lang="fr-FR" dirty="0" err="1"/>
               <a:t>gps</a:t>
             </a:r>
-            <a:endParaRPr lang="fr-FR" dirty="0" smtClean="0"/>
-          </a:p>
-          <a:p>
-            <a:r>
-              <a:rPr lang="fr-FR" dirty="0" err="1" smtClean="0"/>
+            <a:endParaRPr lang="fr-FR" dirty="0"/>
+          </a:p>
+          <a:p>
+            <a:r>
+              <a:rPr lang="fr-FR" dirty="0" err="1"/>
               <a:t>Speed_gps</a:t>
             </a:r>
-            <a:endParaRPr lang="fr-FR" dirty="0" smtClean="0"/>
+            <a:endParaRPr lang="fr-FR" dirty="0"/>
           </a:p>
           <a:p>
             <a:endParaRPr lang="fr-FR" dirty="0"/>

</xml_diff>

<commit_message>
Corrections des bugs de calculs, gestion des boutons pour analyser et exporter
</commit_message>
<xml_diff>
--- a/ressources/code.pptx
+++ b/ressources/code.pptx
@@ -243,7 +243,7 @@
           <a:p>
             <a:fld id="{253B1B7A-19D7-47DD-996A-6E83BE59A4F5}" type="datetimeFigureOut">
               <a:rPr lang="fr-FR" smtClean="0"/>
-              <a:t>04/03/2026</a:t>
+              <a:t>11/03/2026</a:t>
             </a:fld>
             <a:endParaRPr lang="fr-FR"/>
           </a:p>
@@ -411,7 +411,7 @@
           <a:p>
             <a:fld id="{253B1B7A-19D7-47DD-996A-6E83BE59A4F5}" type="datetimeFigureOut">
               <a:rPr lang="fr-FR" smtClean="0"/>
-              <a:t>04/03/2026</a:t>
+              <a:t>11/03/2026</a:t>
             </a:fld>
             <a:endParaRPr lang="fr-FR"/>
           </a:p>
@@ -589,7 +589,7 @@
           <a:p>
             <a:fld id="{253B1B7A-19D7-47DD-996A-6E83BE59A4F5}" type="datetimeFigureOut">
               <a:rPr lang="fr-FR" smtClean="0"/>
-              <a:t>04/03/2026</a:t>
+              <a:t>11/03/2026</a:t>
             </a:fld>
             <a:endParaRPr lang="fr-FR"/>
           </a:p>
@@ -757,7 +757,7 @@
           <a:p>
             <a:fld id="{253B1B7A-19D7-47DD-996A-6E83BE59A4F5}" type="datetimeFigureOut">
               <a:rPr lang="fr-FR" smtClean="0"/>
-              <a:t>04/03/2026</a:t>
+              <a:t>11/03/2026</a:t>
             </a:fld>
             <a:endParaRPr lang="fr-FR"/>
           </a:p>
@@ -1002,7 +1002,7 @@
           <a:p>
             <a:fld id="{253B1B7A-19D7-47DD-996A-6E83BE59A4F5}" type="datetimeFigureOut">
               <a:rPr lang="fr-FR" smtClean="0"/>
-              <a:t>04/03/2026</a:t>
+              <a:t>11/03/2026</a:t>
             </a:fld>
             <a:endParaRPr lang="fr-FR"/>
           </a:p>
@@ -1231,7 +1231,7 @@
           <a:p>
             <a:fld id="{253B1B7A-19D7-47DD-996A-6E83BE59A4F5}" type="datetimeFigureOut">
               <a:rPr lang="fr-FR" smtClean="0"/>
-              <a:t>04/03/2026</a:t>
+              <a:t>11/03/2026</a:t>
             </a:fld>
             <a:endParaRPr lang="fr-FR"/>
           </a:p>
@@ -1595,7 +1595,7 @@
           <a:p>
             <a:fld id="{253B1B7A-19D7-47DD-996A-6E83BE59A4F5}" type="datetimeFigureOut">
               <a:rPr lang="fr-FR" smtClean="0"/>
-              <a:t>04/03/2026</a:t>
+              <a:t>11/03/2026</a:t>
             </a:fld>
             <a:endParaRPr lang="fr-FR"/>
           </a:p>
@@ -1712,7 +1712,7 @@
           <a:p>
             <a:fld id="{253B1B7A-19D7-47DD-996A-6E83BE59A4F5}" type="datetimeFigureOut">
               <a:rPr lang="fr-FR" smtClean="0"/>
-              <a:t>04/03/2026</a:t>
+              <a:t>11/03/2026</a:t>
             </a:fld>
             <a:endParaRPr lang="fr-FR"/>
           </a:p>
@@ -1807,7 +1807,7 @@
           <a:p>
             <a:fld id="{253B1B7A-19D7-47DD-996A-6E83BE59A4F5}" type="datetimeFigureOut">
               <a:rPr lang="fr-FR" smtClean="0"/>
-              <a:t>04/03/2026</a:t>
+              <a:t>11/03/2026</a:t>
             </a:fld>
             <a:endParaRPr lang="fr-FR"/>
           </a:p>
@@ -2082,7 +2082,7 @@
           <a:p>
             <a:fld id="{253B1B7A-19D7-47DD-996A-6E83BE59A4F5}" type="datetimeFigureOut">
               <a:rPr lang="fr-FR" smtClean="0"/>
-              <a:t>04/03/2026</a:t>
+              <a:t>11/03/2026</a:t>
             </a:fld>
             <a:endParaRPr lang="fr-FR"/>
           </a:p>
@@ -2334,7 +2334,7 @@
           <a:p>
             <a:fld id="{253B1B7A-19D7-47DD-996A-6E83BE59A4F5}" type="datetimeFigureOut">
               <a:rPr lang="fr-FR" smtClean="0"/>
-              <a:t>04/03/2026</a:t>
+              <a:t>11/03/2026</a:t>
             </a:fld>
             <a:endParaRPr lang="fr-FR"/>
           </a:p>
@@ -2545,7 +2545,7 @@
           <a:p>
             <a:fld id="{253B1B7A-19D7-47DD-996A-6E83BE59A4F5}" type="datetimeFigureOut">
               <a:rPr lang="fr-FR" smtClean="0"/>
-              <a:t>04/03/2026</a:t>
+              <a:t>11/03/2026</a:t>
             </a:fld>
             <a:endParaRPr lang="fr-FR"/>
           </a:p>
@@ -4003,64 +4003,6 @@
       </p:sp>
       <p:sp>
         <p:nvSpPr>
-          <p:cNvPr id="10" name="ZoneTexte 9"/>
-          <p:cNvSpPr txBox="1"/>
-          <p:nvPr/>
-        </p:nvSpPr>
-        <p:spPr>
-          <a:xfrm>
-            <a:off x="583519" y="46304"/>
-            <a:ext cx="1037463" cy="369332"/>
-          </a:xfrm>
-          <a:prstGeom prst="rect">
-            <a:avLst/>
-          </a:prstGeom>
-          <a:noFill/>
-        </p:spPr>
-        <p:txBody>
-          <a:bodyPr wrap="none" rtlCol="0">
-            <a:spAutoFit/>
-          </a:bodyPr>
-          <a:lstStyle/>
-          <a:p>
-            <a:r>
-              <a:rPr lang="fr-FR" dirty="0"/>
-              <a:t>Variables</a:t>
-            </a:r>
-          </a:p>
-        </p:txBody>
-      </p:sp>
-      <p:sp>
-        <p:nvSpPr>
-          <p:cNvPr id="11" name="ZoneTexte 10"/>
-          <p:cNvSpPr txBox="1"/>
-          <p:nvPr/>
-        </p:nvSpPr>
-        <p:spPr>
-          <a:xfrm>
-            <a:off x="3548392" y="23153"/>
-            <a:ext cx="1092030" cy="369332"/>
-          </a:xfrm>
-          <a:prstGeom prst="rect">
-            <a:avLst/>
-          </a:prstGeom>
-          <a:noFill/>
-        </p:spPr>
-        <p:txBody>
-          <a:bodyPr wrap="none" rtlCol="0">
-            <a:spAutoFit/>
-          </a:bodyPr>
-          <a:lstStyle/>
-          <a:p>
-            <a:r>
-              <a:rPr lang="fr-FR" dirty="0"/>
-              <a:t>Fonctions</a:t>
-            </a:r>
-          </a:p>
-        </p:txBody>
-      </p:sp>
-      <p:sp>
-        <p:nvSpPr>
           <p:cNvPr id="22" name="Rectangle 21"/>
           <p:cNvSpPr/>
           <p:nvPr/>
@@ -4117,8 +4059,8 @@
         </p:nvSpPr>
         <p:spPr>
           <a:xfrm>
-            <a:off x="3548392" y="415636"/>
-            <a:ext cx="6276109" cy="4154984"/>
+            <a:off x="3469734" y="595745"/>
+            <a:ext cx="3894627" cy="4131900"/>
           </a:xfrm>
           <a:prstGeom prst="rect">
             <a:avLst/>
@@ -4323,11 +4265,7 @@
             </a:r>
           </a:p>
           <a:p>
-            <a:r>
-              <a:rPr lang="fr-FR" sz="1200" b="1" dirty="0" err="1"/>
-              <a:t>raw_data</a:t>
-            </a:r>
-            <a:endParaRPr lang="fr-FR" sz="1200" b="1" dirty="0"/>
+            <a:endParaRPr lang="fr-FR" sz="1050" dirty="0"/>
           </a:p>
           <a:p>
             <a:r>
@@ -4366,11 +4304,419 @@
           <a:p>
             <a:r>
               <a:rPr lang="fr-FR" sz="1200" b="1" dirty="0" err="1"/>
-              <a:t>is_active</a:t>
+              <a:t>is_data_processed</a:t>
             </a:r>
             <a:r>
               <a:rPr lang="fr-FR" sz="1200" b="1" dirty="0"/>
-              <a:t> </a:t>
+              <a:t>  </a:t>
+            </a:r>
+          </a:p>
+        </p:txBody>
+      </p:sp>
+      <p:sp>
+        <p:nvSpPr>
+          <p:cNvPr id="3" name="ZoneTexte 2">
+            <a:extLst>
+              <a:ext uri="{FF2B5EF4-FFF2-40B4-BE49-F238E27FC236}">
+                <a16:creationId xmlns:a16="http://schemas.microsoft.com/office/drawing/2014/main" id="{E3D92BFA-7DD1-7524-619E-0D30E94BC3A0}"/>
+              </a:ext>
+            </a:extLst>
+          </p:cNvPr>
+          <p:cNvSpPr txBox="1"/>
+          <p:nvPr/>
+        </p:nvSpPr>
+        <p:spPr>
+          <a:xfrm>
+            <a:off x="6636775" y="595745"/>
+            <a:ext cx="2904962" cy="5386090"/>
+          </a:xfrm>
+          <a:prstGeom prst="rect">
+            <a:avLst/>
+          </a:prstGeom>
+          <a:noFill/>
+        </p:spPr>
+        <p:txBody>
+          <a:bodyPr wrap="none" rtlCol="0">
+            <a:spAutoFit/>
+          </a:bodyPr>
+          <a:lstStyle/>
+          <a:p>
+            <a:r>
+              <a:rPr lang="fr-FR" sz="1400" b="1" dirty="0" err="1"/>
+              <a:t>raw_data</a:t>
+            </a:r>
+            <a:endParaRPr lang="fr-FR" sz="1400" b="1" dirty="0"/>
+          </a:p>
+          <a:p>
+            <a:r>
+              <a:rPr lang="fr-FR" sz="1100" dirty="0"/>
+              <a:t>                        flight["data"]["</a:t>
+            </a:r>
+            <a:r>
+              <a:rPr lang="fr-FR" sz="1100" dirty="0" err="1"/>
+              <a:t>GNSS_time</a:t>
+            </a:r>
+            <a:r>
+              <a:rPr lang="fr-FR" sz="1100" dirty="0"/>
+              <a:t>"][i]</a:t>
+            </a:r>
+          </a:p>
+          <a:p>
+            <a:r>
+              <a:rPr lang="fr-FR" sz="1100" dirty="0"/>
+              <a:t>                        flight["data"]["</a:t>
+            </a:r>
+            <a:r>
+              <a:rPr lang="fr-FR" sz="1100" dirty="0" err="1"/>
+              <a:t>GNSS_lat</a:t>
+            </a:r>
+            <a:r>
+              <a:rPr lang="fr-FR" sz="1100" dirty="0"/>
+              <a:t>"][i],</a:t>
+            </a:r>
+          </a:p>
+          <a:p>
+            <a:r>
+              <a:rPr lang="fr-FR" sz="1100" dirty="0"/>
+              <a:t>                        flight["data"]["</a:t>
+            </a:r>
+            <a:r>
+              <a:rPr lang="fr-FR" sz="1100" dirty="0" err="1"/>
+              <a:t>GNSS_lon</a:t>
+            </a:r>
+            <a:r>
+              <a:rPr lang="fr-FR" sz="1100" dirty="0"/>
+              <a:t>"][i],</a:t>
+            </a:r>
+          </a:p>
+          <a:p>
+            <a:r>
+              <a:rPr lang="fr-FR" sz="1100" dirty="0"/>
+              <a:t>                        flight["data"]["</a:t>
+            </a:r>
+            <a:r>
+              <a:rPr lang="fr-FR" sz="1100" dirty="0" err="1"/>
+              <a:t>GNSS_alt</a:t>
+            </a:r>
+            <a:r>
+              <a:rPr lang="fr-FR" sz="1100" dirty="0"/>
+              <a:t>"][i],</a:t>
+            </a:r>
+          </a:p>
+          <a:p>
+            <a:r>
+              <a:rPr lang="fr-FR" sz="1100" dirty="0"/>
+              <a:t>                        flight["data"]["</a:t>
+            </a:r>
+            <a:r>
+              <a:rPr lang="fr-FR" sz="1100" dirty="0" err="1"/>
+              <a:t>GNSS_speed</a:t>
+            </a:r>
+            <a:r>
+              <a:rPr lang="fr-FR" sz="1100" dirty="0"/>
+              <a:t>"][i],</a:t>
+            </a:r>
+          </a:p>
+          <a:p>
+            <a:r>
+              <a:rPr lang="fr-FR" sz="1100" dirty="0"/>
+              <a:t>                        flight["data"]["</a:t>
+            </a:r>
+            <a:r>
+              <a:rPr lang="fr-FR" sz="1100" dirty="0" err="1"/>
+              <a:t>GNSS_head</a:t>
+            </a:r>
+            <a:r>
+              <a:rPr lang="fr-FR" sz="1100" dirty="0"/>
+              <a:t>"][i],</a:t>
+            </a:r>
+          </a:p>
+          <a:p>
+            <a:r>
+              <a:rPr lang="fr-FR" sz="1100" dirty="0"/>
+              <a:t>                        flight["data"]["</a:t>
+            </a:r>
+            <a:r>
+              <a:rPr lang="fr-FR" sz="1100" dirty="0" err="1"/>
+              <a:t>QNS_alt</a:t>
+            </a:r>
+            <a:r>
+              <a:rPr lang="fr-FR" sz="1100" dirty="0"/>
+              <a:t>"][i],</a:t>
+            </a:r>
+          </a:p>
+          <a:p>
+            <a:r>
+              <a:rPr lang="fr-FR" sz="1100" dirty="0"/>
+              <a:t>                        flight["data"]["</a:t>
+            </a:r>
+            <a:r>
+              <a:rPr lang="fr-FR" sz="1100" dirty="0" err="1"/>
+              <a:t>compass_head</a:t>
+            </a:r>
+            <a:r>
+              <a:rPr lang="fr-FR" sz="1100" dirty="0"/>
+              <a:t>"][i],</a:t>
+            </a:r>
+          </a:p>
+          <a:p>
+            <a:r>
+              <a:rPr lang="fr-FR" sz="1100" dirty="0"/>
+              <a:t>                        flight["data"]["pitch"][i],</a:t>
+            </a:r>
+          </a:p>
+          <a:p>
+            <a:r>
+              <a:rPr lang="fr-FR" sz="1100" dirty="0"/>
+              <a:t>                        flight["data"]["roll"][i],</a:t>
+            </a:r>
+          </a:p>
+          <a:p>
+            <a:r>
+              <a:rPr lang="fr-FR" sz="1100" dirty="0"/>
+              <a:t>                        flight["data"]["</a:t>
+            </a:r>
+            <a:r>
+              <a:rPr lang="fr-FR" sz="1100" dirty="0" err="1"/>
+              <a:t>G_force</a:t>
+            </a:r>
+            <a:r>
+              <a:rPr lang="fr-FR" sz="1100" dirty="0"/>
+              <a:t>"][i],</a:t>
+            </a:r>
+          </a:p>
+          <a:p>
+            <a:r>
+              <a:rPr lang="fr-FR" sz="1100" dirty="0"/>
+              <a:t>                        flight["data"]["</a:t>
+            </a:r>
+            <a:r>
+              <a:rPr lang="fr-FR" sz="1100" dirty="0" err="1"/>
+              <a:t>vario</a:t>
+            </a:r>
+            <a:r>
+              <a:rPr lang="fr-FR" sz="1100" dirty="0"/>
+              <a:t>"][i],</a:t>
+            </a:r>
+          </a:p>
+          <a:p>
+            <a:r>
+              <a:rPr lang="fr-FR" sz="1100" dirty="0"/>
+              <a:t>                        flight["data"]["DP"][i],</a:t>
+            </a:r>
+          </a:p>
+          <a:p>
+            <a:r>
+              <a:rPr lang="fr-FR" sz="1100" dirty="0"/>
+              <a:t>                        flight["data"]["</a:t>
+            </a:r>
+            <a:r>
+              <a:rPr lang="fr-FR" sz="1100" dirty="0" err="1"/>
+              <a:t>T_sensor</a:t>
+            </a:r>
+            <a:r>
+              <a:rPr lang="fr-FR" sz="1100" dirty="0"/>
+              <a:t>"][i],</a:t>
+            </a:r>
+          </a:p>
+          <a:p>
+            <a:r>
+              <a:rPr lang="fr-FR" sz="1100" dirty="0"/>
+              <a:t>                        flight["data"]["</a:t>
+            </a:r>
+            <a:r>
+              <a:rPr lang="fr-FR" sz="1100" dirty="0" err="1"/>
+              <a:t>P_stat</a:t>
+            </a:r>
+            <a:r>
+              <a:rPr lang="fr-FR" sz="1100" dirty="0"/>
+              <a:t>"][i],</a:t>
+            </a:r>
+          </a:p>
+          <a:p>
+            <a:r>
+              <a:rPr lang="fr-FR" sz="1100" dirty="0"/>
+              <a:t>                        flight["data"]["</a:t>
+            </a:r>
+            <a:r>
+              <a:rPr lang="fr-FR" sz="1100" dirty="0" err="1"/>
+              <a:t>air_T</a:t>
+            </a:r>
+            <a:r>
+              <a:rPr lang="fr-FR" sz="1100" dirty="0"/>
+              <a:t>"][i],</a:t>
+            </a:r>
+          </a:p>
+          <a:p>
+            <a:r>
+              <a:rPr lang="fr-FR" sz="1100" dirty="0"/>
+              <a:t>                        flight["data"]["</a:t>
+            </a:r>
+            <a:r>
+              <a:rPr lang="fr-FR" sz="1100" dirty="0" err="1"/>
+              <a:t>air_RH</a:t>
+            </a:r>
+            <a:r>
+              <a:rPr lang="fr-FR" sz="1100" dirty="0"/>
+              <a:t>"][i],</a:t>
+            </a:r>
+          </a:p>
+          <a:p>
+            <a:r>
+              <a:rPr lang="fr-FR" sz="1100" dirty="0"/>
+              <a:t>                        flight["data"]["</a:t>
+            </a:r>
+            <a:r>
+              <a:rPr lang="fr-FR" sz="1100" dirty="0" err="1"/>
+              <a:t>wind_origin</a:t>
+            </a:r>
+            <a:r>
+              <a:rPr lang="fr-FR" sz="1100" dirty="0"/>
+              <a:t>"][i],</a:t>
+            </a:r>
+          </a:p>
+          <a:p>
+            <a:r>
+              <a:rPr lang="fr-FR" sz="1100" dirty="0"/>
+              <a:t>                        flight["data"]["</a:t>
+            </a:r>
+            <a:r>
+              <a:rPr lang="fr-FR" sz="1100" dirty="0" err="1"/>
+              <a:t>wind_vel</a:t>
+            </a:r>
+            <a:r>
+              <a:rPr lang="fr-FR" sz="1100" dirty="0"/>
+              <a:t>"][i],</a:t>
+            </a:r>
+          </a:p>
+          <a:p>
+            <a:r>
+              <a:rPr lang="fr-FR" sz="1100" dirty="0"/>
+              <a:t>                        flight["data"]["</a:t>
+            </a:r>
+            <a:r>
+              <a:rPr lang="fr-FR" sz="1100" dirty="0" err="1"/>
+              <a:t>netto</a:t>
+            </a:r>
+            <a:r>
+              <a:rPr lang="fr-FR" sz="1100" dirty="0"/>
+              <a:t>"][i],</a:t>
+            </a:r>
+          </a:p>
+          <a:p>
+            <a:r>
+              <a:rPr lang="fr-FR" sz="1100" dirty="0"/>
+              <a:t>                        flight["data"]["IAS"][i],</a:t>
+            </a:r>
+          </a:p>
+          <a:p>
+            <a:r>
+              <a:rPr lang="fr-FR" sz="1100" dirty="0"/>
+              <a:t>                        flight["data"]["</a:t>
+            </a:r>
+            <a:r>
+              <a:rPr lang="fr-FR" sz="1100" dirty="0" err="1"/>
+              <a:t>AirES</a:t>
+            </a:r>
+            <a:r>
+              <a:rPr lang="fr-FR" sz="1100" dirty="0"/>
+              <a:t>"][i],</a:t>
+            </a:r>
+          </a:p>
+          <a:p>
+            <a:r>
+              <a:rPr lang="fr-FR" sz="1100" dirty="0"/>
+              <a:t>                        flight["data"]["</a:t>
+            </a:r>
+            <a:r>
+              <a:rPr lang="fr-FR" sz="1100" dirty="0" err="1"/>
+              <a:t>AirE</a:t>
+            </a:r>
+            <a:r>
+              <a:rPr lang="fr-FR" sz="1100" dirty="0"/>
+              <a:t>"][i],</a:t>
+            </a:r>
+          </a:p>
+          <a:p>
+            <a:r>
+              <a:rPr lang="fr-FR" sz="1100" dirty="0"/>
+              <a:t>                        flight["data"]["</a:t>
+            </a:r>
+            <a:r>
+              <a:rPr lang="fr-FR" sz="1100" dirty="0" err="1"/>
+              <a:t>AirW</a:t>
+            </a:r>
+            <a:r>
+              <a:rPr lang="fr-FR" sz="1100" dirty="0"/>
+              <a:t>"][i],</a:t>
+            </a:r>
+          </a:p>
+          <a:p>
+            <a:r>
+              <a:rPr lang="fr-FR" sz="1100" dirty="0"/>
+              <a:t>                        flight["data"]["</a:t>
+            </a:r>
+            <a:r>
+              <a:rPr lang="fr-FR" sz="1100" dirty="0" err="1"/>
+              <a:t>AirTd</a:t>
+            </a:r>
+            <a:r>
+              <a:rPr lang="fr-FR" sz="1100" dirty="0"/>
+              <a:t>"][i],</a:t>
+            </a:r>
+          </a:p>
+          <a:p>
+            <a:r>
+              <a:rPr lang="fr-FR" sz="1100" dirty="0"/>
+              <a:t>                        flight["data"]["LCL"][i],</a:t>
+            </a:r>
+          </a:p>
+          <a:p>
+            <a:r>
+              <a:rPr lang="fr-FR" sz="1100" dirty="0"/>
+              <a:t>                        flight["data"]["</a:t>
+            </a:r>
+            <a:r>
+              <a:rPr lang="fr-FR" sz="1100" dirty="0" err="1"/>
+              <a:t>AirTheta</a:t>
+            </a:r>
+            <a:r>
+              <a:rPr lang="fr-FR" sz="1100" dirty="0"/>
+              <a:t>"][i],</a:t>
+            </a:r>
+          </a:p>
+          <a:p>
+            <a:r>
+              <a:rPr lang="fr-FR" sz="1100" dirty="0"/>
+              <a:t>                        flight["data"]["</a:t>
+            </a:r>
+            <a:r>
+              <a:rPr lang="fr-FR" sz="1100" dirty="0" err="1"/>
+              <a:t>AirRho</a:t>
+            </a:r>
+            <a:r>
+              <a:rPr lang="fr-FR" sz="1100" dirty="0"/>
+              <a:t>"][i],</a:t>
+            </a:r>
+          </a:p>
+          <a:p>
+            <a:r>
+              <a:rPr lang="fr-FR" sz="1100" dirty="0"/>
+              <a:t>                        flight["data"]["</a:t>
+            </a:r>
+            <a:r>
+              <a:rPr lang="fr-FR" sz="1100" dirty="0" err="1"/>
+              <a:t>VarioIAS</a:t>
+            </a:r>
+            <a:r>
+              <a:rPr lang="fr-FR" sz="1100" dirty="0"/>
+              <a:t>"][i],</a:t>
+            </a:r>
+          </a:p>
+          <a:p>
+            <a:r>
+              <a:rPr lang="fr-FR" sz="1100" dirty="0"/>
+              <a:t>                        flight["data"]["TAS"][i],</a:t>
             </a:r>
           </a:p>
         </p:txBody>
@@ -5592,21 +5938,21 @@
           <p:nvPr>
             <p:extLst>
               <p:ext uri="{D42A27DB-BD31-4B8C-83A1-F6EECF244321}">
-                <p14:modId xmlns:p14="http://schemas.microsoft.com/office/powerpoint/2010/main" val="77452228"/>
+                <p14:modId xmlns:p14="http://schemas.microsoft.com/office/powerpoint/2010/main" val="4035915352"/>
               </p:ext>
             </p:extLst>
           </p:nvPr>
         </p:nvGraphicFramePr>
         <p:xfrm>
-          <a:off x="4572798" y="874109"/>
-          <a:ext cx="821745" cy="4752198"/>
+          <a:off x="4591665" y="874109"/>
+          <a:ext cx="802878" cy="4752198"/>
         </p:xfrm>
         <a:graphic>
           <a:graphicData uri="http://schemas.openxmlformats.org/drawingml/2006/table">
             <a:tbl>
               <a:tblPr/>
               <a:tblGrid>
-                <a:gridCol w="821745">
+                <a:gridCol w="802878">
                   <a:extLst>
                     <a:ext uri="{9D8B030D-6E8A-4147-A177-3AD203B41FA5}">
                       <a16:colId xmlns:a16="http://schemas.microsoft.com/office/drawing/2014/main" val="2977931163"/>
@@ -8496,8 +8842,8 @@
         </p:nvSpPr>
         <p:spPr>
           <a:xfrm>
-            <a:off x="6063817" y="5626307"/>
-            <a:ext cx="1590963" cy="369332"/>
+            <a:off x="5470997" y="5321507"/>
+            <a:ext cx="2320492" cy="923330"/>
           </a:xfrm>
           <a:prstGeom prst="rect">
             <a:avLst/>
@@ -8514,6 +8860,27 @@
               <a:rPr lang="fr-FR" dirty="0"/>
               <a:t>IAS</a:t>
             </a:r>
+            <a:br>
+              <a:rPr lang="fr-FR" dirty="0"/>
+            </a:br>
+            <a:r>
+              <a:rPr lang="fr-FR" dirty="0"/>
+              <a:t>Netto -&gt; </a:t>
+            </a:r>
+            <a:r>
+              <a:rPr lang="fr-FR" sz="1200" dirty="0">
+                <a:solidFill>
+                  <a:srgbClr val="FF0000"/>
+                </a:solidFill>
+              </a:rPr>
+              <a:t>Nan</a:t>
+            </a:r>
+          </a:p>
+          <a:p>
+            <a:r>
+              <a:rPr lang="fr-FR" dirty="0"/>
+              <a:t>Alt -&gt; Nan</a:t>
+            </a:r>
           </a:p>
         </p:txBody>
       </p:sp>
@@ -8525,8 +8892,8 @@
         </p:nvSpPr>
         <p:spPr>
           <a:xfrm>
-            <a:off x="2297462" y="4928632"/>
-            <a:ext cx="1590963" cy="1477328"/>
+            <a:off x="2291161" y="4023111"/>
+            <a:ext cx="1590963" cy="2031325"/>
           </a:xfrm>
           <a:prstGeom prst="rect">
             <a:avLst/>
@@ -8571,10 +8938,19 @@
               <a:rPr lang="fr-FR" dirty="0" err="1"/>
               <a:t>Speed_gps</a:t>
             </a:r>
+            <a:br>
+              <a:rPr lang="fr-FR" dirty="0"/>
+            </a:br>
+            <a:br>
+              <a:rPr lang="fr-FR" dirty="0"/>
+            </a:br>
             <a:endParaRPr lang="fr-FR" dirty="0"/>
           </a:p>
           <a:p>
-            <a:endParaRPr lang="fr-FR" dirty="0"/>
+            <a:r>
+              <a:rPr lang="fr-FR" dirty="0"/>
+              <a:t>DP Nan</a:t>
+            </a:r>
           </a:p>
         </p:txBody>
       </p:sp>

</xml_diff>

<commit_message>
Début du volet graph 1D , avec gestion des variables à afficher
</commit_message>
<xml_diff>
--- a/ressources/code.pptx
+++ b/ressources/code.pptx
@@ -243,7 +243,7 @@
           <a:p>
             <a:fld id="{253B1B7A-19D7-47DD-996A-6E83BE59A4F5}" type="datetimeFigureOut">
               <a:rPr lang="fr-FR" smtClean="0"/>
-              <a:t>11/03/2026</a:t>
+              <a:t>12/03/2026</a:t>
             </a:fld>
             <a:endParaRPr lang="fr-FR"/>
           </a:p>
@@ -411,7 +411,7 @@
           <a:p>
             <a:fld id="{253B1B7A-19D7-47DD-996A-6E83BE59A4F5}" type="datetimeFigureOut">
               <a:rPr lang="fr-FR" smtClean="0"/>
-              <a:t>11/03/2026</a:t>
+              <a:t>12/03/2026</a:t>
             </a:fld>
             <a:endParaRPr lang="fr-FR"/>
           </a:p>
@@ -589,7 +589,7 @@
           <a:p>
             <a:fld id="{253B1B7A-19D7-47DD-996A-6E83BE59A4F5}" type="datetimeFigureOut">
               <a:rPr lang="fr-FR" smtClean="0"/>
-              <a:t>11/03/2026</a:t>
+              <a:t>12/03/2026</a:t>
             </a:fld>
             <a:endParaRPr lang="fr-FR"/>
           </a:p>
@@ -757,7 +757,7 @@
           <a:p>
             <a:fld id="{253B1B7A-19D7-47DD-996A-6E83BE59A4F5}" type="datetimeFigureOut">
               <a:rPr lang="fr-FR" smtClean="0"/>
-              <a:t>11/03/2026</a:t>
+              <a:t>12/03/2026</a:t>
             </a:fld>
             <a:endParaRPr lang="fr-FR"/>
           </a:p>
@@ -1002,7 +1002,7 @@
           <a:p>
             <a:fld id="{253B1B7A-19D7-47DD-996A-6E83BE59A4F5}" type="datetimeFigureOut">
               <a:rPr lang="fr-FR" smtClean="0"/>
-              <a:t>11/03/2026</a:t>
+              <a:t>12/03/2026</a:t>
             </a:fld>
             <a:endParaRPr lang="fr-FR"/>
           </a:p>
@@ -1231,7 +1231,7 @@
           <a:p>
             <a:fld id="{253B1B7A-19D7-47DD-996A-6E83BE59A4F5}" type="datetimeFigureOut">
               <a:rPr lang="fr-FR" smtClean="0"/>
-              <a:t>11/03/2026</a:t>
+              <a:t>12/03/2026</a:t>
             </a:fld>
             <a:endParaRPr lang="fr-FR"/>
           </a:p>
@@ -1595,7 +1595,7 @@
           <a:p>
             <a:fld id="{253B1B7A-19D7-47DD-996A-6E83BE59A4F5}" type="datetimeFigureOut">
               <a:rPr lang="fr-FR" smtClean="0"/>
-              <a:t>11/03/2026</a:t>
+              <a:t>12/03/2026</a:t>
             </a:fld>
             <a:endParaRPr lang="fr-FR"/>
           </a:p>
@@ -1712,7 +1712,7 @@
           <a:p>
             <a:fld id="{253B1B7A-19D7-47DD-996A-6E83BE59A4F5}" type="datetimeFigureOut">
               <a:rPr lang="fr-FR" smtClean="0"/>
-              <a:t>11/03/2026</a:t>
+              <a:t>12/03/2026</a:t>
             </a:fld>
             <a:endParaRPr lang="fr-FR"/>
           </a:p>
@@ -1807,7 +1807,7 @@
           <a:p>
             <a:fld id="{253B1B7A-19D7-47DD-996A-6E83BE59A4F5}" type="datetimeFigureOut">
               <a:rPr lang="fr-FR" smtClean="0"/>
-              <a:t>11/03/2026</a:t>
+              <a:t>12/03/2026</a:t>
             </a:fld>
             <a:endParaRPr lang="fr-FR"/>
           </a:p>
@@ -2082,7 +2082,7 @@
           <a:p>
             <a:fld id="{253B1B7A-19D7-47DD-996A-6E83BE59A4F5}" type="datetimeFigureOut">
               <a:rPr lang="fr-FR" smtClean="0"/>
-              <a:t>11/03/2026</a:t>
+              <a:t>12/03/2026</a:t>
             </a:fld>
             <a:endParaRPr lang="fr-FR"/>
           </a:p>
@@ -2334,7 +2334,7 @@
           <a:p>
             <a:fld id="{253B1B7A-19D7-47DD-996A-6E83BE59A4F5}" type="datetimeFigureOut">
               <a:rPr lang="fr-FR" smtClean="0"/>
-              <a:t>11/03/2026</a:t>
+              <a:t>12/03/2026</a:t>
             </a:fld>
             <a:endParaRPr lang="fr-FR"/>
           </a:p>
@@ -2545,7 +2545,7 @@
           <a:p>
             <a:fld id="{253B1B7A-19D7-47DD-996A-6E83BE59A4F5}" type="datetimeFigureOut">
               <a:rPr lang="fr-FR" smtClean="0"/>
-              <a:t>11/03/2026</a:t>
+              <a:t>12/03/2026</a:t>
             </a:fld>
             <a:endParaRPr lang="fr-FR"/>
           </a:p>
@@ -4060,7 +4060,7 @@
         <p:spPr>
           <a:xfrm>
             <a:off x="3469734" y="595745"/>
-            <a:ext cx="3894627" cy="4131900"/>
+            <a:ext cx="3894627" cy="3947234"/>
           </a:xfrm>
           <a:prstGeom prst="rect">
             <a:avLst/>
@@ -4272,13 +4272,6 @@
               <a:rPr lang="fr-FR" sz="1200" b="1" dirty="0"/>
               <a:t>	</a:t>
             </a:r>
-          </a:p>
-          <a:p>
-            <a:r>
-              <a:rPr lang="fr-FR" sz="1200" b="1" dirty="0" err="1"/>
-              <a:t>processed_data</a:t>
-            </a:r>
-            <a:endParaRPr lang="fr-FR" sz="1200" b="1" dirty="0"/>
           </a:p>
           <a:p>
             <a:r>
@@ -4342,8 +4335,8 @@
           <a:lstStyle/>
           <a:p>
             <a:r>
-              <a:rPr lang="fr-FR" sz="1400" b="1" dirty="0" err="1"/>
-              <a:t>raw_data</a:t>
+              <a:rPr lang="fr-FR" sz="1400" b="1"/>
+              <a:t>data</a:t>
             </a:r>
             <a:endParaRPr lang="fr-FR" sz="1400" b="1" dirty="0"/>
           </a:p>

</xml_diff>

<commit_message>
Gestion des unités , création d'une nouvelle window. Ecriture dans les registres avec QSettings, et conversion sur les graphiques OK
</commit_message>
<xml_diff>
--- a/ressources/code.pptx
+++ b/ressources/code.pptx
@@ -243,7 +243,7 @@
           <a:p>
             <a:fld id="{253B1B7A-19D7-47DD-996A-6E83BE59A4F5}" type="datetimeFigureOut">
               <a:rPr lang="fr-FR" smtClean="0"/>
-              <a:t>12/03/2026</a:t>
+              <a:t>13/03/2026</a:t>
             </a:fld>
             <a:endParaRPr lang="fr-FR"/>
           </a:p>
@@ -411,7 +411,7 @@
           <a:p>
             <a:fld id="{253B1B7A-19D7-47DD-996A-6E83BE59A4F5}" type="datetimeFigureOut">
               <a:rPr lang="fr-FR" smtClean="0"/>
-              <a:t>12/03/2026</a:t>
+              <a:t>13/03/2026</a:t>
             </a:fld>
             <a:endParaRPr lang="fr-FR"/>
           </a:p>
@@ -589,7 +589,7 @@
           <a:p>
             <a:fld id="{253B1B7A-19D7-47DD-996A-6E83BE59A4F5}" type="datetimeFigureOut">
               <a:rPr lang="fr-FR" smtClean="0"/>
-              <a:t>12/03/2026</a:t>
+              <a:t>13/03/2026</a:t>
             </a:fld>
             <a:endParaRPr lang="fr-FR"/>
           </a:p>
@@ -757,7 +757,7 @@
           <a:p>
             <a:fld id="{253B1B7A-19D7-47DD-996A-6E83BE59A4F5}" type="datetimeFigureOut">
               <a:rPr lang="fr-FR" smtClean="0"/>
-              <a:t>12/03/2026</a:t>
+              <a:t>13/03/2026</a:t>
             </a:fld>
             <a:endParaRPr lang="fr-FR"/>
           </a:p>
@@ -1002,7 +1002,7 @@
           <a:p>
             <a:fld id="{253B1B7A-19D7-47DD-996A-6E83BE59A4F5}" type="datetimeFigureOut">
               <a:rPr lang="fr-FR" smtClean="0"/>
-              <a:t>12/03/2026</a:t>
+              <a:t>13/03/2026</a:t>
             </a:fld>
             <a:endParaRPr lang="fr-FR"/>
           </a:p>
@@ -1231,7 +1231,7 @@
           <a:p>
             <a:fld id="{253B1B7A-19D7-47DD-996A-6E83BE59A4F5}" type="datetimeFigureOut">
               <a:rPr lang="fr-FR" smtClean="0"/>
-              <a:t>12/03/2026</a:t>
+              <a:t>13/03/2026</a:t>
             </a:fld>
             <a:endParaRPr lang="fr-FR"/>
           </a:p>
@@ -1595,7 +1595,7 @@
           <a:p>
             <a:fld id="{253B1B7A-19D7-47DD-996A-6E83BE59A4F5}" type="datetimeFigureOut">
               <a:rPr lang="fr-FR" smtClean="0"/>
-              <a:t>12/03/2026</a:t>
+              <a:t>13/03/2026</a:t>
             </a:fld>
             <a:endParaRPr lang="fr-FR"/>
           </a:p>
@@ -1712,7 +1712,7 @@
           <a:p>
             <a:fld id="{253B1B7A-19D7-47DD-996A-6E83BE59A4F5}" type="datetimeFigureOut">
               <a:rPr lang="fr-FR" smtClean="0"/>
-              <a:t>12/03/2026</a:t>
+              <a:t>13/03/2026</a:t>
             </a:fld>
             <a:endParaRPr lang="fr-FR"/>
           </a:p>
@@ -1807,7 +1807,7 @@
           <a:p>
             <a:fld id="{253B1B7A-19D7-47DD-996A-6E83BE59A4F5}" type="datetimeFigureOut">
               <a:rPr lang="fr-FR" smtClean="0"/>
-              <a:t>12/03/2026</a:t>
+              <a:t>13/03/2026</a:t>
             </a:fld>
             <a:endParaRPr lang="fr-FR"/>
           </a:p>
@@ -2082,7 +2082,7 @@
           <a:p>
             <a:fld id="{253B1B7A-19D7-47DD-996A-6E83BE59A4F5}" type="datetimeFigureOut">
               <a:rPr lang="fr-FR" smtClean="0"/>
-              <a:t>12/03/2026</a:t>
+              <a:t>13/03/2026</a:t>
             </a:fld>
             <a:endParaRPr lang="fr-FR"/>
           </a:p>
@@ -2334,7 +2334,7 @@
           <a:p>
             <a:fld id="{253B1B7A-19D7-47DD-996A-6E83BE59A4F5}" type="datetimeFigureOut">
               <a:rPr lang="fr-FR" smtClean="0"/>
-              <a:t>12/03/2026</a:t>
+              <a:t>13/03/2026</a:t>
             </a:fld>
             <a:endParaRPr lang="fr-FR"/>
           </a:p>
@@ -2545,7 +2545,7 @@
           <a:p>
             <a:fld id="{253B1B7A-19D7-47DD-996A-6E83BE59A4F5}" type="datetimeFigureOut">
               <a:rPr lang="fr-FR" smtClean="0"/>
-              <a:t>12/03/2026</a:t>
+              <a:t>13/03/2026</a:t>
             </a:fld>
             <a:endParaRPr lang="fr-FR"/>
           </a:p>
@@ -7081,7 +7081,7 @@
                         </a:spcAft>
                       </a:pPr>
                       <a:r>
-                        <a:rPr lang="fr-FR" sz="800" b="1" i="0" u="none" strike="noStrike">
+                        <a:rPr lang="fr-FR" sz="800" b="1" i="0" u="none" strike="noStrike" dirty="0" err="1">
                           <a:solidFill>
                             <a:srgbClr val="0000FF"/>
                           </a:solidFill>
@@ -7090,7 +7090,7 @@
                         </a:rPr>
                         <a:t>Pstat</a:t>
                       </a:r>
-                      <a:endParaRPr lang="fr-FR" sz="1200">
+                      <a:endParaRPr lang="fr-FR" sz="1200" dirty="0">
                         <a:effectLst/>
                       </a:endParaRPr>
                     </a:p>
@@ -7155,7 +7155,7 @@
                         </a:spcAft>
                       </a:pPr>
                       <a:r>
-                        <a:rPr lang="fr-FR" sz="800" b="1" i="0" u="none" strike="noStrike">
+                        <a:rPr lang="fr-FR" sz="800" b="1" i="0" u="none" strike="noStrike" dirty="0">
                           <a:solidFill>
                             <a:srgbClr val="0000FF"/>
                           </a:solidFill>
@@ -7164,7 +7164,7 @@
                         </a:rPr>
                         <a:t>Vario</a:t>
                       </a:r>
-                      <a:endParaRPr lang="fr-FR" sz="1200">
+                      <a:endParaRPr lang="fr-FR" sz="1200" dirty="0">
                         <a:effectLst/>
                       </a:endParaRPr>
                     </a:p>
@@ -7229,7 +7229,7 @@
                         </a:spcAft>
                       </a:pPr>
                       <a:r>
-                        <a:rPr lang="fr-FR" sz="800" b="1" i="0" u="none" strike="noStrike">
+                        <a:rPr lang="fr-FR" sz="800" b="1" i="0" u="none" strike="noStrike" dirty="0" err="1">
                           <a:solidFill>
                             <a:srgbClr val="000000"/>
                           </a:solidFill>
@@ -7238,7 +7238,7 @@
                         </a:rPr>
                         <a:t>Gs</a:t>
                       </a:r>
-                      <a:endParaRPr lang="fr-FR" sz="1200">
+                      <a:endParaRPr lang="fr-FR" sz="1200" dirty="0">
                         <a:effectLst/>
                       </a:endParaRPr>
                     </a:p>
@@ -7624,7 +7624,7 @@
                         </a:spcAft>
                       </a:pPr>
                       <a:r>
-                        <a:rPr lang="fr-FR" sz="1100" b="1" i="0" u="none" strike="noStrike">
+                        <a:rPr lang="fr-FR" sz="1100" b="1" i="0" u="none" strike="noStrike" dirty="0" err="1">
                           <a:solidFill>
                             <a:srgbClr val="000000"/>
                           </a:solidFill>
@@ -7633,7 +7633,7 @@
                         </a:rPr>
                         <a:t>AirES</a:t>
                       </a:r>
-                      <a:endParaRPr lang="fr-FR">
+                      <a:endParaRPr lang="fr-FR" dirty="0">
                         <a:effectLst/>
                       </a:endParaRPr>
                     </a:p>

</xml_diff>

<commit_message>
Avancement onglet 2D, ajouts des barbules avec modification de la densité. Colorimetrie pour le 3eme axe. Manque ajout d'un fond de carte
</commit_message>
<xml_diff>
--- a/ressources/code.pptx
+++ b/ressources/code.pptx
@@ -243,7 +243,7 @@
           <a:p>
             <a:fld id="{253B1B7A-19D7-47DD-996A-6E83BE59A4F5}" type="datetimeFigureOut">
               <a:rPr lang="fr-FR" smtClean="0"/>
-              <a:t>13/03/2026</a:t>
+              <a:t>19/03/2026</a:t>
             </a:fld>
             <a:endParaRPr lang="fr-FR"/>
           </a:p>
@@ -411,7 +411,7 @@
           <a:p>
             <a:fld id="{253B1B7A-19D7-47DD-996A-6E83BE59A4F5}" type="datetimeFigureOut">
               <a:rPr lang="fr-FR" smtClean="0"/>
-              <a:t>13/03/2026</a:t>
+              <a:t>19/03/2026</a:t>
             </a:fld>
             <a:endParaRPr lang="fr-FR"/>
           </a:p>
@@ -589,7 +589,7 @@
           <a:p>
             <a:fld id="{253B1B7A-19D7-47DD-996A-6E83BE59A4F5}" type="datetimeFigureOut">
               <a:rPr lang="fr-FR" smtClean="0"/>
-              <a:t>13/03/2026</a:t>
+              <a:t>19/03/2026</a:t>
             </a:fld>
             <a:endParaRPr lang="fr-FR"/>
           </a:p>
@@ -757,7 +757,7 @@
           <a:p>
             <a:fld id="{253B1B7A-19D7-47DD-996A-6E83BE59A4F5}" type="datetimeFigureOut">
               <a:rPr lang="fr-FR" smtClean="0"/>
-              <a:t>13/03/2026</a:t>
+              <a:t>19/03/2026</a:t>
             </a:fld>
             <a:endParaRPr lang="fr-FR"/>
           </a:p>
@@ -1002,7 +1002,7 @@
           <a:p>
             <a:fld id="{253B1B7A-19D7-47DD-996A-6E83BE59A4F5}" type="datetimeFigureOut">
               <a:rPr lang="fr-FR" smtClean="0"/>
-              <a:t>13/03/2026</a:t>
+              <a:t>19/03/2026</a:t>
             </a:fld>
             <a:endParaRPr lang="fr-FR"/>
           </a:p>
@@ -1231,7 +1231,7 @@
           <a:p>
             <a:fld id="{253B1B7A-19D7-47DD-996A-6E83BE59A4F5}" type="datetimeFigureOut">
               <a:rPr lang="fr-FR" smtClean="0"/>
-              <a:t>13/03/2026</a:t>
+              <a:t>19/03/2026</a:t>
             </a:fld>
             <a:endParaRPr lang="fr-FR"/>
           </a:p>
@@ -1595,7 +1595,7 @@
           <a:p>
             <a:fld id="{253B1B7A-19D7-47DD-996A-6E83BE59A4F5}" type="datetimeFigureOut">
               <a:rPr lang="fr-FR" smtClean="0"/>
-              <a:t>13/03/2026</a:t>
+              <a:t>19/03/2026</a:t>
             </a:fld>
             <a:endParaRPr lang="fr-FR"/>
           </a:p>
@@ -1712,7 +1712,7 @@
           <a:p>
             <a:fld id="{253B1B7A-19D7-47DD-996A-6E83BE59A4F5}" type="datetimeFigureOut">
               <a:rPr lang="fr-FR" smtClean="0"/>
-              <a:t>13/03/2026</a:t>
+              <a:t>19/03/2026</a:t>
             </a:fld>
             <a:endParaRPr lang="fr-FR"/>
           </a:p>
@@ -1807,7 +1807,7 @@
           <a:p>
             <a:fld id="{253B1B7A-19D7-47DD-996A-6E83BE59A4F5}" type="datetimeFigureOut">
               <a:rPr lang="fr-FR" smtClean="0"/>
-              <a:t>13/03/2026</a:t>
+              <a:t>19/03/2026</a:t>
             </a:fld>
             <a:endParaRPr lang="fr-FR"/>
           </a:p>
@@ -2082,7 +2082,7 @@
           <a:p>
             <a:fld id="{253B1B7A-19D7-47DD-996A-6E83BE59A4F5}" type="datetimeFigureOut">
               <a:rPr lang="fr-FR" smtClean="0"/>
-              <a:t>13/03/2026</a:t>
+              <a:t>19/03/2026</a:t>
             </a:fld>
             <a:endParaRPr lang="fr-FR"/>
           </a:p>
@@ -2334,7 +2334,7 @@
           <a:p>
             <a:fld id="{253B1B7A-19D7-47DD-996A-6E83BE59A4F5}" type="datetimeFigureOut">
               <a:rPr lang="fr-FR" smtClean="0"/>
-              <a:t>13/03/2026</a:t>
+              <a:t>19/03/2026</a:t>
             </a:fld>
             <a:endParaRPr lang="fr-FR"/>
           </a:p>
@@ -2545,7 +2545,7 @@
           <a:p>
             <a:fld id="{253B1B7A-19D7-47DD-996A-6E83BE59A4F5}" type="datetimeFigureOut">
               <a:rPr lang="fr-FR" smtClean="0"/>
-              <a:t>13/03/2026</a:t>
+              <a:t>19/03/2026</a:t>
             </a:fld>
             <a:endParaRPr lang="fr-FR"/>
           </a:p>
@@ -4060,7 +4060,7 @@
         <p:spPr>
           <a:xfrm>
             <a:off x="3469734" y="595745"/>
-            <a:ext cx="3894627" cy="3947234"/>
+            <a:ext cx="3894627" cy="4685898"/>
           </a:xfrm>
           <a:prstGeom prst="rect">
             <a:avLst/>
@@ -4302,6 +4302,35 @@
             <a:r>
               <a:rPr lang="fr-FR" sz="1200" b="1" dirty="0"/>
               <a:t>  </a:t>
+            </a:r>
+          </a:p>
+          <a:p>
+            <a:r>
+              <a:rPr lang="fr-FR" sz="1200" b="1" dirty="0"/>
+              <a:t>Plot:</a:t>
+            </a:r>
+            <a:r>
+              <a:rPr lang="fr-FR" sz="1200" dirty="0"/>
+              <a:t>                « variables_1D" : </a:t>
+            </a:r>
+          </a:p>
+          <a:p>
+            <a:r>
+              <a:rPr lang="fr-FR" sz="1200" dirty="0"/>
+              <a:t>	« windbarbs_2D" :,</a:t>
+            </a:r>
+          </a:p>
+          <a:p>
+            <a:pPr lvl="2"/>
+            <a:r>
+              <a:rPr lang="fr-FR" sz="1200" dirty="0"/>
+              <a:t>"variables_2D" : </a:t>
+            </a:r>
+          </a:p>
+          <a:p>
+            <a:r>
+              <a:rPr lang="fr-FR" sz="1200" b="1" dirty="0"/>
+              <a:t>	</a:t>
             </a:r>
           </a:p>
         </p:txBody>

</xml_diff>

<commit_message>
gors Avancement onglet Polaire. Manque pas mal de feature
</commit_message>
<xml_diff>
--- a/ressources/code.pptx
+++ b/ressources/code.pptx
@@ -243,7 +243,7 @@
           <a:p>
             <a:fld id="{253B1B7A-19D7-47DD-996A-6E83BE59A4F5}" type="datetimeFigureOut">
               <a:rPr lang="fr-FR" smtClean="0"/>
-              <a:t>19/03/2026</a:t>
+              <a:t>24/03/2026</a:t>
             </a:fld>
             <a:endParaRPr lang="fr-FR"/>
           </a:p>
@@ -411,7 +411,7 @@
           <a:p>
             <a:fld id="{253B1B7A-19D7-47DD-996A-6E83BE59A4F5}" type="datetimeFigureOut">
               <a:rPr lang="fr-FR" smtClean="0"/>
-              <a:t>19/03/2026</a:t>
+              <a:t>24/03/2026</a:t>
             </a:fld>
             <a:endParaRPr lang="fr-FR"/>
           </a:p>
@@ -589,7 +589,7 @@
           <a:p>
             <a:fld id="{253B1B7A-19D7-47DD-996A-6E83BE59A4F5}" type="datetimeFigureOut">
               <a:rPr lang="fr-FR" smtClean="0"/>
-              <a:t>19/03/2026</a:t>
+              <a:t>24/03/2026</a:t>
             </a:fld>
             <a:endParaRPr lang="fr-FR"/>
           </a:p>
@@ -757,7 +757,7 @@
           <a:p>
             <a:fld id="{253B1B7A-19D7-47DD-996A-6E83BE59A4F5}" type="datetimeFigureOut">
               <a:rPr lang="fr-FR" smtClean="0"/>
-              <a:t>19/03/2026</a:t>
+              <a:t>24/03/2026</a:t>
             </a:fld>
             <a:endParaRPr lang="fr-FR"/>
           </a:p>
@@ -1002,7 +1002,7 @@
           <a:p>
             <a:fld id="{253B1B7A-19D7-47DD-996A-6E83BE59A4F5}" type="datetimeFigureOut">
               <a:rPr lang="fr-FR" smtClean="0"/>
-              <a:t>19/03/2026</a:t>
+              <a:t>24/03/2026</a:t>
             </a:fld>
             <a:endParaRPr lang="fr-FR"/>
           </a:p>
@@ -1231,7 +1231,7 @@
           <a:p>
             <a:fld id="{253B1B7A-19D7-47DD-996A-6E83BE59A4F5}" type="datetimeFigureOut">
               <a:rPr lang="fr-FR" smtClean="0"/>
-              <a:t>19/03/2026</a:t>
+              <a:t>24/03/2026</a:t>
             </a:fld>
             <a:endParaRPr lang="fr-FR"/>
           </a:p>
@@ -1595,7 +1595,7 @@
           <a:p>
             <a:fld id="{253B1B7A-19D7-47DD-996A-6E83BE59A4F5}" type="datetimeFigureOut">
               <a:rPr lang="fr-FR" smtClean="0"/>
-              <a:t>19/03/2026</a:t>
+              <a:t>24/03/2026</a:t>
             </a:fld>
             <a:endParaRPr lang="fr-FR"/>
           </a:p>
@@ -1712,7 +1712,7 @@
           <a:p>
             <a:fld id="{253B1B7A-19D7-47DD-996A-6E83BE59A4F5}" type="datetimeFigureOut">
               <a:rPr lang="fr-FR" smtClean="0"/>
-              <a:t>19/03/2026</a:t>
+              <a:t>24/03/2026</a:t>
             </a:fld>
             <a:endParaRPr lang="fr-FR"/>
           </a:p>
@@ -1807,7 +1807,7 @@
           <a:p>
             <a:fld id="{253B1B7A-19D7-47DD-996A-6E83BE59A4F5}" type="datetimeFigureOut">
               <a:rPr lang="fr-FR" smtClean="0"/>
-              <a:t>19/03/2026</a:t>
+              <a:t>24/03/2026</a:t>
             </a:fld>
             <a:endParaRPr lang="fr-FR"/>
           </a:p>
@@ -2082,7 +2082,7 @@
           <a:p>
             <a:fld id="{253B1B7A-19D7-47DD-996A-6E83BE59A4F5}" type="datetimeFigureOut">
               <a:rPr lang="fr-FR" smtClean="0"/>
-              <a:t>19/03/2026</a:t>
+              <a:t>24/03/2026</a:t>
             </a:fld>
             <a:endParaRPr lang="fr-FR"/>
           </a:p>
@@ -2334,7 +2334,7 @@
           <a:p>
             <a:fld id="{253B1B7A-19D7-47DD-996A-6E83BE59A4F5}" type="datetimeFigureOut">
               <a:rPr lang="fr-FR" smtClean="0"/>
-              <a:t>19/03/2026</a:t>
+              <a:t>24/03/2026</a:t>
             </a:fld>
             <a:endParaRPr lang="fr-FR"/>
           </a:p>
@@ -2545,7 +2545,7 @@
           <a:p>
             <a:fld id="{253B1B7A-19D7-47DD-996A-6E83BE59A4F5}" type="datetimeFigureOut">
               <a:rPr lang="fr-FR" smtClean="0"/>
-              <a:t>19/03/2026</a:t>
+              <a:t>24/03/2026</a:t>
             </a:fld>
             <a:endParaRPr lang="fr-FR"/>
           </a:p>
@@ -3968,7 +3968,7 @@
         </p:nvSpPr>
         <p:spPr>
           <a:xfrm>
-            <a:off x="3325091" y="415636"/>
+            <a:off x="4278820" y="365480"/>
             <a:ext cx="8132618" cy="5846619"/>
           </a:xfrm>
           <a:prstGeom prst="rect">
@@ -4060,7 +4060,7 @@
         <p:spPr>
           <a:xfrm>
             <a:off x="3469734" y="595745"/>
-            <a:ext cx="3894627" cy="4685898"/>
+            <a:ext cx="5330137" cy="5424562"/>
           </a:xfrm>
           <a:prstGeom prst="rect">
             <a:avLst/>
@@ -4265,6 +4265,7 @@
             </a:r>
           </a:p>
           <a:p>
+            <a:pPr lvl="2"/>
             <a:endParaRPr lang="fr-FR" sz="1050" dirty="0"/>
           </a:p>
           <a:p>
@@ -4307,7 +4308,7 @@
           <a:p>
             <a:r>
               <a:rPr lang="fr-FR" sz="1200" b="1" dirty="0"/>
-              <a:t>Plot:</a:t>
+              <a:t>plot:</a:t>
             </a:r>
             <a:r>
               <a:rPr lang="fr-FR" sz="1200" dirty="0"/>
@@ -4317,7 +4318,7 @@
           <a:p>
             <a:r>
               <a:rPr lang="fr-FR" sz="1200" dirty="0"/>
-              <a:t>	« windbarbs_2D" :,</a:t>
+              <a:t>	«windbarbs_2D" :,</a:t>
             </a:r>
           </a:p>
           <a:p>
@@ -4326,6 +4327,99 @@
               <a:rPr lang="fr-FR" sz="1200" dirty="0"/>
               <a:t>"variables_2D" : </a:t>
             </a:r>
+          </a:p>
+          <a:p>
+            <a:pPr lvl="2"/>
+            <a:r>
+              <a:rPr lang="fr-FR" sz="1200" dirty="0"/>
+              <a:t>«polar »: [‘roi’ , ‘</a:t>
+            </a:r>
+            <a:r>
+              <a:rPr lang="fr-FR" sz="1200" dirty="0" err="1"/>
+              <a:t>ias_avg</a:t>
+            </a:r>
+            <a:r>
+              <a:rPr lang="fr-FR" sz="1200" dirty="0"/>
+              <a:t>’ ‘</a:t>
+            </a:r>
+            <a:r>
+              <a:rPr lang="fr-FR" sz="1200" dirty="0" err="1"/>
+              <a:t>vx_avg</a:t>
+            </a:r>
+            <a:r>
+              <a:rPr lang="fr-FR" sz="1200" dirty="0"/>
+              <a:t>’ ‘</a:t>
+            </a:r>
+            <a:r>
+              <a:rPr lang="fr-FR" sz="1200" dirty="0" err="1"/>
+              <a:t>vz_avg</a:t>
+            </a:r>
+            <a:r>
+              <a:rPr lang="fr-FR" sz="1200" dirty="0"/>
+              <a:t>’ ‘</a:t>
+            </a:r>
+            <a:r>
+              <a:rPr lang="fr-FR" sz="1200" dirty="0" err="1"/>
+              <a:t>glide_avg</a:t>
+            </a:r>
+            <a:r>
+              <a:rPr lang="fr-FR" sz="1200" dirty="0"/>
+              <a:t>’] liste de liste </a:t>
+            </a:r>
+          </a:p>
+          <a:p>
+            <a:pPr lvl="2"/>
+            <a:r>
+              <a:rPr lang="fr-FR" sz="1200" dirty="0"/>
+              <a:t>« </a:t>
+            </a:r>
+            <a:r>
+              <a:rPr lang="fr-FR" sz="1200" dirty="0" err="1"/>
+              <a:t>plot_color</a:t>
+            </a:r>
+            <a:r>
+              <a:rPr lang="fr-FR" sz="1200" dirty="0"/>
+              <a:t> »: </a:t>
+            </a:r>
+            <a:r>
+              <a:rPr lang="fr-FR" sz="1200" dirty="0" err="1"/>
+              <a:t>str</a:t>
+            </a:r>
+            <a:r>
+              <a:rPr lang="fr-FR" sz="1200" dirty="0"/>
+              <a:t> None</a:t>
+            </a:r>
+          </a:p>
+          <a:p>
+            <a:pPr lvl="2"/>
+            <a:r>
+              <a:rPr lang="fr-FR" sz="1200" dirty="0"/>
+              <a:t>« </a:t>
+            </a:r>
+            <a:r>
+              <a:rPr lang="fr-FR" sz="1200" dirty="0" err="1"/>
+              <a:t>crosshair_v</a:t>
+            </a:r>
+            <a:r>
+              <a:rPr lang="fr-FR" sz="1200" dirty="0"/>
+              <a:t> »</a:t>
+            </a:r>
+          </a:p>
+          <a:p>
+            <a:pPr lvl="2"/>
+            <a:r>
+              <a:rPr lang="fr-FR" sz="1200" dirty="0"/>
+              <a:t>« </a:t>
+            </a:r>
+            <a:r>
+              <a:rPr lang="fr-FR" sz="1200" dirty="0" err="1"/>
+              <a:t>crosshair_h</a:t>
+            </a:r>
+            <a:r>
+              <a:rPr lang="fr-FR" sz="1200"/>
+              <a:t> »</a:t>
+            </a:r>
+            <a:endParaRPr lang="fr-FR" sz="1200" dirty="0"/>
           </a:p>
           <a:p>
             <a:r>
@@ -4349,7 +4443,7 @@
         </p:nvSpPr>
         <p:spPr>
           <a:xfrm>
-            <a:off x="6636775" y="595745"/>
+            <a:off x="8091949" y="581890"/>
             <a:ext cx="2904962" cy="5386090"/>
           </a:xfrm>
           <a:prstGeom prst="rect">
@@ -4364,10 +4458,9 @@
           <a:lstStyle/>
           <a:p>
             <a:r>
-              <a:rPr lang="fr-FR" sz="1400" b="1"/>
+              <a:rPr lang="fr-FR" sz="1400" b="1" dirty="0"/>
               <a:t>data</a:t>
             </a:r>
-            <a:endParaRPr lang="fr-FR" sz="1400" b="1" dirty="0"/>
           </a:p>
           <a:p>
             <a:r>

</xml_diff>

<commit_message>
Correction bug + GUI polaire. Ajout du début de l'export KML
</commit_message>
<xml_diff>
--- a/ressources/code.pptx
+++ b/ressources/code.pptx
@@ -243,7 +243,7 @@
           <a:p>
             <a:fld id="{253B1B7A-19D7-47DD-996A-6E83BE59A4F5}" type="datetimeFigureOut">
               <a:rPr lang="fr-FR" smtClean="0"/>
-              <a:t>24/03/2026</a:t>
+              <a:t>25/03/2026</a:t>
             </a:fld>
             <a:endParaRPr lang="fr-FR"/>
           </a:p>
@@ -411,7 +411,7 @@
           <a:p>
             <a:fld id="{253B1B7A-19D7-47DD-996A-6E83BE59A4F5}" type="datetimeFigureOut">
               <a:rPr lang="fr-FR" smtClean="0"/>
-              <a:t>24/03/2026</a:t>
+              <a:t>25/03/2026</a:t>
             </a:fld>
             <a:endParaRPr lang="fr-FR"/>
           </a:p>
@@ -589,7 +589,7 @@
           <a:p>
             <a:fld id="{253B1B7A-19D7-47DD-996A-6E83BE59A4F5}" type="datetimeFigureOut">
               <a:rPr lang="fr-FR" smtClean="0"/>
-              <a:t>24/03/2026</a:t>
+              <a:t>25/03/2026</a:t>
             </a:fld>
             <a:endParaRPr lang="fr-FR"/>
           </a:p>
@@ -757,7 +757,7 @@
           <a:p>
             <a:fld id="{253B1B7A-19D7-47DD-996A-6E83BE59A4F5}" type="datetimeFigureOut">
               <a:rPr lang="fr-FR" smtClean="0"/>
-              <a:t>24/03/2026</a:t>
+              <a:t>25/03/2026</a:t>
             </a:fld>
             <a:endParaRPr lang="fr-FR"/>
           </a:p>
@@ -1002,7 +1002,7 @@
           <a:p>
             <a:fld id="{253B1B7A-19D7-47DD-996A-6E83BE59A4F5}" type="datetimeFigureOut">
               <a:rPr lang="fr-FR" smtClean="0"/>
-              <a:t>24/03/2026</a:t>
+              <a:t>25/03/2026</a:t>
             </a:fld>
             <a:endParaRPr lang="fr-FR"/>
           </a:p>
@@ -1231,7 +1231,7 @@
           <a:p>
             <a:fld id="{253B1B7A-19D7-47DD-996A-6E83BE59A4F5}" type="datetimeFigureOut">
               <a:rPr lang="fr-FR" smtClean="0"/>
-              <a:t>24/03/2026</a:t>
+              <a:t>25/03/2026</a:t>
             </a:fld>
             <a:endParaRPr lang="fr-FR"/>
           </a:p>
@@ -1595,7 +1595,7 @@
           <a:p>
             <a:fld id="{253B1B7A-19D7-47DD-996A-6E83BE59A4F5}" type="datetimeFigureOut">
               <a:rPr lang="fr-FR" smtClean="0"/>
-              <a:t>24/03/2026</a:t>
+              <a:t>25/03/2026</a:t>
             </a:fld>
             <a:endParaRPr lang="fr-FR"/>
           </a:p>
@@ -1712,7 +1712,7 @@
           <a:p>
             <a:fld id="{253B1B7A-19D7-47DD-996A-6E83BE59A4F5}" type="datetimeFigureOut">
               <a:rPr lang="fr-FR" smtClean="0"/>
-              <a:t>24/03/2026</a:t>
+              <a:t>25/03/2026</a:t>
             </a:fld>
             <a:endParaRPr lang="fr-FR"/>
           </a:p>
@@ -1807,7 +1807,7 @@
           <a:p>
             <a:fld id="{253B1B7A-19D7-47DD-996A-6E83BE59A4F5}" type="datetimeFigureOut">
               <a:rPr lang="fr-FR" smtClean="0"/>
-              <a:t>24/03/2026</a:t>
+              <a:t>25/03/2026</a:t>
             </a:fld>
             <a:endParaRPr lang="fr-FR"/>
           </a:p>
@@ -2082,7 +2082,7 @@
           <a:p>
             <a:fld id="{253B1B7A-19D7-47DD-996A-6E83BE59A4F5}" type="datetimeFigureOut">
               <a:rPr lang="fr-FR" smtClean="0"/>
-              <a:t>24/03/2026</a:t>
+              <a:t>25/03/2026</a:t>
             </a:fld>
             <a:endParaRPr lang="fr-FR"/>
           </a:p>
@@ -2334,7 +2334,7 @@
           <a:p>
             <a:fld id="{253B1B7A-19D7-47DD-996A-6E83BE59A4F5}" type="datetimeFigureOut">
               <a:rPr lang="fr-FR" smtClean="0"/>
-              <a:t>24/03/2026</a:t>
+              <a:t>25/03/2026</a:t>
             </a:fld>
             <a:endParaRPr lang="fr-FR"/>
           </a:p>
@@ -2545,7 +2545,7 @@
           <a:p>
             <a:fld id="{253B1B7A-19D7-47DD-996A-6E83BE59A4F5}" type="datetimeFigureOut">
               <a:rPr lang="fr-FR" smtClean="0"/>
-              <a:t>24/03/2026</a:t>
+              <a:t>25/03/2026</a:t>
             </a:fld>
             <a:endParaRPr lang="fr-FR"/>
           </a:p>
@@ -4060,7 +4060,7 @@
         <p:spPr>
           <a:xfrm>
             <a:off x="3469734" y="595745"/>
-            <a:ext cx="5330137" cy="5424562"/>
+            <a:ext cx="5330137" cy="5793894"/>
           </a:xfrm>
           <a:prstGeom prst="rect">
             <a:avLst/>
@@ -4332,7 +4332,15 @@
             <a:pPr lvl="2"/>
             <a:r>
               <a:rPr lang="fr-FR" sz="1200" dirty="0"/>
-              <a:t>«polar »: [‘roi’ , ‘</a:t>
+              <a:t>«</a:t>
+            </a:r>
+            <a:r>
+              <a:rPr lang="fr-FR" sz="1200" dirty="0" err="1"/>
+              <a:t>roi_polar</a:t>
+            </a:r>
+            <a:r>
+              <a:rPr lang="fr-FR" sz="1200" dirty="0"/>
+              <a:t> »: [‘roi’ , ‘</a:t>
             </a:r>
             <a:r>
               <a:rPr lang="fr-FR" sz="1200" dirty="0" err="1"/>
@@ -4416,10 +4424,24 @@
               <a:t>crosshair_h</a:t>
             </a:r>
             <a:r>
-              <a:rPr lang="fr-FR" sz="1200"/>
+              <a:rPr lang="fr-FR" sz="1200" dirty="0"/>
               <a:t> »</a:t>
             </a:r>
-            <a:endParaRPr lang="fr-FR" sz="1200" dirty="0"/>
+          </a:p>
+          <a:p>
+            <a:pPr lvl="2"/>
+            <a:r>
+              <a:rPr lang="fr-FR" sz="1200" dirty="0"/>
+              <a:t>« </a:t>
+            </a:r>
+            <a:r>
+              <a:rPr lang="fr-FR" sz="1200" dirty="0" err="1"/>
+              <a:t>roi_emagram</a:t>
+            </a:r>
+            <a:r>
+              <a:rPr lang="fr-FR" sz="1200" dirty="0"/>
+              <a:t> »</a:t>
+            </a:r>
           </a:p>
           <a:p>
             <a:r>

</xml_diff>

<commit_message>
Debut d'emagramme , tres peu fonctionnel
</commit_message>
<xml_diff>
--- a/ressources/code.pptx
+++ b/ressources/code.pptx
@@ -243,7 +243,7 @@
           <a:p>
             <a:fld id="{253B1B7A-19D7-47DD-996A-6E83BE59A4F5}" type="datetimeFigureOut">
               <a:rPr lang="fr-FR" smtClean="0"/>
-              <a:t>25/03/2026</a:t>
+              <a:t>26/03/2026</a:t>
             </a:fld>
             <a:endParaRPr lang="fr-FR"/>
           </a:p>
@@ -411,7 +411,7 @@
           <a:p>
             <a:fld id="{253B1B7A-19D7-47DD-996A-6E83BE59A4F5}" type="datetimeFigureOut">
               <a:rPr lang="fr-FR" smtClean="0"/>
-              <a:t>25/03/2026</a:t>
+              <a:t>26/03/2026</a:t>
             </a:fld>
             <a:endParaRPr lang="fr-FR"/>
           </a:p>
@@ -589,7 +589,7 @@
           <a:p>
             <a:fld id="{253B1B7A-19D7-47DD-996A-6E83BE59A4F5}" type="datetimeFigureOut">
               <a:rPr lang="fr-FR" smtClean="0"/>
-              <a:t>25/03/2026</a:t>
+              <a:t>26/03/2026</a:t>
             </a:fld>
             <a:endParaRPr lang="fr-FR"/>
           </a:p>
@@ -757,7 +757,7 @@
           <a:p>
             <a:fld id="{253B1B7A-19D7-47DD-996A-6E83BE59A4F5}" type="datetimeFigureOut">
               <a:rPr lang="fr-FR" smtClean="0"/>
-              <a:t>25/03/2026</a:t>
+              <a:t>26/03/2026</a:t>
             </a:fld>
             <a:endParaRPr lang="fr-FR"/>
           </a:p>
@@ -1002,7 +1002,7 @@
           <a:p>
             <a:fld id="{253B1B7A-19D7-47DD-996A-6E83BE59A4F5}" type="datetimeFigureOut">
               <a:rPr lang="fr-FR" smtClean="0"/>
-              <a:t>25/03/2026</a:t>
+              <a:t>26/03/2026</a:t>
             </a:fld>
             <a:endParaRPr lang="fr-FR"/>
           </a:p>
@@ -1231,7 +1231,7 @@
           <a:p>
             <a:fld id="{253B1B7A-19D7-47DD-996A-6E83BE59A4F5}" type="datetimeFigureOut">
               <a:rPr lang="fr-FR" smtClean="0"/>
-              <a:t>25/03/2026</a:t>
+              <a:t>26/03/2026</a:t>
             </a:fld>
             <a:endParaRPr lang="fr-FR"/>
           </a:p>
@@ -1595,7 +1595,7 @@
           <a:p>
             <a:fld id="{253B1B7A-19D7-47DD-996A-6E83BE59A4F5}" type="datetimeFigureOut">
               <a:rPr lang="fr-FR" smtClean="0"/>
-              <a:t>25/03/2026</a:t>
+              <a:t>26/03/2026</a:t>
             </a:fld>
             <a:endParaRPr lang="fr-FR"/>
           </a:p>
@@ -1712,7 +1712,7 @@
           <a:p>
             <a:fld id="{253B1B7A-19D7-47DD-996A-6E83BE59A4F5}" type="datetimeFigureOut">
               <a:rPr lang="fr-FR" smtClean="0"/>
-              <a:t>25/03/2026</a:t>
+              <a:t>26/03/2026</a:t>
             </a:fld>
             <a:endParaRPr lang="fr-FR"/>
           </a:p>
@@ -1807,7 +1807,7 @@
           <a:p>
             <a:fld id="{253B1B7A-19D7-47DD-996A-6E83BE59A4F5}" type="datetimeFigureOut">
               <a:rPr lang="fr-FR" smtClean="0"/>
-              <a:t>25/03/2026</a:t>
+              <a:t>26/03/2026</a:t>
             </a:fld>
             <a:endParaRPr lang="fr-FR"/>
           </a:p>
@@ -2082,7 +2082,7 @@
           <a:p>
             <a:fld id="{253B1B7A-19D7-47DD-996A-6E83BE59A4F5}" type="datetimeFigureOut">
               <a:rPr lang="fr-FR" smtClean="0"/>
-              <a:t>25/03/2026</a:t>
+              <a:t>26/03/2026</a:t>
             </a:fld>
             <a:endParaRPr lang="fr-FR"/>
           </a:p>
@@ -2334,7 +2334,7 @@
           <a:p>
             <a:fld id="{253B1B7A-19D7-47DD-996A-6E83BE59A4F5}" type="datetimeFigureOut">
               <a:rPr lang="fr-FR" smtClean="0"/>
-              <a:t>25/03/2026</a:t>
+              <a:t>26/03/2026</a:t>
             </a:fld>
             <a:endParaRPr lang="fr-FR"/>
           </a:p>
@@ -2545,7 +2545,7 @@
           <a:p>
             <a:fld id="{253B1B7A-19D7-47DD-996A-6E83BE59A4F5}" type="datetimeFigureOut">
               <a:rPr lang="fr-FR" smtClean="0"/>
-              <a:t>25/03/2026</a:t>
+              <a:t>26/03/2026</a:t>
             </a:fld>
             <a:endParaRPr lang="fr-FR"/>
           </a:p>

</xml_diff>

<commit_message>
Fin de la partie génération de polaire. A tester
</commit_message>
<xml_diff>
--- a/ressources/code.pptx
+++ b/ressources/code.pptx
@@ -243,7 +243,7 @@
           <a:p>
             <a:fld id="{253B1B7A-19D7-47DD-996A-6E83BE59A4F5}" type="datetimeFigureOut">
               <a:rPr lang="fr-FR" smtClean="0"/>
-              <a:t>26/03/2026</a:t>
+              <a:t>28/03/2026</a:t>
             </a:fld>
             <a:endParaRPr lang="fr-FR"/>
           </a:p>
@@ -411,7 +411,7 @@
           <a:p>
             <a:fld id="{253B1B7A-19D7-47DD-996A-6E83BE59A4F5}" type="datetimeFigureOut">
               <a:rPr lang="fr-FR" smtClean="0"/>
-              <a:t>26/03/2026</a:t>
+              <a:t>28/03/2026</a:t>
             </a:fld>
             <a:endParaRPr lang="fr-FR"/>
           </a:p>
@@ -589,7 +589,7 @@
           <a:p>
             <a:fld id="{253B1B7A-19D7-47DD-996A-6E83BE59A4F5}" type="datetimeFigureOut">
               <a:rPr lang="fr-FR" smtClean="0"/>
-              <a:t>26/03/2026</a:t>
+              <a:t>28/03/2026</a:t>
             </a:fld>
             <a:endParaRPr lang="fr-FR"/>
           </a:p>
@@ -757,7 +757,7 @@
           <a:p>
             <a:fld id="{253B1B7A-19D7-47DD-996A-6E83BE59A4F5}" type="datetimeFigureOut">
               <a:rPr lang="fr-FR" smtClean="0"/>
-              <a:t>26/03/2026</a:t>
+              <a:t>28/03/2026</a:t>
             </a:fld>
             <a:endParaRPr lang="fr-FR"/>
           </a:p>
@@ -1002,7 +1002,7 @@
           <a:p>
             <a:fld id="{253B1B7A-19D7-47DD-996A-6E83BE59A4F5}" type="datetimeFigureOut">
               <a:rPr lang="fr-FR" smtClean="0"/>
-              <a:t>26/03/2026</a:t>
+              <a:t>28/03/2026</a:t>
             </a:fld>
             <a:endParaRPr lang="fr-FR"/>
           </a:p>
@@ -1231,7 +1231,7 @@
           <a:p>
             <a:fld id="{253B1B7A-19D7-47DD-996A-6E83BE59A4F5}" type="datetimeFigureOut">
               <a:rPr lang="fr-FR" smtClean="0"/>
-              <a:t>26/03/2026</a:t>
+              <a:t>28/03/2026</a:t>
             </a:fld>
             <a:endParaRPr lang="fr-FR"/>
           </a:p>
@@ -1595,7 +1595,7 @@
           <a:p>
             <a:fld id="{253B1B7A-19D7-47DD-996A-6E83BE59A4F5}" type="datetimeFigureOut">
               <a:rPr lang="fr-FR" smtClean="0"/>
-              <a:t>26/03/2026</a:t>
+              <a:t>28/03/2026</a:t>
             </a:fld>
             <a:endParaRPr lang="fr-FR"/>
           </a:p>
@@ -1712,7 +1712,7 @@
           <a:p>
             <a:fld id="{253B1B7A-19D7-47DD-996A-6E83BE59A4F5}" type="datetimeFigureOut">
               <a:rPr lang="fr-FR" smtClean="0"/>
-              <a:t>26/03/2026</a:t>
+              <a:t>28/03/2026</a:t>
             </a:fld>
             <a:endParaRPr lang="fr-FR"/>
           </a:p>
@@ -1807,7 +1807,7 @@
           <a:p>
             <a:fld id="{253B1B7A-19D7-47DD-996A-6E83BE59A4F5}" type="datetimeFigureOut">
               <a:rPr lang="fr-FR" smtClean="0"/>
-              <a:t>26/03/2026</a:t>
+              <a:t>28/03/2026</a:t>
             </a:fld>
             <a:endParaRPr lang="fr-FR"/>
           </a:p>
@@ -2082,7 +2082,7 @@
           <a:p>
             <a:fld id="{253B1B7A-19D7-47DD-996A-6E83BE59A4F5}" type="datetimeFigureOut">
               <a:rPr lang="fr-FR" smtClean="0"/>
-              <a:t>26/03/2026</a:t>
+              <a:t>28/03/2026</a:t>
             </a:fld>
             <a:endParaRPr lang="fr-FR"/>
           </a:p>
@@ -2334,7 +2334,7 @@
           <a:p>
             <a:fld id="{253B1B7A-19D7-47DD-996A-6E83BE59A4F5}" type="datetimeFigureOut">
               <a:rPr lang="fr-FR" smtClean="0"/>
-              <a:t>26/03/2026</a:t>
+              <a:t>28/03/2026</a:t>
             </a:fld>
             <a:endParaRPr lang="fr-FR"/>
           </a:p>
@@ -2545,7 +2545,7 @@
           <a:p>
             <a:fld id="{253B1B7A-19D7-47DD-996A-6E83BE59A4F5}" type="datetimeFigureOut">
               <a:rPr lang="fr-FR" smtClean="0"/>
-              <a:t>26/03/2026</a:t>
+              <a:t>28/03/2026</a:t>
             </a:fld>
             <a:endParaRPr lang="fr-FR"/>
           </a:p>
@@ -4372,6 +4372,14 @@
             </a:r>
             <a:r>
               <a:rPr lang="fr-FR" sz="1200" dirty="0"/>
+              <a:t>’ ‘</a:t>
+            </a:r>
+            <a:r>
+              <a:rPr lang="fr-FR" sz="1200" dirty="0" err="1"/>
+              <a:t>scatter</a:t>
+            </a:r>
+            <a:r>
+              <a:rPr lang="fr-FR" sz="1200" dirty="0"/>
               <a:t>’] liste de liste </a:t>
             </a:r>
           </a:p>

</xml_diff>

<commit_message>
Ajout du mapping de toutes les variables en 2D + début de tableau qui indique toutes les valeurs
</commit_message>
<xml_diff>
--- a/ressources/code.pptx
+++ b/ressources/code.pptx
@@ -4060,7 +4060,7 @@
         <p:spPr>
           <a:xfrm>
             <a:off x="3469734" y="595745"/>
-            <a:ext cx="5330137" cy="5793894"/>
+            <a:ext cx="5330137" cy="5978560"/>
           </a:xfrm>
           <a:prstGeom prst="rect">
             <a:avLst/>
@@ -4372,15 +4372,29 @@
             </a:r>
             <a:r>
               <a:rPr lang="fr-FR" sz="1200" dirty="0"/>
-              <a:t>’ ‘</a:t>
+              <a:t>’ </a:t>
+            </a:r>
+          </a:p>
+          <a:p>
+            <a:pPr lvl="2"/>
+            <a:r>
+              <a:rPr lang="fr-FR" sz="1200" dirty="0"/>
+              <a:t>liste de liste </a:t>
+            </a:r>
+          </a:p>
+          <a:p>
+            <a:pPr lvl="2"/>
+            <a:r>
+              <a:rPr lang="fr-FR" sz="1200" dirty="0"/>
+              <a:t>« </a:t>
             </a:r>
             <a:r>
               <a:rPr lang="fr-FR" sz="1200" dirty="0" err="1"/>
-              <a:t>scatter</a:t>
+              <a:t>scatter_vxvz</a:t>
             </a:r>
             <a:r>
               <a:rPr lang="fr-FR" sz="1200" dirty="0"/>
-              <a:t>’] liste de liste </a:t>
+              <a:t> »</a:t>
             </a:r>
           </a:p>
           <a:p>

</xml_diff>

<commit_message>
Ajout du drag'n'drop , changement de quelques GUI, correction de bugs, ajout des crosshair sur la carte 2D, modification de l'onglet import
</commit_message>
<xml_diff>
--- a/ressources/code.pptx
+++ b/ressources/code.pptx
@@ -243,7 +243,7 @@
           <a:p>
             <a:fld id="{253B1B7A-19D7-47DD-996A-6E83BE59A4F5}" type="datetimeFigureOut">
               <a:rPr lang="fr-FR" smtClean="0"/>
-              <a:t>28/03/2026</a:t>
+              <a:t>02/04/2026</a:t>
             </a:fld>
             <a:endParaRPr lang="fr-FR"/>
           </a:p>
@@ -411,7 +411,7 @@
           <a:p>
             <a:fld id="{253B1B7A-19D7-47DD-996A-6E83BE59A4F5}" type="datetimeFigureOut">
               <a:rPr lang="fr-FR" smtClean="0"/>
-              <a:t>28/03/2026</a:t>
+              <a:t>02/04/2026</a:t>
             </a:fld>
             <a:endParaRPr lang="fr-FR"/>
           </a:p>
@@ -589,7 +589,7 @@
           <a:p>
             <a:fld id="{253B1B7A-19D7-47DD-996A-6E83BE59A4F5}" type="datetimeFigureOut">
               <a:rPr lang="fr-FR" smtClean="0"/>
-              <a:t>28/03/2026</a:t>
+              <a:t>02/04/2026</a:t>
             </a:fld>
             <a:endParaRPr lang="fr-FR"/>
           </a:p>
@@ -757,7 +757,7 @@
           <a:p>
             <a:fld id="{253B1B7A-19D7-47DD-996A-6E83BE59A4F5}" type="datetimeFigureOut">
               <a:rPr lang="fr-FR" smtClean="0"/>
-              <a:t>28/03/2026</a:t>
+              <a:t>02/04/2026</a:t>
             </a:fld>
             <a:endParaRPr lang="fr-FR"/>
           </a:p>
@@ -1002,7 +1002,7 @@
           <a:p>
             <a:fld id="{253B1B7A-19D7-47DD-996A-6E83BE59A4F5}" type="datetimeFigureOut">
               <a:rPr lang="fr-FR" smtClean="0"/>
-              <a:t>28/03/2026</a:t>
+              <a:t>02/04/2026</a:t>
             </a:fld>
             <a:endParaRPr lang="fr-FR"/>
           </a:p>
@@ -1231,7 +1231,7 @@
           <a:p>
             <a:fld id="{253B1B7A-19D7-47DD-996A-6E83BE59A4F5}" type="datetimeFigureOut">
               <a:rPr lang="fr-FR" smtClean="0"/>
-              <a:t>28/03/2026</a:t>
+              <a:t>02/04/2026</a:t>
             </a:fld>
             <a:endParaRPr lang="fr-FR"/>
           </a:p>
@@ -1595,7 +1595,7 @@
           <a:p>
             <a:fld id="{253B1B7A-19D7-47DD-996A-6E83BE59A4F5}" type="datetimeFigureOut">
               <a:rPr lang="fr-FR" smtClean="0"/>
-              <a:t>28/03/2026</a:t>
+              <a:t>02/04/2026</a:t>
             </a:fld>
             <a:endParaRPr lang="fr-FR"/>
           </a:p>
@@ -1712,7 +1712,7 @@
           <a:p>
             <a:fld id="{253B1B7A-19D7-47DD-996A-6E83BE59A4F5}" type="datetimeFigureOut">
               <a:rPr lang="fr-FR" smtClean="0"/>
-              <a:t>28/03/2026</a:t>
+              <a:t>02/04/2026</a:t>
             </a:fld>
             <a:endParaRPr lang="fr-FR"/>
           </a:p>
@@ -1807,7 +1807,7 @@
           <a:p>
             <a:fld id="{253B1B7A-19D7-47DD-996A-6E83BE59A4F5}" type="datetimeFigureOut">
               <a:rPr lang="fr-FR" smtClean="0"/>
-              <a:t>28/03/2026</a:t>
+              <a:t>02/04/2026</a:t>
             </a:fld>
             <a:endParaRPr lang="fr-FR"/>
           </a:p>
@@ -2082,7 +2082,7 @@
           <a:p>
             <a:fld id="{253B1B7A-19D7-47DD-996A-6E83BE59A4F5}" type="datetimeFigureOut">
               <a:rPr lang="fr-FR" smtClean="0"/>
-              <a:t>28/03/2026</a:t>
+              <a:t>02/04/2026</a:t>
             </a:fld>
             <a:endParaRPr lang="fr-FR"/>
           </a:p>
@@ -2334,7 +2334,7 @@
           <a:p>
             <a:fld id="{253B1B7A-19D7-47DD-996A-6E83BE59A4F5}" type="datetimeFigureOut">
               <a:rPr lang="fr-FR" smtClean="0"/>
-              <a:t>28/03/2026</a:t>
+              <a:t>02/04/2026</a:t>
             </a:fld>
             <a:endParaRPr lang="fr-FR"/>
           </a:p>
@@ -2545,7 +2545,7 @@
           <a:p>
             <a:fld id="{253B1B7A-19D7-47DD-996A-6E83BE59A4F5}" type="datetimeFigureOut">
               <a:rPr lang="fr-FR" smtClean="0"/>
-              <a:t>28/03/2026</a:t>
+              <a:t>02/04/2026</a:t>
             </a:fld>
             <a:endParaRPr lang="fr-FR"/>
           </a:p>
@@ -3962,47 +3962,6 @@
       </p:sp>
       <p:sp>
         <p:nvSpPr>
-          <p:cNvPr id="5" name="Rectangle 4"/>
-          <p:cNvSpPr/>
-          <p:nvPr/>
-        </p:nvSpPr>
-        <p:spPr>
-          <a:xfrm>
-            <a:off x="4278820" y="365480"/>
-            <a:ext cx="8132618" cy="5846619"/>
-          </a:xfrm>
-          <a:prstGeom prst="rect">
-            <a:avLst/>
-          </a:prstGeom>
-          <a:noFill/>
-        </p:spPr>
-        <p:style>
-          <a:lnRef idx="2">
-            <a:schemeClr val="accent1">
-              <a:shade val="50000"/>
-            </a:schemeClr>
-          </a:lnRef>
-          <a:fillRef idx="1">
-            <a:schemeClr val="accent1"/>
-          </a:fillRef>
-          <a:effectRef idx="0">
-            <a:schemeClr val="accent1"/>
-          </a:effectRef>
-          <a:fontRef idx="minor">
-            <a:schemeClr val="lt1"/>
-          </a:fontRef>
-        </p:style>
-        <p:txBody>
-          <a:bodyPr rtlCol="0" anchor="ctr"/>
-          <a:lstStyle/>
-          <a:p>
-            <a:pPr algn="ctr"/>
-            <a:endParaRPr lang="fr-FR"/>
-          </a:p>
-        </p:txBody>
-      </p:sp>
-      <p:sp>
-        <p:nvSpPr>
           <p:cNvPr id="22" name="Rectangle 21"/>
           <p:cNvSpPr/>
           <p:nvPr/>
@@ -4059,8 +4018,8 @@
         </p:nvSpPr>
         <p:spPr>
           <a:xfrm>
-            <a:off x="3469734" y="595745"/>
-            <a:ext cx="5330137" cy="5978560"/>
+            <a:off x="3469734" y="81395"/>
+            <a:ext cx="5330137" cy="7271221"/>
           </a:xfrm>
           <a:prstGeom prst="rect">
             <a:avLst/>
@@ -4266,6 +4225,14 @@
           </a:p>
           <a:p>
             <a:pPr lvl="2"/>
+            <a:r>
+              <a:rPr lang="fr-FR" sz="1200"/>
+              <a:t>« alias" :</a:t>
+            </a:r>
+            <a:endParaRPr lang="fr-FR" sz="1200" dirty="0"/>
+          </a:p>
+          <a:p>
+            <a:pPr lvl="2"/>
             <a:endParaRPr lang="fr-FR" sz="1050" dirty="0"/>
           </a:p>
           <a:p>
@@ -4325,13 +4292,6 @@
             <a:pPr lvl="2"/>
             <a:r>
               <a:rPr lang="fr-FR" sz="1200" dirty="0"/>
-              <a:t>"variables_2D" : </a:t>
-            </a:r>
-          </a:p>
-          <a:p>
-            <a:pPr lvl="2"/>
-            <a:r>
-              <a:rPr lang="fr-FR" sz="1200" dirty="0"/>
               <a:t>«</a:t>
             </a:r>
             <a:r>
@@ -4405,6 +4365,51 @@
             </a:r>
             <a:r>
               <a:rPr lang="fr-FR" sz="1200" dirty="0" err="1"/>
+              <a:t>scatter_map</a:t>
+            </a:r>
+            <a:r>
+              <a:rPr lang="fr-FR" sz="1200" dirty="0"/>
+              <a:t> »</a:t>
+            </a:r>
+          </a:p>
+          <a:p>
+            <a:pPr lvl="2"/>
+            <a:r>
+              <a:rPr lang="fr-FR" sz="1200" dirty="0"/>
+              <a:t>« </a:t>
+            </a:r>
+            <a:r>
+              <a:rPr lang="fr-FR" sz="1200" dirty="0" err="1"/>
+              <a:t>text_map_start</a:t>
+            </a:r>
+            <a:r>
+              <a:rPr lang="fr-FR" sz="1200" dirty="0"/>
+              <a:t> »</a:t>
+            </a:r>
+          </a:p>
+          <a:p>
+            <a:pPr lvl="2"/>
+            <a:r>
+              <a:rPr lang="fr-FR" sz="1200" dirty="0"/>
+              <a:t>« </a:t>
+            </a:r>
+            <a:r>
+              <a:rPr lang="fr-FR" sz="1200" dirty="0" err="1"/>
+              <a:t>text_map_end</a:t>
+            </a:r>
+            <a:r>
+              <a:rPr lang="fr-FR" sz="1200" dirty="0"/>
+              <a:t>»_</a:t>
+            </a:r>
+          </a:p>
+          <a:p>
+            <a:pPr lvl="2"/>
+            <a:r>
+              <a:rPr lang="fr-FR" sz="1200" dirty="0"/>
+              <a:t>« </a:t>
+            </a:r>
+            <a:r>
+              <a:rPr lang="fr-FR" sz="1200" dirty="0" err="1"/>
               <a:t>plot_color</a:t>
             </a:r>
             <a:r>
@@ -4428,7 +4433,7 @@
             </a:r>
             <a:r>
               <a:rPr lang="fr-FR" sz="1200" dirty="0" err="1"/>
-              <a:t>crosshair_v</a:t>
+              <a:t>crosshair_v_polar</a:t>
             </a:r>
             <a:r>
               <a:rPr lang="fr-FR" sz="1200" dirty="0"/>
@@ -4443,11 +4448,55 @@
             </a:r>
             <a:r>
               <a:rPr lang="fr-FR" sz="1200" dirty="0" err="1"/>
-              <a:t>crosshair_h</a:t>
+              <a:t>crosshair_h_polar</a:t>
             </a:r>
             <a:r>
               <a:rPr lang="fr-FR" sz="1200" dirty="0"/>
               <a:t> »</a:t>
+            </a:r>
+          </a:p>
+          <a:p>
+            <a:pPr lvl="2"/>
+            <a:r>
+              <a:rPr lang="fr-FR" sz="1200" dirty="0"/>
+              <a:t>« </a:t>
+            </a:r>
+            <a:r>
+              <a:rPr lang="fr-FR" sz="1200" dirty="0" err="1"/>
+              <a:t>crosshair_v_map</a:t>
+            </a:r>
+            <a:r>
+              <a:rPr lang="fr-FR" sz="1200" dirty="0"/>
+              <a:t>»</a:t>
+            </a:r>
+          </a:p>
+          <a:p>
+            <a:pPr lvl="2"/>
+            <a:r>
+              <a:rPr lang="fr-FR" sz="1200" dirty="0"/>
+              <a:t>« </a:t>
+            </a:r>
+            <a:r>
+              <a:rPr lang="fr-FR" sz="1200" dirty="0" err="1"/>
+              <a:t>crosshair_h_map</a:t>
+            </a:r>
+            <a:r>
+              <a:rPr lang="fr-FR" sz="1200" dirty="0"/>
+              <a:t> »</a:t>
+            </a:r>
+          </a:p>
+          <a:p>
+            <a:pPr lvl="2"/>
+            <a:r>
+              <a:rPr lang="fr-FR" sz="1200" dirty="0"/>
+              <a:t>« crosshair_v_time_1»</a:t>
+            </a:r>
+          </a:p>
+          <a:p>
+            <a:pPr lvl="2"/>
+            <a:r>
+              <a:rPr lang="fr-FR" sz="1200" dirty="0"/>
+              <a:t>« crosshair_h_time_2»</a:t>
             </a:r>
           </a:p>
           <a:p>

</xml_diff>

<commit_message>
Grosse refonte des fonctions d'affichage des graphiques pour ajout des crosshairs, correction de bugs, ajout des Qsliders, ajout des tableaux de visualisation de données lorsqu'on clique sur un point
</commit_message>
<xml_diff>
--- a/ressources/code.pptx
+++ b/ressources/code.pptx
@@ -243,7 +243,7 @@
           <a:p>
             <a:fld id="{253B1B7A-19D7-47DD-996A-6E83BE59A4F5}" type="datetimeFigureOut">
               <a:rPr lang="fr-FR" smtClean="0"/>
-              <a:t>02/04/2026</a:t>
+              <a:t>08/04/2026</a:t>
             </a:fld>
             <a:endParaRPr lang="fr-FR"/>
           </a:p>
@@ -411,7 +411,7 @@
           <a:p>
             <a:fld id="{253B1B7A-19D7-47DD-996A-6E83BE59A4F5}" type="datetimeFigureOut">
               <a:rPr lang="fr-FR" smtClean="0"/>
-              <a:t>02/04/2026</a:t>
+              <a:t>08/04/2026</a:t>
             </a:fld>
             <a:endParaRPr lang="fr-FR"/>
           </a:p>
@@ -589,7 +589,7 @@
           <a:p>
             <a:fld id="{253B1B7A-19D7-47DD-996A-6E83BE59A4F5}" type="datetimeFigureOut">
               <a:rPr lang="fr-FR" smtClean="0"/>
-              <a:t>02/04/2026</a:t>
+              <a:t>08/04/2026</a:t>
             </a:fld>
             <a:endParaRPr lang="fr-FR"/>
           </a:p>
@@ -757,7 +757,7 @@
           <a:p>
             <a:fld id="{253B1B7A-19D7-47DD-996A-6E83BE59A4F5}" type="datetimeFigureOut">
               <a:rPr lang="fr-FR" smtClean="0"/>
-              <a:t>02/04/2026</a:t>
+              <a:t>08/04/2026</a:t>
             </a:fld>
             <a:endParaRPr lang="fr-FR"/>
           </a:p>
@@ -1002,7 +1002,7 @@
           <a:p>
             <a:fld id="{253B1B7A-19D7-47DD-996A-6E83BE59A4F5}" type="datetimeFigureOut">
               <a:rPr lang="fr-FR" smtClean="0"/>
-              <a:t>02/04/2026</a:t>
+              <a:t>08/04/2026</a:t>
             </a:fld>
             <a:endParaRPr lang="fr-FR"/>
           </a:p>
@@ -1231,7 +1231,7 @@
           <a:p>
             <a:fld id="{253B1B7A-19D7-47DD-996A-6E83BE59A4F5}" type="datetimeFigureOut">
               <a:rPr lang="fr-FR" smtClean="0"/>
-              <a:t>02/04/2026</a:t>
+              <a:t>08/04/2026</a:t>
             </a:fld>
             <a:endParaRPr lang="fr-FR"/>
           </a:p>
@@ -1595,7 +1595,7 @@
           <a:p>
             <a:fld id="{253B1B7A-19D7-47DD-996A-6E83BE59A4F5}" type="datetimeFigureOut">
               <a:rPr lang="fr-FR" smtClean="0"/>
-              <a:t>02/04/2026</a:t>
+              <a:t>08/04/2026</a:t>
             </a:fld>
             <a:endParaRPr lang="fr-FR"/>
           </a:p>
@@ -1712,7 +1712,7 @@
           <a:p>
             <a:fld id="{253B1B7A-19D7-47DD-996A-6E83BE59A4F5}" type="datetimeFigureOut">
               <a:rPr lang="fr-FR" smtClean="0"/>
-              <a:t>02/04/2026</a:t>
+              <a:t>08/04/2026</a:t>
             </a:fld>
             <a:endParaRPr lang="fr-FR"/>
           </a:p>
@@ -1807,7 +1807,7 @@
           <a:p>
             <a:fld id="{253B1B7A-19D7-47DD-996A-6E83BE59A4F5}" type="datetimeFigureOut">
               <a:rPr lang="fr-FR" smtClean="0"/>
-              <a:t>02/04/2026</a:t>
+              <a:t>08/04/2026</a:t>
             </a:fld>
             <a:endParaRPr lang="fr-FR"/>
           </a:p>
@@ -2082,7 +2082,7 @@
           <a:p>
             <a:fld id="{253B1B7A-19D7-47DD-996A-6E83BE59A4F5}" type="datetimeFigureOut">
               <a:rPr lang="fr-FR" smtClean="0"/>
-              <a:t>02/04/2026</a:t>
+              <a:t>08/04/2026</a:t>
             </a:fld>
             <a:endParaRPr lang="fr-FR"/>
           </a:p>
@@ -2334,7 +2334,7 @@
           <a:p>
             <a:fld id="{253B1B7A-19D7-47DD-996A-6E83BE59A4F5}" type="datetimeFigureOut">
               <a:rPr lang="fr-FR" smtClean="0"/>
-              <a:t>02/04/2026</a:t>
+              <a:t>08/04/2026</a:t>
             </a:fld>
             <a:endParaRPr lang="fr-FR"/>
           </a:p>
@@ -2545,7 +2545,7 @@
           <a:p>
             <a:fld id="{253B1B7A-19D7-47DD-996A-6E83BE59A4F5}" type="datetimeFigureOut">
               <a:rPr lang="fr-FR" smtClean="0"/>
-              <a:t>02/04/2026</a:t>
+              <a:t>08/04/2026</a:t>
             </a:fld>
             <a:endParaRPr lang="fr-FR"/>
           </a:p>
@@ -4226,10 +4226,9 @@
           <a:p>
             <a:pPr lvl="2"/>
             <a:r>
-              <a:rPr lang="fr-FR" sz="1200"/>
+              <a:rPr lang="fr-FR" sz="1200" dirty="0"/>
               <a:t>« alias" :</a:t>
             </a:r>
-            <a:endParaRPr lang="fr-FR" sz="1200" dirty="0"/>
           </a:p>
           <a:p>
             <a:pPr lvl="2"/>
@@ -4463,26 +4462,11 @@
             </a:r>
             <a:r>
               <a:rPr lang="fr-FR" sz="1200" dirty="0" err="1"/>
-              <a:t>crosshair_v_map</a:t>
+              <a:t>highlight_point_map</a:t>
             </a:r>
             <a:r>
               <a:rPr lang="fr-FR" sz="1200" dirty="0"/>
               <a:t>»</a:t>
-            </a:r>
-          </a:p>
-          <a:p>
-            <a:pPr lvl="2"/>
-            <a:r>
-              <a:rPr lang="fr-FR" sz="1200" dirty="0"/>
-              <a:t>« </a:t>
-            </a:r>
-            <a:r>
-              <a:rPr lang="fr-FR" sz="1200" dirty="0" err="1"/>
-              <a:t>crosshair_h_map</a:t>
-            </a:r>
-            <a:r>
-              <a:rPr lang="fr-FR" sz="1200" dirty="0"/>
-              <a:t> »</a:t>
             </a:r>
           </a:p>
           <a:p>

</xml_diff>

<commit_message>
Correction du problème de Settings. Grosse avancée sur l'émagramme
</commit_message>
<xml_diff>
--- a/ressources/code.pptx
+++ b/ressources/code.pptx
@@ -243,7 +243,7 @@
           <a:p>
             <a:fld id="{253B1B7A-19D7-47DD-996A-6E83BE59A4F5}" type="datetimeFigureOut">
               <a:rPr lang="fr-FR" smtClean="0"/>
-              <a:t>08/04/2026</a:t>
+              <a:t>13/04/2026</a:t>
             </a:fld>
             <a:endParaRPr lang="fr-FR"/>
           </a:p>
@@ -411,7 +411,7 @@
           <a:p>
             <a:fld id="{253B1B7A-19D7-47DD-996A-6E83BE59A4F5}" type="datetimeFigureOut">
               <a:rPr lang="fr-FR" smtClean="0"/>
-              <a:t>08/04/2026</a:t>
+              <a:t>13/04/2026</a:t>
             </a:fld>
             <a:endParaRPr lang="fr-FR"/>
           </a:p>
@@ -589,7 +589,7 @@
           <a:p>
             <a:fld id="{253B1B7A-19D7-47DD-996A-6E83BE59A4F5}" type="datetimeFigureOut">
               <a:rPr lang="fr-FR" smtClean="0"/>
-              <a:t>08/04/2026</a:t>
+              <a:t>13/04/2026</a:t>
             </a:fld>
             <a:endParaRPr lang="fr-FR"/>
           </a:p>
@@ -757,7 +757,7 @@
           <a:p>
             <a:fld id="{253B1B7A-19D7-47DD-996A-6E83BE59A4F5}" type="datetimeFigureOut">
               <a:rPr lang="fr-FR" smtClean="0"/>
-              <a:t>08/04/2026</a:t>
+              <a:t>13/04/2026</a:t>
             </a:fld>
             <a:endParaRPr lang="fr-FR"/>
           </a:p>
@@ -1002,7 +1002,7 @@
           <a:p>
             <a:fld id="{253B1B7A-19D7-47DD-996A-6E83BE59A4F5}" type="datetimeFigureOut">
               <a:rPr lang="fr-FR" smtClean="0"/>
-              <a:t>08/04/2026</a:t>
+              <a:t>13/04/2026</a:t>
             </a:fld>
             <a:endParaRPr lang="fr-FR"/>
           </a:p>
@@ -1231,7 +1231,7 @@
           <a:p>
             <a:fld id="{253B1B7A-19D7-47DD-996A-6E83BE59A4F5}" type="datetimeFigureOut">
               <a:rPr lang="fr-FR" smtClean="0"/>
-              <a:t>08/04/2026</a:t>
+              <a:t>13/04/2026</a:t>
             </a:fld>
             <a:endParaRPr lang="fr-FR"/>
           </a:p>
@@ -1595,7 +1595,7 @@
           <a:p>
             <a:fld id="{253B1B7A-19D7-47DD-996A-6E83BE59A4F5}" type="datetimeFigureOut">
               <a:rPr lang="fr-FR" smtClean="0"/>
-              <a:t>08/04/2026</a:t>
+              <a:t>13/04/2026</a:t>
             </a:fld>
             <a:endParaRPr lang="fr-FR"/>
           </a:p>
@@ -1712,7 +1712,7 @@
           <a:p>
             <a:fld id="{253B1B7A-19D7-47DD-996A-6E83BE59A4F5}" type="datetimeFigureOut">
               <a:rPr lang="fr-FR" smtClean="0"/>
-              <a:t>08/04/2026</a:t>
+              <a:t>13/04/2026</a:t>
             </a:fld>
             <a:endParaRPr lang="fr-FR"/>
           </a:p>
@@ -1807,7 +1807,7 @@
           <a:p>
             <a:fld id="{253B1B7A-19D7-47DD-996A-6E83BE59A4F5}" type="datetimeFigureOut">
               <a:rPr lang="fr-FR" smtClean="0"/>
-              <a:t>08/04/2026</a:t>
+              <a:t>13/04/2026</a:t>
             </a:fld>
             <a:endParaRPr lang="fr-FR"/>
           </a:p>
@@ -2082,7 +2082,7 @@
           <a:p>
             <a:fld id="{253B1B7A-19D7-47DD-996A-6E83BE59A4F5}" type="datetimeFigureOut">
               <a:rPr lang="fr-FR" smtClean="0"/>
-              <a:t>08/04/2026</a:t>
+              <a:t>13/04/2026</a:t>
             </a:fld>
             <a:endParaRPr lang="fr-FR"/>
           </a:p>
@@ -2334,7 +2334,7 @@
           <a:p>
             <a:fld id="{253B1B7A-19D7-47DD-996A-6E83BE59A4F5}" type="datetimeFigureOut">
               <a:rPr lang="fr-FR" smtClean="0"/>
-              <a:t>08/04/2026</a:t>
+              <a:t>13/04/2026</a:t>
             </a:fld>
             <a:endParaRPr lang="fr-FR"/>
           </a:p>
@@ -2545,7 +2545,7 @@
           <a:p>
             <a:fld id="{253B1B7A-19D7-47DD-996A-6E83BE59A4F5}" type="datetimeFigureOut">
               <a:rPr lang="fr-FR" smtClean="0"/>
-              <a:t>08/04/2026</a:t>
+              <a:t>13/04/2026</a:t>
             </a:fld>
             <a:endParaRPr lang="fr-FR"/>
           </a:p>
@@ -4379,6 +4379,50 @@
             </a:r>
             <a:r>
               <a:rPr lang="fr-FR" sz="1200" dirty="0" err="1"/>
+              <a:t>scatter_emagram</a:t>
+            </a:r>
+            <a:r>
+              <a:rPr lang="fr-FR" sz="1200" dirty="0"/>
+              <a:t> » : [</a:t>
+            </a:r>
+            <a:r>
+              <a:rPr lang="fr-FR" sz="1200" dirty="0" err="1"/>
+              <a:t>scatter</a:t>
+            </a:r>
+            <a:r>
+              <a:rPr lang="fr-FR" sz="1200" dirty="0"/>
+              <a:t> t dry , </a:t>
+            </a:r>
+            <a:r>
+              <a:rPr lang="fr-FR" sz="1200" dirty="0" err="1"/>
+              <a:t>scatter</a:t>
+            </a:r>
+            <a:r>
+              <a:rPr lang="fr-FR" sz="1200" dirty="0"/>
+              <a:t> t </a:t>
+            </a:r>
+            <a:r>
+              <a:rPr lang="fr-FR" sz="1200" dirty="0" err="1"/>
+              <a:t>moist</a:t>
+            </a:r>
+            <a:r>
+              <a:rPr lang="fr-FR" sz="1200" dirty="0"/>
+              <a:t> ] </a:t>
+            </a:r>
+            <a:r>
+              <a:rPr lang="fr-FR" sz="1200"/>
+              <a:t>(liste)</a:t>
+            </a:r>
+            <a:endParaRPr lang="fr-FR" sz="1200" dirty="0"/>
+          </a:p>
+          <a:p>
+            <a:pPr lvl="2"/>
+            <a:r>
+              <a:rPr lang="fr-FR" sz="1200" dirty="0"/>
+              <a:t>« </a:t>
+            </a:r>
+            <a:r>
+              <a:rPr lang="fr-FR" sz="1200" dirty="0" err="1"/>
               <a:t>text_map_start</a:t>
             </a:r>
             <a:r>

</xml_diff>

<commit_message>
Ajouts améliorations graphiques. Colorbar toujours en cours
</commit_message>
<xml_diff>
--- a/ressources/code.pptx
+++ b/ressources/code.pptx
@@ -243,7 +243,7 @@
           <a:p>
             <a:fld id="{253B1B7A-19D7-47DD-996A-6E83BE59A4F5}" type="datetimeFigureOut">
               <a:rPr lang="fr-FR" smtClean="0"/>
-              <a:t>13/04/2026</a:t>
+              <a:t>30/04/2026</a:t>
             </a:fld>
             <a:endParaRPr lang="fr-FR"/>
           </a:p>
@@ -411,7 +411,7 @@
           <a:p>
             <a:fld id="{253B1B7A-19D7-47DD-996A-6E83BE59A4F5}" type="datetimeFigureOut">
               <a:rPr lang="fr-FR" smtClean="0"/>
-              <a:t>13/04/2026</a:t>
+              <a:t>30/04/2026</a:t>
             </a:fld>
             <a:endParaRPr lang="fr-FR"/>
           </a:p>
@@ -589,7 +589,7 @@
           <a:p>
             <a:fld id="{253B1B7A-19D7-47DD-996A-6E83BE59A4F5}" type="datetimeFigureOut">
               <a:rPr lang="fr-FR" smtClean="0"/>
-              <a:t>13/04/2026</a:t>
+              <a:t>30/04/2026</a:t>
             </a:fld>
             <a:endParaRPr lang="fr-FR"/>
           </a:p>
@@ -757,7 +757,7 @@
           <a:p>
             <a:fld id="{253B1B7A-19D7-47DD-996A-6E83BE59A4F5}" type="datetimeFigureOut">
               <a:rPr lang="fr-FR" smtClean="0"/>
-              <a:t>13/04/2026</a:t>
+              <a:t>30/04/2026</a:t>
             </a:fld>
             <a:endParaRPr lang="fr-FR"/>
           </a:p>
@@ -1002,7 +1002,7 @@
           <a:p>
             <a:fld id="{253B1B7A-19D7-47DD-996A-6E83BE59A4F5}" type="datetimeFigureOut">
               <a:rPr lang="fr-FR" smtClean="0"/>
-              <a:t>13/04/2026</a:t>
+              <a:t>30/04/2026</a:t>
             </a:fld>
             <a:endParaRPr lang="fr-FR"/>
           </a:p>
@@ -1231,7 +1231,7 @@
           <a:p>
             <a:fld id="{253B1B7A-19D7-47DD-996A-6E83BE59A4F5}" type="datetimeFigureOut">
               <a:rPr lang="fr-FR" smtClean="0"/>
-              <a:t>13/04/2026</a:t>
+              <a:t>30/04/2026</a:t>
             </a:fld>
             <a:endParaRPr lang="fr-FR"/>
           </a:p>
@@ -1595,7 +1595,7 @@
           <a:p>
             <a:fld id="{253B1B7A-19D7-47DD-996A-6E83BE59A4F5}" type="datetimeFigureOut">
               <a:rPr lang="fr-FR" smtClean="0"/>
-              <a:t>13/04/2026</a:t>
+              <a:t>30/04/2026</a:t>
             </a:fld>
             <a:endParaRPr lang="fr-FR"/>
           </a:p>
@@ -1712,7 +1712,7 @@
           <a:p>
             <a:fld id="{253B1B7A-19D7-47DD-996A-6E83BE59A4F5}" type="datetimeFigureOut">
               <a:rPr lang="fr-FR" smtClean="0"/>
-              <a:t>13/04/2026</a:t>
+              <a:t>30/04/2026</a:t>
             </a:fld>
             <a:endParaRPr lang="fr-FR"/>
           </a:p>
@@ -1807,7 +1807,7 @@
           <a:p>
             <a:fld id="{253B1B7A-19D7-47DD-996A-6E83BE59A4F5}" type="datetimeFigureOut">
               <a:rPr lang="fr-FR" smtClean="0"/>
-              <a:t>13/04/2026</a:t>
+              <a:t>30/04/2026</a:t>
             </a:fld>
             <a:endParaRPr lang="fr-FR"/>
           </a:p>
@@ -2082,7 +2082,7 @@
           <a:p>
             <a:fld id="{253B1B7A-19D7-47DD-996A-6E83BE59A4F5}" type="datetimeFigureOut">
               <a:rPr lang="fr-FR" smtClean="0"/>
-              <a:t>13/04/2026</a:t>
+              <a:t>30/04/2026</a:t>
             </a:fld>
             <a:endParaRPr lang="fr-FR"/>
           </a:p>
@@ -2334,7 +2334,7 @@
           <a:p>
             <a:fld id="{253B1B7A-19D7-47DD-996A-6E83BE59A4F5}" type="datetimeFigureOut">
               <a:rPr lang="fr-FR" smtClean="0"/>
-              <a:t>13/04/2026</a:t>
+              <a:t>30/04/2026</a:t>
             </a:fld>
             <a:endParaRPr lang="fr-FR"/>
           </a:p>
@@ -2545,7 +2545,7 @@
           <a:p>
             <a:fld id="{253B1B7A-19D7-47DD-996A-6E83BE59A4F5}" type="datetimeFigureOut">
               <a:rPr lang="fr-FR" smtClean="0"/>
-              <a:t>13/04/2026</a:t>
+              <a:t>30/04/2026</a:t>
             </a:fld>
             <a:endParaRPr lang="fr-FR"/>
           </a:p>
@@ -4019,7 +4019,7 @@
         <p:spPr>
           <a:xfrm>
             <a:off x="3469734" y="81395"/>
-            <a:ext cx="5330137" cy="7271221"/>
+            <a:ext cx="5330137" cy="7455887"/>
           </a:xfrm>
           <a:prstGeom prst="rect">
             <a:avLst/>
@@ -4273,6 +4273,13 @@
           </a:p>
           <a:p>
             <a:r>
+              <a:rPr lang="fr-FR" sz="1200" b="1" dirty="0" err="1"/>
+              <a:t>is_flight_selected</a:t>
+            </a:r>
+            <a:endParaRPr lang="fr-FR" sz="1200" b="1" dirty="0"/>
+          </a:p>
+          <a:p>
+            <a:r>
               <a:rPr lang="fr-FR" sz="1200" b="1" dirty="0"/>
               <a:t>plot:</a:t>
             </a:r>
@@ -4407,13 +4414,8 @@
             </a:r>
             <a:r>
               <a:rPr lang="fr-FR" sz="1200" dirty="0"/>
-              <a:t> ] </a:t>
-            </a:r>
-            <a:r>
-              <a:rPr lang="fr-FR" sz="1200"/>
-              <a:t>(liste)</a:t>
-            </a:r>
-            <a:endParaRPr lang="fr-FR" sz="1200" dirty="0"/>
+              <a:t> ] (liste)</a:t>
+            </a:r>
           </a:p>
           <a:p>
             <a:pPr lvl="2"/>

</xml_diff>